<commit_message>
docs: apresentação SAREL: títulos sem numeração e slide de estratificação explicado
Co-Authored-By: Claude Sonnet 5.5 <noreply@anthropic.com>
Claude-Session: https://claude.ai/code/session_01QBooVKGGKQGrenTtP2atqx
</commit_message>
<xml_diff>
--- a/docs/Apresentacao_SAREL_Plataforma_Metodo_Desafios.pptx
+++ b/docs/Apresentacao_SAREL_Plataforma_Metodo_Desafios.pptx
@@ -1755,7 +1755,7 @@
           <a:p>
             <a:r>
               <a:rPr lang="en-US" dirty="0"/>
-              <a:t>(1 min) Os estratos vêm do produto de três dimensões: tercis de declividade (energia do relevo), tercis de frequência de solo nu (tempo de solo descoberto) e dois níveis de erodibilidade (suscetibilidade do solo). São 3 x 3 x 2 = 18. A erodibilidade vem da carta da Embrapa de 2024, com nível 1 nas classes baixa a média e nível 2 nas classes alta a extremamente alta. O desenho prevê quatro polígonos por estrato, dois para treino e dois para teste. A decisão sobre a classe 6 foi aprovada em 19/10 e está sendo registrada.</a:t>
+              <a:t>(1,5 min) Estratificar é dividir os candidatos em grupos internamente parecidos e amostrar cada grupo separadamente, para que as combinações raras também entrem na amostra. Usamos três dimensões. Declividade, em três faixas (tercis): é a energia do relevo, que governa o escoamento. Frequência de solo nu, em três faixas: é o tempo em que o solo fica descoberto e exposto à chuva. Erodibilidade, em dois níveis: é a suscetibilidade intrínseca do solo, vinda da carta da Embrapa de 2024; nível 2 são as classes alta, muito alta e extremamente alta. Tercil significa dividir os candidatos em três grupos de tamanho semelhante. 3 x 3 x 2 dá 18 estratos, com quatro polígonos cada: dois para treino e dois para teste. A decisão sobre a classe 6 foi aprovada em 19/10 e está em registro.</a:t>
             </a:r>
             <a:endParaRPr lang="en-US" dirty="0"/>
           </a:p>
@@ -3343,7 +3343,7 @@
                 <a:ea typeface="Cambria" pitchFamily="34" charset="-122"/>
                 <a:cs typeface="Cambria" pitchFamily="34" charset="-120"/>
               </a:rPr>
-              <a:t>Passos 6 e 7: voo cego, delineação e rótulo por fração</a:t>
+              <a:t>Voo cego, delineação e rótulo por fração</a:t>
             </a:r>
             <a:endParaRPr lang="en-US" sz="2200" dirty="0"/>
           </a:p>
@@ -3647,7 +3647,7 @@
                 <a:ea typeface="Cambria" pitchFamily="34" charset="-122"/>
                 <a:cs typeface="Cambria" pitchFamily="34" charset="-120"/>
               </a:rPr>
-              <a:t>Passo 8: âncora de campo com o SAREL Coletor</a:t>
+              <a:t>Âncora de campo com o SAREL Coletor</a:t>
             </a:r>
             <a:endParaRPr lang="en-US" sz="2200" dirty="0"/>
           </a:p>
@@ -4196,7 +4196,7 @@
                 <a:ea typeface="Cambria" pitchFamily="34" charset="-122"/>
                 <a:cs typeface="Cambria" pitchFamily="34" charset="-120"/>
               </a:rPr>
-              <a:t>Passo 10: avaliação única, com o critério fixado antes</a:t>
+              <a:t>Avaliação única, com o critério fixado antes</a:t>
             </a:r>
             <a:endParaRPr lang="en-US" sz="2200" dirty="0"/>
           </a:p>
@@ -9098,7 +9098,7 @@
                 <a:ea typeface="Cambria" pitchFamily="34" charset="-122"/>
                 <a:cs typeface="Cambria" pitchFamily="34" charset="-120"/>
               </a:rPr>
-              <a:t>Passo 3: estratificação em 18 estratos</a:t>
+              <a:t>Estratificação: como se chega aos 18 estratos</a:t>
             </a:r>
             <a:endParaRPr lang="en-US" sz="2200" dirty="0"/>
           </a:p>
@@ -9151,12 +9151,12 @@
         </p:nvSpPr>
         <p:spPr>
           <a:xfrm>
-            <a:off x="457200" y="1188720"/>
-            <a:ext cx="2468880" cy="1463040"/>
+            <a:off x="457200" y="1005840"/>
+            <a:ext cx="2468880" cy="1874520"/>
           </a:xfrm>
           <a:prstGeom prst="roundRect">
             <a:avLst>
-              <a:gd name="adj" fmla="val 5000"/>
+              <a:gd name="adj" fmla="val 3902"/>
             </a:avLst>
           </a:prstGeom>
           <a:solidFill>
@@ -9178,8 +9178,8 @@
         </p:nvSpPr>
         <p:spPr>
           <a:xfrm>
-            <a:off x="457200" y="1261872"/>
-            <a:ext cx="2468880" cy="640080"/>
+            <a:off x="594360" y="1097280"/>
+            <a:ext cx="2194560" cy="365760"/>
           </a:xfrm>
           <a:prstGeom prst="rect">
             <a:avLst/>
@@ -9191,11 +9191,11 @@
           <a:bodyPr wrap="square" lIns="0" tIns="0" rIns="0" bIns="0" rtlCol="0" anchor="t"/>
           <a:lstStyle/>
           <a:p>
-            <a:pPr algn="ctr" indent="0" marL="0">
+            <a:pPr indent="0" marL="0">
               <a:buNone/>
             </a:pPr>
             <a:r>
-              <a:rPr lang="en-US" sz="2800" b="1" dirty="0">
+              <a:rPr lang="en-US" sz="1600" b="1" dirty="0">
                 <a:solidFill>
                   <a:srgbClr val="2F6B4F"/>
                 </a:solidFill>
@@ -9203,9 +9203,9 @@
                 <a:ea typeface="Cambria" pitchFamily="34" charset="-122"/>
                 <a:cs typeface="Cambria" pitchFamily="34" charset="-120"/>
               </a:rPr>
-              <a:t>3</a:t>
-            </a:r>
-            <a:endParaRPr lang="en-US" sz="2800" dirty="0"/>
+              <a:t>Declividade</a:t>
+            </a:r>
+            <a:endParaRPr lang="en-US" sz="1600" dirty="0"/>
           </a:p>
         </p:txBody>
       </p:sp>
@@ -9217,8 +9217,8 @@
         </p:nvSpPr>
         <p:spPr>
           <a:xfrm>
-            <a:off x="457200" y="1920240"/>
-            <a:ext cx="2468880" cy="320040"/>
+            <a:off x="594360" y="1481328"/>
+            <a:ext cx="2194560" cy="274320"/>
           </a:xfrm>
           <a:prstGeom prst="rect">
             <a:avLst/>
@@ -9230,88 +9230,88 @@
           <a:bodyPr wrap="square" lIns="0" tIns="0" rIns="0" bIns="0" rtlCol="0" anchor="t"/>
           <a:lstStyle/>
           <a:p>
+            <a:pPr indent="0" marL="0">
+              <a:buNone/>
+            </a:pPr>
+            <a:r>
+              <a:rPr lang="en-US" sz="1200" b="1" dirty="0">
+                <a:solidFill>
+                  <a:srgbClr val="C65D3B"/>
+                </a:solidFill>
+                <a:latin typeface="Calibri" pitchFamily="34" charset="0"/>
+                <a:ea typeface="Calibri" pitchFamily="34" charset="-122"/>
+                <a:cs typeface="Calibri" pitchFamily="34" charset="-120"/>
+              </a:rPr>
+              <a:t>3 faixas (tercis)</a:t>
+            </a:r>
+            <a:endParaRPr lang="en-US" sz="1200" dirty="0"/>
+          </a:p>
+        </p:txBody>
+      </p:sp>
+      <p:sp>
+        <p:nvSpPr>
+          <p:cNvPr id="8" name="Text 5"/>
+          <p:cNvSpPr txBox="1"/>
+          <p:nvPr/>
+        </p:nvSpPr>
+        <p:spPr>
+          <a:xfrm>
+            <a:off x="594360" y="1810512"/>
+            <a:ext cx="2194560" cy="1280160"/>
+          </a:xfrm>
+          <a:prstGeom prst="rect">
+            <a:avLst/>
+          </a:prstGeom>
+          <a:noFill/>
+          <a:ln/>
+        </p:spPr>
+        <p:txBody>
+          <a:bodyPr wrap="square" lIns="0" tIns="0" rIns="0" bIns="0" rtlCol="0" anchor="t"/>
+          <a:lstStyle/>
+          <a:p>
+            <a:pPr indent="0" marL="0">
+              <a:buNone/>
+            </a:pPr>
+            <a:r>
+              <a:rPr lang="en-US" sz="1150" dirty="0">
+                <a:solidFill>
+                  <a:srgbClr val="1B2A22"/>
+                </a:solidFill>
+                <a:latin typeface="Calibri" pitchFamily="34" charset="0"/>
+                <a:ea typeface="Calibri" pitchFamily="34" charset="-122"/>
+                <a:cs typeface="Calibri" pitchFamily="34" charset="-120"/>
+              </a:rPr>
+              <a:t>Energia do relevo: quanto mais inclinado, maior a capacidade de transporte do escoamento.</a:t>
+            </a:r>
+            <a:endParaRPr lang="en-US" sz="1150" dirty="0"/>
+          </a:p>
+        </p:txBody>
+      </p:sp>
+      <p:sp>
+        <p:nvSpPr>
+          <p:cNvPr id="9" name="Text 6"/>
+          <p:cNvSpPr txBox="1"/>
+          <p:nvPr/>
+        </p:nvSpPr>
+        <p:spPr>
+          <a:xfrm>
+            <a:off x="2926080" y="1783080"/>
+            <a:ext cx="365760" cy="548640"/>
+          </a:xfrm>
+          <a:prstGeom prst="rect">
+            <a:avLst/>
+          </a:prstGeom>
+          <a:noFill/>
+          <a:ln/>
+        </p:spPr>
+        <p:txBody>
+          <a:bodyPr wrap="square" lIns="0" tIns="0" rIns="0" bIns="0" rtlCol="0" anchor="t"/>
+          <a:lstStyle/>
+          <a:p>
             <a:pPr algn="ctr" indent="0" marL="0">
               <a:buNone/>
             </a:pPr>
             <a:r>
-              <a:rPr lang="en-US" sz="1400" b="1" dirty="0">
-                <a:solidFill>
-                  <a:srgbClr val="1B2A22"/>
-                </a:solidFill>
-                <a:latin typeface="Calibri" pitchFamily="34" charset="0"/>
-                <a:ea typeface="Calibri" pitchFamily="34" charset="-122"/>
-                <a:cs typeface="Calibri" pitchFamily="34" charset="-120"/>
-              </a:rPr>
-              <a:t>tercis de declividade</a:t>
-            </a:r>
-            <a:endParaRPr lang="en-US" sz="1400" dirty="0"/>
-          </a:p>
-        </p:txBody>
-      </p:sp>
-      <p:sp>
-        <p:nvSpPr>
-          <p:cNvPr id="8" name="Text 5"/>
-          <p:cNvSpPr txBox="1"/>
-          <p:nvPr/>
-        </p:nvSpPr>
-        <p:spPr>
-          <a:xfrm>
-            <a:off x="457200" y="2240280"/>
-            <a:ext cx="2468880" cy="320040"/>
-          </a:xfrm>
-          <a:prstGeom prst="rect">
-            <a:avLst/>
-          </a:prstGeom>
-          <a:noFill/>
-          <a:ln/>
-        </p:spPr>
-        <p:txBody>
-          <a:bodyPr wrap="square" lIns="0" tIns="0" rIns="0" bIns="0" rtlCol="0" anchor="t"/>
-          <a:lstStyle/>
-          <a:p>
-            <a:pPr algn="ctr" indent="0" marL="0">
-              <a:buNone/>
-            </a:pPr>
-            <a:r>
-              <a:rPr lang="en-US" sz="1200" dirty="0">
-                <a:solidFill>
-                  <a:srgbClr val="52605A"/>
-                </a:solidFill>
-                <a:latin typeface="Calibri" pitchFamily="34" charset="0"/>
-                <a:ea typeface="Calibri" pitchFamily="34" charset="-122"/>
-                <a:cs typeface="Calibri" pitchFamily="34" charset="-120"/>
-              </a:rPr>
-              <a:t>energia do relevo</a:t>
-            </a:r>
-            <a:endParaRPr lang="en-US" sz="1200" dirty="0"/>
-          </a:p>
-        </p:txBody>
-      </p:sp>
-      <p:sp>
-        <p:nvSpPr>
-          <p:cNvPr id="9" name="Text 6"/>
-          <p:cNvSpPr txBox="1"/>
-          <p:nvPr/>
-        </p:nvSpPr>
-        <p:spPr>
-          <a:xfrm>
-            <a:off x="2926080" y="1600200"/>
-            <a:ext cx="365760" cy="548640"/>
-          </a:xfrm>
-          <a:prstGeom prst="rect">
-            <a:avLst/>
-          </a:prstGeom>
-          <a:noFill/>
-          <a:ln/>
-        </p:spPr>
-        <p:txBody>
-          <a:bodyPr wrap="square" lIns="0" tIns="0" rIns="0" bIns="0" rtlCol="0" anchor="t"/>
-          <a:lstStyle/>
-          <a:p>
-            <a:pPr algn="ctr" indent="0" marL="0">
-              <a:buNone/>
-            </a:pPr>
-            <a:r>
               <a:rPr lang="en-US" sz="2600" b="1" dirty="0">
                 <a:solidFill>
                   <a:srgbClr val="C65D3B"/>
@@ -9334,12 +9334,12 @@
         </p:nvSpPr>
         <p:spPr>
           <a:xfrm>
-            <a:off x="3291840" y="1188720"/>
-            <a:ext cx="2468880" cy="1463040"/>
+            <a:off x="3291840" y="1005840"/>
+            <a:ext cx="2468880" cy="1874520"/>
           </a:xfrm>
           <a:prstGeom prst="roundRect">
             <a:avLst>
-              <a:gd name="adj" fmla="val 5000"/>
+              <a:gd name="adj" fmla="val 3902"/>
             </a:avLst>
           </a:prstGeom>
           <a:solidFill>
@@ -9361,8 +9361,8 @@
         </p:nvSpPr>
         <p:spPr>
           <a:xfrm>
-            <a:off x="3291840" y="1261872"/>
-            <a:ext cx="2468880" cy="640080"/>
+            <a:off x="3429000" y="1097280"/>
+            <a:ext cx="2194560" cy="365760"/>
           </a:xfrm>
           <a:prstGeom prst="rect">
             <a:avLst/>
@@ -9374,11 +9374,11 @@
           <a:bodyPr wrap="square" lIns="0" tIns="0" rIns="0" bIns="0" rtlCol="0" anchor="t"/>
           <a:lstStyle/>
           <a:p>
-            <a:pPr algn="ctr" indent="0" marL="0">
+            <a:pPr indent="0" marL="0">
               <a:buNone/>
             </a:pPr>
             <a:r>
-              <a:rPr lang="en-US" sz="2800" b="1" dirty="0">
+              <a:rPr lang="en-US" sz="1600" b="1" dirty="0">
                 <a:solidFill>
                   <a:srgbClr val="2F6B4F"/>
                 </a:solidFill>
@@ -9386,9 +9386,9 @@
                 <a:ea typeface="Cambria" pitchFamily="34" charset="-122"/>
                 <a:cs typeface="Cambria" pitchFamily="34" charset="-120"/>
               </a:rPr>
-              <a:t>3</a:t>
-            </a:r>
-            <a:endParaRPr lang="en-US" sz="2800" dirty="0"/>
+              <a:t>Solo nu</a:t>
+            </a:r>
+            <a:endParaRPr lang="en-US" sz="1600" dirty="0"/>
           </a:p>
         </p:txBody>
       </p:sp>
@@ -9400,8 +9400,8 @@
         </p:nvSpPr>
         <p:spPr>
           <a:xfrm>
-            <a:off x="3291840" y="1920240"/>
-            <a:ext cx="2468880" cy="320040"/>
+            <a:off x="3429000" y="1481328"/>
+            <a:ext cx="2194560" cy="274320"/>
           </a:xfrm>
           <a:prstGeom prst="rect">
             <a:avLst/>
@@ -9413,88 +9413,88 @@
           <a:bodyPr wrap="square" lIns="0" tIns="0" rIns="0" bIns="0" rtlCol="0" anchor="t"/>
           <a:lstStyle/>
           <a:p>
+            <a:pPr indent="0" marL="0">
+              <a:buNone/>
+            </a:pPr>
+            <a:r>
+              <a:rPr lang="en-US" sz="1200" b="1" dirty="0">
+                <a:solidFill>
+                  <a:srgbClr val="C65D3B"/>
+                </a:solidFill>
+                <a:latin typeface="Calibri" pitchFamily="34" charset="0"/>
+                <a:ea typeface="Calibri" pitchFamily="34" charset="-122"/>
+                <a:cs typeface="Calibri" pitchFamily="34" charset="-120"/>
+              </a:rPr>
+              <a:t>3 faixas (tercis)</a:t>
+            </a:r>
+            <a:endParaRPr lang="en-US" sz="1200" dirty="0"/>
+          </a:p>
+        </p:txBody>
+      </p:sp>
+      <p:sp>
+        <p:nvSpPr>
+          <p:cNvPr id="13" name="Text 10"/>
+          <p:cNvSpPr txBox="1"/>
+          <p:nvPr/>
+        </p:nvSpPr>
+        <p:spPr>
+          <a:xfrm>
+            <a:off x="3429000" y="1810512"/>
+            <a:ext cx="2194560" cy="1280160"/>
+          </a:xfrm>
+          <a:prstGeom prst="rect">
+            <a:avLst/>
+          </a:prstGeom>
+          <a:noFill/>
+          <a:ln/>
+        </p:spPr>
+        <p:txBody>
+          <a:bodyPr wrap="square" lIns="0" tIns="0" rIns="0" bIns="0" rtlCol="0" anchor="t"/>
+          <a:lstStyle/>
+          <a:p>
+            <a:pPr indent="0" marL="0">
+              <a:buNone/>
+            </a:pPr>
+            <a:r>
+              <a:rPr lang="en-US" sz="1150" dirty="0">
+                <a:solidFill>
+                  <a:srgbClr val="1B2A22"/>
+                </a:solidFill>
+                <a:latin typeface="Calibri" pitchFamily="34" charset="0"/>
+                <a:ea typeface="Calibri" pitchFamily="34" charset="-122"/>
+                <a:cs typeface="Calibri" pitchFamily="34" charset="-120"/>
+              </a:rPr>
+              <a:t>Tempo de solo descoberto: fração de cenas de satélite válidas em que a célula aparece exposta à chuva.</a:t>
+            </a:r>
+            <a:endParaRPr lang="en-US" sz="1150" dirty="0"/>
+          </a:p>
+        </p:txBody>
+      </p:sp>
+      <p:sp>
+        <p:nvSpPr>
+          <p:cNvPr id="14" name="Text 11"/>
+          <p:cNvSpPr txBox="1"/>
+          <p:nvPr/>
+        </p:nvSpPr>
+        <p:spPr>
+          <a:xfrm>
+            <a:off x="5760720" y="1783080"/>
+            <a:ext cx="365760" cy="548640"/>
+          </a:xfrm>
+          <a:prstGeom prst="rect">
+            <a:avLst/>
+          </a:prstGeom>
+          <a:noFill/>
+          <a:ln/>
+        </p:spPr>
+        <p:txBody>
+          <a:bodyPr wrap="square" lIns="0" tIns="0" rIns="0" bIns="0" rtlCol="0" anchor="t"/>
+          <a:lstStyle/>
+          <a:p>
             <a:pPr algn="ctr" indent="0" marL="0">
               <a:buNone/>
             </a:pPr>
             <a:r>
-              <a:rPr lang="en-US" sz="1400" b="1" dirty="0">
-                <a:solidFill>
-                  <a:srgbClr val="1B2A22"/>
-                </a:solidFill>
-                <a:latin typeface="Calibri" pitchFamily="34" charset="0"/>
-                <a:ea typeface="Calibri" pitchFamily="34" charset="-122"/>
-                <a:cs typeface="Calibri" pitchFamily="34" charset="-120"/>
-              </a:rPr>
-              <a:t>tercis de solo nu</a:t>
-            </a:r>
-            <a:endParaRPr lang="en-US" sz="1400" dirty="0"/>
-          </a:p>
-        </p:txBody>
-      </p:sp>
-      <p:sp>
-        <p:nvSpPr>
-          <p:cNvPr id="13" name="Text 10"/>
-          <p:cNvSpPr txBox="1"/>
-          <p:nvPr/>
-        </p:nvSpPr>
-        <p:spPr>
-          <a:xfrm>
-            <a:off x="3291840" y="2240280"/>
-            <a:ext cx="2468880" cy="320040"/>
-          </a:xfrm>
-          <a:prstGeom prst="rect">
-            <a:avLst/>
-          </a:prstGeom>
-          <a:noFill/>
-          <a:ln/>
-        </p:spPr>
-        <p:txBody>
-          <a:bodyPr wrap="square" lIns="0" tIns="0" rIns="0" bIns="0" rtlCol="0" anchor="t"/>
-          <a:lstStyle/>
-          <a:p>
-            <a:pPr algn="ctr" indent="0" marL="0">
-              <a:buNone/>
-            </a:pPr>
-            <a:r>
-              <a:rPr lang="en-US" sz="1200" dirty="0">
-                <a:solidFill>
-                  <a:srgbClr val="52605A"/>
-                </a:solidFill>
-                <a:latin typeface="Calibri" pitchFamily="34" charset="0"/>
-                <a:ea typeface="Calibri" pitchFamily="34" charset="-122"/>
-                <a:cs typeface="Calibri" pitchFamily="34" charset="-120"/>
-              </a:rPr>
-              <a:t>tempo de solo descoberto</a:t>
-            </a:r>
-            <a:endParaRPr lang="en-US" sz="1200" dirty="0"/>
-          </a:p>
-        </p:txBody>
-      </p:sp>
-      <p:sp>
-        <p:nvSpPr>
-          <p:cNvPr id="14" name="Text 11"/>
-          <p:cNvSpPr txBox="1"/>
-          <p:nvPr/>
-        </p:nvSpPr>
-        <p:spPr>
-          <a:xfrm>
-            <a:off x="5760720" y="1600200"/>
-            <a:ext cx="365760" cy="548640"/>
-          </a:xfrm>
-          <a:prstGeom prst="rect">
-            <a:avLst/>
-          </a:prstGeom>
-          <a:noFill/>
-          <a:ln/>
-        </p:spPr>
-        <p:txBody>
-          <a:bodyPr wrap="square" lIns="0" tIns="0" rIns="0" bIns="0" rtlCol="0" anchor="t"/>
-          <a:lstStyle/>
-          <a:p>
-            <a:pPr algn="ctr" indent="0" marL="0">
-              <a:buNone/>
-            </a:pPr>
-            <a:r>
               <a:rPr lang="en-US" sz="2600" b="1" dirty="0">
                 <a:solidFill>
                   <a:srgbClr val="C65D3B"/>
@@ -9517,12 +9517,12 @@
         </p:nvSpPr>
         <p:spPr>
           <a:xfrm>
-            <a:off x="6126480" y="1188720"/>
-            <a:ext cx="2468880" cy="1463040"/>
+            <a:off x="6126480" y="1005840"/>
+            <a:ext cx="2468880" cy="1874520"/>
           </a:xfrm>
           <a:prstGeom prst="roundRect">
             <a:avLst>
-              <a:gd name="adj" fmla="val 5000"/>
+              <a:gd name="adj" fmla="val 3902"/>
             </a:avLst>
           </a:prstGeom>
           <a:solidFill>
@@ -9544,8 +9544,8 @@
         </p:nvSpPr>
         <p:spPr>
           <a:xfrm>
-            <a:off x="6126480" y="1261872"/>
-            <a:ext cx="2468880" cy="640080"/>
+            <a:off x="6263640" y="1097280"/>
+            <a:ext cx="2194560" cy="365760"/>
           </a:xfrm>
           <a:prstGeom prst="rect">
             <a:avLst/>
@@ -9557,11 +9557,11 @@
           <a:bodyPr wrap="square" lIns="0" tIns="0" rIns="0" bIns="0" rtlCol="0" anchor="t"/>
           <a:lstStyle/>
           <a:p>
-            <a:pPr algn="ctr" indent="0" marL="0">
+            <a:pPr indent="0" marL="0">
               <a:buNone/>
             </a:pPr>
             <a:r>
-              <a:rPr lang="en-US" sz="2800" b="1" dirty="0">
+              <a:rPr lang="en-US" sz="1600" b="1" dirty="0">
                 <a:solidFill>
                   <a:srgbClr val="2F6B4F"/>
                 </a:solidFill>
@@ -9569,9 +9569,9 @@
                 <a:ea typeface="Cambria" pitchFamily="34" charset="-122"/>
                 <a:cs typeface="Cambria" pitchFamily="34" charset="-120"/>
               </a:rPr>
-              <a:t>2</a:t>
-            </a:r>
-            <a:endParaRPr lang="en-US" sz="2800" dirty="0"/>
+              <a:t>Erodibilidade</a:t>
+            </a:r>
+            <a:endParaRPr lang="en-US" sz="1600" dirty="0"/>
           </a:p>
         </p:txBody>
       </p:sp>
@@ -9583,8 +9583,8 @@
         </p:nvSpPr>
         <p:spPr>
           <a:xfrm>
-            <a:off x="6126480" y="1920240"/>
-            <a:ext cx="2468880" cy="320040"/>
+            <a:off x="6263640" y="1481328"/>
+            <a:ext cx="2194560" cy="274320"/>
           </a:xfrm>
           <a:prstGeom prst="rect">
             <a:avLst/>
@@ -9596,21 +9596,21 @@
           <a:bodyPr wrap="square" lIns="0" tIns="0" rIns="0" bIns="0" rtlCol="0" anchor="t"/>
           <a:lstStyle/>
           <a:p>
-            <a:pPr algn="ctr" indent="0" marL="0">
+            <a:pPr indent="0" marL="0">
               <a:buNone/>
             </a:pPr>
             <a:r>
-              <a:rPr lang="en-US" sz="1400" b="1" dirty="0">
-                <a:solidFill>
-                  <a:srgbClr val="1B2A22"/>
-                </a:solidFill>
-                <a:latin typeface="Calibri" pitchFamily="34" charset="0"/>
-                <a:ea typeface="Calibri" pitchFamily="34" charset="-122"/>
-                <a:cs typeface="Calibri" pitchFamily="34" charset="-120"/>
-              </a:rPr>
-              <a:t>níveis de erodibilidade</a:t>
-            </a:r>
-            <a:endParaRPr lang="en-US" sz="1400" dirty="0"/>
+              <a:rPr lang="en-US" sz="1200" b="1" dirty="0">
+                <a:solidFill>
+                  <a:srgbClr val="C65D3B"/>
+                </a:solidFill>
+                <a:latin typeface="Calibri" pitchFamily="34" charset="0"/>
+                <a:ea typeface="Calibri" pitchFamily="34" charset="-122"/>
+                <a:cs typeface="Calibri" pitchFamily="34" charset="-120"/>
+              </a:rPr>
+              <a:t>2 níveis</a:t>
+            </a:r>
+            <a:endParaRPr lang="en-US" sz="1200" dirty="0"/>
           </a:p>
         </p:txBody>
       </p:sp>
@@ -9622,8 +9622,8 @@
         </p:nvSpPr>
         <p:spPr>
           <a:xfrm>
-            <a:off x="6126480" y="2240280"/>
-            <a:ext cx="2468880" cy="320040"/>
+            <a:off x="6263640" y="1810512"/>
+            <a:ext cx="2194560" cy="1280160"/>
           </a:xfrm>
           <a:prstGeom prst="rect">
             <a:avLst/>
@@ -9635,21 +9635,21 @@
           <a:bodyPr wrap="square" lIns="0" tIns="0" rIns="0" bIns="0" rtlCol="0" anchor="t"/>
           <a:lstStyle/>
           <a:p>
-            <a:pPr algn="ctr" indent="0" marL="0">
+            <a:pPr indent="0" marL="0">
               <a:buNone/>
             </a:pPr>
             <a:r>
-              <a:rPr lang="en-US" sz="1200" dirty="0">
-                <a:solidFill>
-                  <a:srgbClr val="52605A"/>
-                </a:solidFill>
-                <a:latin typeface="Calibri" pitchFamily="34" charset="0"/>
-                <a:ea typeface="Calibri" pitchFamily="34" charset="-122"/>
-                <a:cs typeface="Calibri" pitchFamily="34" charset="-120"/>
-              </a:rPr>
-              <a:t>suscetibilidade do solo</a:t>
-            </a:r>
-            <a:endParaRPr lang="en-US" sz="1200" dirty="0"/>
+              <a:rPr lang="en-US" sz="1150" dirty="0">
+                <a:solidFill>
+                  <a:srgbClr val="1B2A22"/>
+                </a:solidFill>
+                <a:latin typeface="Calibri" pitchFamily="34" charset="0"/>
+                <a:ea typeface="Calibri" pitchFamily="34" charset="-122"/>
+                <a:cs typeface="Calibri" pitchFamily="34" charset="-120"/>
+              </a:rPr>
+              <a:t>Suscetibilidade do solo à erosão, pela carta de 2024 (Embrapa Doc. 246): nível 2 = classes alta, muito alta e extremamente alta.</a:t>
+            </a:r>
+            <a:endParaRPr lang="en-US" sz="1150" dirty="0"/>
           </a:p>
         </p:txBody>
       </p:sp>
@@ -9661,8 +9661,8 @@
         </p:nvSpPr>
         <p:spPr>
           <a:xfrm>
-            <a:off x="457200" y="2926080"/>
-            <a:ext cx="8229600" cy="457200"/>
+            <a:off x="457200" y="3017520"/>
+            <a:ext cx="8229600" cy="365760"/>
           </a:xfrm>
           <a:prstGeom prst="rect">
             <a:avLst/>
@@ -9678,7 +9678,7 @@
               <a:buNone/>
             </a:pPr>
             <a:r>
-              <a:rPr lang="en-US" sz="1800" dirty="0">
+              <a:rPr lang="en-US" sz="1500" b="1" dirty="0">
                 <a:solidFill>
                   <a:srgbClr val="1B2A22"/>
                 </a:solidFill>
@@ -9686,9 +9686,9 @@
                 <a:ea typeface="Cambria" pitchFamily="34" charset="-122"/>
                 <a:cs typeface="Cambria" pitchFamily="34" charset="-120"/>
               </a:rPr>
-              <a:t>= 18 estratos, com 4 polígonos por estrato: 2 para treino e 2 para held-out</a:t>
-            </a:r>
-            <a:endParaRPr lang="en-US" sz="1800" dirty="0"/>
+              <a:t>3 × 3 × 2 = 18 estratos × 4 polígonos (2 treino + 2 held-out) = 72</a:t>
+            </a:r>
+            <a:endParaRPr lang="en-US" sz="1500" dirty="0"/>
           </a:p>
         </p:txBody>
       </p:sp>
@@ -9715,13 +9715,13 @@
           <a:p>
             <a:pPr marL="342900" indent="-342900">
               <a:spcAft>
-                <a:spcPts val="700"/>
+                <a:spcPts val="500"/>
               </a:spcAft>
               <a:buSzPct val="100000"/>
               <a:buChar char="•"/>
             </a:pPr>
             <a:r>
-              <a:rPr lang="en-US" sz="1250" dirty="0">
+              <a:rPr lang="en-US" sz="1200" dirty="0">
                 <a:solidFill>
                   <a:srgbClr val="1B2A22"/>
                 </a:solidFill>
@@ -9729,20 +9729,20 @@
                 <a:ea typeface="Calibri" pitchFamily="34" charset="-122"/>
                 <a:cs typeface="Calibri" pitchFamily="34" charset="-120"/>
               </a:rPr>
-              <a:t>A erodibilidade vem da carta de 2024 (Embrapa Solos, Documentos 246): nível 2 = classes alta, muito alta e extremamente alta (emenda de 19/10/2026 a D09, em registro)</a:t>
-            </a:r>
-            <a:endParaRPr lang="en-US" sz="1250" dirty="0"/>
+              <a:t>Por que estratificar: sem isso, o acaso concentraria a amostra nas combinações comuns e deixaria vazios os estratos raros (declive alto, muito solo nu, solo erodível), que são justamente os de maior interesse</a:t>
+            </a:r>
+            <a:endParaRPr lang="en-US" sz="1200" dirty="0"/>
           </a:p>
           <a:p>
             <a:pPr marL="342900" indent="-342900">
               <a:spcAft>
-                <a:spcPts val="700"/>
+                <a:spcPts val="500"/>
               </a:spcAft>
               <a:buSzPct val="100000"/>
               <a:buChar char="•"/>
             </a:pPr>
             <a:r>
-              <a:rPr lang="en-US" sz="1250" dirty="0">
+              <a:rPr lang="en-US" sz="1200" dirty="0">
                 <a:solidFill>
                   <a:srgbClr val="1B2A22"/>
                 </a:solidFill>
@@ -9750,9 +9750,9 @@
                 <a:ea typeface="Calibri" pitchFamily="34" charset="-122"/>
                 <a:cs typeface="Calibri" pitchFamily="34" charset="-120"/>
               </a:rPr>
-              <a:t>A frequência de solo nu é a fração de cenas válidas em que a célula aparece com solo exposto</a:t>
-            </a:r>
-            <a:endParaRPr lang="en-US" sz="1250" dirty="0"/>
+              <a:t>Tercil: divide os candidatos em três grupos de tamanho semelhante; o corte vem dos dados, não de valores fixados à mão</a:t>
+            </a:r>
+            <a:endParaRPr lang="en-US" sz="1200" dirty="0"/>
           </a:p>
         </p:txBody>
       </p:sp>
@@ -10827,7 +10827,7 @@
                 <a:ea typeface="Cambria" pitchFamily="34" charset="-122"/>
                 <a:cs typeface="Cambria" pitchFamily="34" charset="-120"/>
               </a:rPr>
-              <a:t>Passo 5: sorteio selado e o problema da recusa</a:t>
+              <a:t>Sorteio selado e o problema da recusa</a:t>
             </a:r>
             <a:endParaRPr lang="en-US" sz="2200" dirty="0"/>
           </a:p>

</xml_diff>

<commit_message>
docs: apresentação SAREL: descrição dos tercis conforme o código
Co-Authored-By: Claude Sonnet 5.5 <noreply@anthropic.com>
Claude-Session: https://claude.ai/code/session_01QBooVKGGKQGrenTtP2atqx
</commit_message>
<xml_diff>
--- a/docs/Apresentacao_SAREL_Plataforma_Metodo_Desafios.pptx
+++ b/docs/Apresentacao_SAREL_Plataforma_Metodo_Desafios.pptx
@@ -1755,7 +1755,7 @@
           <a:p>
             <a:r>
               <a:rPr lang="en-US" dirty="0"/>
-              <a:t>(1,5 min) Estratificar é dividir os candidatos em grupos internamente parecidos e amostrar cada grupo separadamente, para que as combinações raras também entrem na amostra. Usamos três dimensões. Declividade, em três faixas (tercis): é a energia do relevo, que governa o escoamento. Frequência de solo nu, em três faixas: é o tempo em que o solo fica descoberto e exposto à chuva. Erodibilidade, em dois níveis: é a suscetibilidade intrínseca do solo, vinda da carta da Embrapa de 2024; nível 2 são as classes alta, muito alta e extremamente alta. Tercil significa dividir os candidatos em três grupos de tamanho semelhante. 3 x 3 x 2 dá 18 estratos, com quatro polígonos cada: dois para treino e dois para teste. A decisão sobre a classe 6 foi aprovada em 19/10 e está em registro.</a:t>
+              <a:t>(1,5 min) Estratificar é dividir os candidatos em grupos internamente parecidos e amostrar cada grupo separadamente, para que as combinações raras também entrem na amostra. Usamos três dimensões. Declividade, em três faixas (tercis): é a energia do relevo, que governa o escoamento. Frequência de solo nu, em três faixas: é o tempo em que o solo fica descoberto e exposto à chuva. Erodibilidade, em dois níveis: é a suscetibilidade intrínseca do solo, vinda da carta da Embrapa de 2024; nível 2 são as classes alta, muito alta e extremamente alta. Tercil significa dividir os candidatos em três grupos de tamanho aproximado; os dois cortes são calculados sobre os candidatos da própria área, e valores empatados no corte caem no grupo mais baixo, de modo que os grupos podem diferir um pouco em tamanho. 3 x 3 x 2 dá 18 estratos, com quatro polígonos cada: dois para treino e dois para teste. A decisão sobre a classe 6 foi aprovada em 19/10 e está em registro.</a:t>
             </a:r>
             <a:endParaRPr lang="en-US" dirty="0"/>
           </a:p>
@@ -9750,7 +9750,7 @@
                 <a:ea typeface="Calibri" pitchFamily="34" charset="-122"/>
                 <a:cs typeface="Calibri" pitchFamily="34" charset="-120"/>
               </a:rPr>
-              <a:t>Tercil: divide os candidatos em três grupos de tamanho semelhante; o corte vem dos dados, não de valores fixados à mão</a:t>
+              <a:t>Tercil: divide em três grupos de tamanho aproximado; o corte é calculado sobre os candidatos da própria área e empates caem no grupo mais baixo</a:t>
             </a:r>
             <a:endParaRPr lang="en-US" sz="1200" dirty="0"/>
           </a:p>

</xml_diff>

<commit_message>
docs: apresentação SAREL: slide de logística explicita nº de voos, jornadas e faixa de tempo
Co-Authored-By: Claude Sonnet 5.5 <noreply@anthropic.com>
Claude-Session: https://claude.ai/code/session_01QBooVKGGKQGrenTtP2atqx
</commit_message>
<xml_diff>
--- a/docs/Apresentacao_SAREL_Plataforma_Metodo_Desafios.pptx
+++ b/docs/Apresentacao_SAREL_Plataforma_Metodo_Desafios.pptx
@@ -875,7 +875,7 @@
           <a:p>
             <a:r>
               <a:rPr lang="en-US" dirty="0"/>
-              <a:t>(1,5 min) Cada polígono dá cerca de 2,2 minutos de voo, com produtividade medida de 2,3 ha/min a GSD de cerca de 4 cm. Mas campanha de sítios dispersos é dominada por deslocamento e montagem, não por bateria: o número de dias de campo é maior que 3 e cresce de 36 para 72 polígonos. Outro ganho medido: a delineação sobre ortomosaico tem CE90 de 1,47 m, contra 3 a 8 m do GNSS de frequência única do aparelho de campo. A tela mostra os três conjuntos da campanha: 72 polígonos de 5,02 ha, 60 a 80 pontos de campo e a confirmação prospectiva.</a:t>
+              <a:t>(1,5 min) Quantidade de voos: são 72 polígonos de 5,02 ha, ou seja, 72 missões de mapeamento, uma por polígono; eram 36 no desenho anterior. Elas não precisam ser 72 saídas: o planejador agrupa polígonos próximos em jornadas de campo, com teto padrão de 6 polígonos por jornada, ajustável, o que dá cerca de 12 jornadas. Esse agrupamento é uma proposta do planejador, ainda não validada em campo. Tempo de voo: a produtividade medida foi de 2,3 ha/min na Missão 009, o que dá cerca de 2,2 min por polígono; mas a única outra missão válida, a 000, teve 0,53 ha/min, o que dá cerca de 9,5 min. Com duas missões medidas, a faixa honesta é de 2 a 10 minutos por polígono, ou de 2,6 a 11 horas de voo no total, sem contar deslocamento. O que domina a campanha é deslocamento, montagem e as 72 autorizações. O número de baterias e de decolagens não está definido: depende da aeronave e do agrupamento, e não tenho esse dado. A tela mostra os três conjuntos da campanha.</a:t>
             </a:r>
             <a:endParaRPr lang="en-US" dirty="0"/>
           </a:p>
@@ -2686,7 +2686,7 @@
                 <a:ea typeface="Cambria" pitchFamily="34" charset="-122"/>
                 <a:cs typeface="Cambria" pitchFamily="34" charset="-120"/>
               </a:rPr>
-              <a:t>Dificuldade 3: logística do voo e posição do rótulo</a:t>
+              <a:t>Dificuldade 3: quantos voos e quanto tempo</a:t>
             </a:r>
             <a:endParaRPr lang="en-US" sz="2200" dirty="0"/>
           </a:p>
@@ -2740,7 +2740,7 @@
         <p:spPr>
           <a:xfrm>
             <a:off x="457200" y="1005840"/>
-            <a:ext cx="1783080" cy="1188720"/>
+            <a:ext cx="1920240" cy="1188720"/>
           </a:xfrm>
           <a:prstGeom prst="roundRect">
             <a:avLst>
@@ -2767,7 +2767,7 @@
         <p:spPr>
           <a:xfrm>
             <a:off x="457200" y="1115568"/>
-            <a:ext cx="1783080" cy="594360"/>
+            <a:ext cx="1920240" cy="594360"/>
           </a:xfrm>
           <a:prstGeom prst="rect">
             <a:avLst/>
@@ -2785,13 +2785,13 @@
             <a:r>
               <a:rPr lang="en-US" sz="2200" b="1" dirty="0">
                 <a:solidFill>
-                  <a:srgbClr val="2F6B4F"/>
+                  <a:srgbClr val="C65D3B"/>
                 </a:solidFill>
                 <a:latin typeface="Cambria" pitchFamily="34" charset="0"/>
                 <a:ea typeface="Cambria" pitchFamily="34" charset="-122"/>
                 <a:cs typeface="Cambria" pitchFamily="34" charset="-120"/>
               </a:rPr>
-              <a:t>2,3 ha/min</a:t>
+              <a:t>72</a:t>
             </a:r>
             <a:endParaRPr lang="en-US" sz="2200" dirty="0"/>
           </a:p>
@@ -2806,7 +2806,7 @@
         <p:spPr>
           <a:xfrm>
             <a:off x="548640" y="1719072"/>
-            <a:ext cx="1600200" cy="457200"/>
+            <a:ext cx="1737360" cy="457200"/>
           </a:xfrm>
           <a:prstGeom prst="rect">
             <a:avLst/>
@@ -2830,7 +2830,7 @@
                 <a:ea typeface="Calibri" pitchFamily="34" charset="-122"/>
                 <a:cs typeface="Calibri" pitchFamily="34" charset="-120"/>
               </a:rPr>
-              <a:t>produtividade medida do voo (≈ 4 cm)</a:t>
+              <a:t>missões de mapeamento, uma por polígono (eram 36)</a:t>
             </a:r>
             <a:endParaRPr lang="en-US" sz="1100" dirty="0"/>
           </a:p>
@@ -2844,8 +2844,8 @@
         </p:nvSpPr>
         <p:spPr>
           <a:xfrm>
-            <a:off x="2377440" y="1005840"/>
-            <a:ext cx="1783080" cy="1188720"/>
+            <a:off x="2514600" y="1005840"/>
+            <a:ext cx="1920240" cy="1188720"/>
           </a:xfrm>
           <a:prstGeom prst="roundRect">
             <a:avLst>
@@ -2871,8 +2871,8 @@
         </p:nvSpPr>
         <p:spPr>
           <a:xfrm>
-            <a:off x="2377440" y="1115568"/>
-            <a:ext cx="1783080" cy="594360"/>
+            <a:off x="2514600" y="1115568"/>
+            <a:ext cx="1920240" cy="594360"/>
           </a:xfrm>
           <a:prstGeom prst="rect">
             <a:avLst/>
@@ -2896,7 +2896,7 @@
                 <a:ea typeface="Cambria" pitchFamily="34" charset="-122"/>
                 <a:cs typeface="Cambria" pitchFamily="34" charset="-120"/>
               </a:rPr>
-              <a:t>≈ 2,2 min</a:t>
+              <a:t>≈ 12</a:t>
             </a:r>
             <a:endParaRPr lang="en-US" sz="2200" dirty="0"/>
           </a:p>
@@ -2910,8 +2910,8 @@
         </p:nvSpPr>
         <p:spPr>
           <a:xfrm>
-            <a:off x="2468880" y="1719072"/>
-            <a:ext cx="1600200" cy="457200"/>
+            <a:off x="2606040" y="1719072"/>
+            <a:ext cx="1737360" cy="457200"/>
           </a:xfrm>
           <a:prstGeom prst="rect">
             <a:avLst/>
@@ -2935,7 +2935,7 @@
                 <a:ea typeface="Calibri" pitchFamily="34" charset="-122"/>
                 <a:cs typeface="Calibri" pitchFamily="34" charset="-120"/>
               </a:rPr>
-              <a:t>de voo por polígono</a:t>
+              <a:t>jornadas de campo, com até 6 polígonos cada (proposta)</a:t>
             </a:r>
             <a:endParaRPr lang="en-US" sz="1100" dirty="0"/>
           </a:p>
@@ -2949,8 +2949,8 @@
         </p:nvSpPr>
         <p:spPr>
           <a:xfrm>
-            <a:off x="4297680" y="1005840"/>
-            <a:ext cx="1783080" cy="1188720"/>
+            <a:off x="4572000" y="1005840"/>
+            <a:ext cx="1920240" cy="1188720"/>
           </a:xfrm>
           <a:prstGeom prst="roundRect">
             <a:avLst>
@@ -2976,8 +2976,8 @@
         </p:nvSpPr>
         <p:spPr>
           <a:xfrm>
-            <a:off x="4297680" y="1115568"/>
-            <a:ext cx="1783080" cy="594360"/>
+            <a:off x="4572000" y="1115568"/>
+            <a:ext cx="1920240" cy="594360"/>
           </a:xfrm>
           <a:prstGeom prst="rect">
             <a:avLst/>
@@ -2995,13 +2995,13 @@
             <a:r>
               <a:rPr lang="en-US" sz="2200" b="1" dirty="0">
                 <a:solidFill>
-                  <a:srgbClr val="C65D3B"/>
+                  <a:srgbClr val="2F6B4F"/>
                 </a:solidFill>
                 <a:latin typeface="Cambria" pitchFamily="34" charset="0"/>
                 <a:ea typeface="Cambria" pitchFamily="34" charset="-122"/>
                 <a:cs typeface="Cambria" pitchFamily="34" charset="-120"/>
               </a:rPr>
-              <a:t>72</a:t>
+              <a:t>2 a 10 min</a:t>
             </a:r>
             <a:endParaRPr lang="en-US" sz="2200" dirty="0"/>
           </a:p>
@@ -3015,8 +3015,8 @@
         </p:nvSpPr>
         <p:spPr>
           <a:xfrm>
-            <a:off x="4389120" y="1719072"/>
-            <a:ext cx="1600200" cy="457200"/>
+            <a:off x="4663440" y="1719072"/>
+            <a:ext cx="1737360" cy="457200"/>
           </a:xfrm>
           <a:prstGeom prst="rect">
             <a:avLst/>
@@ -3040,7 +3040,7 @@
                 <a:ea typeface="Calibri" pitchFamily="34" charset="-122"/>
                 <a:cs typeface="Calibri" pitchFamily="34" charset="-120"/>
               </a:rPr>
-              <a:t>autorizações e sítios a visitar (eram 36)</a:t>
+              <a:t>de voo por polígono (2,3 ha/min na Missão 009; 0,53 na 000)</a:t>
             </a:r>
             <a:endParaRPr lang="en-US" sz="1100" dirty="0"/>
           </a:p>
@@ -3054,8 +3054,8 @@
         </p:nvSpPr>
         <p:spPr>
           <a:xfrm>
-            <a:off x="6217920" y="1005840"/>
-            <a:ext cx="2468880" cy="1188720"/>
+            <a:off x="6629400" y="1005840"/>
+            <a:ext cx="2057400" cy="1188720"/>
           </a:xfrm>
           <a:prstGeom prst="roundRect">
             <a:avLst>
@@ -3081,8 +3081,8 @@
         </p:nvSpPr>
         <p:spPr>
           <a:xfrm>
-            <a:off x="6217920" y="1115568"/>
-            <a:ext cx="2468880" cy="594360"/>
+            <a:off x="6629400" y="1115568"/>
+            <a:ext cx="2057400" cy="594360"/>
           </a:xfrm>
           <a:prstGeom prst="rect">
             <a:avLst/>
@@ -3100,13 +3100,13 @@
             <a:r>
               <a:rPr lang="en-US" sz="2200" b="1" dirty="0">
                 <a:solidFill>
-                  <a:srgbClr val="2F6B4F"/>
+                  <a:srgbClr val="C65D3B"/>
                 </a:solidFill>
                 <a:latin typeface="Cambria" pitchFamily="34" charset="0"/>
                 <a:ea typeface="Cambria" pitchFamily="34" charset="-122"/>
                 <a:cs typeface="Cambria" pitchFamily="34" charset="-120"/>
               </a:rPr>
-              <a:t>1,47 vs 3–8 m</a:t>
+              <a:t>72</a:t>
             </a:r>
             <a:endParaRPr lang="en-US" sz="2200" dirty="0"/>
           </a:p>
@@ -3120,8 +3120,8 @@
         </p:nvSpPr>
         <p:spPr>
           <a:xfrm>
-            <a:off x="6309360" y="1719072"/>
-            <a:ext cx="2286000" cy="457200"/>
+            <a:off x="6720840" y="1719072"/>
+            <a:ext cx="1874520" cy="457200"/>
           </a:xfrm>
           <a:prstGeom prst="rect">
             <a:avLst/>
@@ -3145,7 +3145,7 @@
                 <a:ea typeface="Calibri" pitchFamily="34" charset="-122"/>
                 <a:cs typeface="Calibri" pitchFamily="34" charset="-120"/>
               </a:rPr>
-              <a:t>CE90 da delineação vs GNSS do aparelho de campo</a:t>
+              <a:t>autorizações de proprietário</a:t>
             </a:r>
             <a:endParaRPr lang="en-US" sz="1100" dirty="0"/>
           </a:p>
@@ -3159,8 +3159,8 @@
         </p:nvSpPr>
         <p:spPr>
           <a:xfrm>
-            <a:off x="438912" y="2404872"/>
-            <a:ext cx="8266176" cy="1754405"/>
+            <a:off x="1158736" y="2313432"/>
+            <a:ext cx="6826528" cy="1453896"/>
           </a:xfrm>
           <a:prstGeom prst="rect">
             <a:avLst/>
@@ -3192,8 +3192,8 @@
         </p:blipFill>
         <p:spPr>
           <a:xfrm>
-            <a:off x="457200" y="2423160"/>
-            <a:ext cx="8229600" cy="1717829"/>
+            <a:off x="1177024" y="2331720"/>
+            <a:ext cx="6789952" cy="1417320"/>
           </a:xfrm>
           <a:prstGeom prst="rect">
             <a:avLst/>
@@ -3208,8 +3208,8 @@
         </p:nvSpPr>
         <p:spPr>
           <a:xfrm>
-            <a:off x="457200" y="4224528"/>
-            <a:ext cx="8229600" cy="274320"/>
+            <a:off x="457200" y="3794760"/>
+            <a:ext cx="8229600" cy="914400"/>
           </a:xfrm>
           <a:prstGeom prst="rect">
             <a:avLst/>
@@ -3221,11 +3221,96 @@
           <a:bodyPr wrap="square" lIns="0" tIns="0" rIns="0" bIns="0" rtlCol="0" anchor="t"/>
           <a:lstStyle/>
           <a:p>
+            <a:pPr marL="342900" indent="-342900">
+              <a:spcAft>
+                <a:spcPts val="300"/>
+              </a:spcAft>
+              <a:buSzPct val="100000"/>
+              <a:buChar char="•"/>
+            </a:pPr>
+            <a:r>
+              <a:rPr lang="en-US" sz="1100" dirty="0">
+                <a:solidFill>
+                  <a:srgbClr val="1B2A22"/>
+                </a:solidFill>
+                <a:latin typeface="Calibri" pitchFamily="34" charset="0"/>
+                <a:ea typeface="Calibri" pitchFamily="34" charset="-122"/>
+                <a:cs typeface="Calibri" pitchFamily="34" charset="-120"/>
+              </a:rPr>
+              <a:t>Tempo total de voo: de 2,6 h a 11 h, sem contar o deslocamento, que domina a campanha</a:t>
+            </a:r>
+            <a:endParaRPr lang="en-US" sz="1100" dirty="0"/>
+          </a:p>
+          <a:p>
+            <a:pPr marL="342900" indent="-342900">
+              <a:spcAft>
+                <a:spcPts val="300"/>
+              </a:spcAft>
+              <a:buSzPct val="100000"/>
+              <a:buChar char="•"/>
+            </a:pPr>
+            <a:r>
+              <a:rPr lang="en-US" sz="1100" dirty="0">
+                <a:solidFill>
+                  <a:srgbClr val="1B2A22"/>
+                </a:solidFill>
+                <a:latin typeface="Calibri" pitchFamily="34" charset="0"/>
+                <a:ea typeface="Calibri" pitchFamily="34" charset="-122"/>
+                <a:cs typeface="Calibri" pitchFamily="34" charset="-120"/>
+              </a:rPr>
+              <a:t>Nº de baterias e de decolagens: ainda não definido; depende da aeronave e do agrupamento</a:t>
+            </a:r>
+            <a:endParaRPr lang="en-US" sz="1100" dirty="0"/>
+          </a:p>
+          <a:p>
+            <a:pPr marL="342900" indent="-342900">
+              <a:spcAft>
+                <a:spcPts val="300"/>
+              </a:spcAft>
+              <a:buSzPct val="100000"/>
+              <a:buChar char="•"/>
+            </a:pPr>
+            <a:r>
+              <a:rPr lang="en-US" sz="1100" dirty="0">
+                <a:solidFill>
+                  <a:srgbClr val="1B2A22"/>
+                </a:solidFill>
+                <a:latin typeface="Calibri" pitchFamily="34" charset="0"/>
+                <a:ea typeface="Calibri" pitchFamily="34" charset="-122"/>
+                <a:cs typeface="Calibri" pitchFamily="34" charset="-120"/>
+              </a:rPr>
+              <a:t>Base: 2 missões medidas (uma terceira foi excluída por ortomosaico degenerado); é uma faixa, não uma estimativa precisa</a:t>
+            </a:r>
+            <a:endParaRPr lang="en-US" sz="1100" dirty="0"/>
+          </a:p>
+        </p:txBody>
+      </p:sp>
+      <p:sp>
+        <p:nvSpPr>
+          <p:cNvPr id="20" name="Text 16"/>
+          <p:cNvSpPr txBox="1"/>
+          <p:nvPr/>
+        </p:nvSpPr>
+        <p:spPr>
+          <a:xfrm>
+            <a:off x="457200" y="4754880"/>
+            <a:ext cx="7863840" cy="292608"/>
+          </a:xfrm>
+          <a:prstGeom prst="rect">
+            <a:avLst/>
+          </a:prstGeom>
+          <a:noFill/>
+          <a:ln/>
+        </p:spPr>
+        <p:txBody>
+          <a:bodyPr wrap="square" lIns="0" tIns="0" rIns="0" bIns="0" rtlCol="0" anchor="ctr"/>
+          <a:lstStyle/>
+          <a:p>
             <a:pPr indent="0" marL="0">
               <a:buNone/>
             </a:pPr>
             <a:r>
-              <a:rPr lang="en-US" sz="1100" i="1" dirty="0">
+              <a:rPr lang="en-US" sz="1000" i="1" dirty="0">
                 <a:solidFill>
                   <a:srgbClr val="52605A"/>
                 </a:solidFill>
@@ -3233,46 +3318,7 @@
                 <a:ea typeface="Calibri" pitchFamily="34" charset="-122"/>
                 <a:cs typeface="Calibri" pitchFamily="34" charset="-120"/>
               </a:rPr>
-              <a:t>Central de Campanha: os três conjuntos do desenho (polígonos de VANT, pontos de campo e confirmação prospectiva).</a:t>
-            </a:r>
-            <a:endParaRPr lang="en-US" sz="1100" dirty="0"/>
-          </a:p>
-        </p:txBody>
-      </p:sp>
-      <p:sp>
-        <p:nvSpPr>
-          <p:cNvPr id="20" name="Text 16"/>
-          <p:cNvSpPr txBox="1"/>
-          <p:nvPr/>
-        </p:nvSpPr>
-        <p:spPr>
-          <a:xfrm>
-            <a:off x="457200" y="4754880"/>
-            <a:ext cx="7863840" cy="292608"/>
-          </a:xfrm>
-          <a:prstGeom prst="rect">
-            <a:avLst/>
-          </a:prstGeom>
-          <a:noFill/>
-          <a:ln/>
-        </p:spPr>
-        <p:txBody>
-          <a:bodyPr wrap="square" lIns="0" tIns="0" rIns="0" bIns="0" rtlCol="0" anchor="ctr"/>
-          <a:lstStyle/>
-          <a:p>
-            <a:pPr indent="0" marL="0">
-              <a:buNone/>
-            </a:pPr>
-            <a:r>
-              <a:rPr lang="en-US" sz="1000" i="1" dirty="0">
-                <a:solidFill>
-                  <a:srgbClr val="52605A"/>
-                </a:solidFill>
-                <a:latin typeface="Calibri" pitchFamily="34" charset="0"/>
-                <a:ea typeface="Calibri" pitchFamily="34" charset="-122"/>
-                <a:cs typeface="Calibri" pitchFamily="34" charset="-120"/>
-              </a:rPr>
-              <a:t>Fonte: D16 (docs/verificacoes/voo/cobertura_voos.geojson). Dias de campo: deslocamento e montagem dominam, mais que a bateria.</a:t>
+              <a:t>Fonte: D16; cobertura_voos.geojson (Missões 000 e 009); agrupamento: planejador de jornadas (teto padrão 6).</a:t>
             </a:r>
             <a:endParaRPr lang="en-US" sz="1000" dirty="0"/>
           </a:p>

</xml_diff>

<commit_message>
docs: apresentação SAREL: remove slide de pool por estrato (14 slides, ~16,5 min)
Co-Authored-By: Claude Sonnet 5.5 <noreply@anthropic.com>
Claude-Session: https://claude.ai/code/session_01QBooVKGGKQGrenTtP2atqx
</commit_message>
<xml_diff>
--- a/docs/Apresentacao_SAREL_Plataforma_Metodo_Desafios.pptx
+++ b/docs/Apresentacao_SAREL_Plataforma_Metodo_Desafios.pptx
@@ -19,10 +19,9 @@
     <p:sldId id="267" r:id="rId13"/>
     <p:sldId id="268" r:id="rId14"/>
     <p:sldId id="269" r:id="rId15"/>
-    <p:sldId id="270" r:id="rId16"/>
   </p:sldIdLst>
   <p:notesMasterIdLst>
-    <p:notesMasterId r:id="rId17"/>
+    <p:notesMasterId r:id="rId16"/>
   </p:notesMasterIdLst>
   <p:sldSz cx="9144000" cy="5143500"/>
   <p:notesSz cx="5143500" cy="9144000"/>
@@ -875,7 +874,7 @@
           <a:p>
             <a:r>
               <a:rPr lang="en-US" dirty="0"/>
-              <a:t>(1,5 min) Quantidade de voos: são 72 polígonos de 5,02 ha, ou seja, 72 missões de mapeamento, uma por polígono; eram 36 no desenho anterior. Elas não precisam ser 72 saídas: o planejador agrupa polígonos próximos em jornadas de campo, com teto padrão de 6 polígonos por jornada, ajustável, o que dá cerca de 12 jornadas. Esse agrupamento é uma proposta do planejador, ainda não validada em campo. Tempo de voo: a produtividade medida foi de 2,3 ha/min na Missão 009, o que dá cerca de 2,2 min por polígono; mas a única outra missão válida, a 000, teve 0,53 ha/min, o que dá cerca de 9,5 min. Com duas missões medidas, a faixa honesta é de 2 a 10 minutos por polígono, ou de 2,6 a 11 horas de voo no total, sem contar deslocamento. O que domina a campanha é deslocamento, montagem e as 72 autorizações. O número de baterias e de decolagens não está definido: depende da aeronave e do agrupamento, e não tenho esse dado. A tela mostra os três conjuntos da campanha.</a:t>
+              <a:t>(1 min) O alvo do modelo não é uma classe, e sim a fração da célula de 10 m delineada como erodida, entre 0 e 1, obtida por rasterização da delineação feita sobre o ortomosaico. O binário, fração maior ou igual a 25%, é derivado e secundário. O intérprete recebe só um código opaco, sem estrato nem papel; o app tem exportação cega por perfil. Isso impede que o modelo aprenda a concordar com o rastreio espectral. Planos de voo só saem com terreno real; os de demonstração são marcados como sintéticos.</a:t>
             </a:r>
             <a:endParaRPr lang="en-US" dirty="0"/>
           </a:p>
@@ -963,7 +962,7 @@
           <a:p>
             <a:r>
               <a:rPr lang="en-US" dirty="0"/>
-              <a:t>(1 min) O alvo do modelo não é uma classe, e sim a fração da célula de 10 m delineada como erodida, entre 0 e 1, obtida por rasterização da delineação feita sobre o ortomosaico. O binário, fração maior ou igual a 25%, é derivado e secundário. O intérprete recebe só um código opaco, sem estrato nem papel; o app tem exportação cega por perfil. Isso impede que o modelo aprenda a concordar com o rastreio espectral. Planos de voo só saem com terreno real; os de demonstração são marcados como sintéticos.</a:t>
+              <a:t>(1 min) O campo deixou de ser massa de treino e virou âncora: 60 a 80 pontos dispersos pela bacia, fora dos polígonos, sorteados com probabilidade conhecida, coletados no aplicativo SAREL Coletor, em Android, sob protocolo cego. A função é estimar a prevalência real, por estimador ponderado, e calibrar a acurácia posicional do aparelho. A campanha tem duas ondas; os 30 primeiros pontos são lote piloto. O KoboCollect foi substituído e a fotointerpretação foi aposentada, porque o rótulo centimétrico do voo é melhor e mais fiel ao fenômeno.</a:t>
             </a:r>
             <a:endParaRPr lang="en-US" dirty="0"/>
           </a:p>
@@ -1051,7 +1050,7 @@
           <a:p>
             <a:r>
               <a:rPr lang="en-US" dirty="0"/>
-              <a:t>(1 min) O campo deixou de ser massa de treino e virou âncora: 60 a 80 pontos dispersos pela bacia, fora dos polígonos, sorteados com probabilidade conhecida, coletados no aplicativo SAREL Coletor, em Android, sob protocolo cego. A função é estimar a prevalência real, por estimador ponderado, e calibrar a acurácia posicional do aparelho. A campanha tem duas ondas; os 30 primeiros pontos são lote piloto. O KoboCollect foi substituído e a fotointerpretação foi aposentada, porque o rótulo centimétrico do voo é melhor e mais fiel ao fenômeno.</a:t>
+              <a:t>(1,5 min) A tela mostra o registro oficial das decisões, com o critério de refutação de D25: três competidores (linha de base RUSLE, regressão penalizada e XGBoost), métrica primária de Spearman no held-out, piso de 0,40 e margem de 0,10 sobre a RUSLE. A inferência usa bootstrap por polígono, porque células do mesmo polígono não são independentes. Os desfechos são corroborada, inconclusiva ou refutada. O estado exibido hoje é 'não avaliado', e isso é intencional: não há resultado. O script grava uma trava e recusa uma segunda avaliação.</a:t>
             </a:r>
             <a:endParaRPr lang="en-US" dirty="0"/>
           </a:p>
@@ -1139,7 +1138,7 @@
           <a:p>
             <a:r>
               <a:rPr lang="en-US" dirty="0"/>
-              <a:t>(1,5 min) A tela mostra o registro oficial das decisões, com o critério de refutação de D25: três competidores (linha de base RUSLE, regressão penalizada e XGBoost), métrica primária de Spearman no held-out, piso de 0,40 e margem de 0,10 sobre a RUSLE. A inferência usa bootstrap por polígono, porque células do mesmo polígono não são independentes. Os desfechos são corroborada, inconclusiva ou refutada. O estado exibido hoje é 'não avaliado', e isso é intencional: não há resultado. O script grava uma trava e recusa uma segunda avaliação.</a:t>
+              <a:t>(1 min) Honestidade sobre o estágio: o que está pronto e o que depende de decisões e de dados. Não há resultado empírico. O sorteio ainda não foi realizado; há decisões do pesquisador pendentes que o sorteio exige e a checagem do pool com candidatos reais. A cifra de acerto de atribuição, antes citada, segue em verificação.</a:t>
             </a:r>
             <a:endParaRPr lang="en-US" dirty="0"/>
           </a:p>
@@ -1227,7 +1226,7 @@
           <a:p>
             <a:r>
               <a:rPr lang="en-US" dirty="0"/>
-              <a:t>(1 min) Honestidade sobre o estágio: o que está pronto e o que depende de decisões e de dados. Não há resultado empírico. O sorteio ainda não foi realizado; há decisões do pesquisador pendentes que o sorteio exige e a checagem do pool com candidatos reais. A cifra de acerto de atribuição, antes citada, segue em verificação.</a:t>
+              <a:t>(Consulta) Lista das referências que sustentam as decisões apresentadas, nos termos em que constam do registro de decisões. As marcadas com † tiveram a leitura e a conferência da fonte feitas no projeto; as demais constam do registro e aguardam conferência bibliográfica completa antes da dissertação.</a:t>
             </a:r>
             <a:endParaRPr lang="en-US" dirty="0"/>
           </a:p>
@@ -1251,94 +1250,6 @@
             <a:fld id="{F7021451-1387-4CA6-816F-3879F97B5CBC}" type="slidenum">
               <a:rPr lang="en-US"/>
               <a:t>14</a:t>
-            </a:fld>
-            <a:endParaRPr lang="en-US"/>
-          </a:p>
-        </p:txBody>
-      </p:sp>
-    </p:spTree>
-    <p:extLst>
-      <p:ext uri="{BB962C8B-B14F-4D97-AF65-F5344CB8AC3E}">
-        <p14:creationId xmlns:p14="http://schemas.microsoft.com/office/powerpoint/2010/main" val="1024086991"/>
-      </p:ext>
-    </p:extLst>
-  </p:cSld>
-  <p:clrMapOvr>
-    <a:masterClrMapping/>
-  </p:clrMapOvr>
-</p:notes>
-</file>
-
-<file path=ppt/notesSlides/notesSlide15.xml><?xml version="1.0" encoding="utf-8"?>
-<p:notes xmlns:a="http://schemas.openxmlformats.org/drawingml/2006/main" xmlns:r="http://schemas.openxmlformats.org/officeDocument/2006/relationships" xmlns:p="http://schemas.openxmlformats.org/presentationml/2006/main">
-  <p:cSld>
-    <p:spTree>
-      <p:nvGrpSpPr>
-        <p:cNvPr id="1" name=""/>
-        <p:cNvGrpSpPr/>
-        <p:nvPr/>
-      </p:nvGrpSpPr>
-      <p:grpSpPr>
-        <a:xfrm>
-          <a:off x="0" y="0"/>
-          <a:ext cx="0" cy="0"/>
-          <a:chOff x="0" y="0"/>
-          <a:chExt cx="0" cy="0"/>
-        </a:xfrm>
-      </p:grpSpPr>
-      <p:sp>
-        <p:nvSpPr>
-          <p:cNvPr id="2" name="Slide Image Placeholder 1"/>
-          <p:cNvSpPr>
-            <a:spLocks noGrp="1" noRot="1" noChangeAspect="1"/>
-          </p:cNvSpPr>
-          <p:nvPr>
-            <p:ph type="sldImg"/>
-          </p:nvPr>
-        </p:nvSpPr>
-        <p:spPr/>
-      </p:sp>
-      <p:sp>
-        <p:nvSpPr>
-          <p:cNvPr id="3" name="Notes Placeholder 2"/>
-          <p:cNvSpPr>
-            <a:spLocks noGrp="1"/>
-          </p:cNvSpPr>
-          <p:nvPr>
-            <p:ph type="body" idx="1"/>
-          </p:nvPr>
-        </p:nvSpPr>
-        <p:spPr/>
-        <p:txBody>
-          <a:bodyPr/>
-          <a:lstStyle/>
-          <a:p>
-            <a:r>
-              <a:rPr lang="en-US" dirty="0"/>
-              <a:t>(Consulta) Lista das referências que sustentam as decisões apresentadas, nos termos em que constam do registro de decisões. As marcadas com † tiveram a leitura e a conferência da fonte feitas no projeto; as demais constam do registro e aguardam conferência bibliográfica completa antes da dissertação.</a:t>
-            </a:r>
-            <a:endParaRPr lang="en-US" dirty="0"/>
-          </a:p>
-        </p:txBody>
-      </p:sp>
-      <p:sp>
-        <p:nvSpPr>
-          <p:cNvPr id="4" name="Slide Number Placeholder 3"/>
-          <p:cNvSpPr>
-            <a:spLocks noGrp="1"/>
-          </p:cNvSpPr>
-          <p:nvPr>
-            <p:ph type="sldNum" sz="quarter" idx="10"/>
-          </p:nvPr>
-        </p:nvSpPr>
-        <p:spPr/>
-        <p:txBody>
-          <a:bodyPr/>
-          <a:lstStyle/>
-          <a:p>
-            <a:fld id="{F7021451-1387-4CA6-816F-3879F97B5CBC}" type="slidenum">
-              <a:rPr lang="en-US"/>
-              <a:t>15</a:t>
             </a:fld>
             <a:endParaRPr lang="en-US"/>
           </a:p>
@@ -1843,7 +1754,7 @@
           <a:p>
             <a:r>
               <a:rPr lang="en-US" dirty="0"/>
-              <a:t>(1,5 min) Esta é a primeira dificuldade real. Numa medição preliminar de 29/09/2026 sobre 90 candidatos, só 5 estavam no nível de erodibilidade alta dentro da faixa de declividade do método. A extrapolação para os 593 imóveis do divisor de águas dava cerca de 33. Hoje o desenho pede 36 titulares nesse nível (9 estratos vezes 4), mais reservas. Atenção: é um indício, calculado sobre um artefato pequeno, e o pool real ainda não foi medido. Há uma ferramenta pronta para medir. A tentação de mover o limiar de erodibilidade para acomodar a amostra foi recusada: o limiar é físico e vem da fonte.</a:t>
+              <a:t>(1,5 min) Para voar é preciso autorização, e para pedir autorização o polígono tem de caber dentro de um só imóvel. Sobre os 73.643 imóveis rurais do envelope da bacia, com mediana de 11,7 ha, um quadrado de 10 ha cabia em apenas 43,4%. Ao reduzir para 5,02 ha, a elegibilidade sobe para 64,7%, e para 71,8% admitindo retângulo com razão até 1:2. Atenção: são limites superiores, pois o teste usa a caixa envolvente do imóvel. O custo foi dobrar as autorizações, de 36 para 72, e fica um viés declarado: amostras só em imóveis maiores, que tendem a ter outro manejo.</a:t>
             </a:r>
             <a:endParaRPr lang="en-US" dirty="0"/>
           </a:p>
@@ -1931,7 +1842,7 @@
           <a:p>
             <a:r>
               <a:rPr lang="en-US" dirty="0"/>
-              <a:t>(1,5 min) Para voar é preciso autorização, e para pedir autorização o polígono tem de caber dentro de um só imóvel. Sobre os 73.643 imóveis rurais do envelope da bacia, com mediana de 11,7 ha, um quadrado de 10 ha cabia em apenas 43,4%. Ao reduzir para 5,02 ha, a elegibilidade sobe para 64,7%, e para 71,8% admitindo retângulo com razão até 1:2. Atenção: são limites superiores, pois o teste usa a caixa envolvente do imóvel. O custo foi dobrar as autorizações, de 36 para 72, e fica um viés declarado: amostras só em imóveis maiores, que tendem a ter outro manejo.</a:t>
+              <a:t>(1,5 min) O sorteio registra semente, commit do código, hash do conjunto de candidatos e uma tabela reversa de códigos opacos, que fica fora do Git. Uma vez gerado, o selo não pode ser refeito, senão se poderia escolher o sorteio que favoreça o resultado. Mas e se o proprietário recusar? A proposta, ainda sem parâmetros decididos, é o mesmo selo trazer, por estrato, uma lista ordenada de reservas: a recusa aciona a próxima do mesmo estrato, que herda o papel de treino ou teste. A ferramenta de pool já existe; a parte das reservas está em implementação.</a:t>
             </a:r>
             <a:endParaRPr lang="en-US" dirty="0"/>
           </a:p>
@@ -2019,7 +1930,7 @@
           <a:p>
             <a:r>
               <a:rPr lang="en-US" dirty="0"/>
-              <a:t>(1,5 min) O sorteio registra semente, commit do código, hash do conjunto de candidatos e uma tabela reversa de códigos opacos, que fica fora do Git. Uma vez gerado, o selo não pode ser refeito, senão se poderia escolher o sorteio que favoreça o resultado. Mas e se o proprietário recusar? A proposta, ainda sem parâmetros decididos, é o mesmo selo trazer, por estrato, uma lista ordenada de reservas: a recusa aciona a próxima do mesmo estrato, que herda o papel de treino ou teste. A ferramenta de pool já existe; a parte das reservas está em implementação.</a:t>
+              <a:t>(1,5 min) Quantidade de voos: são 72 polígonos de 5,02 ha, ou seja, 72 missões de mapeamento, uma por polígono; eram 36 no desenho anterior. Elas não precisam ser 72 saídas: o planejador agrupa polígonos próximos em jornadas de campo, com teto padrão de 6 polígonos por jornada, ajustável, o que dá cerca de 12 jornadas. Esse agrupamento é uma proposta do planejador, ainda não validada em campo. Tempo de voo: a produtividade medida foi de 2,3 ha/min na Missão 009, o que dá cerca de 2,2 min por polígono; mas a única outra missão válida, a 000, teve 0,53 ha/min, o que dá cerca de 9,5 min. Com duas missões medidas, a faixa honesta é de 2 a 10 minutos por polígono, ou de 2,6 a 11 horas de voo no total, sem contar deslocamento. O que domina a campanha é deslocamento, montagem e as 72 autorizações. O número de baterias e de decolagens não está definido: depende da aeronave e do agrupamento, e não tenho esse dado. A tela mostra os três conjuntos da campanha.</a:t>
             </a:r>
             <a:endParaRPr lang="en-US" dirty="0"/>
           </a:p>
@@ -2686,7 +2597,7 @@
                 <a:ea typeface="Cambria" pitchFamily="34" charset="-122"/>
                 <a:cs typeface="Cambria" pitchFamily="34" charset="-120"/>
               </a:rPr>
-              <a:t>Dificuldade 3: quantos voos e quanto tempo</a:t>
+              <a:t>Voo cego, delineação e rótulo por fração</a:t>
             </a:r>
             <a:endParaRPr lang="en-US" sz="2200" dirty="0"/>
           </a:p>
@@ -2739,428 +2650,8 @@
         </p:nvSpPr>
         <p:spPr>
           <a:xfrm>
-            <a:off x="457200" y="1005840"/>
-            <a:ext cx="1920240" cy="1188720"/>
-          </a:xfrm>
-          <a:prstGeom prst="roundRect">
-            <a:avLst>
-              <a:gd name="adj" fmla="val 6154"/>
-            </a:avLst>
-          </a:prstGeom>
-          <a:solidFill>
-            <a:srgbClr val="EEF3EF"/>
-          </a:solidFill>
-          <a:ln w="12700">
-            <a:solidFill>
-              <a:srgbClr val="EEF3EF"/>
-            </a:solidFill>
-            <a:prstDash val="solid"/>
-          </a:ln>
-        </p:spPr>
-      </p:sp>
-      <p:sp>
-        <p:nvSpPr>
-          <p:cNvPr id="6" name="Text 3"/>
-          <p:cNvSpPr txBox="1"/>
-          <p:nvPr/>
-        </p:nvSpPr>
-        <p:spPr>
-          <a:xfrm>
-            <a:off x="457200" y="1115568"/>
-            <a:ext cx="1920240" cy="594360"/>
-          </a:xfrm>
-          <a:prstGeom prst="rect">
-            <a:avLst/>
-          </a:prstGeom>
-          <a:noFill/>
-          <a:ln/>
-        </p:spPr>
-        <p:txBody>
-          <a:bodyPr wrap="square" lIns="0" tIns="0" rIns="0" bIns="0" rtlCol="0" anchor="t"/>
-          <a:lstStyle/>
-          <a:p>
-            <a:pPr algn="ctr" indent="0" marL="0">
-              <a:buNone/>
-            </a:pPr>
-            <a:r>
-              <a:rPr lang="en-US" sz="2200" b="1" dirty="0">
-                <a:solidFill>
-                  <a:srgbClr val="C65D3B"/>
-                </a:solidFill>
-                <a:latin typeface="Cambria" pitchFamily="34" charset="0"/>
-                <a:ea typeface="Cambria" pitchFamily="34" charset="-122"/>
-                <a:cs typeface="Cambria" pitchFamily="34" charset="-120"/>
-              </a:rPr>
-              <a:t>72</a:t>
-            </a:r>
-            <a:endParaRPr lang="en-US" sz="2200" dirty="0"/>
-          </a:p>
-        </p:txBody>
-      </p:sp>
-      <p:sp>
-        <p:nvSpPr>
-          <p:cNvPr id="7" name="Text 4"/>
-          <p:cNvSpPr txBox="1"/>
-          <p:nvPr/>
-        </p:nvSpPr>
-        <p:spPr>
-          <a:xfrm>
-            <a:off x="548640" y="1719072"/>
-            <a:ext cx="1737360" cy="457200"/>
-          </a:xfrm>
-          <a:prstGeom prst="rect">
-            <a:avLst/>
-          </a:prstGeom>
-          <a:noFill/>
-          <a:ln/>
-        </p:spPr>
-        <p:txBody>
-          <a:bodyPr wrap="square" lIns="0" tIns="0" rIns="0" bIns="0" rtlCol="0" anchor="t"/>
-          <a:lstStyle/>
-          <a:p>
-            <a:pPr algn="ctr" indent="0" marL="0">
-              <a:buNone/>
-            </a:pPr>
-            <a:r>
-              <a:rPr lang="en-US" sz="1100" dirty="0">
-                <a:solidFill>
-                  <a:srgbClr val="52605A"/>
-                </a:solidFill>
-                <a:latin typeface="Calibri" pitchFamily="34" charset="0"/>
-                <a:ea typeface="Calibri" pitchFamily="34" charset="-122"/>
-                <a:cs typeface="Calibri" pitchFamily="34" charset="-120"/>
-              </a:rPr>
-              <a:t>missões de mapeamento, uma por polígono (eram 36)</a:t>
-            </a:r>
-            <a:endParaRPr lang="en-US" sz="1100" dirty="0"/>
-          </a:p>
-        </p:txBody>
-      </p:sp>
-      <p:sp>
-        <p:nvSpPr>
-          <p:cNvPr id="8" name="Shape 5"/>
-          <p:cNvSpPr/>
-          <p:nvPr/>
-        </p:nvSpPr>
-        <p:spPr>
-          <a:xfrm>
-            <a:off x="2514600" y="1005840"/>
-            <a:ext cx="1920240" cy="1188720"/>
-          </a:xfrm>
-          <a:prstGeom prst="roundRect">
-            <a:avLst>
-              <a:gd name="adj" fmla="val 6154"/>
-            </a:avLst>
-          </a:prstGeom>
-          <a:solidFill>
-            <a:srgbClr val="EEF3EF"/>
-          </a:solidFill>
-          <a:ln w="12700">
-            <a:solidFill>
-              <a:srgbClr val="EEF3EF"/>
-            </a:solidFill>
-            <a:prstDash val="solid"/>
-          </a:ln>
-        </p:spPr>
-      </p:sp>
-      <p:sp>
-        <p:nvSpPr>
-          <p:cNvPr id="9" name="Text 6"/>
-          <p:cNvSpPr txBox="1"/>
-          <p:nvPr/>
-        </p:nvSpPr>
-        <p:spPr>
-          <a:xfrm>
-            <a:off x="2514600" y="1115568"/>
-            <a:ext cx="1920240" cy="594360"/>
-          </a:xfrm>
-          <a:prstGeom prst="rect">
-            <a:avLst/>
-          </a:prstGeom>
-          <a:noFill/>
-          <a:ln/>
-        </p:spPr>
-        <p:txBody>
-          <a:bodyPr wrap="square" lIns="0" tIns="0" rIns="0" bIns="0" rtlCol="0" anchor="t"/>
-          <a:lstStyle/>
-          <a:p>
-            <a:pPr algn="ctr" indent="0" marL="0">
-              <a:buNone/>
-            </a:pPr>
-            <a:r>
-              <a:rPr lang="en-US" sz="2200" b="1" dirty="0">
-                <a:solidFill>
-                  <a:srgbClr val="2F6B4F"/>
-                </a:solidFill>
-                <a:latin typeface="Cambria" pitchFamily="34" charset="0"/>
-                <a:ea typeface="Cambria" pitchFamily="34" charset="-122"/>
-                <a:cs typeface="Cambria" pitchFamily="34" charset="-120"/>
-              </a:rPr>
-              <a:t>≈ 12</a:t>
-            </a:r>
-            <a:endParaRPr lang="en-US" sz="2200" dirty="0"/>
-          </a:p>
-        </p:txBody>
-      </p:sp>
-      <p:sp>
-        <p:nvSpPr>
-          <p:cNvPr id="10" name="Text 7"/>
-          <p:cNvSpPr txBox="1"/>
-          <p:nvPr/>
-        </p:nvSpPr>
-        <p:spPr>
-          <a:xfrm>
-            <a:off x="2606040" y="1719072"/>
-            <a:ext cx="1737360" cy="457200"/>
-          </a:xfrm>
-          <a:prstGeom prst="rect">
-            <a:avLst/>
-          </a:prstGeom>
-          <a:noFill/>
-          <a:ln/>
-        </p:spPr>
-        <p:txBody>
-          <a:bodyPr wrap="square" lIns="0" tIns="0" rIns="0" bIns="0" rtlCol="0" anchor="t"/>
-          <a:lstStyle/>
-          <a:p>
-            <a:pPr algn="ctr" indent="0" marL="0">
-              <a:buNone/>
-            </a:pPr>
-            <a:r>
-              <a:rPr lang="en-US" sz="1100" dirty="0">
-                <a:solidFill>
-                  <a:srgbClr val="52605A"/>
-                </a:solidFill>
-                <a:latin typeface="Calibri" pitchFamily="34" charset="0"/>
-                <a:ea typeface="Calibri" pitchFamily="34" charset="-122"/>
-                <a:cs typeface="Calibri" pitchFamily="34" charset="-120"/>
-              </a:rPr>
-              <a:t>jornadas de campo, com até 6 polígonos cada (proposta)</a:t>
-            </a:r>
-            <a:endParaRPr lang="en-US" sz="1100" dirty="0"/>
-          </a:p>
-        </p:txBody>
-      </p:sp>
-      <p:sp>
-        <p:nvSpPr>
-          <p:cNvPr id="11" name="Shape 8"/>
-          <p:cNvSpPr/>
-          <p:nvPr/>
-        </p:nvSpPr>
-        <p:spPr>
-          <a:xfrm>
-            <a:off x="4572000" y="1005840"/>
-            <a:ext cx="1920240" cy="1188720"/>
-          </a:xfrm>
-          <a:prstGeom prst="roundRect">
-            <a:avLst>
-              <a:gd name="adj" fmla="val 6154"/>
-            </a:avLst>
-          </a:prstGeom>
-          <a:solidFill>
-            <a:srgbClr val="EEF3EF"/>
-          </a:solidFill>
-          <a:ln w="12700">
-            <a:solidFill>
-              <a:srgbClr val="EEF3EF"/>
-            </a:solidFill>
-            <a:prstDash val="solid"/>
-          </a:ln>
-        </p:spPr>
-      </p:sp>
-      <p:sp>
-        <p:nvSpPr>
-          <p:cNvPr id="12" name="Text 9"/>
-          <p:cNvSpPr txBox="1"/>
-          <p:nvPr/>
-        </p:nvSpPr>
-        <p:spPr>
-          <a:xfrm>
-            <a:off x="4572000" y="1115568"/>
-            <a:ext cx="1920240" cy="594360"/>
-          </a:xfrm>
-          <a:prstGeom prst="rect">
-            <a:avLst/>
-          </a:prstGeom>
-          <a:noFill/>
-          <a:ln/>
-        </p:spPr>
-        <p:txBody>
-          <a:bodyPr wrap="square" lIns="0" tIns="0" rIns="0" bIns="0" rtlCol="0" anchor="t"/>
-          <a:lstStyle/>
-          <a:p>
-            <a:pPr algn="ctr" indent="0" marL="0">
-              <a:buNone/>
-            </a:pPr>
-            <a:r>
-              <a:rPr lang="en-US" sz="2200" b="1" dirty="0">
-                <a:solidFill>
-                  <a:srgbClr val="2F6B4F"/>
-                </a:solidFill>
-                <a:latin typeface="Cambria" pitchFamily="34" charset="0"/>
-                <a:ea typeface="Cambria" pitchFamily="34" charset="-122"/>
-                <a:cs typeface="Cambria" pitchFamily="34" charset="-120"/>
-              </a:rPr>
-              <a:t>2 a 10 min</a:t>
-            </a:r>
-            <a:endParaRPr lang="en-US" sz="2200" dirty="0"/>
-          </a:p>
-        </p:txBody>
-      </p:sp>
-      <p:sp>
-        <p:nvSpPr>
-          <p:cNvPr id="13" name="Text 10"/>
-          <p:cNvSpPr txBox="1"/>
-          <p:nvPr/>
-        </p:nvSpPr>
-        <p:spPr>
-          <a:xfrm>
-            <a:off x="4663440" y="1719072"/>
-            <a:ext cx="1737360" cy="457200"/>
-          </a:xfrm>
-          <a:prstGeom prst="rect">
-            <a:avLst/>
-          </a:prstGeom>
-          <a:noFill/>
-          <a:ln/>
-        </p:spPr>
-        <p:txBody>
-          <a:bodyPr wrap="square" lIns="0" tIns="0" rIns="0" bIns="0" rtlCol="0" anchor="t"/>
-          <a:lstStyle/>
-          <a:p>
-            <a:pPr algn="ctr" indent="0" marL="0">
-              <a:buNone/>
-            </a:pPr>
-            <a:r>
-              <a:rPr lang="en-US" sz="1100" dirty="0">
-                <a:solidFill>
-                  <a:srgbClr val="52605A"/>
-                </a:solidFill>
-                <a:latin typeface="Calibri" pitchFamily="34" charset="0"/>
-                <a:ea typeface="Calibri" pitchFamily="34" charset="-122"/>
-                <a:cs typeface="Calibri" pitchFamily="34" charset="-120"/>
-              </a:rPr>
-              <a:t>de voo por polígono (2,3 ha/min na Missão 009; 0,53 na 000)</a:t>
-            </a:r>
-            <a:endParaRPr lang="en-US" sz="1100" dirty="0"/>
-          </a:p>
-        </p:txBody>
-      </p:sp>
-      <p:sp>
-        <p:nvSpPr>
-          <p:cNvPr id="14" name="Shape 11"/>
-          <p:cNvSpPr/>
-          <p:nvPr/>
-        </p:nvSpPr>
-        <p:spPr>
-          <a:xfrm>
-            <a:off x="6629400" y="1005840"/>
-            <a:ext cx="2057400" cy="1188720"/>
-          </a:xfrm>
-          <a:prstGeom prst="roundRect">
-            <a:avLst>
-              <a:gd name="adj" fmla="val 6154"/>
-            </a:avLst>
-          </a:prstGeom>
-          <a:solidFill>
-            <a:srgbClr val="EEF3EF"/>
-          </a:solidFill>
-          <a:ln w="12700">
-            <a:solidFill>
-              <a:srgbClr val="EEF3EF"/>
-            </a:solidFill>
-            <a:prstDash val="solid"/>
-          </a:ln>
-        </p:spPr>
-      </p:sp>
-      <p:sp>
-        <p:nvSpPr>
-          <p:cNvPr id="15" name="Text 12"/>
-          <p:cNvSpPr txBox="1"/>
-          <p:nvPr/>
-        </p:nvSpPr>
-        <p:spPr>
-          <a:xfrm>
-            <a:off x="6629400" y="1115568"/>
-            <a:ext cx="2057400" cy="594360"/>
-          </a:xfrm>
-          <a:prstGeom prst="rect">
-            <a:avLst/>
-          </a:prstGeom>
-          <a:noFill/>
-          <a:ln/>
-        </p:spPr>
-        <p:txBody>
-          <a:bodyPr wrap="square" lIns="0" tIns="0" rIns="0" bIns="0" rtlCol="0" anchor="t"/>
-          <a:lstStyle/>
-          <a:p>
-            <a:pPr algn="ctr" indent="0" marL="0">
-              <a:buNone/>
-            </a:pPr>
-            <a:r>
-              <a:rPr lang="en-US" sz="2200" b="1" dirty="0">
-                <a:solidFill>
-                  <a:srgbClr val="C65D3B"/>
-                </a:solidFill>
-                <a:latin typeface="Cambria" pitchFamily="34" charset="0"/>
-                <a:ea typeface="Cambria" pitchFamily="34" charset="-122"/>
-                <a:cs typeface="Cambria" pitchFamily="34" charset="-120"/>
-              </a:rPr>
-              <a:t>72</a:t>
-            </a:r>
-            <a:endParaRPr lang="en-US" sz="2200" dirty="0"/>
-          </a:p>
-        </p:txBody>
-      </p:sp>
-      <p:sp>
-        <p:nvSpPr>
-          <p:cNvPr id="16" name="Text 13"/>
-          <p:cNvSpPr txBox="1"/>
-          <p:nvPr/>
-        </p:nvSpPr>
-        <p:spPr>
-          <a:xfrm>
-            <a:off x="6720840" y="1719072"/>
-            <a:ext cx="1874520" cy="457200"/>
-          </a:xfrm>
-          <a:prstGeom prst="rect">
-            <a:avLst/>
-          </a:prstGeom>
-          <a:noFill/>
-          <a:ln/>
-        </p:spPr>
-        <p:txBody>
-          <a:bodyPr wrap="square" lIns="0" tIns="0" rIns="0" bIns="0" rtlCol="0" anchor="t"/>
-          <a:lstStyle/>
-          <a:p>
-            <a:pPr algn="ctr" indent="0" marL="0">
-              <a:buNone/>
-            </a:pPr>
-            <a:r>
-              <a:rPr lang="en-US" sz="1100" dirty="0">
-                <a:solidFill>
-                  <a:srgbClr val="52605A"/>
-                </a:solidFill>
-                <a:latin typeface="Calibri" pitchFamily="34" charset="0"/>
-                <a:ea typeface="Calibri" pitchFamily="34" charset="-122"/>
-                <a:cs typeface="Calibri" pitchFamily="34" charset="-120"/>
-              </a:rPr>
-              <a:t>autorizações de proprietário</a:t>
-            </a:r>
-            <a:endParaRPr lang="en-US" sz="1100" dirty="0"/>
-          </a:p>
-        </p:txBody>
-      </p:sp>
-      <p:sp>
-        <p:nvSpPr>
-          <p:cNvPr id="17" name="Shape 14"/>
-          <p:cNvSpPr/>
-          <p:nvPr/>
-        </p:nvSpPr>
-        <p:spPr>
-          <a:xfrm>
-            <a:off x="1158736" y="2313432"/>
-            <a:ext cx="6826528" cy="1453896"/>
+            <a:off x="472440" y="987552"/>
+            <a:ext cx="8199120" cy="1225296"/>
           </a:xfrm>
           <a:prstGeom prst="rect">
             <a:avLst/>
@@ -3178,7 +2669,7 @@
       </p:sp>
       <p:pic>
         <p:nvPicPr>
-          <p:cNvPr id="18" name="Image 0" descr="img/camp_cards.png">    </p:cNvPr>
+          <p:cNvPr id="6" name="Image 0" descr="img/camp_topo.png">    </p:cNvPr>
           <p:cNvPicPr>
             <a:picLocks noChangeAspect="1"/>
           </p:cNvPicPr>
@@ -3192,8 +2683,8 @@
         </p:blipFill>
         <p:spPr>
           <a:xfrm>
-            <a:off x="1177024" y="2331720"/>
-            <a:ext cx="6789952" cy="1417320"/>
+            <a:off x="490728" y="1005840"/>
+            <a:ext cx="8162544" cy="1188720"/>
           </a:xfrm>
           <a:prstGeom prst="rect">
             <a:avLst/>
@@ -3202,14 +2693,14 @@
       </p:pic>
       <p:sp>
         <p:nvSpPr>
-          <p:cNvPr id="19" name="Text 15"/>
+          <p:cNvPr id="7" name="Text 3"/>
           <p:cNvSpPr txBox="1"/>
           <p:nvPr/>
         </p:nvSpPr>
         <p:spPr>
           <a:xfrm>
-            <a:off x="457200" y="3794760"/>
-            <a:ext cx="8229600" cy="914400"/>
+            <a:off x="457200" y="2423160"/>
+            <a:ext cx="8229600" cy="2194560"/>
           </a:xfrm>
           <a:prstGeom prst="rect">
             <a:avLst/>
@@ -3223,13 +2714,13 @@
           <a:p>
             <a:pPr marL="342900" indent="-342900">
               <a:spcAft>
-                <a:spcPts val="300"/>
+                <a:spcPts val="700"/>
               </a:spcAft>
               <a:buSzPct val="100000"/>
               <a:buChar char="•"/>
             </a:pPr>
             <a:r>
-              <a:rPr lang="en-US" sz="1100" dirty="0">
+              <a:rPr lang="en-US" sz="1300" dirty="0">
                 <a:solidFill>
                   <a:srgbClr val="1B2A22"/>
                 </a:solidFill>
@@ -3237,20 +2728,20 @@
                 <a:ea typeface="Calibri" pitchFamily="34" charset="-122"/>
                 <a:cs typeface="Calibri" pitchFamily="34" charset="-120"/>
               </a:rPr>
-              <a:t>Tempo total de voo: de 2,6 h a 11 h, sem contar o deslocamento, que domina a campanha</a:t>
-            </a:r>
-            <a:endParaRPr lang="en-US" sz="1100" dirty="0"/>
+              <a:t>Alvo primário: fração da célula de 10 m delineada como erodida, de 0 a 1 (D26); binário ≥ 0,25 é derivado</a:t>
+            </a:r>
+            <a:endParaRPr lang="en-US" sz="1300" dirty="0"/>
           </a:p>
           <a:p>
             <a:pPr marL="342900" indent="-342900">
               <a:spcAft>
-                <a:spcPts val="300"/>
+                <a:spcPts val="700"/>
               </a:spcAft>
               <a:buSzPct val="100000"/>
               <a:buChar char="•"/>
             </a:pPr>
             <a:r>
-              <a:rPr lang="en-US" sz="1100" dirty="0">
+              <a:rPr lang="en-US" sz="1300" dirty="0">
                 <a:solidFill>
                   <a:srgbClr val="1B2A22"/>
                 </a:solidFill>
@@ -3258,20 +2749,20 @@
                 <a:ea typeface="Calibri" pitchFamily="34" charset="-122"/>
                 <a:cs typeface="Calibri" pitchFamily="34" charset="-120"/>
               </a:rPr>
-              <a:t>Nº de baterias e de decolagens: ainda não definido; depende da aeronave e do agrupamento</a:t>
-            </a:r>
-            <a:endParaRPr lang="en-US" sz="1100" dirty="0"/>
+              <a:t>Intérprete cego: recebe só um código opaco, sem estrato nem papel (exportação cega por perfil)</a:t>
+            </a:r>
+            <a:endParaRPr lang="en-US" sz="1300" dirty="0"/>
           </a:p>
           <a:p>
             <a:pPr marL="342900" indent="-342900">
               <a:spcAft>
-                <a:spcPts val="300"/>
+                <a:spcPts val="700"/>
               </a:spcAft>
               <a:buSzPct val="100000"/>
               <a:buChar char="•"/>
             </a:pPr>
             <a:r>
-              <a:rPr lang="en-US" sz="1100" dirty="0">
+              <a:rPr lang="en-US" sz="1300" dirty="0">
                 <a:solidFill>
                   <a:srgbClr val="1B2A22"/>
                 </a:solidFill>
@@ -3279,15 +2770,36 @@
                 <a:ea typeface="Calibri" pitchFamily="34" charset="-122"/>
                 <a:cs typeface="Calibri" pitchFamily="34" charset="-120"/>
               </a:rPr>
-              <a:t>Base: 2 missões medidas (uma terceira foi excluída por ortomosaico degenerado); é uma faixa, não uma estimativa precisa</a:t>
-            </a:r>
-            <a:endParaRPr lang="en-US" sz="1100" dirty="0"/>
-          </a:p>
-        </p:txBody>
-      </p:sp>
-      <p:sp>
-        <p:nvSpPr>
-          <p:cNvPr id="20" name="Text 16"/>
+              <a:t>Polígonos sorteados pelos estratos biofísicos, nunca pelo rastreio espectral (evita circularidade)</a:t>
+            </a:r>
+            <a:endParaRPr lang="en-US" sz="1300" dirty="0"/>
+          </a:p>
+          <a:p>
+            <a:pPr marL="342900" indent="-342900">
+              <a:spcAft>
+                <a:spcPts val="700"/>
+              </a:spcAft>
+              <a:buSzPct val="100000"/>
+              <a:buChar char="•"/>
+            </a:pPr>
+            <a:r>
+              <a:rPr lang="en-US" sz="1300" dirty="0">
+                <a:solidFill>
+                  <a:srgbClr val="1B2A22"/>
+                </a:solidFill>
+                <a:latin typeface="Calibri" pitchFamily="34" charset="0"/>
+                <a:ea typeface="Calibri" pitchFamily="34" charset="-122"/>
+                <a:cs typeface="Calibri" pitchFamily="34" charset="-120"/>
+              </a:rPr>
+              <a:t>Planos de voo só com terreno real (Copernicus 30 m); os de demonstração são marcados como sintéticos e não voáveis</a:t>
+            </a:r>
+            <a:endParaRPr lang="en-US" sz="1300" dirty="0"/>
+          </a:p>
+        </p:txBody>
+      </p:sp>
+      <p:sp>
+        <p:nvSpPr>
+          <p:cNvPr id="8" name="Text 4"/>
           <p:cNvSpPr txBox="1"/>
           <p:nvPr/>
         </p:nvSpPr>
@@ -3318,7 +2830,7 @@
                 <a:ea typeface="Calibri" pitchFamily="34" charset="-122"/>
                 <a:cs typeface="Calibri" pitchFamily="34" charset="-120"/>
               </a:rPr>
-              <a:t>Fonte: D16; cobertura_voos.geojson (Missões 000 e 009); agrupamento: planejador de jornadas (teto padrão 6).</a:t>
+              <a:t>Refs.: D26, D16, D02; Altman &amp; Royston (2006) sobre dicotomizar variável contínua.</a:t>
             </a:r>
             <a:endParaRPr lang="en-US" sz="1000" dirty="0"/>
           </a:p>
@@ -3389,7 +2901,7 @@
                 <a:ea typeface="Cambria" pitchFamily="34" charset="-122"/>
                 <a:cs typeface="Cambria" pitchFamily="34" charset="-120"/>
               </a:rPr>
-              <a:t>Voo cego, delineação e rótulo por fração</a:t>
+              <a:t>Âncora de campo com o SAREL Coletor</a:t>
             </a:r>
             <a:endParaRPr lang="en-US" sz="2200" dirty="0"/>
           </a:p>
@@ -3442,57 +2954,323 @@
         </p:nvSpPr>
         <p:spPr>
           <a:xfrm>
-            <a:off x="472440" y="987552"/>
-            <a:ext cx="8199120" cy="1225296"/>
-          </a:xfrm>
-          <a:prstGeom prst="rect">
-            <a:avLst/>
+            <a:off x="457200" y="1097280"/>
+            <a:ext cx="2606040" cy="1828800"/>
+          </a:xfrm>
+          <a:prstGeom prst="roundRect">
+            <a:avLst>
+              <a:gd name="adj" fmla="val 4000"/>
+            </a:avLst>
           </a:prstGeom>
           <a:solidFill>
-            <a:srgbClr val="FFFFFF"/>
+            <a:srgbClr val="EEF3EF"/>
           </a:solidFill>
-          <a:ln w="9525">
+          <a:ln w="12700">
             <a:solidFill>
-              <a:srgbClr val="B8C4BC"/>
+              <a:srgbClr val="EEF3EF"/>
             </a:solidFill>
             <a:prstDash val="solid"/>
           </a:ln>
         </p:spPr>
       </p:sp>
-      <p:pic>
-        <p:nvPicPr>
-          <p:cNvPr id="6" name="Image 0" descr="img/camp_topo.png">    </p:cNvPr>
-          <p:cNvPicPr>
-            <a:picLocks noChangeAspect="1"/>
-          </p:cNvPicPr>
-          <p:nvPr/>
-        </p:nvPicPr>
-        <p:blipFill>
-          <a:blip r:embed="rId1"/>
-          <a:stretch>
-            <a:fillRect/>
-          </a:stretch>
-        </p:blipFill>
-        <p:spPr>
-          <a:xfrm>
-            <a:off x="490728" y="1005840"/>
-            <a:ext cx="8162544" cy="1188720"/>
+      <p:sp>
+        <p:nvSpPr>
+          <p:cNvPr id="6" name="Text 3"/>
+          <p:cNvSpPr txBox="1"/>
+          <p:nvPr/>
+        </p:nvSpPr>
+        <p:spPr>
+          <a:xfrm>
+            <a:off x="640080" y="1207008"/>
+            <a:ext cx="2240280" cy="457200"/>
           </a:xfrm>
           <a:prstGeom prst="rect">
             <a:avLst/>
           </a:prstGeom>
-        </p:spPr>
-      </p:pic>
-      <p:sp>
-        <p:nvSpPr>
-          <p:cNvPr id="7" name="Text 3"/>
+          <a:noFill/>
+          <a:ln/>
+        </p:spPr>
+        <p:txBody>
+          <a:bodyPr wrap="square" lIns="0" tIns="0" rIns="0" bIns="0" rtlCol="0" anchor="t"/>
+          <a:lstStyle/>
+          <a:p>
+            <a:pPr indent="0" marL="0">
+              <a:buNone/>
+            </a:pPr>
+            <a:r>
+              <a:rPr lang="en-US" sz="1700" b="1" dirty="0">
+                <a:solidFill>
+                  <a:srgbClr val="2F6B4F"/>
+                </a:solidFill>
+                <a:latin typeface="Cambria" pitchFamily="34" charset="0"/>
+                <a:ea typeface="Cambria" pitchFamily="34" charset="-122"/>
+                <a:cs typeface="Cambria" pitchFamily="34" charset="-120"/>
+              </a:rPr>
+              <a:t>60 a 80 pontos</a:t>
+            </a:r>
+            <a:endParaRPr lang="en-US" sz="1700" dirty="0"/>
+          </a:p>
+        </p:txBody>
+      </p:sp>
+      <p:sp>
+        <p:nvSpPr>
+          <p:cNvPr id="7" name="Text 4"/>
           <p:cNvSpPr txBox="1"/>
           <p:nvPr/>
         </p:nvSpPr>
         <p:spPr>
           <a:xfrm>
-            <a:off x="457200" y="2423160"/>
-            <a:ext cx="8229600" cy="2194560"/>
+            <a:off x="640080" y="1737360"/>
+            <a:ext cx="2240280" cy="1143000"/>
+          </a:xfrm>
+          <a:prstGeom prst="rect">
+            <a:avLst/>
+          </a:prstGeom>
+          <a:noFill/>
+          <a:ln/>
+        </p:spPr>
+        <p:txBody>
+          <a:bodyPr wrap="square" lIns="0" tIns="0" rIns="0" bIns="0" rtlCol="0" anchor="t"/>
+          <a:lstStyle/>
+          <a:p>
+            <a:pPr indent="0" marL="0">
+              <a:buNone/>
+            </a:pPr>
+            <a:r>
+              <a:rPr lang="en-US" sz="1300" dirty="0">
+                <a:solidFill>
+                  <a:srgbClr val="1B2A22"/>
+                </a:solidFill>
+                <a:latin typeface="Calibri" pitchFamily="34" charset="0"/>
+                <a:ea typeface="Calibri" pitchFamily="34" charset="-122"/>
+                <a:cs typeface="Calibri" pitchFamily="34" charset="-120"/>
+              </a:rPr>
+              <a:t>dispersos pela bacia, fora dos polígonos, com probabilidade de inclusão conhecida</a:t>
+            </a:r>
+            <a:endParaRPr lang="en-US" sz="1300" dirty="0"/>
+          </a:p>
+        </p:txBody>
+      </p:sp>
+      <p:sp>
+        <p:nvSpPr>
+          <p:cNvPr id="8" name="Shape 5"/>
+          <p:cNvSpPr/>
+          <p:nvPr/>
+        </p:nvSpPr>
+        <p:spPr>
+          <a:xfrm>
+            <a:off x="3246120" y="1097280"/>
+            <a:ext cx="2606040" cy="1828800"/>
+          </a:xfrm>
+          <a:prstGeom prst="roundRect">
+            <a:avLst>
+              <a:gd name="adj" fmla="val 4000"/>
+            </a:avLst>
+          </a:prstGeom>
+          <a:solidFill>
+            <a:srgbClr val="EEF3EF"/>
+          </a:solidFill>
+          <a:ln w="12700">
+            <a:solidFill>
+              <a:srgbClr val="EEF3EF"/>
+            </a:solidFill>
+            <a:prstDash val="solid"/>
+          </a:ln>
+        </p:spPr>
+      </p:sp>
+      <p:sp>
+        <p:nvSpPr>
+          <p:cNvPr id="9" name="Text 6"/>
+          <p:cNvSpPr txBox="1"/>
+          <p:nvPr/>
+        </p:nvSpPr>
+        <p:spPr>
+          <a:xfrm>
+            <a:off x="3429000" y="1207008"/>
+            <a:ext cx="2240280" cy="457200"/>
+          </a:xfrm>
+          <a:prstGeom prst="rect">
+            <a:avLst/>
+          </a:prstGeom>
+          <a:noFill/>
+          <a:ln/>
+        </p:spPr>
+        <p:txBody>
+          <a:bodyPr wrap="square" lIns="0" tIns="0" rIns="0" bIns="0" rtlCol="0" anchor="t"/>
+          <a:lstStyle/>
+          <a:p>
+            <a:pPr indent="0" marL="0">
+              <a:buNone/>
+            </a:pPr>
+            <a:r>
+              <a:rPr lang="en-US" sz="1700" b="1" dirty="0">
+                <a:solidFill>
+                  <a:srgbClr val="2F6B4F"/>
+                </a:solidFill>
+                <a:latin typeface="Cambria" pitchFamily="34" charset="0"/>
+                <a:ea typeface="Cambria" pitchFamily="34" charset="-122"/>
+                <a:cs typeface="Cambria" pitchFamily="34" charset="-120"/>
+              </a:rPr>
+              <a:t>2 ondas</a:t>
+            </a:r>
+            <a:endParaRPr lang="en-US" sz="1700" dirty="0"/>
+          </a:p>
+        </p:txBody>
+      </p:sp>
+      <p:sp>
+        <p:nvSpPr>
+          <p:cNvPr id="10" name="Text 7"/>
+          <p:cNvSpPr txBox="1"/>
+          <p:nvPr/>
+        </p:nvSpPr>
+        <p:spPr>
+          <a:xfrm>
+            <a:off x="3429000" y="1737360"/>
+            <a:ext cx="2240280" cy="1143000"/>
+          </a:xfrm>
+          <a:prstGeom prst="rect">
+            <a:avLst/>
+          </a:prstGeom>
+          <a:noFill/>
+          <a:ln/>
+        </p:spPr>
+        <p:txBody>
+          <a:bodyPr wrap="square" lIns="0" tIns="0" rIns="0" bIns="0" rtlCol="0" anchor="t"/>
+          <a:lstStyle/>
+          <a:p>
+            <a:pPr indent="0" marL="0">
+              <a:buNone/>
+            </a:pPr>
+            <a:r>
+              <a:rPr lang="en-US" sz="1300" dirty="0">
+                <a:solidFill>
+                  <a:srgbClr val="1B2A22"/>
+                </a:solidFill>
+                <a:latin typeface="Calibri" pitchFamily="34" charset="0"/>
+                <a:ea typeface="Calibri" pitchFamily="34" charset="-122"/>
+                <a:cs typeface="Calibri" pitchFamily="34" charset="-120"/>
+              </a:rPr>
+              <a:t>os 30 primeiros pontos são lote piloto: validam o protocolo e medem a acurácia do aparelho</a:t>
+            </a:r>
+            <a:endParaRPr lang="en-US" sz="1300" dirty="0"/>
+          </a:p>
+        </p:txBody>
+      </p:sp>
+      <p:sp>
+        <p:nvSpPr>
+          <p:cNvPr id="11" name="Shape 8"/>
+          <p:cNvSpPr/>
+          <p:nvPr/>
+        </p:nvSpPr>
+        <p:spPr>
+          <a:xfrm>
+            <a:off x="6035040" y="1097280"/>
+            <a:ext cx="2606040" cy="1828800"/>
+          </a:xfrm>
+          <a:prstGeom prst="roundRect">
+            <a:avLst>
+              <a:gd name="adj" fmla="val 4000"/>
+            </a:avLst>
+          </a:prstGeom>
+          <a:solidFill>
+            <a:srgbClr val="EEF3EF"/>
+          </a:solidFill>
+          <a:ln w="12700">
+            <a:solidFill>
+              <a:srgbClr val="EEF3EF"/>
+            </a:solidFill>
+            <a:prstDash val="solid"/>
+          </a:ln>
+        </p:spPr>
+      </p:sp>
+      <p:sp>
+        <p:nvSpPr>
+          <p:cNvPr id="12" name="Text 9"/>
+          <p:cNvSpPr txBox="1"/>
+          <p:nvPr/>
+        </p:nvSpPr>
+        <p:spPr>
+          <a:xfrm>
+            <a:off x="6217920" y="1207008"/>
+            <a:ext cx="2240280" cy="457200"/>
+          </a:xfrm>
+          <a:prstGeom prst="rect">
+            <a:avLst/>
+          </a:prstGeom>
+          <a:noFill/>
+          <a:ln/>
+        </p:spPr>
+        <p:txBody>
+          <a:bodyPr wrap="square" lIns="0" tIns="0" rIns="0" bIns="0" rtlCol="0" anchor="t"/>
+          <a:lstStyle/>
+          <a:p>
+            <a:pPr indent="0" marL="0">
+              <a:buNone/>
+            </a:pPr>
+            <a:r>
+              <a:rPr lang="en-US" sz="1700" b="1" dirty="0">
+                <a:solidFill>
+                  <a:srgbClr val="2F6B4F"/>
+                </a:solidFill>
+                <a:latin typeface="Cambria" pitchFamily="34" charset="0"/>
+                <a:ea typeface="Cambria" pitchFamily="34" charset="-122"/>
+                <a:cs typeface="Cambria" pitchFamily="34" charset="-120"/>
+              </a:rPr>
+              <a:t>Função</a:t>
+            </a:r>
+            <a:endParaRPr lang="en-US" sz="1700" dirty="0"/>
+          </a:p>
+        </p:txBody>
+      </p:sp>
+      <p:sp>
+        <p:nvSpPr>
+          <p:cNvPr id="13" name="Text 10"/>
+          <p:cNvSpPr txBox="1"/>
+          <p:nvPr/>
+        </p:nvSpPr>
+        <p:spPr>
+          <a:xfrm>
+            <a:off x="6217920" y="1737360"/>
+            <a:ext cx="2240280" cy="1143000"/>
+          </a:xfrm>
+          <a:prstGeom prst="rect">
+            <a:avLst/>
+          </a:prstGeom>
+          <a:noFill/>
+          <a:ln/>
+        </p:spPr>
+        <p:txBody>
+          <a:bodyPr wrap="square" lIns="0" tIns="0" rIns="0" bIns="0" rtlCol="0" anchor="t"/>
+          <a:lstStyle/>
+          <a:p>
+            <a:pPr indent="0" marL="0">
+              <a:buNone/>
+            </a:pPr>
+            <a:r>
+              <a:rPr lang="en-US" sz="1300" dirty="0">
+                <a:solidFill>
+                  <a:srgbClr val="1B2A22"/>
+                </a:solidFill>
+                <a:latin typeface="Calibri" pitchFamily="34" charset="0"/>
+                <a:ea typeface="Calibri" pitchFamily="34" charset="-122"/>
+                <a:cs typeface="Calibri" pitchFamily="34" charset="-120"/>
+              </a:rPr>
+              <a:t>estimar a prevalência real e calibrar a posição; não é para treinar o modelo</a:t>
+            </a:r>
+            <a:endParaRPr lang="en-US" sz="1300" dirty="0"/>
+          </a:p>
+        </p:txBody>
+      </p:sp>
+      <p:sp>
+        <p:nvSpPr>
+          <p:cNvPr id="14" name="Text 11"/>
+          <p:cNvSpPr txBox="1"/>
+          <p:nvPr/>
+        </p:nvSpPr>
+        <p:spPr>
+          <a:xfrm>
+            <a:off x="457200" y="3154680"/>
+            <a:ext cx="8229600" cy="1463040"/>
           </a:xfrm>
           <a:prstGeom prst="rect">
             <a:avLst/>
@@ -3520,7 +3298,7 @@
                 <a:ea typeface="Calibri" pitchFamily="34" charset="-122"/>
                 <a:cs typeface="Calibri" pitchFamily="34" charset="-120"/>
               </a:rPr>
-              <a:t>Alvo primário: fração da célula de 10 m delineada como erodida, de 0 a 1 (D26); binário ≥ 0,25 é derivado</a:t>
+              <a:t>Instrumento: SAREL Coletor (Android), em substituição ao KoboCollect</a:t>
             </a:r>
             <a:endParaRPr lang="en-US" sz="1300" dirty="0"/>
           </a:p>
@@ -3541,7 +3319,7 @@
                 <a:ea typeface="Calibri" pitchFamily="34" charset="-122"/>
                 <a:cs typeface="Calibri" pitchFamily="34" charset="-120"/>
               </a:rPr>
-              <a:t>Intérprete cego: recebe só um código opaco, sem estrato nem papel (exportação cega por perfil)</a:t>
+              <a:t>Fotointerpretação (Fase A) aposentada: o rótulo centimétrico do voo é mais fiel à mancha contínua da erosão</a:t>
             </a:r>
             <a:endParaRPr lang="en-US" sz="1300" dirty="0"/>
           </a:p>
@@ -3562,36 +3340,15 @@
                 <a:ea typeface="Calibri" pitchFamily="34" charset="-122"/>
                 <a:cs typeface="Calibri" pitchFamily="34" charset="-120"/>
               </a:rPr>
-              <a:t>Polígonos sorteados pelos estratos biofísicos, nunca pelo rastreio espectral (evita circularidade)</a:t>
+              <a:t>Estimador ponderado pela probabilidade de inclusão (Horvitz-Thompson)</a:t>
             </a:r>
             <a:endParaRPr lang="en-US" sz="1300" dirty="0"/>
           </a:p>
-          <a:p>
-            <a:pPr marL="342900" indent="-342900">
-              <a:spcAft>
-                <a:spcPts val="700"/>
-              </a:spcAft>
-              <a:buSzPct val="100000"/>
-              <a:buChar char="•"/>
-            </a:pPr>
-            <a:r>
-              <a:rPr lang="en-US" sz="1300" dirty="0">
-                <a:solidFill>
-                  <a:srgbClr val="1B2A22"/>
-                </a:solidFill>
-                <a:latin typeface="Calibri" pitchFamily="34" charset="0"/>
-                <a:ea typeface="Calibri" pitchFamily="34" charset="-122"/>
-                <a:cs typeface="Calibri" pitchFamily="34" charset="-120"/>
-              </a:rPr>
-              <a:t>Planos de voo só com terreno real (Copernicus 30 m); os de demonstração são marcados como sintéticos e não voáveis</a:t>
-            </a:r>
-            <a:endParaRPr lang="en-US" sz="1300" dirty="0"/>
-          </a:p>
-        </p:txBody>
-      </p:sp>
-      <p:sp>
-        <p:nvSpPr>
-          <p:cNvPr id="8" name="Text 4"/>
+        </p:txBody>
+      </p:sp>
+      <p:sp>
+        <p:nvSpPr>
+          <p:cNvPr id="15" name="Text 12"/>
           <p:cNvSpPr txBox="1"/>
           <p:nvPr/>
         </p:nvSpPr>
@@ -3622,7 +3379,7 @@
                 <a:ea typeface="Calibri" pitchFamily="34" charset="-122"/>
                 <a:cs typeface="Calibri" pitchFamily="34" charset="-120"/>
               </a:rPr>
-              <a:t>Refs.: D26, D16, D02; Altman &amp; Royston (2006) sobre dicotomizar variável contínua.</a:t>
+              <a:t>Refs.: D16, D23; Olofsson et al. (2014), amostragem e estimativa de área em sensoriamento remoto.</a:t>
             </a:r>
             <a:endParaRPr lang="en-US" sz="1000" dirty="0"/>
           </a:p>
@@ -3693,7 +3450,7 @@
                 <a:ea typeface="Cambria" pitchFamily="34" charset="-122"/>
                 <a:cs typeface="Cambria" pitchFamily="34" charset="-120"/>
               </a:rPr>
-              <a:t>Âncora de campo com o SAREL Coletor</a:t>
+              <a:t>Avaliação única, com o critério fixado antes</a:t>
             </a:r>
             <a:endParaRPr lang="en-US" sz="2200" dirty="0"/>
           </a:p>
@@ -3746,323 +3503,57 @@
         </p:nvSpPr>
         <p:spPr>
           <a:xfrm>
-            <a:off x="457200" y="1097280"/>
-            <a:ext cx="2606040" cy="1828800"/>
-          </a:xfrm>
-          <a:prstGeom prst="roundRect">
-            <a:avLst>
-              <a:gd name="adj" fmla="val 4000"/>
-            </a:avLst>
+            <a:off x="438912" y="941832"/>
+            <a:ext cx="3831336" cy="3310816"/>
+          </a:xfrm>
+          <a:prstGeom prst="rect">
+            <a:avLst/>
           </a:prstGeom>
           <a:solidFill>
-            <a:srgbClr val="EEF3EF"/>
+            <a:srgbClr val="FFFFFF"/>
           </a:solidFill>
-          <a:ln w="12700">
+          <a:ln w="9525">
             <a:solidFill>
-              <a:srgbClr val="EEF3EF"/>
+              <a:srgbClr val="B8C4BC"/>
             </a:solidFill>
             <a:prstDash val="solid"/>
           </a:ln>
         </p:spPr>
       </p:sp>
-      <p:sp>
-        <p:nvSpPr>
-          <p:cNvPr id="6" name="Text 3"/>
-          <p:cNvSpPr txBox="1"/>
-          <p:nvPr/>
-        </p:nvSpPr>
-        <p:spPr>
-          <a:xfrm>
-            <a:off x="640080" y="1207008"/>
-            <a:ext cx="2240280" cy="457200"/>
+      <p:pic>
+        <p:nvPicPr>
+          <p:cNvPr id="6" name="Image 0" descr="img/decisoes.png">    </p:cNvPr>
+          <p:cNvPicPr>
+            <a:picLocks noChangeAspect="1"/>
+          </p:cNvPicPr>
+          <p:nvPr/>
+        </p:nvPicPr>
+        <p:blipFill>
+          <a:blip r:embed="rId1"/>
+          <a:stretch>
+            <a:fillRect/>
+          </a:stretch>
+        </p:blipFill>
+        <p:spPr>
+          <a:xfrm>
+            <a:off x="457200" y="960120"/>
+            <a:ext cx="3794760" cy="3274240"/>
           </a:xfrm>
           <a:prstGeom prst="rect">
             <a:avLst/>
           </a:prstGeom>
-          <a:noFill/>
-          <a:ln/>
-        </p:spPr>
-        <p:txBody>
-          <a:bodyPr wrap="square" lIns="0" tIns="0" rIns="0" bIns="0" rtlCol="0" anchor="t"/>
-          <a:lstStyle/>
-          <a:p>
-            <a:pPr indent="0" marL="0">
-              <a:buNone/>
-            </a:pPr>
-            <a:r>
-              <a:rPr lang="en-US" sz="1700" b="1" dirty="0">
-                <a:solidFill>
-                  <a:srgbClr val="2F6B4F"/>
-                </a:solidFill>
-                <a:latin typeface="Cambria" pitchFamily="34" charset="0"/>
-                <a:ea typeface="Cambria" pitchFamily="34" charset="-122"/>
-                <a:cs typeface="Cambria" pitchFamily="34" charset="-120"/>
-              </a:rPr>
-              <a:t>60 a 80 pontos</a:t>
-            </a:r>
-            <a:endParaRPr lang="en-US" sz="1700" dirty="0"/>
-          </a:p>
-        </p:txBody>
-      </p:sp>
-      <p:sp>
-        <p:nvSpPr>
-          <p:cNvPr id="7" name="Text 4"/>
+        </p:spPr>
+      </p:pic>
+      <p:sp>
+        <p:nvSpPr>
+          <p:cNvPr id="7" name="Text 3"/>
           <p:cNvSpPr txBox="1"/>
           <p:nvPr/>
         </p:nvSpPr>
         <p:spPr>
           <a:xfrm>
-            <a:off x="640080" y="1737360"/>
-            <a:ext cx="2240280" cy="1143000"/>
-          </a:xfrm>
-          <a:prstGeom prst="rect">
-            <a:avLst/>
-          </a:prstGeom>
-          <a:noFill/>
-          <a:ln/>
-        </p:spPr>
-        <p:txBody>
-          <a:bodyPr wrap="square" lIns="0" tIns="0" rIns="0" bIns="0" rtlCol="0" anchor="t"/>
-          <a:lstStyle/>
-          <a:p>
-            <a:pPr indent="0" marL="0">
-              <a:buNone/>
-            </a:pPr>
-            <a:r>
-              <a:rPr lang="en-US" sz="1300" dirty="0">
-                <a:solidFill>
-                  <a:srgbClr val="1B2A22"/>
-                </a:solidFill>
-                <a:latin typeface="Calibri" pitchFamily="34" charset="0"/>
-                <a:ea typeface="Calibri" pitchFamily="34" charset="-122"/>
-                <a:cs typeface="Calibri" pitchFamily="34" charset="-120"/>
-              </a:rPr>
-              <a:t>dispersos pela bacia, fora dos polígonos, com probabilidade de inclusão conhecida</a:t>
-            </a:r>
-            <a:endParaRPr lang="en-US" sz="1300" dirty="0"/>
-          </a:p>
-        </p:txBody>
-      </p:sp>
-      <p:sp>
-        <p:nvSpPr>
-          <p:cNvPr id="8" name="Shape 5"/>
-          <p:cNvSpPr/>
-          <p:nvPr/>
-        </p:nvSpPr>
-        <p:spPr>
-          <a:xfrm>
-            <a:off x="3246120" y="1097280"/>
-            <a:ext cx="2606040" cy="1828800"/>
-          </a:xfrm>
-          <a:prstGeom prst="roundRect">
-            <a:avLst>
-              <a:gd name="adj" fmla="val 4000"/>
-            </a:avLst>
-          </a:prstGeom>
-          <a:solidFill>
-            <a:srgbClr val="EEF3EF"/>
-          </a:solidFill>
-          <a:ln w="12700">
-            <a:solidFill>
-              <a:srgbClr val="EEF3EF"/>
-            </a:solidFill>
-            <a:prstDash val="solid"/>
-          </a:ln>
-        </p:spPr>
-      </p:sp>
-      <p:sp>
-        <p:nvSpPr>
-          <p:cNvPr id="9" name="Text 6"/>
-          <p:cNvSpPr txBox="1"/>
-          <p:nvPr/>
-        </p:nvSpPr>
-        <p:spPr>
-          <a:xfrm>
-            <a:off x="3429000" y="1207008"/>
-            <a:ext cx="2240280" cy="457200"/>
-          </a:xfrm>
-          <a:prstGeom prst="rect">
-            <a:avLst/>
-          </a:prstGeom>
-          <a:noFill/>
-          <a:ln/>
-        </p:spPr>
-        <p:txBody>
-          <a:bodyPr wrap="square" lIns="0" tIns="0" rIns="0" bIns="0" rtlCol="0" anchor="t"/>
-          <a:lstStyle/>
-          <a:p>
-            <a:pPr indent="0" marL="0">
-              <a:buNone/>
-            </a:pPr>
-            <a:r>
-              <a:rPr lang="en-US" sz="1700" b="1" dirty="0">
-                <a:solidFill>
-                  <a:srgbClr val="2F6B4F"/>
-                </a:solidFill>
-                <a:latin typeface="Cambria" pitchFamily="34" charset="0"/>
-                <a:ea typeface="Cambria" pitchFamily="34" charset="-122"/>
-                <a:cs typeface="Cambria" pitchFamily="34" charset="-120"/>
-              </a:rPr>
-              <a:t>2 ondas</a:t>
-            </a:r>
-            <a:endParaRPr lang="en-US" sz="1700" dirty="0"/>
-          </a:p>
-        </p:txBody>
-      </p:sp>
-      <p:sp>
-        <p:nvSpPr>
-          <p:cNvPr id="10" name="Text 7"/>
-          <p:cNvSpPr txBox="1"/>
-          <p:nvPr/>
-        </p:nvSpPr>
-        <p:spPr>
-          <a:xfrm>
-            <a:off x="3429000" y="1737360"/>
-            <a:ext cx="2240280" cy="1143000"/>
-          </a:xfrm>
-          <a:prstGeom prst="rect">
-            <a:avLst/>
-          </a:prstGeom>
-          <a:noFill/>
-          <a:ln/>
-        </p:spPr>
-        <p:txBody>
-          <a:bodyPr wrap="square" lIns="0" tIns="0" rIns="0" bIns="0" rtlCol="0" anchor="t"/>
-          <a:lstStyle/>
-          <a:p>
-            <a:pPr indent="0" marL="0">
-              <a:buNone/>
-            </a:pPr>
-            <a:r>
-              <a:rPr lang="en-US" sz="1300" dirty="0">
-                <a:solidFill>
-                  <a:srgbClr val="1B2A22"/>
-                </a:solidFill>
-                <a:latin typeface="Calibri" pitchFamily="34" charset="0"/>
-                <a:ea typeface="Calibri" pitchFamily="34" charset="-122"/>
-                <a:cs typeface="Calibri" pitchFamily="34" charset="-120"/>
-              </a:rPr>
-              <a:t>os 30 primeiros pontos são lote piloto: validam o protocolo e medem a acurácia do aparelho</a:t>
-            </a:r>
-            <a:endParaRPr lang="en-US" sz="1300" dirty="0"/>
-          </a:p>
-        </p:txBody>
-      </p:sp>
-      <p:sp>
-        <p:nvSpPr>
-          <p:cNvPr id="11" name="Shape 8"/>
-          <p:cNvSpPr/>
-          <p:nvPr/>
-        </p:nvSpPr>
-        <p:spPr>
-          <a:xfrm>
-            <a:off x="6035040" y="1097280"/>
-            <a:ext cx="2606040" cy="1828800"/>
-          </a:xfrm>
-          <a:prstGeom prst="roundRect">
-            <a:avLst>
-              <a:gd name="adj" fmla="val 4000"/>
-            </a:avLst>
-          </a:prstGeom>
-          <a:solidFill>
-            <a:srgbClr val="EEF3EF"/>
-          </a:solidFill>
-          <a:ln w="12700">
-            <a:solidFill>
-              <a:srgbClr val="EEF3EF"/>
-            </a:solidFill>
-            <a:prstDash val="solid"/>
-          </a:ln>
-        </p:spPr>
-      </p:sp>
-      <p:sp>
-        <p:nvSpPr>
-          <p:cNvPr id="12" name="Text 9"/>
-          <p:cNvSpPr txBox="1"/>
-          <p:nvPr/>
-        </p:nvSpPr>
-        <p:spPr>
-          <a:xfrm>
-            <a:off x="6217920" y="1207008"/>
-            <a:ext cx="2240280" cy="457200"/>
-          </a:xfrm>
-          <a:prstGeom prst="rect">
-            <a:avLst/>
-          </a:prstGeom>
-          <a:noFill/>
-          <a:ln/>
-        </p:spPr>
-        <p:txBody>
-          <a:bodyPr wrap="square" lIns="0" tIns="0" rIns="0" bIns="0" rtlCol="0" anchor="t"/>
-          <a:lstStyle/>
-          <a:p>
-            <a:pPr indent="0" marL="0">
-              <a:buNone/>
-            </a:pPr>
-            <a:r>
-              <a:rPr lang="en-US" sz="1700" b="1" dirty="0">
-                <a:solidFill>
-                  <a:srgbClr val="2F6B4F"/>
-                </a:solidFill>
-                <a:latin typeface="Cambria" pitchFamily="34" charset="0"/>
-                <a:ea typeface="Cambria" pitchFamily="34" charset="-122"/>
-                <a:cs typeface="Cambria" pitchFamily="34" charset="-120"/>
-              </a:rPr>
-              <a:t>Função</a:t>
-            </a:r>
-            <a:endParaRPr lang="en-US" sz="1700" dirty="0"/>
-          </a:p>
-        </p:txBody>
-      </p:sp>
-      <p:sp>
-        <p:nvSpPr>
-          <p:cNvPr id="13" name="Text 10"/>
-          <p:cNvSpPr txBox="1"/>
-          <p:nvPr/>
-        </p:nvSpPr>
-        <p:spPr>
-          <a:xfrm>
-            <a:off x="6217920" y="1737360"/>
-            <a:ext cx="2240280" cy="1143000"/>
-          </a:xfrm>
-          <a:prstGeom prst="rect">
-            <a:avLst/>
-          </a:prstGeom>
-          <a:noFill/>
-          <a:ln/>
-        </p:spPr>
-        <p:txBody>
-          <a:bodyPr wrap="square" lIns="0" tIns="0" rIns="0" bIns="0" rtlCol="0" anchor="t"/>
-          <a:lstStyle/>
-          <a:p>
-            <a:pPr indent="0" marL="0">
-              <a:buNone/>
-            </a:pPr>
-            <a:r>
-              <a:rPr lang="en-US" sz="1300" dirty="0">
-                <a:solidFill>
-                  <a:srgbClr val="1B2A22"/>
-                </a:solidFill>
-                <a:latin typeface="Calibri" pitchFamily="34" charset="0"/>
-                <a:ea typeface="Calibri" pitchFamily="34" charset="-122"/>
-                <a:cs typeface="Calibri" pitchFamily="34" charset="-120"/>
-              </a:rPr>
-              <a:t>estimar a prevalência real e calibrar a posição; não é para treinar o modelo</a:t>
-            </a:r>
-            <a:endParaRPr lang="en-US" sz="1300" dirty="0"/>
-          </a:p>
-        </p:txBody>
-      </p:sp>
-      <p:sp>
-        <p:nvSpPr>
-          <p:cNvPr id="14" name="Text 11"/>
-          <p:cNvSpPr txBox="1"/>
-          <p:nvPr/>
-        </p:nvSpPr>
-        <p:spPr>
-          <a:xfrm>
-            <a:off x="457200" y="3154680"/>
-            <a:ext cx="8229600" cy="1463040"/>
+            <a:off x="4526280" y="1051560"/>
+            <a:ext cx="4251960" cy="3566160"/>
           </a:xfrm>
           <a:prstGeom prst="rect">
             <a:avLst/>
@@ -4082,7 +3573,7 @@
               <a:buChar char="•"/>
             </a:pPr>
             <a:r>
-              <a:rPr lang="en-US" sz="1300" dirty="0">
+              <a:rPr lang="en-US" sz="1250" dirty="0">
                 <a:solidFill>
                   <a:srgbClr val="1B2A22"/>
                 </a:solidFill>
@@ -4090,9 +3581,9 @@
                 <a:ea typeface="Calibri" pitchFamily="34" charset="-122"/>
                 <a:cs typeface="Calibri" pitchFamily="34" charset="-120"/>
               </a:rPr>
-              <a:t>Instrumento: SAREL Coletor (Android), em substituição ao KoboCollect</a:t>
-            </a:r>
-            <a:endParaRPr lang="en-US" sz="1300" dirty="0"/>
+              <a:t>Competidores: linha de base RUSLE, regressão penalizada e XGBoost (perda Tweedie)</a:t>
+            </a:r>
+            <a:endParaRPr lang="en-US" sz="1250" dirty="0"/>
           </a:p>
           <a:p>
             <a:pPr marL="342900" indent="-342900">
@@ -4103,7 +3594,7 @@
               <a:buChar char="•"/>
             </a:pPr>
             <a:r>
-              <a:rPr lang="en-US" sz="1300" dirty="0">
+              <a:rPr lang="en-US" sz="1250" dirty="0">
                 <a:solidFill>
                   <a:srgbClr val="1B2A22"/>
                 </a:solidFill>
@@ -4111,9 +3602,9 @@
                 <a:ea typeface="Calibri" pitchFamily="34" charset="-122"/>
                 <a:cs typeface="Calibri" pitchFamily="34" charset="-120"/>
               </a:rPr>
-              <a:t>Fotointerpretação (Fase A) aposentada: o rótulo centimétrico do voo é mais fiel à mancha contínua da erosão</a:t>
-            </a:r>
-            <a:endParaRPr lang="en-US" sz="1300" dirty="0"/>
+              <a:t>Métrica primária: Spearman no held-out; piso 0,40 e margem 0,10 sobre a RUSLE</a:t>
+            </a:r>
+            <a:endParaRPr lang="en-US" sz="1250" dirty="0"/>
           </a:p>
           <a:p>
             <a:pPr marL="342900" indent="-342900">
@@ -4124,7 +3615,7 @@
               <a:buChar char="•"/>
             </a:pPr>
             <a:r>
-              <a:rPr lang="en-US" sz="1300" dirty="0">
+              <a:rPr lang="en-US" sz="1250" dirty="0">
                 <a:solidFill>
                   <a:srgbClr val="1B2A22"/>
                 </a:solidFill>
@@ -4132,15 +3623,57 @@
                 <a:ea typeface="Calibri" pitchFamily="34" charset="-122"/>
                 <a:cs typeface="Calibri" pitchFamily="34" charset="-120"/>
               </a:rPr>
-              <a:t>Estimador ponderado pela probabilidade de inclusão (Horvitz-Thompson)</a:t>
-            </a:r>
-            <a:endParaRPr lang="en-US" sz="1300" dirty="0"/>
-          </a:p>
-        </p:txBody>
-      </p:sp>
-      <p:sp>
-        <p:nvSpPr>
-          <p:cNvPr id="15" name="Text 12"/>
+              <a:t>Bootstrap por polígono (as células de um polígono não são independentes)</a:t>
+            </a:r>
+            <a:endParaRPr lang="en-US" sz="1250" dirty="0"/>
+          </a:p>
+          <a:p>
+            <a:pPr marL="342900" indent="-342900">
+              <a:spcAft>
+                <a:spcPts val="700"/>
+              </a:spcAft>
+              <a:buSzPct val="100000"/>
+              <a:buChar char="•"/>
+            </a:pPr>
+            <a:r>
+              <a:rPr lang="en-US" sz="1250" dirty="0">
+                <a:solidFill>
+                  <a:srgbClr val="1B2A22"/>
+                </a:solidFill>
+                <a:latin typeface="Calibri" pitchFamily="34" charset="0"/>
+                <a:ea typeface="Calibri" pitchFamily="34" charset="-122"/>
+                <a:cs typeface="Calibri" pitchFamily="34" charset="-120"/>
+              </a:rPr>
+              <a:t>Desfechos: corroborada, inconclusiva ou refutada (e inconclusiva por margem)</a:t>
+            </a:r>
+            <a:endParaRPr lang="en-US" sz="1250" dirty="0"/>
+          </a:p>
+          <a:p>
+            <a:pPr marL="342900" indent="-342900">
+              <a:spcAft>
+                <a:spcPts val="700"/>
+              </a:spcAft>
+              <a:buSzPct val="100000"/>
+              <a:buChar char="•"/>
+            </a:pPr>
+            <a:r>
+              <a:rPr lang="en-US" sz="1250" dirty="0">
+                <a:solidFill>
+                  <a:srgbClr val="1B2A22"/>
+                </a:solidFill>
+                <a:latin typeface="Calibri" pitchFamily="34" charset="0"/>
+                <a:ea typeface="Calibri" pitchFamily="34" charset="-122"/>
+                <a:cs typeface="Calibri" pitchFamily="34" charset="-120"/>
+              </a:rPr>
+              <a:t>Estado hoje: não avaliado. O script grava uma trava e recusa a segunda avaliação</a:t>
+            </a:r>
+            <a:endParaRPr lang="en-US" sz="1250" dirty="0"/>
+          </a:p>
+        </p:txBody>
+      </p:sp>
+      <p:sp>
+        <p:nvSpPr>
+          <p:cNvPr id="8" name="Text 4"/>
           <p:cNvSpPr txBox="1"/>
           <p:nvPr/>
         </p:nvSpPr>
@@ -4171,7 +3704,7 @@
                 <a:ea typeface="Calibri" pitchFamily="34" charset="-122"/>
                 <a:cs typeface="Calibri" pitchFamily="34" charset="-120"/>
               </a:rPr>
-              <a:t>Refs.: D16, D23; Olofsson et al. (2014), amostragem e estimativa de área em sensoriamento remoto.</a:t>
+              <a:t>Refs.: D25, D24, D26; Nosek et al. (2018); Cameron et al. (2008); van der Ploeg et al. (2014); Hanley &amp; McNeil (1982).</a:t>
             </a:r>
             <a:endParaRPr lang="en-US" sz="1000" dirty="0"/>
           </a:p>
@@ -4242,7 +3775,7 @@
                 <a:ea typeface="Cambria" pitchFamily="34" charset="-122"/>
                 <a:cs typeface="Cambria" pitchFamily="34" charset="-120"/>
               </a:rPr>
-              <a:t>Avaliação única, com o critério fixado antes</a:t>
+              <a:t>Estado atual, limites e próximos passos</a:t>
             </a:r>
             <a:endParaRPr lang="en-US" sz="2200" dirty="0"/>
           </a:p>
@@ -4295,57 +3828,74 @@
         </p:nvSpPr>
         <p:spPr>
           <a:xfrm>
-            <a:off x="438912" y="941832"/>
-            <a:ext cx="3831336" cy="3310816"/>
-          </a:xfrm>
-          <a:prstGeom prst="rect">
-            <a:avLst/>
+            <a:off x="457200" y="1051560"/>
+            <a:ext cx="4023360" cy="3474720"/>
+          </a:xfrm>
+          <a:prstGeom prst="roundRect">
+            <a:avLst>
+              <a:gd name="adj" fmla="val 2105"/>
+            </a:avLst>
           </a:prstGeom>
           <a:solidFill>
-            <a:srgbClr val="FFFFFF"/>
+            <a:srgbClr val="EEF3EF"/>
           </a:solidFill>
-          <a:ln w="9525">
+          <a:ln w="12700">
             <a:solidFill>
-              <a:srgbClr val="B8C4BC"/>
+              <a:srgbClr val="EEF3EF"/>
             </a:solidFill>
             <a:prstDash val="solid"/>
           </a:ln>
         </p:spPr>
       </p:sp>
-      <p:pic>
-        <p:nvPicPr>
-          <p:cNvPr id="6" name="Image 0" descr="img/decisoes.png">    </p:cNvPr>
-          <p:cNvPicPr>
-            <a:picLocks noChangeAspect="1"/>
-          </p:cNvPicPr>
-          <p:nvPr/>
-        </p:nvPicPr>
-        <p:blipFill>
-          <a:blip r:embed="rId1"/>
-          <a:stretch>
-            <a:fillRect/>
-          </a:stretch>
-        </p:blipFill>
-        <p:spPr>
-          <a:xfrm>
-            <a:off x="457200" y="960120"/>
-            <a:ext cx="3794760" cy="3274240"/>
+      <p:sp>
+        <p:nvSpPr>
+          <p:cNvPr id="6" name="Text 3"/>
+          <p:cNvSpPr txBox="1"/>
+          <p:nvPr/>
+        </p:nvSpPr>
+        <p:spPr>
+          <a:xfrm>
+            <a:off x="640080" y="1170432"/>
+            <a:ext cx="3657600" cy="365760"/>
           </a:xfrm>
           <a:prstGeom prst="rect">
             <a:avLst/>
           </a:prstGeom>
-        </p:spPr>
-      </p:pic>
-      <p:sp>
-        <p:nvSpPr>
-          <p:cNvPr id="7" name="Text 3"/>
+          <a:noFill/>
+          <a:ln/>
+        </p:spPr>
+        <p:txBody>
+          <a:bodyPr wrap="square" lIns="0" tIns="0" rIns="0" bIns="0" rtlCol="0" anchor="t"/>
+          <a:lstStyle/>
+          <a:p>
+            <a:pPr indent="0" marL="0">
+              <a:buNone/>
+            </a:pPr>
+            <a:r>
+              <a:rPr lang="en-US" sz="1900" b="1" dirty="0">
+                <a:solidFill>
+                  <a:srgbClr val="2F6B4F"/>
+                </a:solidFill>
+                <a:latin typeface="Cambria" pitchFamily="34" charset="0"/>
+                <a:ea typeface="Cambria" pitchFamily="34" charset="-122"/>
+                <a:cs typeface="Cambria" pitchFamily="34" charset="-120"/>
+              </a:rPr>
+              <a:t>Pronto</a:t>
+            </a:r>
+            <a:endParaRPr lang="en-US" sz="1900" dirty="0"/>
+          </a:p>
+        </p:txBody>
+      </p:sp>
+      <p:sp>
+        <p:nvSpPr>
+          <p:cNvPr id="7" name="Text 4"/>
           <p:cNvSpPr txBox="1"/>
           <p:nvPr/>
         </p:nvSpPr>
         <p:spPr>
           <a:xfrm>
-            <a:off x="4526280" y="1051560"/>
-            <a:ext cx="4251960" cy="3566160"/>
+            <a:off x="640080" y="1600200"/>
+            <a:ext cx="3657600" cy="2834640"/>
           </a:xfrm>
           <a:prstGeom prst="rect">
             <a:avLst/>
@@ -4373,7 +3923,7 @@
                 <a:ea typeface="Calibri" pitchFamily="34" charset="-122"/>
                 <a:cs typeface="Calibri" pitchFamily="34" charset="-120"/>
               </a:rPr>
-              <a:t>Competidores: linha de base RUSLE, regressão penalizada e XGBoost (perda Tweedie)</a:t>
+              <a:t>Plataforma com os módulos do fluxo e recusa de dado sintético</a:t>
             </a:r>
             <a:endParaRPr lang="en-US" sz="1250" dirty="0"/>
           </a:p>
@@ -4394,7 +3944,7 @@
                 <a:ea typeface="Calibri" pitchFamily="34" charset="-122"/>
                 <a:cs typeface="Calibri" pitchFamily="34" charset="-120"/>
               </a:rPr>
-              <a:t>Métrica primária: Spearman no held-out; piso 0,40 e margem 0,10 sobre a RUSLE</a:t>
+              <a:t>Desenho amostral e critério de avaliação pré-registrados</a:t>
             </a:r>
             <a:endParaRPr lang="en-US" sz="1250" dirty="0"/>
           </a:p>
@@ -4415,7 +3965,7 @@
                 <a:ea typeface="Calibri" pitchFamily="34" charset="-122"/>
                 <a:cs typeface="Calibri" pitchFamily="34" charset="-120"/>
               </a:rPr>
-              <a:t>Bootstrap por polígono (as células de um polígono não são independentes)</a:t>
+              <a:t>Ferramenta de checagem do pool por estrato (somente leitura)</a:t>
             </a:r>
             <a:endParaRPr lang="en-US" sz="1250" dirty="0"/>
           </a:p>
@@ -4436,10 +3986,98 @@
                 <a:ea typeface="Calibri" pitchFamily="34" charset="-122"/>
                 <a:cs typeface="Calibri" pitchFamily="34" charset="-120"/>
               </a:rPr>
-              <a:t>Desfechos: corroborada, inconclusiva ou refutada (e inconclusiva por margem)</a:t>
+              <a:t>Pacote de reprodutibilidade com verificador de integridade</a:t>
             </a:r>
             <a:endParaRPr lang="en-US" sz="1250" dirty="0"/>
           </a:p>
+        </p:txBody>
+      </p:sp>
+      <p:sp>
+        <p:nvSpPr>
+          <p:cNvPr id="8" name="Shape 5"/>
+          <p:cNvSpPr/>
+          <p:nvPr/>
+        </p:nvSpPr>
+        <p:spPr>
+          <a:xfrm>
+            <a:off x="4663440" y="1051560"/>
+            <a:ext cx="4023360" cy="3474720"/>
+          </a:xfrm>
+          <a:prstGeom prst="roundRect">
+            <a:avLst>
+              <a:gd name="adj" fmla="val 2105"/>
+            </a:avLst>
+          </a:prstGeom>
+          <a:solidFill>
+            <a:srgbClr val="EEF3EF"/>
+          </a:solidFill>
+          <a:ln w="12700">
+            <a:solidFill>
+              <a:srgbClr val="EEF3EF"/>
+            </a:solidFill>
+            <a:prstDash val="solid"/>
+          </a:ln>
+        </p:spPr>
+      </p:sp>
+      <p:sp>
+        <p:nvSpPr>
+          <p:cNvPr id="9" name="Text 6"/>
+          <p:cNvSpPr txBox="1"/>
+          <p:nvPr/>
+        </p:nvSpPr>
+        <p:spPr>
+          <a:xfrm>
+            <a:off x="4846320" y="1170432"/>
+            <a:ext cx="3657600" cy="365760"/>
+          </a:xfrm>
+          <a:prstGeom prst="rect">
+            <a:avLst/>
+          </a:prstGeom>
+          <a:noFill/>
+          <a:ln/>
+        </p:spPr>
+        <p:txBody>
+          <a:bodyPr wrap="square" lIns="0" tIns="0" rIns="0" bIns="0" rtlCol="0" anchor="t"/>
+          <a:lstStyle/>
+          <a:p>
+            <a:pPr indent="0" marL="0">
+              <a:buNone/>
+            </a:pPr>
+            <a:r>
+              <a:rPr lang="en-US" sz="1900" b="1" dirty="0">
+                <a:solidFill>
+                  <a:srgbClr val="C65D3B"/>
+                </a:solidFill>
+                <a:latin typeface="Cambria" pitchFamily="34" charset="0"/>
+                <a:ea typeface="Cambria" pitchFamily="34" charset="-122"/>
+                <a:cs typeface="Cambria" pitchFamily="34" charset="-120"/>
+              </a:rPr>
+              <a:t>Pendente</a:t>
+            </a:r>
+            <a:endParaRPr lang="en-US" sz="1900" dirty="0"/>
+          </a:p>
+        </p:txBody>
+      </p:sp>
+      <p:sp>
+        <p:nvSpPr>
+          <p:cNvPr id="10" name="Text 7"/>
+          <p:cNvSpPr txBox="1"/>
+          <p:nvPr/>
+        </p:nvSpPr>
+        <p:spPr>
+          <a:xfrm>
+            <a:off x="4846320" y="1600200"/>
+            <a:ext cx="3657600" cy="2834640"/>
+          </a:xfrm>
+          <a:prstGeom prst="rect">
+            <a:avLst/>
+          </a:prstGeom>
+          <a:noFill/>
+          <a:ln/>
+        </p:spPr>
+        <p:txBody>
+          <a:bodyPr wrap="square" lIns="0" tIns="0" rIns="0" bIns="0" rtlCol="0" anchor="t"/>
+          <a:lstStyle/>
           <a:p>
             <a:pPr marL="342900" indent="-342900">
               <a:spcAft>
@@ -4457,48 +4095,93 @@
                 <a:ea typeface="Calibri" pitchFamily="34" charset="-122"/>
                 <a:cs typeface="Calibri" pitchFamily="34" charset="-120"/>
               </a:rPr>
-              <a:t>Estado hoje: não avaliado. O script grava uma trava e recusa a segunda avaliação</a:t>
+              <a:t>Nenhum resultado empírico ainda</a:t>
             </a:r>
             <a:endParaRPr lang="en-US" sz="1250" dirty="0"/>
           </a:p>
-        </p:txBody>
-      </p:sp>
-      <p:sp>
-        <p:nvSpPr>
-          <p:cNvPr id="8" name="Text 4"/>
-          <p:cNvSpPr txBox="1"/>
-          <p:nvPr/>
-        </p:nvSpPr>
-        <p:spPr>
-          <a:xfrm>
-            <a:off x="457200" y="4754880"/>
-            <a:ext cx="7863840" cy="292608"/>
-          </a:xfrm>
-          <a:prstGeom prst="rect">
-            <a:avLst/>
-          </a:prstGeom>
-          <a:noFill/>
-          <a:ln/>
-        </p:spPr>
-        <p:txBody>
-          <a:bodyPr wrap="square" lIns="0" tIns="0" rIns="0" bIns="0" rtlCol="0" anchor="ctr"/>
-          <a:lstStyle/>
-          <a:p>
-            <a:pPr indent="0" marL="0">
-              <a:buNone/>
-            </a:pPr>
-            <a:r>
-              <a:rPr lang="en-US" sz="1000" i="1" dirty="0">
-                <a:solidFill>
-                  <a:srgbClr val="52605A"/>
-                </a:solidFill>
-                <a:latin typeface="Calibri" pitchFamily="34" charset="0"/>
-                <a:ea typeface="Calibri" pitchFamily="34" charset="-122"/>
-                <a:cs typeface="Calibri" pitchFamily="34" charset="-120"/>
-              </a:rPr>
-              <a:t>Refs.: D25, D24, D26; Nosek et al. (2018); Cameron et al. (2008); van der Ploeg et al. (2014); Hanley &amp; McNeil (1982).</a:t>
-            </a:r>
-            <a:endParaRPr lang="en-US" sz="1000" dirty="0"/>
+          <a:p>
+            <a:pPr marL="342900" indent="-342900">
+              <a:spcAft>
+                <a:spcPts val="700"/>
+              </a:spcAft>
+              <a:buSzPct val="100000"/>
+              <a:buChar char="•"/>
+            </a:pPr>
+            <a:r>
+              <a:rPr lang="en-US" sz="1250" dirty="0">
+                <a:solidFill>
+                  <a:srgbClr val="1B2A22"/>
+                </a:solidFill>
+                <a:latin typeface="Calibri" pitchFamily="34" charset="0"/>
+                <a:ea typeface="Calibri" pitchFamily="34" charset="-122"/>
+                <a:cs typeface="Calibri" pitchFamily="34" charset="-120"/>
+              </a:rPr>
+              <a:t>Medir o pool real por estrato e decidir reservas e n mínimo</a:t>
+            </a:r>
+            <a:endParaRPr lang="en-US" sz="1250" dirty="0"/>
+          </a:p>
+          <a:p>
+            <a:pPr marL="342900" indent="-342900">
+              <a:spcAft>
+                <a:spcPts val="700"/>
+              </a:spcAft>
+              <a:buSzPct val="100000"/>
+              <a:buChar char="•"/>
+            </a:pPr>
+            <a:r>
+              <a:rPr lang="en-US" sz="1250" dirty="0">
+                <a:solidFill>
+                  <a:srgbClr val="1B2A22"/>
+                </a:solidFill>
+                <a:latin typeface="Calibri" pitchFamily="34" charset="0"/>
+                <a:ea typeface="Calibri" pitchFamily="34" charset="-122"/>
+                <a:cs typeface="Calibri" pitchFamily="34" charset="-120"/>
+              </a:rPr>
+              <a:t>Decisões antes do sorteio: solo nu, declividade, empates dos tercis</a:t>
+            </a:r>
+            <a:endParaRPr lang="en-US" sz="1250" dirty="0"/>
+          </a:p>
+          <a:p>
+            <a:pPr marL="342900" indent="-342900">
+              <a:spcAft>
+                <a:spcPts val="700"/>
+              </a:spcAft>
+              <a:buSzPct val="100000"/>
+              <a:buChar char="•"/>
+            </a:pPr>
+            <a:r>
+              <a:rPr lang="en-US" sz="1250" dirty="0">
+                <a:solidFill>
+                  <a:srgbClr val="1B2A22"/>
+                </a:solidFill>
+                <a:latin typeface="Calibri" pitchFamily="34" charset="0"/>
+                <a:ea typeface="Calibri" pitchFamily="34" charset="-122"/>
+                <a:cs typeface="Calibri" pitchFamily="34" charset="-120"/>
+              </a:rPr>
+              <a:t>Autorizações, voos e delineação</a:t>
+            </a:r>
+            <a:endParaRPr lang="en-US" sz="1250" dirty="0"/>
+          </a:p>
+          <a:p>
+            <a:pPr marL="342900" indent="-342900">
+              <a:spcAft>
+                <a:spcPts val="700"/>
+              </a:spcAft>
+              <a:buSzPct val="100000"/>
+              <a:buChar char="•"/>
+            </a:pPr>
+            <a:r>
+              <a:rPr lang="en-US" sz="1250" dirty="0">
+                <a:solidFill>
+                  <a:srgbClr val="1B2A22"/>
+                </a:solidFill>
+                <a:latin typeface="Calibri" pitchFamily="34" charset="0"/>
+                <a:ea typeface="Calibri" pitchFamily="34" charset="-122"/>
+                <a:cs typeface="Calibri" pitchFamily="34" charset="-120"/>
+              </a:rPr>
+              <a:t>Acerto de atribuição (antes ≈ 78%): em verificação</a:t>
+            </a:r>
+            <a:endParaRPr lang="en-US" sz="1250" dirty="0"/>
           </a:p>
         </p:txBody>
       </p:sp>
@@ -4567,7 +4250,7 @@
                 <a:ea typeface="Cambria" pitchFamily="34" charset="-122"/>
                 <a:cs typeface="Cambria" pitchFamily="34" charset="-120"/>
               </a:rPr>
-              <a:t>Estado atual, limites e próximos passos</a:t>
+              <a:t>Referências citadas nas decisões do projeto</a:t>
             </a:r>
             <a:endParaRPr lang="en-US" sz="2200" dirty="0"/>
           </a:p>
@@ -4607,481 +4290,6 @@
                 <a:cs typeface="Calibri" pitchFamily="34" charset="-120"/>
               </a:rPr>
               <a:t>14</a:t>
-            </a:r>
-            <a:endParaRPr lang="en-US" sz="1000" dirty="0"/>
-          </a:p>
-        </p:txBody>
-      </p:sp>
-      <p:sp>
-        <p:nvSpPr>
-          <p:cNvPr id="5" name="Shape 2"/>
-          <p:cNvSpPr/>
-          <p:nvPr/>
-        </p:nvSpPr>
-        <p:spPr>
-          <a:xfrm>
-            <a:off x="457200" y="1051560"/>
-            <a:ext cx="4023360" cy="3474720"/>
-          </a:xfrm>
-          <a:prstGeom prst="roundRect">
-            <a:avLst>
-              <a:gd name="adj" fmla="val 2105"/>
-            </a:avLst>
-          </a:prstGeom>
-          <a:solidFill>
-            <a:srgbClr val="EEF3EF"/>
-          </a:solidFill>
-          <a:ln w="12700">
-            <a:solidFill>
-              <a:srgbClr val="EEF3EF"/>
-            </a:solidFill>
-            <a:prstDash val="solid"/>
-          </a:ln>
-        </p:spPr>
-      </p:sp>
-      <p:sp>
-        <p:nvSpPr>
-          <p:cNvPr id="6" name="Text 3"/>
-          <p:cNvSpPr txBox="1"/>
-          <p:nvPr/>
-        </p:nvSpPr>
-        <p:spPr>
-          <a:xfrm>
-            <a:off x="640080" y="1170432"/>
-            <a:ext cx="3657600" cy="365760"/>
-          </a:xfrm>
-          <a:prstGeom prst="rect">
-            <a:avLst/>
-          </a:prstGeom>
-          <a:noFill/>
-          <a:ln/>
-        </p:spPr>
-        <p:txBody>
-          <a:bodyPr wrap="square" lIns="0" tIns="0" rIns="0" bIns="0" rtlCol="0" anchor="t"/>
-          <a:lstStyle/>
-          <a:p>
-            <a:pPr indent="0" marL="0">
-              <a:buNone/>
-            </a:pPr>
-            <a:r>
-              <a:rPr lang="en-US" sz="1900" b="1" dirty="0">
-                <a:solidFill>
-                  <a:srgbClr val="2F6B4F"/>
-                </a:solidFill>
-                <a:latin typeface="Cambria" pitchFamily="34" charset="0"/>
-                <a:ea typeface="Cambria" pitchFamily="34" charset="-122"/>
-                <a:cs typeface="Cambria" pitchFamily="34" charset="-120"/>
-              </a:rPr>
-              <a:t>Pronto</a:t>
-            </a:r>
-            <a:endParaRPr lang="en-US" sz="1900" dirty="0"/>
-          </a:p>
-        </p:txBody>
-      </p:sp>
-      <p:sp>
-        <p:nvSpPr>
-          <p:cNvPr id="7" name="Text 4"/>
-          <p:cNvSpPr txBox="1"/>
-          <p:nvPr/>
-        </p:nvSpPr>
-        <p:spPr>
-          <a:xfrm>
-            <a:off x="640080" y="1600200"/>
-            <a:ext cx="3657600" cy="2834640"/>
-          </a:xfrm>
-          <a:prstGeom prst="rect">
-            <a:avLst/>
-          </a:prstGeom>
-          <a:noFill/>
-          <a:ln/>
-        </p:spPr>
-        <p:txBody>
-          <a:bodyPr wrap="square" lIns="0" tIns="0" rIns="0" bIns="0" rtlCol="0" anchor="t"/>
-          <a:lstStyle/>
-          <a:p>
-            <a:pPr marL="342900" indent="-342900">
-              <a:spcAft>
-                <a:spcPts val="700"/>
-              </a:spcAft>
-              <a:buSzPct val="100000"/>
-              <a:buChar char="•"/>
-            </a:pPr>
-            <a:r>
-              <a:rPr lang="en-US" sz="1250" dirty="0">
-                <a:solidFill>
-                  <a:srgbClr val="1B2A22"/>
-                </a:solidFill>
-                <a:latin typeface="Calibri" pitchFamily="34" charset="0"/>
-                <a:ea typeface="Calibri" pitchFamily="34" charset="-122"/>
-                <a:cs typeface="Calibri" pitchFamily="34" charset="-120"/>
-              </a:rPr>
-              <a:t>Plataforma com os módulos do fluxo e recusa de dado sintético</a:t>
-            </a:r>
-            <a:endParaRPr lang="en-US" sz="1250" dirty="0"/>
-          </a:p>
-          <a:p>
-            <a:pPr marL="342900" indent="-342900">
-              <a:spcAft>
-                <a:spcPts val="700"/>
-              </a:spcAft>
-              <a:buSzPct val="100000"/>
-              <a:buChar char="•"/>
-            </a:pPr>
-            <a:r>
-              <a:rPr lang="en-US" sz="1250" dirty="0">
-                <a:solidFill>
-                  <a:srgbClr val="1B2A22"/>
-                </a:solidFill>
-                <a:latin typeface="Calibri" pitchFamily="34" charset="0"/>
-                <a:ea typeface="Calibri" pitchFamily="34" charset="-122"/>
-                <a:cs typeface="Calibri" pitchFamily="34" charset="-120"/>
-              </a:rPr>
-              <a:t>Desenho amostral e critério de avaliação pré-registrados</a:t>
-            </a:r>
-            <a:endParaRPr lang="en-US" sz="1250" dirty="0"/>
-          </a:p>
-          <a:p>
-            <a:pPr marL="342900" indent="-342900">
-              <a:spcAft>
-                <a:spcPts val="700"/>
-              </a:spcAft>
-              <a:buSzPct val="100000"/>
-              <a:buChar char="•"/>
-            </a:pPr>
-            <a:r>
-              <a:rPr lang="en-US" sz="1250" dirty="0">
-                <a:solidFill>
-                  <a:srgbClr val="1B2A22"/>
-                </a:solidFill>
-                <a:latin typeface="Calibri" pitchFamily="34" charset="0"/>
-                <a:ea typeface="Calibri" pitchFamily="34" charset="-122"/>
-                <a:cs typeface="Calibri" pitchFamily="34" charset="-120"/>
-              </a:rPr>
-              <a:t>Ferramenta de checagem do pool por estrato (somente leitura)</a:t>
-            </a:r>
-            <a:endParaRPr lang="en-US" sz="1250" dirty="0"/>
-          </a:p>
-          <a:p>
-            <a:pPr marL="342900" indent="-342900">
-              <a:spcAft>
-                <a:spcPts val="700"/>
-              </a:spcAft>
-              <a:buSzPct val="100000"/>
-              <a:buChar char="•"/>
-            </a:pPr>
-            <a:r>
-              <a:rPr lang="en-US" sz="1250" dirty="0">
-                <a:solidFill>
-                  <a:srgbClr val="1B2A22"/>
-                </a:solidFill>
-                <a:latin typeface="Calibri" pitchFamily="34" charset="0"/>
-                <a:ea typeface="Calibri" pitchFamily="34" charset="-122"/>
-                <a:cs typeface="Calibri" pitchFamily="34" charset="-120"/>
-              </a:rPr>
-              <a:t>Pacote de reprodutibilidade com verificador de integridade</a:t>
-            </a:r>
-            <a:endParaRPr lang="en-US" sz="1250" dirty="0"/>
-          </a:p>
-        </p:txBody>
-      </p:sp>
-      <p:sp>
-        <p:nvSpPr>
-          <p:cNvPr id="8" name="Shape 5"/>
-          <p:cNvSpPr/>
-          <p:nvPr/>
-        </p:nvSpPr>
-        <p:spPr>
-          <a:xfrm>
-            <a:off x="4663440" y="1051560"/>
-            <a:ext cx="4023360" cy="3474720"/>
-          </a:xfrm>
-          <a:prstGeom prst="roundRect">
-            <a:avLst>
-              <a:gd name="adj" fmla="val 2105"/>
-            </a:avLst>
-          </a:prstGeom>
-          <a:solidFill>
-            <a:srgbClr val="EEF3EF"/>
-          </a:solidFill>
-          <a:ln w="12700">
-            <a:solidFill>
-              <a:srgbClr val="EEF3EF"/>
-            </a:solidFill>
-            <a:prstDash val="solid"/>
-          </a:ln>
-        </p:spPr>
-      </p:sp>
-      <p:sp>
-        <p:nvSpPr>
-          <p:cNvPr id="9" name="Text 6"/>
-          <p:cNvSpPr txBox="1"/>
-          <p:nvPr/>
-        </p:nvSpPr>
-        <p:spPr>
-          <a:xfrm>
-            <a:off x="4846320" y="1170432"/>
-            <a:ext cx="3657600" cy="365760"/>
-          </a:xfrm>
-          <a:prstGeom prst="rect">
-            <a:avLst/>
-          </a:prstGeom>
-          <a:noFill/>
-          <a:ln/>
-        </p:spPr>
-        <p:txBody>
-          <a:bodyPr wrap="square" lIns="0" tIns="0" rIns="0" bIns="0" rtlCol="0" anchor="t"/>
-          <a:lstStyle/>
-          <a:p>
-            <a:pPr indent="0" marL="0">
-              <a:buNone/>
-            </a:pPr>
-            <a:r>
-              <a:rPr lang="en-US" sz="1900" b="1" dirty="0">
-                <a:solidFill>
-                  <a:srgbClr val="C65D3B"/>
-                </a:solidFill>
-                <a:latin typeface="Cambria" pitchFamily="34" charset="0"/>
-                <a:ea typeface="Cambria" pitchFamily="34" charset="-122"/>
-                <a:cs typeface="Cambria" pitchFamily="34" charset="-120"/>
-              </a:rPr>
-              <a:t>Pendente</a:t>
-            </a:r>
-            <a:endParaRPr lang="en-US" sz="1900" dirty="0"/>
-          </a:p>
-        </p:txBody>
-      </p:sp>
-      <p:sp>
-        <p:nvSpPr>
-          <p:cNvPr id="10" name="Text 7"/>
-          <p:cNvSpPr txBox="1"/>
-          <p:nvPr/>
-        </p:nvSpPr>
-        <p:spPr>
-          <a:xfrm>
-            <a:off x="4846320" y="1600200"/>
-            <a:ext cx="3657600" cy="2834640"/>
-          </a:xfrm>
-          <a:prstGeom prst="rect">
-            <a:avLst/>
-          </a:prstGeom>
-          <a:noFill/>
-          <a:ln/>
-        </p:spPr>
-        <p:txBody>
-          <a:bodyPr wrap="square" lIns="0" tIns="0" rIns="0" bIns="0" rtlCol="0" anchor="t"/>
-          <a:lstStyle/>
-          <a:p>
-            <a:pPr marL="342900" indent="-342900">
-              <a:spcAft>
-                <a:spcPts val="700"/>
-              </a:spcAft>
-              <a:buSzPct val="100000"/>
-              <a:buChar char="•"/>
-            </a:pPr>
-            <a:r>
-              <a:rPr lang="en-US" sz="1250" dirty="0">
-                <a:solidFill>
-                  <a:srgbClr val="1B2A22"/>
-                </a:solidFill>
-                <a:latin typeface="Calibri" pitchFamily="34" charset="0"/>
-                <a:ea typeface="Calibri" pitchFamily="34" charset="-122"/>
-                <a:cs typeface="Calibri" pitchFamily="34" charset="-120"/>
-              </a:rPr>
-              <a:t>Nenhum resultado empírico ainda</a:t>
-            </a:r>
-            <a:endParaRPr lang="en-US" sz="1250" dirty="0"/>
-          </a:p>
-          <a:p>
-            <a:pPr marL="342900" indent="-342900">
-              <a:spcAft>
-                <a:spcPts val="700"/>
-              </a:spcAft>
-              <a:buSzPct val="100000"/>
-              <a:buChar char="•"/>
-            </a:pPr>
-            <a:r>
-              <a:rPr lang="en-US" sz="1250" dirty="0">
-                <a:solidFill>
-                  <a:srgbClr val="1B2A22"/>
-                </a:solidFill>
-                <a:latin typeface="Calibri" pitchFamily="34" charset="0"/>
-                <a:ea typeface="Calibri" pitchFamily="34" charset="-122"/>
-                <a:cs typeface="Calibri" pitchFamily="34" charset="-120"/>
-              </a:rPr>
-              <a:t>Medir o pool real por estrato e decidir reservas e n mínimo</a:t>
-            </a:r>
-            <a:endParaRPr lang="en-US" sz="1250" dirty="0"/>
-          </a:p>
-          <a:p>
-            <a:pPr marL="342900" indent="-342900">
-              <a:spcAft>
-                <a:spcPts val="700"/>
-              </a:spcAft>
-              <a:buSzPct val="100000"/>
-              <a:buChar char="•"/>
-            </a:pPr>
-            <a:r>
-              <a:rPr lang="en-US" sz="1250" dirty="0">
-                <a:solidFill>
-                  <a:srgbClr val="1B2A22"/>
-                </a:solidFill>
-                <a:latin typeface="Calibri" pitchFamily="34" charset="0"/>
-                <a:ea typeface="Calibri" pitchFamily="34" charset="-122"/>
-                <a:cs typeface="Calibri" pitchFamily="34" charset="-120"/>
-              </a:rPr>
-              <a:t>Decisões antes do sorteio: solo nu, declividade, empates dos tercis</a:t>
-            </a:r>
-            <a:endParaRPr lang="en-US" sz="1250" dirty="0"/>
-          </a:p>
-          <a:p>
-            <a:pPr marL="342900" indent="-342900">
-              <a:spcAft>
-                <a:spcPts val="700"/>
-              </a:spcAft>
-              <a:buSzPct val="100000"/>
-              <a:buChar char="•"/>
-            </a:pPr>
-            <a:r>
-              <a:rPr lang="en-US" sz="1250" dirty="0">
-                <a:solidFill>
-                  <a:srgbClr val="1B2A22"/>
-                </a:solidFill>
-                <a:latin typeface="Calibri" pitchFamily="34" charset="0"/>
-                <a:ea typeface="Calibri" pitchFamily="34" charset="-122"/>
-                <a:cs typeface="Calibri" pitchFamily="34" charset="-120"/>
-              </a:rPr>
-              <a:t>Autorizações, voos e delineação</a:t>
-            </a:r>
-            <a:endParaRPr lang="en-US" sz="1250" dirty="0"/>
-          </a:p>
-          <a:p>
-            <a:pPr marL="342900" indent="-342900">
-              <a:spcAft>
-                <a:spcPts val="700"/>
-              </a:spcAft>
-              <a:buSzPct val="100000"/>
-              <a:buChar char="•"/>
-            </a:pPr>
-            <a:r>
-              <a:rPr lang="en-US" sz="1250" dirty="0">
-                <a:solidFill>
-                  <a:srgbClr val="1B2A22"/>
-                </a:solidFill>
-                <a:latin typeface="Calibri" pitchFamily="34" charset="0"/>
-                <a:ea typeface="Calibri" pitchFamily="34" charset="-122"/>
-                <a:cs typeface="Calibri" pitchFamily="34" charset="-120"/>
-              </a:rPr>
-              <a:t>Acerto de atribuição (antes ≈ 78%): em verificação</a:t>
-            </a:r>
-            <a:endParaRPr lang="en-US" sz="1250" dirty="0"/>
-          </a:p>
-        </p:txBody>
-      </p:sp>
-    </p:spTree>
-  </p:cSld>
-  <p:clrMapOvr>
-    <a:masterClrMapping/>
-  </p:clrMapOvr>
-</p:sld>
-</file>
-
-<file path=ppt/slides/slide15.xml><?xml version="1.0" encoding="utf-8"?>
-<p:sld xmlns:a="http://schemas.openxmlformats.org/drawingml/2006/main" xmlns:r="http://schemas.openxmlformats.org/officeDocument/2006/relationships" xmlns:p="http://schemas.openxmlformats.org/presentationml/2006/main">
-  <p:cSld name="Slide 15">
-    <p:bg>
-      <p:bgPr>
-        <a:solidFill>
-          <a:srgbClr val="FFFFFF"/>
-        </a:solidFill>
-      </p:bgPr>
-    </p:bg>
-    <p:spTree>
-      <p:nvGrpSpPr>
-        <p:cNvPr id="1" name=""/>
-        <p:cNvGrpSpPr/>
-        <p:nvPr/>
-      </p:nvGrpSpPr>
-      <p:grpSpPr>
-        <a:xfrm>
-          <a:off x="0" y="0"/>
-          <a:ext cx="0" cy="0"/>
-          <a:chOff x="0" y="0"/>
-          <a:chExt cx="0" cy="0"/>
-        </a:xfrm>
-      </p:grpSpPr>
-      <p:sp>
-        <p:nvSpPr>
-          <p:cNvPr id="2" name="Text 0"/>
-          <p:cNvSpPr txBox="1"/>
-          <p:nvPr/>
-        </p:nvSpPr>
-        <p:spPr>
-          <a:xfrm>
-            <a:off x="457200" y="256032"/>
-            <a:ext cx="8229600" cy="685800"/>
-          </a:xfrm>
-          <a:prstGeom prst="rect">
-            <a:avLst/>
-          </a:prstGeom>
-          <a:noFill/>
-          <a:ln/>
-        </p:spPr>
-        <p:txBody>
-          <a:bodyPr wrap="square" lIns="0" tIns="0" rIns="0" bIns="0" rtlCol="0" anchor="t"/>
-          <a:lstStyle/>
-          <a:p>
-            <a:pPr indent="0" marL="0">
-              <a:buNone/>
-            </a:pPr>
-            <a:r>
-              <a:rPr lang="en-US" sz="2200" b="1" dirty="0">
-                <a:solidFill>
-                  <a:srgbClr val="1B2A22"/>
-                </a:solidFill>
-                <a:latin typeface="Cambria" pitchFamily="34" charset="0"/>
-                <a:ea typeface="Cambria" pitchFamily="34" charset="-122"/>
-                <a:cs typeface="Cambria" pitchFamily="34" charset="-120"/>
-              </a:rPr>
-              <a:t>Referências citadas nas decisões do projeto</a:t>
-            </a:r>
-            <a:endParaRPr lang="en-US" sz="2200" dirty="0"/>
-          </a:p>
-        </p:txBody>
-      </p:sp>
-      <p:sp>
-        <p:nvSpPr>
-          <p:cNvPr id="3" name="Text 1"/>
-          <p:cNvSpPr txBox="1"/>
-          <p:nvPr/>
-        </p:nvSpPr>
-        <p:spPr>
-          <a:xfrm>
-            <a:off x="8412480" y="4800600"/>
-            <a:ext cx="457200" cy="228600"/>
-          </a:xfrm>
-          <a:prstGeom prst="rect">
-            <a:avLst/>
-          </a:prstGeom>
-          <a:noFill/>
-          <a:ln/>
-        </p:spPr>
-        <p:txBody>
-          <a:bodyPr wrap="square" lIns="0" tIns="0" rIns="0" bIns="0" rtlCol="0" anchor="t"/>
-          <a:lstStyle/>
-          <a:p>
-            <a:pPr algn="r" indent="0" marL="0">
-              <a:buNone/>
-            </a:pPr>
-            <a:r>
-              <a:rPr lang="en-US" sz="1000" dirty="0">
-                <a:solidFill>
-                  <a:srgbClr val="52605A"/>
-                </a:solidFill>
-                <a:latin typeface="Calibri" pitchFamily="34" charset="0"/>
-                <a:ea typeface="Calibri" pitchFamily="34" charset="-122"/>
-                <a:cs typeface="Calibri" pitchFamily="34" charset="-120"/>
-              </a:rPr>
-              <a:t>15</a:t>
             </a:r>
             <a:endParaRPr lang="en-US" sz="1000" dirty="0"/>
           </a:p>
@@ -9906,7 +9114,7 @@
                 <a:ea typeface="Cambria" pitchFamily="34" charset="-122"/>
                 <a:cs typeface="Cambria" pitchFamily="34" charset="-120"/>
               </a:rPr>
-              <a:t>Dificuldade 1: poucos candidatos nos estratos de erodibilidade alta</a:t>
+              <a:t>Dificuldade: o polígono precisa caber em um único imóvel</a:t>
             </a:r>
             <a:endParaRPr lang="en-US" sz="2200" dirty="0"/>
           </a:p>
@@ -9951,436 +9159,32 @@
           </a:p>
         </p:txBody>
       </p:sp>
-      <p:sp>
-        <p:nvSpPr>
-          <p:cNvPr id="5" name="Shape 2"/>
-          <p:cNvSpPr/>
-          <p:nvPr/>
-        </p:nvSpPr>
-        <p:spPr>
-          <a:xfrm>
-            <a:off x="457200" y="1143000"/>
-            <a:ext cx="1920240" cy="1188720"/>
-          </a:xfrm>
-          <a:prstGeom prst="roundRect">
-            <a:avLst>
-              <a:gd name="adj" fmla="val 6154"/>
-            </a:avLst>
-          </a:prstGeom>
-          <a:solidFill>
-            <a:srgbClr val="EEF3EF"/>
-          </a:solidFill>
-          <a:ln w="12700">
-            <a:solidFill>
-              <a:srgbClr val="EEF3EF"/>
-            </a:solidFill>
-            <a:prstDash val="solid"/>
-          </a:ln>
-        </p:spPr>
-      </p:sp>
-      <p:sp>
-        <p:nvSpPr>
-          <p:cNvPr id="6" name="Text 3"/>
+      <p:graphicFrame>
+        <p:nvGraphicFramePr>
+          <p:cNvPr id="5" name="Chart 0" descr=""/>
+          <p:cNvGraphicFramePr/>
+          <p:nvPr/>
+        </p:nvGraphicFramePr>
+        <p:xfrm>
+          <a:off x="457200" y="1005840"/>
+          <a:ext cx="4754880" cy="3383280"/>
+        </p:xfrm>
+        <a:graphic xmlns:a="http://schemas.openxmlformats.org/drawingml/2006/main">
+          <a:graphicData uri="http://schemas.openxmlformats.org/drawingml/2006/chart">
+            <c:chart xmlns:c="http://schemas.openxmlformats.org/drawingml/2006/chart" r:id="rId1"/>
+          </a:graphicData>
+        </a:graphic>
+      </p:graphicFrame>
+      <p:sp>
+        <p:nvSpPr>
+          <p:cNvPr id="6" name="Text 2"/>
           <p:cNvSpPr txBox="1"/>
           <p:nvPr/>
         </p:nvSpPr>
         <p:spPr>
           <a:xfrm>
-            <a:off x="457200" y="1252728"/>
-            <a:ext cx="1920240" cy="594360"/>
-          </a:xfrm>
-          <a:prstGeom prst="rect">
-            <a:avLst/>
-          </a:prstGeom>
-          <a:noFill/>
-          <a:ln/>
-        </p:spPr>
-        <p:txBody>
-          <a:bodyPr wrap="square" lIns="0" tIns="0" rIns="0" bIns="0" rtlCol="0" anchor="t"/>
-          <a:lstStyle/>
-          <a:p>
-            <a:pPr algn="ctr" indent="0" marL="0">
-              <a:buNone/>
-            </a:pPr>
-            <a:r>
-              <a:rPr lang="en-US" sz="2200" b="1" dirty="0">
-                <a:solidFill>
-                  <a:srgbClr val="2F6B4F"/>
-                </a:solidFill>
-                <a:latin typeface="Cambria" pitchFamily="34" charset="0"/>
-                <a:ea typeface="Cambria" pitchFamily="34" charset="-122"/>
-                <a:cs typeface="Cambria" pitchFamily="34" charset="-120"/>
-              </a:rPr>
-              <a:t>5 de 90</a:t>
-            </a:r>
-            <a:endParaRPr lang="en-US" sz="2200" dirty="0"/>
-          </a:p>
-        </p:txBody>
-      </p:sp>
-      <p:sp>
-        <p:nvSpPr>
-          <p:cNvPr id="7" name="Text 4"/>
-          <p:cNvSpPr txBox="1"/>
-          <p:nvPr/>
-        </p:nvSpPr>
-        <p:spPr>
-          <a:xfrm>
-            <a:off x="548640" y="1856232"/>
-            <a:ext cx="1737360" cy="457200"/>
-          </a:xfrm>
-          <a:prstGeom prst="rect">
-            <a:avLst/>
-          </a:prstGeom>
-          <a:noFill/>
-          <a:ln/>
-        </p:spPr>
-        <p:txBody>
-          <a:bodyPr wrap="square" lIns="0" tIns="0" rIns="0" bIns="0" rtlCol="0" anchor="t"/>
-          <a:lstStyle/>
-          <a:p>
-            <a:pPr algn="ctr" indent="0" marL="0">
-              <a:buNone/>
-            </a:pPr>
-            <a:r>
-              <a:rPr lang="en-US" sz="1100" dirty="0">
-                <a:solidFill>
-                  <a:srgbClr val="52605A"/>
-                </a:solidFill>
-                <a:latin typeface="Calibri" pitchFamily="34" charset="0"/>
-                <a:ea typeface="Calibri" pitchFamily="34" charset="-122"/>
-                <a:cs typeface="Calibri" pitchFamily="34" charset="-120"/>
-              </a:rPr>
-              <a:t>candidatos em erodibilidade alta, dentro de 3 a 20% (medição de 29/09)</a:t>
-            </a:r>
-            <a:endParaRPr lang="en-US" sz="1100" dirty="0"/>
-          </a:p>
-        </p:txBody>
-      </p:sp>
-      <p:sp>
-        <p:nvSpPr>
-          <p:cNvPr id="8" name="Shape 5"/>
-          <p:cNvSpPr/>
-          <p:nvPr/>
-        </p:nvSpPr>
-        <p:spPr>
-          <a:xfrm>
-            <a:off x="2514600" y="1143000"/>
-            <a:ext cx="1920240" cy="1188720"/>
-          </a:xfrm>
-          <a:prstGeom prst="roundRect">
-            <a:avLst>
-              <a:gd name="adj" fmla="val 6154"/>
-            </a:avLst>
-          </a:prstGeom>
-          <a:solidFill>
-            <a:srgbClr val="EEF3EF"/>
-          </a:solidFill>
-          <a:ln w="12700">
-            <a:solidFill>
-              <a:srgbClr val="EEF3EF"/>
-            </a:solidFill>
-            <a:prstDash val="solid"/>
-          </a:ln>
-        </p:spPr>
-      </p:sp>
-      <p:sp>
-        <p:nvSpPr>
-          <p:cNvPr id="9" name="Text 6"/>
-          <p:cNvSpPr txBox="1"/>
-          <p:nvPr/>
-        </p:nvSpPr>
-        <p:spPr>
-          <a:xfrm>
-            <a:off x="2514600" y="1252728"/>
-            <a:ext cx="1920240" cy="594360"/>
-          </a:xfrm>
-          <a:prstGeom prst="rect">
-            <a:avLst/>
-          </a:prstGeom>
-          <a:noFill/>
-          <a:ln/>
-        </p:spPr>
-        <p:txBody>
-          <a:bodyPr wrap="square" lIns="0" tIns="0" rIns="0" bIns="0" rtlCol="0" anchor="t"/>
-          <a:lstStyle/>
-          <a:p>
-            <a:pPr algn="ctr" indent="0" marL="0">
-              <a:buNone/>
-            </a:pPr>
-            <a:r>
-              <a:rPr lang="en-US" sz="2200" b="1" dirty="0">
-                <a:solidFill>
-                  <a:srgbClr val="2F6B4F"/>
-                </a:solidFill>
-                <a:latin typeface="Cambria" pitchFamily="34" charset="0"/>
-                <a:ea typeface="Cambria" pitchFamily="34" charset="-122"/>
-                <a:cs typeface="Cambria" pitchFamily="34" charset="-120"/>
-              </a:rPr>
-              <a:t>≈ 33</a:t>
-            </a:r>
-            <a:endParaRPr lang="en-US" sz="2200" dirty="0"/>
-          </a:p>
-        </p:txBody>
-      </p:sp>
-      <p:sp>
-        <p:nvSpPr>
-          <p:cNvPr id="10" name="Text 7"/>
-          <p:cNvSpPr txBox="1"/>
-          <p:nvPr/>
-        </p:nvSpPr>
-        <p:spPr>
-          <a:xfrm>
-            <a:off x="2606040" y="1856232"/>
-            <a:ext cx="1737360" cy="457200"/>
-          </a:xfrm>
-          <a:prstGeom prst="rect">
-            <a:avLst/>
-          </a:prstGeom>
-          <a:noFill/>
-          <a:ln/>
-        </p:spPr>
-        <p:txBody>
-          <a:bodyPr wrap="square" lIns="0" tIns="0" rIns="0" bIns="0" rtlCol="0" anchor="t"/>
-          <a:lstStyle/>
-          <a:p>
-            <a:pPr algn="ctr" indent="0" marL="0">
-              <a:buNone/>
-            </a:pPr>
-            <a:r>
-              <a:rPr lang="en-US" sz="1100" dirty="0">
-                <a:solidFill>
-                  <a:srgbClr val="52605A"/>
-                </a:solidFill>
-                <a:latin typeface="Calibri" pitchFamily="34" charset="0"/>
-                <a:ea typeface="Calibri" pitchFamily="34" charset="-122"/>
-                <a:cs typeface="Calibri" pitchFamily="34" charset="-120"/>
-              </a:rPr>
-              <a:t>extrapolação para os 593 imóveis do divisor (estimativa)</a:t>
-            </a:r>
-            <a:endParaRPr lang="en-US" sz="1100" dirty="0"/>
-          </a:p>
-        </p:txBody>
-      </p:sp>
-      <p:sp>
-        <p:nvSpPr>
-          <p:cNvPr id="11" name="Shape 8"/>
-          <p:cNvSpPr/>
-          <p:nvPr/>
-        </p:nvSpPr>
-        <p:spPr>
-          <a:xfrm>
-            <a:off x="4572000" y="1143000"/>
-            <a:ext cx="1920240" cy="1188720"/>
-          </a:xfrm>
-          <a:prstGeom prst="roundRect">
-            <a:avLst>
-              <a:gd name="adj" fmla="val 6154"/>
-            </a:avLst>
-          </a:prstGeom>
-          <a:solidFill>
-            <a:srgbClr val="EEF3EF"/>
-          </a:solidFill>
-          <a:ln w="12700">
-            <a:solidFill>
-              <a:srgbClr val="EEF3EF"/>
-            </a:solidFill>
-            <a:prstDash val="solid"/>
-          </a:ln>
-        </p:spPr>
-      </p:sp>
-      <p:sp>
-        <p:nvSpPr>
-          <p:cNvPr id="12" name="Text 9"/>
-          <p:cNvSpPr txBox="1"/>
-          <p:nvPr/>
-        </p:nvSpPr>
-        <p:spPr>
-          <a:xfrm>
-            <a:off x="4572000" y="1252728"/>
-            <a:ext cx="1920240" cy="594360"/>
-          </a:xfrm>
-          <a:prstGeom prst="rect">
-            <a:avLst/>
-          </a:prstGeom>
-          <a:noFill/>
-          <a:ln/>
-        </p:spPr>
-        <p:txBody>
-          <a:bodyPr wrap="square" lIns="0" tIns="0" rIns="0" bIns="0" rtlCol="0" anchor="t"/>
-          <a:lstStyle/>
-          <a:p>
-            <a:pPr algn="ctr" indent="0" marL="0">
-              <a:buNone/>
-            </a:pPr>
-            <a:r>
-              <a:rPr lang="en-US" sz="2200" b="1" dirty="0">
-                <a:solidFill>
-                  <a:srgbClr val="C65D3B"/>
-                </a:solidFill>
-                <a:latin typeface="Cambria" pitchFamily="34" charset="0"/>
-                <a:ea typeface="Cambria" pitchFamily="34" charset="-122"/>
-                <a:cs typeface="Cambria" pitchFamily="34" charset="-120"/>
-              </a:rPr>
-              <a:t>36</a:t>
-            </a:r>
-            <a:endParaRPr lang="en-US" sz="2200" dirty="0"/>
-          </a:p>
-        </p:txBody>
-      </p:sp>
-      <p:sp>
-        <p:nvSpPr>
-          <p:cNvPr id="13" name="Text 10"/>
-          <p:cNvSpPr txBox="1"/>
-          <p:nvPr/>
-        </p:nvSpPr>
-        <p:spPr>
-          <a:xfrm>
-            <a:off x="4663440" y="1856232"/>
-            <a:ext cx="1737360" cy="457200"/>
-          </a:xfrm>
-          <a:prstGeom prst="rect">
-            <a:avLst/>
-          </a:prstGeom>
-          <a:noFill/>
-          <a:ln/>
-        </p:spPr>
-        <p:txBody>
-          <a:bodyPr wrap="square" lIns="0" tIns="0" rIns="0" bIns="0" rtlCol="0" anchor="t"/>
-          <a:lstStyle/>
-          <a:p>
-            <a:pPr algn="ctr" indent="0" marL="0">
-              <a:buNone/>
-            </a:pPr>
-            <a:r>
-              <a:rPr lang="en-US" sz="1100" dirty="0">
-                <a:solidFill>
-                  <a:srgbClr val="52605A"/>
-                </a:solidFill>
-                <a:latin typeface="Calibri" pitchFamily="34" charset="0"/>
-                <a:ea typeface="Calibri" pitchFamily="34" charset="-122"/>
-                <a:cs typeface="Calibri" pitchFamily="34" charset="-120"/>
-              </a:rPr>
-              <a:t>titulares exigidos hoje nesse nível: 9 estratos × 4</a:t>
-            </a:r>
-            <a:endParaRPr lang="en-US" sz="1100" dirty="0"/>
-          </a:p>
-        </p:txBody>
-      </p:sp>
-      <p:sp>
-        <p:nvSpPr>
-          <p:cNvPr id="14" name="Shape 11"/>
-          <p:cNvSpPr/>
-          <p:nvPr/>
-        </p:nvSpPr>
-        <p:spPr>
-          <a:xfrm>
-            <a:off x="6629400" y="1143000"/>
-            <a:ext cx="2011680" cy="1188720"/>
-          </a:xfrm>
-          <a:prstGeom prst="roundRect">
-            <a:avLst>
-              <a:gd name="adj" fmla="val 6154"/>
-            </a:avLst>
-          </a:prstGeom>
-          <a:solidFill>
-            <a:srgbClr val="EEF3EF"/>
-          </a:solidFill>
-          <a:ln w="12700">
-            <a:solidFill>
-              <a:srgbClr val="EEF3EF"/>
-            </a:solidFill>
-            <a:prstDash val="solid"/>
-          </a:ln>
-        </p:spPr>
-      </p:sp>
-      <p:sp>
-        <p:nvSpPr>
-          <p:cNvPr id="15" name="Text 12"/>
-          <p:cNvSpPr txBox="1"/>
-          <p:nvPr/>
-        </p:nvSpPr>
-        <p:spPr>
-          <a:xfrm>
-            <a:off x="6629400" y="1252728"/>
-            <a:ext cx="2011680" cy="594360"/>
-          </a:xfrm>
-          <a:prstGeom prst="rect">
-            <a:avLst/>
-          </a:prstGeom>
-          <a:noFill/>
-          <a:ln/>
-        </p:spPr>
-        <p:txBody>
-          <a:bodyPr wrap="square" lIns="0" tIns="0" rIns="0" bIns="0" rtlCol="0" anchor="t"/>
-          <a:lstStyle/>
-          <a:p>
-            <a:pPr algn="ctr" indent="0" marL="0">
-              <a:buNone/>
-            </a:pPr>
-            <a:r>
-              <a:rPr lang="en-US" sz="2200" b="1" dirty="0">
-                <a:solidFill>
-                  <a:srgbClr val="2F6B4F"/>
-                </a:solidFill>
-                <a:latin typeface="Cambria" pitchFamily="34" charset="0"/>
-                <a:ea typeface="Cambria" pitchFamily="34" charset="-122"/>
-                <a:cs typeface="Cambria" pitchFamily="34" charset="-120"/>
-              </a:rPr>
-              <a:t>+ reservas</a:t>
-            </a:r>
-            <a:endParaRPr lang="en-US" sz="2200" dirty="0"/>
-          </a:p>
-        </p:txBody>
-      </p:sp>
-      <p:sp>
-        <p:nvSpPr>
-          <p:cNvPr id="16" name="Text 13"/>
-          <p:cNvSpPr txBox="1"/>
-          <p:nvPr/>
-        </p:nvSpPr>
-        <p:spPr>
-          <a:xfrm>
-            <a:off x="6720840" y="1856232"/>
-            <a:ext cx="1828800" cy="457200"/>
-          </a:xfrm>
-          <a:prstGeom prst="rect">
-            <a:avLst/>
-          </a:prstGeom>
-          <a:noFill/>
-          <a:ln/>
-        </p:spPr>
-        <p:txBody>
-          <a:bodyPr wrap="square" lIns="0" tIns="0" rIns="0" bIns="0" rtlCol="0" anchor="t"/>
-          <a:lstStyle/>
-          <a:p>
-            <a:pPr algn="ctr" indent="0" marL="0">
-              <a:buNone/>
-            </a:pPr>
-            <a:r>
-              <a:rPr lang="en-US" sz="1100" dirty="0">
-                <a:solidFill>
-                  <a:srgbClr val="52605A"/>
-                </a:solidFill>
-                <a:latin typeface="Calibri" pitchFamily="34" charset="0"/>
-                <a:ea typeface="Calibri" pitchFamily="34" charset="-122"/>
-                <a:cs typeface="Calibri" pitchFamily="34" charset="-120"/>
-              </a:rPr>
-              <a:t>para repor recusas, no mesmo selo</a:t>
-            </a:r>
-            <a:endParaRPr lang="en-US" sz="1100" dirty="0"/>
-          </a:p>
-        </p:txBody>
-      </p:sp>
-      <p:sp>
-        <p:nvSpPr>
-          <p:cNvPr id="17" name="Text 14"/>
-          <p:cNvSpPr txBox="1"/>
-          <p:nvPr/>
-        </p:nvSpPr>
-        <p:spPr>
-          <a:xfrm>
-            <a:off x="457200" y="2606040"/>
-            <a:ext cx="8229600" cy="2103120"/>
+            <a:off x="5486400" y="1097280"/>
+            <a:ext cx="3291840" cy="3291840"/>
           </a:xfrm>
           <a:prstGeom prst="rect">
             <a:avLst/>
@@ -10400,7 +9204,7 @@
               <a:buChar char="•"/>
             </a:pPr>
             <a:r>
-              <a:rPr lang="en-US" sz="1300" dirty="0">
+              <a:rPr lang="en-US" sz="1250" dirty="0">
                 <a:solidFill>
                   <a:srgbClr val="1B2A22"/>
                 </a:solidFill>
@@ -10408,9 +9212,9 @@
                 <a:ea typeface="Calibri" pitchFamily="34" charset="-122"/>
                 <a:cs typeface="Calibri" pitchFamily="34" charset="-120"/>
               </a:rPr>
-              <a:t>É um indício, calculado sobre um artefato pequeno. O pool real ainda não foi medido.</a:t>
-            </a:r>
-            <a:endParaRPr lang="en-US" sz="1300" dirty="0"/>
+              <a:t>73.643 imóveis rurais no envelope da bacia</a:t>
+            </a:r>
+            <a:endParaRPr lang="en-US" sz="1250" dirty="0"/>
           </a:p>
           <a:p>
             <a:pPr marL="342900" indent="-342900">
@@ -10421,7 +9225,7 @@
               <a:buChar char="•"/>
             </a:pPr>
             <a:r>
-              <a:rPr lang="en-US" sz="1300" dirty="0">
+              <a:rPr lang="en-US" sz="1250" dirty="0">
                 <a:solidFill>
                   <a:srgbClr val="1B2A22"/>
                 </a:solidFill>
@@ -10429,9 +9233,9 @@
                 <a:ea typeface="Calibri" pitchFamily="34" charset="-122"/>
                 <a:cs typeface="Calibri" pitchFamily="34" charset="-120"/>
               </a:rPr>
-              <a:t>A ferramenta de checagem do pool por estrato está pronta (somente leitura); falta rodá-la com os candidatos reais.</a:t>
-            </a:r>
-            <a:endParaRPr lang="en-US" sz="1300" dirty="0"/>
+              <a:t>Mediana de 11,7 ha: minifúndio do oeste do Paraná</a:t>
+            </a:r>
+            <a:endParaRPr lang="en-US" sz="1250" dirty="0"/>
           </a:p>
           <a:p>
             <a:pPr marL="342900" indent="-342900">
@@ -10442,7 +9246,7 @@
               <a:buChar char="•"/>
             </a:pPr>
             <a:r>
-              <a:rPr lang="en-US" sz="1300" dirty="0">
+              <a:rPr lang="en-US" sz="1250" dirty="0">
                 <a:solidFill>
                   <a:srgbClr val="1B2A22"/>
                 </a:solidFill>
@@ -10450,9 +9254,9 @@
                 <a:ea typeface="Calibri" pitchFamily="34" charset="-122"/>
                 <a:cs typeface="Calibri" pitchFamily="34" charset="-120"/>
               </a:rPr>
-              <a:t>Não se move o limiar físico de erodibilidade para acomodar a amostra: a decisão vem da fonte e da regra registrada.</a:t>
-            </a:r>
-            <a:endParaRPr lang="en-US" sz="1300" dirty="0"/>
+              <a:t>Teste por caixa envolvente: valores são limites superiores</a:t>
+            </a:r>
+            <a:endParaRPr lang="en-US" sz="1250" dirty="0"/>
           </a:p>
           <a:p>
             <a:pPr marL="342900" indent="-342900">
@@ -10463,7 +9267,7 @@
               <a:buChar char="•"/>
             </a:pPr>
             <a:r>
-              <a:rPr lang="en-US" sz="1300" dirty="0">
+              <a:rPr lang="en-US" sz="1250" dirty="0">
                 <a:solidFill>
                   <a:srgbClr val="1B2A22"/>
                 </a:solidFill>
@@ -10471,15 +9275,36 @@
                 <a:ea typeface="Calibri" pitchFamily="34" charset="-122"/>
                 <a:cs typeface="Calibri" pitchFamily="34" charset="-120"/>
               </a:rPr>
-              <a:t>Respostas legítimas: ampliar a área de estudo, usar reservas ordenadas, ou declarar a limitação de potência naquele estrato.</a:t>
-            </a:r>
-            <a:endParaRPr lang="en-US" sz="1300" dirty="0"/>
-          </a:p>
-        </p:txBody>
-      </p:sp>
-      <p:sp>
-        <p:nvSpPr>
-          <p:cNvPr id="18" name="Text 15"/>
+              <a:t>72 autorizações em vez de 36</a:t>
+            </a:r>
+            <a:endParaRPr lang="en-US" sz="1250" dirty="0"/>
+          </a:p>
+          <a:p>
+            <a:pPr marL="342900" indent="-342900">
+              <a:spcAft>
+                <a:spcPts val="700"/>
+              </a:spcAft>
+              <a:buSzPct val="100000"/>
+              <a:buChar char="•"/>
+            </a:pPr>
+            <a:r>
+              <a:rPr lang="en-US" sz="1250" dirty="0">
+                <a:solidFill>
+                  <a:srgbClr val="1B2A22"/>
+                </a:solidFill>
+                <a:latin typeface="Calibri" pitchFamily="34" charset="0"/>
+                <a:ea typeface="Calibri" pitchFamily="34" charset="-122"/>
+                <a:cs typeface="Calibri" pitchFamily="34" charset="-120"/>
+              </a:rPr>
+              <a:t>Viés declarado: amostra tende a imóveis maiores, com outro manejo</a:t>
+            </a:r>
+            <a:endParaRPr lang="en-US" sz="1250" dirty="0"/>
+          </a:p>
+        </p:txBody>
+      </p:sp>
+      <p:sp>
+        <p:nvSpPr>
+          <p:cNvPr id="7" name="Text 3"/>
           <p:cNvSpPr txBox="1"/>
           <p:nvPr/>
         </p:nvSpPr>
@@ -10510,7 +9335,7 @@
                 <a:ea typeface="Calibri" pitchFamily="34" charset="-122"/>
                 <a:cs typeface="Calibri" pitchFamily="34" charset="-120"/>
               </a:rPr>
-              <a:t>Fonte: verificação de 29/09/2026 (docs/verificacoes); decisões D09, D12 e D16; ferramenta scripts/verificar_pool_estratos.ts.</a:t>
+              <a:t>Fonte: decisão D16 (medição de 29/09/2026 sobre data/fundiario_brasil.db).</a:t>
             </a:r>
             <a:endParaRPr lang="en-US" sz="1000" dirty="0"/>
           </a:p>
@@ -10581,7 +9406,7 @@
                 <a:ea typeface="Cambria" pitchFamily="34" charset="-122"/>
                 <a:cs typeface="Cambria" pitchFamily="34" charset="-120"/>
               </a:rPr>
-              <a:t>Dificuldade 2: o polígono precisa caber em um único imóvel</a:t>
+              <a:t>Sorteio selado e o problema da recusa</a:t>
             </a:r>
             <a:endParaRPr lang="en-US" sz="2200" dirty="0"/>
           </a:p>
@@ -10626,32 +9451,82 @@
           </a:p>
         </p:txBody>
       </p:sp>
-      <p:graphicFrame>
-        <p:nvGraphicFramePr>
-          <p:cNvPr id="5" name="Chart 0" descr=""/>
-          <p:cNvGraphicFramePr/>
-          <p:nvPr/>
-        </p:nvGraphicFramePr>
-        <p:xfrm>
-          <a:off x="457200" y="1005840"/>
-          <a:ext cx="4754880" cy="3383280"/>
-        </p:xfrm>
-        <a:graphic xmlns:a="http://schemas.openxmlformats.org/drawingml/2006/main">
-          <a:graphicData uri="http://schemas.openxmlformats.org/drawingml/2006/chart">
-            <c:chart xmlns:c="http://schemas.openxmlformats.org/drawingml/2006/chart" r:id="rId1"/>
-          </a:graphicData>
-        </a:graphic>
-      </p:graphicFrame>
-      <p:sp>
-        <p:nvSpPr>
-          <p:cNvPr id="6" name="Text 2"/>
+      <p:sp>
+        <p:nvSpPr>
+          <p:cNvPr id="5" name="Shape 2"/>
+          <p:cNvSpPr/>
+          <p:nvPr/>
+        </p:nvSpPr>
+        <p:spPr>
+          <a:xfrm>
+            <a:off x="457200" y="1051560"/>
+            <a:ext cx="4023360" cy="3474720"/>
+          </a:xfrm>
+          <a:prstGeom prst="roundRect">
+            <a:avLst>
+              <a:gd name="adj" fmla="val 2105"/>
+            </a:avLst>
+          </a:prstGeom>
+          <a:solidFill>
+            <a:srgbClr val="EEF3EF"/>
+          </a:solidFill>
+          <a:ln w="12700">
+            <a:solidFill>
+              <a:srgbClr val="EEF3EF"/>
+            </a:solidFill>
+            <a:prstDash val="solid"/>
+          </a:ln>
+        </p:spPr>
+      </p:sp>
+      <p:sp>
+        <p:nvSpPr>
+          <p:cNvPr id="6" name="Text 3"/>
           <p:cNvSpPr txBox="1"/>
           <p:nvPr/>
         </p:nvSpPr>
         <p:spPr>
           <a:xfrm>
-            <a:off x="5486400" y="1097280"/>
-            <a:ext cx="3291840" cy="3291840"/>
+            <a:off x="640080" y="1170432"/>
+            <a:ext cx="3657600" cy="365760"/>
+          </a:xfrm>
+          <a:prstGeom prst="rect">
+            <a:avLst/>
+          </a:prstGeom>
+          <a:noFill/>
+          <a:ln/>
+        </p:spPr>
+        <p:txBody>
+          <a:bodyPr wrap="square" lIns="0" tIns="0" rIns="0" bIns="0" rtlCol="0" anchor="t"/>
+          <a:lstStyle/>
+          <a:p>
+            <a:pPr indent="0" marL="0">
+              <a:buNone/>
+            </a:pPr>
+            <a:r>
+              <a:rPr lang="en-US" sz="1500" b="1" dirty="0">
+                <a:solidFill>
+                  <a:srgbClr val="2F6B4F"/>
+                </a:solidFill>
+                <a:latin typeface="Cambria" pitchFamily="34" charset="0"/>
+                <a:ea typeface="Cambria" pitchFamily="34" charset="-122"/>
+                <a:cs typeface="Cambria" pitchFamily="34" charset="-120"/>
+              </a:rPr>
+              <a:t>O que o selo registra</a:t>
+            </a:r>
+            <a:endParaRPr lang="en-US" sz="1500" dirty="0"/>
+          </a:p>
+        </p:txBody>
+      </p:sp>
+      <p:sp>
+        <p:nvSpPr>
+          <p:cNvPr id="7" name="Text 4"/>
+          <p:cNvSpPr txBox="1"/>
+          <p:nvPr/>
+        </p:nvSpPr>
+        <p:spPr>
+          <a:xfrm>
+            <a:off x="640080" y="1600200"/>
+            <a:ext cx="3657600" cy="2834640"/>
           </a:xfrm>
           <a:prstGeom prst="rect">
             <a:avLst/>
@@ -10679,7 +9554,7 @@
                 <a:ea typeface="Calibri" pitchFamily="34" charset="-122"/>
                 <a:cs typeface="Calibri" pitchFamily="34" charset="-120"/>
               </a:rPr>
-              <a:t>73.643 imóveis rurais no envelope da bacia</a:t>
+              <a:t>Semente do sorteio e commit do código</a:t>
             </a:r>
             <a:endParaRPr lang="en-US" sz="1250" dirty="0"/>
           </a:p>
@@ -10700,7 +9575,7 @@
                 <a:ea typeface="Calibri" pitchFamily="34" charset="-122"/>
                 <a:cs typeface="Calibri" pitchFamily="34" charset="-120"/>
               </a:rPr>
-              <a:t>Mediana de 11,7 ha: minifúndio do oeste do Paraná</a:t>
+              <a:t>SHA-256 do conjunto de candidatos</a:t>
             </a:r>
             <a:endParaRPr lang="en-US" sz="1250" dirty="0"/>
           </a:p>
@@ -10721,7 +9596,7 @@
                 <a:ea typeface="Calibri" pitchFamily="34" charset="-122"/>
                 <a:cs typeface="Calibri" pitchFamily="34" charset="-120"/>
               </a:rPr>
-              <a:t>Teste por caixa envolvente: valores são limites superiores</a:t>
+              <a:t>Hash de integridade do resultado</a:t>
             </a:r>
             <a:endParaRPr lang="en-US" sz="1250" dirty="0"/>
           </a:p>
@@ -10742,7 +9617,7 @@
                 <a:ea typeface="Calibri" pitchFamily="34" charset="-122"/>
                 <a:cs typeface="Calibri" pitchFamily="34" charset="-120"/>
               </a:rPr>
-              <a:t>72 autorizações em vez de 36</a:t>
+              <a:t>Tabela reversa de códigos opacos, fora do Git</a:t>
             </a:r>
             <a:endParaRPr lang="en-US" sz="1250" dirty="0"/>
           </a:p>
@@ -10763,7 +9638,7 @@
                 <a:ea typeface="Calibri" pitchFamily="34" charset="-122"/>
                 <a:cs typeface="Calibri" pitchFamily="34" charset="-120"/>
               </a:rPr>
-              <a:t>Viés declarado: amostra tende a imóveis maiores, com outro manejo</a:t>
+              <a:t>Recusa de candidato sintético e de segunda execução</a:t>
             </a:r>
             <a:endParaRPr lang="en-US" sz="1250" dirty="0"/>
           </a:p>
@@ -10771,7 +9646,200 @@
       </p:sp>
       <p:sp>
         <p:nvSpPr>
-          <p:cNvPr id="7" name="Text 3"/>
+          <p:cNvPr id="8" name="Shape 5"/>
+          <p:cNvSpPr/>
+          <p:nvPr/>
+        </p:nvSpPr>
+        <p:spPr>
+          <a:xfrm>
+            <a:off x="4663440" y="1051560"/>
+            <a:ext cx="4023360" cy="3474720"/>
+          </a:xfrm>
+          <a:prstGeom prst="roundRect">
+            <a:avLst>
+              <a:gd name="adj" fmla="val 2105"/>
+            </a:avLst>
+          </a:prstGeom>
+          <a:solidFill>
+            <a:srgbClr val="EEF3EF"/>
+          </a:solidFill>
+          <a:ln w="12700">
+            <a:solidFill>
+              <a:srgbClr val="EEF3EF"/>
+            </a:solidFill>
+            <a:prstDash val="solid"/>
+          </a:ln>
+        </p:spPr>
+      </p:sp>
+      <p:sp>
+        <p:nvSpPr>
+          <p:cNvPr id="9" name="Text 6"/>
+          <p:cNvSpPr txBox="1"/>
+          <p:nvPr/>
+        </p:nvSpPr>
+        <p:spPr>
+          <a:xfrm>
+            <a:off x="4846320" y="1170432"/>
+            <a:ext cx="3657600" cy="365760"/>
+          </a:xfrm>
+          <a:prstGeom prst="rect">
+            <a:avLst/>
+          </a:prstGeom>
+          <a:noFill/>
+          <a:ln/>
+        </p:spPr>
+        <p:txBody>
+          <a:bodyPr wrap="square" lIns="0" tIns="0" rIns="0" bIns="0" rtlCol="0" anchor="t"/>
+          <a:lstStyle/>
+          <a:p>
+            <a:pPr indent="0" marL="0">
+              <a:buNone/>
+            </a:pPr>
+            <a:r>
+              <a:rPr lang="en-US" sz="1500" b="1" dirty="0">
+                <a:solidFill>
+                  <a:srgbClr val="C65D3B"/>
+                </a:solidFill>
+                <a:latin typeface="Cambria" pitchFamily="34" charset="0"/>
+                <a:ea typeface="Cambria" pitchFamily="34" charset="-122"/>
+                <a:cs typeface="Cambria" pitchFamily="34" charset="-120"/>
+              </a:rPr>
+              <a:t>Se recusar (proposta)</a:t>
+            </a:r>
+            <a:endParaRPr lang="en-US" sz="1500" dirty="0"/>
+          </a:p>
+        </p:txBody>
+      </p:sp>
+      <p:sp>
+        <p:nvSpPr>
+          <p:cNvPr id="10" name="Text 7"/>
+          <p:cNvSpPr txBox="1"/>
+          <p:nvPr/>
+        </p:nvSpPr>
+        <p:spPr>
+          <a:xfrm>
+            <a:off x="4846320" y="1600200"/>
+            <a:ext cx="3657600" cy="2834640"/>
+          </a:xfrm>
+          <a:prstGeom prst="rect">
+            <a:avLst/>
+          </a:prstGeom>
+          <a:noFill/>
+          <a:ln/>
+        </p:spPr>
+        <p:txBody>
+          <a:bodyPr wrap="square" lIns="0" tIns="0" rIns="0" bIns="0" rtlCol="0" anchor="t"/>
+          <a:lstStyle/>
+          <a:p>
+            <a:pPr marL="342900" indent="-342900">
+              <a:spcAft>
+                <a:spcPts val="700"/>
+              </a:spcAft>
+              <a:buSzPct val="100000"/>
+              <a:buChar char="•"/>
+            </a:pPr>
+            <a:r>
+              <a:rPr lang="en-US" sz="1250" dirty="0">
+                <a:solidFill>
+                  <a:srgbClr val="1B2A22"/>
+                </a:solidFill>
+                <a:latin typeface="Calibri" pitchFamily="34" charset="0"/>
+                <a:ea typeface="Calibri" pitchFamily="34" charset="-122"/>
+                <a:cs typeface="Calibri" pitchFamily="34" charset="-120"/>
+              </a:rPr>
+              <a:t>No mesmo selo: 4 titulares e reservas ordenadas por estrato</a:t>
+            </a:r>
+            <a:endParaRPr lang="en-US" sz="1250" dirty="0"/>
+          </a:p>
+          <a:p>
+            <a:pPr marL="342900" indent="-342900">
+              <a:spcAft>
+                <a:spcPts val="700"/>
+              </a:spcAft>
+              <a:buSzPct val="100000"/>
+              <a:buChar char="•"/>
+            </a:pPr>
+            <a:r>
+              <a:rPr lang="en-US" sz="1250" dirty="0">
+                <a:solidFill>
+                  <a:srgbClr val="1B2A22"/>
+                </a:solidFill>
+                <a:latin typeface="Calibri" pitchFamily="34" charset="0"/>
+                <a:ea typeface="Calibri" pitchFamily="34" charset="-122"/>
+                <a:cs typeface="Calibri" pitchFamily="34" charset="-120"/>
+              </a:rPr>
+              <a:t>Recusa aciona a próxima reserva do mesmo estrato</a:t>
+            </a:r>
+            <a:endParaRPr lang="en-US" sz="1250" dirty="0"/>
+          </a:p>
+          <a:p>
+            <a:pPr marL="342900" indent="-342900">
+              <a:spcAft>
+                <a:spcPts val="700"/>
+              </a:spcAft>
+              <a:buSzPct val="100000"/>
+              <a:buChar char="•"/>
+            </a:pPr>
+            <a:r>
+              <a:rPr lang="en-US" sz="1250" dirty="0">
+                <a:solidFill>
+                  <a:srgbClr val="1B2A22"/>
+                </a:solidFill>
+                <a:latin typeface="Calibri" pitchFamily="34" charset="0"/>
+                <a:ea typeface="Calibri" pitchFamily="34" charset="-122"/>
+                <a:cs typeface="Calibri" pitchFamily="34" charset="-120"/>
+              </a:rPr>
+              <a:t>A reserva herda o papel (treino ou teste)</a:t>
+            </a:r>
+            <a:endParaRPr lang="en-US" sz="1250" dirty="0"/>
+          </a:p>
+          <a:p>
+            <a:pPr marL="342900" indent="-342900">
+              <a:spcAft>
+                <a:spcPts val="700"/>
+              </a:spcAft>
+              <a:buSzPct val="100000"/>
+              <a:buChar char="•"/>
+            </a:pPr>
+            <a:r>
+              <a:rPr lang="en-US" sz="1250" dirty="0">
+                <a:solidFill>
+                  <a:srgbClr val="1B2A22"/>
+                </a:solidFill>
+                <a:latin typeface="Calibri" pitchFamily="34" charset="0"/>
+                <a:ea typeface="Calibri" pitchFamily="34" charset="-122"/>
+                <a:cs typeface="Calibri" pitchFamily="34" charset="-120"/>
+              </a:rPr>
+              <a:t>Registro append-only, com data e motivo</a:t>
+            </a:r>
+            <a:endParaRPr lang="en-US" sz="1250" dirty="0"/>
+          </a:p>
+          <a:p>
+            <a:pPr marL="342900" indent="-342900">
+              <a:spcAft>
+                <a:spcPts val="700"/>
+              </a:spcAft>
+              <a:buSzPct val="100000"/>
+              <a:buChar char="•"/>
+            </a:pPr>
+            <a:r>
+              <a:rPr lang="en-US" sz="1250" dirty="0">
+                <a:solidFill>
+                  <a:srgbClr val="1B2A22"/>
+                </a:solidFill>
+                <a:latin typeface="Calibri" pitchFamily="34" charset="0"/>
+                <a:ea typeface="Calibri" pitchFamily="34" charset="-122"/>
+                <a:cs typeface="Calibri" pitchFamily="34" charset="-120"/>
+              </a:rPr>
+              <a:t>Parâmetros em aberto: número de reservas, n mínimo e taxa de recusa</a:t>
+            </a:r>
+            <a:endParaRPr lang="en-US" sz="1250" dirty="0"/>
+          </a:p>
+        </p:txBody>
+      </p:sp>
+      <p:sp>
+        <p:nvSpPr>
+          <p:cNvPr id="11" name="Text 8"/>
           <p:cNvSpPr txBox="1"/>
           <p:nvPr/>
         </p:nvSpPr>
@@ -10802,7 +9870,7 @@
                 <a:ea typeface="Calibri" pitchFamily="34" charset="-122"/>
                 <a:cs typeface="Calibri" pitchFamily="34" charset="-120"/>
               </a:rPr>
-              <a:t>Fonte: decisão D16 (medição de 29/09/2026 sobre data/fundiario_brasil.db).</a:t>
+              <a:t>Refs.: D23; King &amp; Zeng (2001); Olofsson et al. (2014); Cochran (1977). O protocolo de reservas é proposta, em implementação.</a:t>
             </a:r>
             <a:endParaRPr lang="en-US" sz="1000" dirty="0"/>
           </a:p>
@@ -10873,7 +9941,7 @@
                 <a:ea typeface="Cambria" pitchFamily="34" charset="-122"/>
                 <a:cs typeface="Cambria" pitchFamily="34" charset="-120"/>
               </a:rPr>
-              <a:t>Sorteio selado e o problema da recusa</a:t>
+              <a:t>Dificuldade: quantos voos e quanto tempo</a:t>
             </a:r>
             <a:endParaRPr lang="en-US" sz="2200" dirty="0"/>
           </a:p>
@@ -10926,12 +9994,12 @@
         </p:nvSpPr>
         <p:spPr>
           <a:xfrm>
-            <a:off x="457200" y="1051560"/>
-            <a:ext cx="4023360" cy="3474720"/>
+            <a:off x="457200" y="1005840"/>
+            <a:ext cx="1920240" cy="1188720"/>
           </a:xfrm>
           <a:prstGeom prst="roundRect">
             <a:avLst>
-              <a:gd name="adj" fmla="val 2105"/>
+              <a:gd name="adj" fmla="val 6154"/>
             </a:avLst>
           </a:prstGeom>
           <a:solidFill>
@@ -10953,8 +10021,8 @@
         </p:nvSpPr>
         <p:spPr>
           <a:xfrm>
-            <a:off x="640080" y="1170432"/>
-            <a:ext cx="3657600" cy="365760"/>
+            <a:off x="457200" y="1115568"/>
+            <a:ext cx="1920240" cy="594360"/>
           </a:xfrm>
           <a:prstGeom prst="rect">
             <a:avLst/>
@@ -10966,21 +10034,21 @@
           <a:bodyPr wrap="square" lIns="0" tIns="0" rIns="0" bIns="0" rtlCol="0" anchor="t"/>
           <a:lstStyle/>
           <a:p>
-            <a:pPr indent="0" marL="0">
+            <a:pPr algn="ctr" indent="0" marL="0">
               <a:buNone/>
             </a:pPr>
             <a:r>
-              <a:rPr lang="en-US" sz="1500" b="1" dirty="0">
-                <a:solidFill>
-                  <a:srgbClr val="2F6B4F"/>
+              <a:rPr lang="en-US" sz="2200" b="1" dirty="0">
+                <a:solidFill>
+                  <a:srgbClr val="C65D3B"/>
                 </a:solidFill>
                 <a:latin typeface="Cambria" pitchFamily="34" charset="0"/>
                 <a:ea typeface="Cambria" pitchFamily="34" charset="-122"/>
                 <a:cs typeface="Cambria" pitchFamily="34" charset="-120"/>
               </a:rPr>
-              <a:t>O que o selo registra</a:t>
-            </a:r>
-            <a:endParaRPr lang="en-US" sz="1500" dirty="0"/>
+              <a:t>72</a:t>
+            </a:r>
+            <a:endParaRPr lang="en-US" sz="2200" dirty="0"/>
           </a:p>
         </p:txBody>
       </p:sp>
@@ -10992,8 +10060,8 @@
         </p:nvSpPr>
         <p:spPr>
           <a:xfrm>
-            <a:off x="640080" y="1600200"/>
-            <a:ext cx="3657600" cy="2834640"/>
+            <a:off x="548640" y="1719072"/>
+            <a:ext cx="1737360" cy="457200"/>
           </a:xfrm>
           <a:prstGeom prst="rect">
             <a:avLst/>
@@ -11005,109 +10073,21 @@
           <a:bodyPr wrap="square" lIns="0" tIns="0" rIns="0" bIns="0" rtlCol="0" anchor="t"/>
           <a:lstStyle/>
           <a:p>
-            <a:pPr marL="342900" indent="-342900">
-              <a:spcAft>
-                <a:spcPts val="700"/>
-              </a:spcAft>
-              <a:buSzPct val="100000"/>
-              <a:buChar char="•"/>
-            </a:pPr>
-            <a:r>
-              <a:rPr lang="en-US" sz="1250" dirty="0">
-                <a:solidFill>
-                  <a:srgbClr val="1B2A22"/>
-                </a:solidFill>
-                <a:latin typeface="Calibri" pitchFamily="34" charset="0"/>
-                <a:ea typeface="Calibri" pitchFamily="34" charset="-122"/>
-                <a:cs typeface="Calibri" pitchFamily="34" charset="-120"/>
-              </a:rPr>
-              <a:t>Semente do sorteio e commit do código</a:t>
-            </a:r>
-            <a:endParaRPr lang="en-US" sz="1250" dirty="0"/>
-          </a:p>
-          <a:p>
-            <a:pPr marL="342900" indent="-342900">
-              <a:spcAft>
-                <a:spcPts val="700"/>
-              </a:spcAft>
-              <a:buSzPct val="100000"/>
-              <a:buChar char="•"/>
-            </a:pPr>
-            <a:r>
-              <a:rPr lang="en-US" sz="1250" dirty="0">
-                <a:solidFill>
-                  <a:srgbClr val="1B2A22"/>
-                </a:solidFill>
-                <a:latin typeface="Calibri" pitchFamily="34" charset="0"/>
-                <a:ea typeface="Calibri" pitchFamily="34" charset="-122"/>
-                <a:cs typeface="Calibri" pitchFamily="34" charset="-120"/>
-              </a:rPr>
-              <a:t>SHA-256 do conjunto de candidatos</a:t>
-            </a:r>
-            <a:endParaRPr lang="en-US" sz="1250" dirty="0"/>
-          </a:p>
-          <a:p>
-            <a:pPr marL="342900" indent="-342900">
-              <a:spcAft>
-                <a:spcPts val="700"/>
-              </a:spcAft>
-              <a:buSzPct val="100000"/>
-              <a:buChar char="•"/>
-            </a:pPr>
-            <a:r>
-              <a:rPr lang="en-US" sz="1250" dirty="0">
-                <a:solidFill>
-                  <a:srgbClr val="1B2A22"/>
-                </a:solidFill>
-                <a:latin typeface="Calibri" pitchFamily="34" charset="0"/>
-                <a:ea typeface="Calibri" pitchFamily="34" charset="-122"/>
-                <a:cs typeface="Calibri" pitchFamily="34" charset="-120"/>
-              </a:rPr>
-              <a:t>Hash de integridade do resultado</a:t>
-            </a:r>
-            <a:endParaRPr lang="en-US" sz="1250" dirty="0"/>
-          </a:p>
-          <a:p>
-            <a:pPr marL="342900" indent="-342900">
-              <a:spcAft>
-                <a:spcPts val="700"/>
-              </a:spcAft>
-              <a:buSzPct val="100000"/>
-              <a:buChar char="•"/>
-            </a:pPr>
-            <a:r>
-              <a:rPr lang="en-US" sz="1250" dirty="0">
-                <a:solidFill>
-                  <a:srgbClr val="1B2A22"/>
-                </a:solidFill>
-                <a:latin typeface="Calibri" pitchFamily="34" charset="0"/>
-                <a:ea typeface="Calibri" pitchFamily="34" charset="-122"/>
-                <a:cs typeface="Calibri" pitchFamily="34" charset="-120"/>
-              </a:rPr>
-              <a:t>Tabela reversa de códigos opacos, fora do Git</a:t>
-            </a:r>
-            <a:endParaRPr lang="en-US" sz="1250" dirty="0"/>
-          </a:p>
-          <a:p>
-            <a:pPr marL="342900" indent="-342900">
-              <a:spcAft>
-                <a:spcPts val="700"/>
-              </a:spcAft>
-              <a:buSzPct val="100000"/>
-              <a:buChar char="•"/>
-            </a:pPr>
-            <a:r>
-              <a:rPr lang="en-US" sz="1250" dirty="0">
-                <a:solidFill>
-                  <a:srgbClr val="1B2A22"/>
-                </a:solidFill>
-                <a:latin typeface="Calibri" pitchFamily="34" charset="0"/>
-                <a:ea typeface="Calibri" pitchFamily="34" charset="-122"/>
-                <a:cs typeface="Calibri" pitchFamily="34" charset="-120"/>
-              </a:rPr>
-              <a:t>Recusa de candidato sintético e de segunda execução</a:t>
-            </a:r>
-            <a:endParaRPr lang="en-US" sz="1250" dirty="0"/>
+            <a:pPr algn="ctr" indent="0" marL="0">
+              <a:buNone/>
+            </a:pPr>
+            <a:r>
+              <a:rPr lang="en-US" sz="1100" dirty="0">
+                <a:solidFill>
+                  <a:srgbClr val="52605A"/>
+                </a:solidFill>
+                <a:latin typeface="Calibri" pitchFamily="34" charset="0"/>
+                <a:ea typeface="Calibri" pitchFamily="34" charset="-122"/>
+                <a:cs typeface="Calibri" pitchFamily="34" charset="-120"/>
+              </a:rPr>
+              <a:t>missões de mapeamento, uma por polígono (eram 36)</a:t>
+            </a:r>
+            <a:endParaRPr lang="en-US" sz="1100" dirty="0"/>
           </a:p>
         </p:txBody>
       </p:sp>
@@ -11119,12 +10099,12 @@
         </p:nvSpPr>
         <p:spPr>
           <a:xfrm>
-            <a:off x="4663440" y="1051560"/>
-            <a:ext cx="4023360" cy="3474720"/>
+            <a:off x="2514600" y="1005840"/>
+            <a:ext cx="1920240" cy="1188720"/>
           </a:xfrm>
           <a:prstGeom prst="roundRect">
             <a:avLst>
-              <a:gd name="adj" fmla="val 2105"/>
+              <a:gd name="adj" fmla="val 6154"/>
             </a:avLst>
           </a:prstGeom>
           <a:solidFill>
@@ -11146,8 +10126,8 @@
         </p:nvSpPr>
         <p:spPr>
           <a:xfrm>
-            <a:off x="4846320" y="1170432"/>
-            <a:ext cx="3657600" cy="365760"/>
+            <a:off x="2514600" y="1115568"/>
+            <a:ext cx="1920240" cy="594360"/>
           </a:xfrm>
           <a:prstGeom prst="rect">
             <a:avLst/>
@@ -11159,21 +10139,21 @@
           <a:bodyPr wrap="square" lIns="0" tIns="0" rIns="0" bIns="0" rtlCol="0" anchor="t"/>
           <a:lstStyle/>
           <a:p>
-            <a:pPr indent="0" marL="0">
+            <a:pPr algn="ctr" indent="0" marL="0">
               <a:buNone/>
             </a:pPr>
             <a:r>
-              <a:rPr lang="en-US" sz="1500" b="1" dirty="0">
-                <a:solidFill>
-                  <a:srgbClr val="C65D3B"/>
+              <a:rPr lang="en-US" sz="2200" b="1" dirty="0">
+                <a:solidFill>
+                  <a:srgbClr val="2F6B4F"/>
                 </a:solidFill>
                 <a:latin typeface="Cambria" pitchFamily="34" charset="0"/>
                 <a:ea typeface="Cambria" pitchFamily="34" charset="-122"/>
                 <a:cs typeface="Cambria" pitchFamily="34" charset="-120"/>
               </a:rPr>
-              <a:t>Se recusar (proposta)</a:t>
-            </a:r>
-            <a:endParaRPr lang="en-US" sz="1500" dirty="0"/>
+              <a:t>≈ 12</a:t>
+            </a:r>
+            <a:endParaRPr lang="en-US" sz="2200" dirty="0"/>
           </a:p>
         </p:txBody>
       </p:sp>
@@ -11185,8 +10165,8 @@
         </p:nvSpPr>
         <p:spPr>
           <a:xfrm>
-            <a:off x="4846320" y="1600200"/>
-            <a:ext cx="3657600" cy="2834640"/>
+            <a:off x="2606040" y="1719072"/>
+            <a:ext cx="1737360" cy="457200"/>
           </a:xfrm>
           <a:prstGeom prst="rect">
             <a:avLst/>
@@ -11198,15 +10178,313 @@
           <a:bodyPr wrap="square" lIns="0" tIns="0" rIns="0" bIns="0" rtlCol="0" anchor="t"/>
           <a:lstStyle/>
           <a:p>
+            <a:pPr algn="ctr" indent="0" marL="0">
+              <a:buNone/>
+            </a:pPr>
+            <a:r>
+              <a:rPr lang="en-US" sz="1100" dirty="0">
+                <a:solidFill>
+                  <a:srgbClr val="52605A"/>
+                </a:solidFill>
+                <a:latin typeface="Calibri" pitchFamily="34" charset="0"/>
+                <a:ea typeface="Calibri" pitchFamily="34" charset="-122"/>
+                <a:cs typeface="Calibri" pitchFamily="34" charset="-120"/>
+              </a:rPr>
+              <a:t>jornadas de campo, com até 6 polígonos cada (proposta)</a:t>
+            </a:r>
+            <a:endParaRPr lang="en-US" sz="1100" dirty="0"/>
+          </a:p>
+        </p:txBody>
+      </p:sp>
+      <p:sp>
+        <p:nvSpPr>
+          <p:cNvPr id="11" name="Shape 8"/>
+          <p:cNvSpPr/>
+          <p:nvPr/>
+        </p:nvSpPr>
+        <p:spPr>
+          <a:xfrm>
+            <a:off x="4572000" y="1005840"/>
+            <a:ext cx="1920240" cy="1188720"/>
+          </a:xfrm>
+          <a:prstGeom prst="roundRect">
+            <a:avLst>
+              <a:gd name="adj" fmla="val 6154"/>
+            </a:avLst>
+          </a:prstGeom>
+          <a:solidFill>
+            <a:srgbClr val="EEF3EF"/>
+          </a:solidFill>
+          <a:ln w="12700">
+            <a:solidFill>
+              <a:srgbClr val="EEF3EF"/>
+            </a:solidFill>
+            <a:prstDash val="solid"/>
+          </a:ln>
+        </p:spPr>
+      </p:sp>
+      <p:sp>
+        <p:nvSpPr>
+          <p:cNvPr id="12" name="Text 9"/>
+          <p:cNvSpPr txBox="1"/>
+          <p:nvPr/>
+        </p:nvSpPr>
+        <p:spPr>
+          <a:xfrm>
+            <a:off x="4572000" y="1115568"/>
+            <a:ext cx="1920240" cy="594360"/>
+          </a:xfrm>
+          <a:prstGeom prst="rect">
+            <a:avLst/>
+          </a:prstGeom>
+          <a:noFill/>
+          <a:ln/>
+        </p:spPr>
+        <p:txBody>
+          <a:bodyPr wrap="square" lIns="0" tIns="0" rIns="0" bIns="0" rtlCol="0" anchor="t"/>
+          <a:lstStyle/>
+          <a:p>
+            <a:pPr algn="ctr" indent="0" marL="0">
+              <a:buNone/>
+            </a:pPr>
+            <a:r>
+              <a:rPr lang="en-US" sz="2200" b="1" dirty="0">
+                <a:solidFill>
+                  <a:srgbClr val="2F6B4F"/>
+                </a:solidFill>
+                <a:latin typeface="Cambria" pitchFamily="34" charset="0"/>
+                <a:ea typeface="Cambria" pitchFamily="34" charset="-122"/>
+                <a:cs typeface="Cambria" pitchFamily="34" charset="-120"/>
+              </a:rPr>
+              <a:t>2 a 10 min</a:t>
+            </a:r>
+            <a:endParaRPr lang="en-US" sz="2200" dirty="0"/>
+          </a:p>
+        </p:txBody>
+      </p:sp>
+      <p:sp>
+        <p:nvSpPr>
+          <p:cNvPr id="13" name="Text 10"/>
+          <p:cNvSpPr txBox="1"/>
+          <p:nvPr/>
+        </p:nvSpPr>
+        <p:spPr>
+          <a:xfrm>
+            <a:off x="4663440" y="1719072"/>
+            <a:ext cx="1737360" cy="457200"/>
+          </a:xfrm>
+          <a:prstGeom prst="rect">
+            <a:avLst/>
+          </a:prstGeom>
+          <a:noFill/>
+          <a:ln/>
+        </p:spPr>
+        <p:txBody>
+          <a:bodyPr wrap="square" lIns="0" tIns="0" rIns="0" bIns="0" rtlCol="0" anchor="t"/>
+          <a:lstStyle/>
+          <a:p>
+            <a:pPr algn="ctr" indent="0" marL="0">
+              <a:buNone/>
+            </a:pPr>
+            <a:r>
+              <a:rPr lang="en-US" sz="1100" dirty="0">
+                <a:solidFill>
+                  <a:srgbClr val="52605A"/>
+                </a:solidFill>
+                <a:latin typeface="Calibri" pitchFamily="34" charset="0"/>
+                <a:ea typeface="Calibri" pitchFamily="34" charset="-122"/>
+                <a:cs typeface="Calibri" pitchFamily="34" charset="-120"/>
+              </a:rPr>
+              <a:t>de voo por polígono (2,3 ha/min na Missão 009; 0,53 na 000)</a:t>
+            </a:r>
+            <a:endParaRPr lang="en-US" sz="1100" dirty="0"/>
+          </a:p>
+        </p:txBody>
+      </p:sp>
+      <p:sp>
+        <p:nvSpPr>
+          <p:cNvPr id="14" name="Shape 11"/>
+          <p:cNvSpPr/>
+          <p:nvPr/>
+        </p:nvSpPr>
+        <p:spPr>
+          <a:xfrm>
+            <a:off x="6629400" y="1005840"/>
+            <a:ext cx="2057400" cy="1188720"/>
+          </a:xfrm>
+          <a:prstGeom prst="roundRect">
+            <a:avLst>
+              <a:gd name="adj" fmla="val 6154"/>
+            </a:avLst>
+          </a:prstGeom>
+          <a:solidFill>
+            <a:srgbClr val="EEF3EF"/>
+          </a:solidFill>
+          <a:ln w="12700">
+            <a:solidFill>
+              <a:srgbClr val="EEF3EF"/>
+            </a:solidFill>
+            <a:prstDash val="solid"/>
+          </a:ln>
+        </p:spPr>
+      </p:sp>
+      <p:sp>
+        <p:nvSpPr>
+          <p:cNvPr id="15" name="Text 12"/>
+          <p:cNvSpPr txBox="1"/>
+          <p:nvPr/>
+        </p:nvSpPr>
+        <p:spPr>
+          <a:xfrm>
+            <a:off x="6629400" y="1115568"/>
+            <a:ext cx="2057400" cy="594360"/>
+          </a:xfrm>
+          <a:prstGeom prst="rect">
+            <a:avLst/>
+          </a:prstGeom>
+          <a:noFill/>
+          <a:ln/>
+        </p:spPr>
+        <p:txBody>
+          <a:bodyPr wrap="square" lIns="0" tIns="0" rIns="0" bIns="0" rtlCol="0" anchor="t"/>
+          <a:lstStyle/>
+          <a:p>
+            <a:pPr algn="ctr" indent="0" marL="0">
+              <a:buNone/>
+            </a:pPr>
+            <a:r>
+              <a:rPr lang="en-US" sz="2200" b="1" dirty="0">
+                <a:solidFill>
+                  <a:srgbClr val="C65D3B"/>
+                </a:solidFill>
+                <a:latin typeface="Cambria" pitchFamily="34" charset="0"/>
+                <a:ea typeface="Cambria" pitchFamily="34" charset="-122"/>
+                <a:cs typeface="Cambria" pitchFamily="34" charset="-120"/>
+              </a:rPr>
+              <a:t>72</a:t>
+            </a:r>
+            <a:endParaRPr lang="en-US" sz="2200" dirty="0"/>
+          </a:p>
+        </p:txBody>
+      </p:sp>
+      <p:sp>
+        <p:nvSpPr>
+          <p:cNvPr id="16" name="Text 13"/>
+          <p:cNvSpPr txBox="1"/>
+          <p:nvPr/>
+        </p:nvSpPr>
+        <p:spPr>
+          <a:xfrm>
+            <a:off x="6720840" y="1719072"/>
+            <a:ext cx="1874520" cy="457200"/>
+          </a:xfrm>
+          <a:prstGeom prst="rect">
+            <a:avLst/>
+          </a:prstGeom>
+          <a:noFill/>
+          <a:ln/>
+        </p:spPr>
+        <p:txBody>
+          <a:bodyPr wrap="square" lIns="0" tIns="0" rIns="0" bIns="0" rtlCol="0" anchor="t"/>
+          <a:lstStyle/>
+          <a:p>
+            <a:pPr algn="ctr" indent="0" marL="0">
+              <a:buNone/>
+            </a:pPr>
+            <a:r>
+              <a:rPr lang="en-US" sz="1100" dirty="0">
+                <a:solidFill>
+                  <a:srgbClr val="52605A"/>
+                </a:solidFill>
+                <a:latin typeface="Calibri" pitchFamily="34" charset="0"/>
+                <a:ea typeface="Calibri" pitchFamily="34" charset="-122"/>
+                <a:cs typeface="Calibri" pitchFamily="34" charset="-120"/>
+              </a:rPr>
+              <a:t>autorizações de proprietário</a:t>
+            </a:r>
+            <a:endParaRPr lang="en-US" sz="1100" dirty="0"/>
+          </a:p>
+        </p:txBody>
+      </p:sp>
+      <p:sp>
+        <p:nvSpPr>
+          <p:cNvPr id="17" name="Shape 14"/>
+          <p:cNvSpPr/>
+          <p:nvPr/>
+        </p:nvSpPr>
+        <p:spPr>
+          <a:xfrm>
+            <a:off x="1158736" y="2313432"/>
+            <a:ext cx="6826528" cy="1453896"/>
+          </a:xfrm>
+          <a:prstGeom prst="rect">
+            <a:avLst/>
+          </a:prstGeom>
+          <a:solidFill>
+            <a:srgbClr val="FFFFFF"/>
+          </a:solidFill>
+          <a:ln w="9525">
+            <a:solidFill>
+              <a:srgbClr val="B8C4BC"/>
+            </a:solidFill>
+            <a:prstDash val="solid"/>
+          </a:ln>
+        </p:spPr>
+      </p:sp>
+      <p:pic>
+        <p:nvPicPr>
+          <p:cNvPr id="18" name="Image 0" descr="img/camp_cards.png">    </p:cNvPr>
+          <p:cNvPicPr>
+            <a:picLocks noChangeAspect="1"/>
+          </p:cNvPicPr>
+          <p:nvPr/>
+        </p:nvPicPr>
+        <p:blipFill>
+          <a:blip r:embed="rId1"/>
+          <a:stretch>
+            <a:fillRect/>
+          </a:stretch>
+        </p:blipFill>
+        <p:spPr>
+          <a:xfrm>
+            <a:off x="1177024" y="2331720"/>
+            <a:ext cx="6789952" cy="1417320"/>
+          </a:xfrm>
+          <a:prstGeom prst="rect">
+            <a:avLst/>
+          </a:prstGeom>
+        </p:spPr>
+      </p:pic>
+      <p:sp>
+        <p:nvSpPr>
+          <p:cNvPr id="19" name="Text 15"/>
+          <p:cNvSpPr txBox="1"/>
+          <p:nvPr/>
+        </p:nvSpPr>
+        <p:spPr>
+          <a:xfrm>
+            <a:off x="457200" y="3794760"/>
+            <a:ext cx="8229600" cy="914400"/>
+          </a:xfrm>
+          <a:prstGeom prst="rect">
+            <a:avLst/>
+          </a:prstGeom>
+          <a:noFill/>
+          <a:ln/>
+        </p:spPr>
+        <p:txBody>
+          <a:bodyPr wrap="square" lIns="0" tIns="0" rIns="0" bIns="0" rtlCol="0" anchor="t"/>
+          <a:lstStyle/>
+          <a:p>
             <a:pPr marL="342900" indent="-342900">
               <a:spcAft>
-                <a:spcPts val="700"/>
+                <a:spcPts val="300"/>
               </a:spcAft>
               <a:buSzPct val="100000"/>
               <a:buChar char="•"/>
             </a:pPr>
             <a:r>
-              <a:rPr lang="en-US" sz="1250" dirty="0">
+              <a:rPr lang="en-US" sz="1100" dirty="0">
                 <a:solidFill>
                   <a:srgbClr val="1B2A22"/>
                 </a:solidFill>
@@ -11214,20 +10492,20 @@
                 <a:ea typeface="Calibri" pitchFamily="34" charset="-122"/>
                 <a:cs typeface="Calibri" pitchFamily="34" charset="-120"/>
               </a:rPr>
-              <a:t>No mesmo selo: 4 titulares e reservas ordenadas por estrato</a:t>
-            </a:r>
-            <a:endParaRPr lang="en-US" sz="1250" dirty="0"/>
+              <a:t>Tempo total de voo: de 2,6 h a 11 h, sem contar o deslocamento, que domina a campanha</a:t>
+            </a:r>
+            <a:endParaRPr lang="en-US" sz="1100" dirty="0"/>
           </a:p>
           <a:p>
             <a:pPr marL="342900" indent="-342900">
               <a:spcAft>
-                <a:spcPts val="700"/>
+                <a:spcPts val="300"/>
               </a:spcAft>
               <a:buSzPct val="100000"/>
               <a:buChar char="•"/>
             </a:pPr>
             <a:r>
-              <a:rPr lang="en-US" sz="1250" dirty="0">
+              <a:rPr lang="en-US" sz="1100" dirty="0">
                 <a:solidFill>
                   <a:srgbClr val="1B2A22"/>
                 </a:solidFill>
@@ -11235,20 +10513,20 @@
                 <a:ea typeface="Calibri" pitchFamily="34" charset="-122"/>
                 <a:cs typeface="Calibri" pitchFamily="34" charset="-120"/>
               </a:rPr>
-              <a:t>Recusa aciona a próxima reserva do mesmo estrato</a:t>
-            </a:r>
-            <a:endParaRPr lang="en-US" sz="1250" dirty="0"/>
+              <a:t>Nº de baterias e de decolagens: ainda não definido; depende da aeronave e do agrupamento</a:t>
+            </a:r>
+            <a:endParaRPr lang="en-US" sz="1100" dirty="0"/>
           </a:p>
           <a:p>
             <a:pPr marL="342900" indent="-342900">
               <a:spcAft>
-                <a:spcPts val="700"/>
+                <a:spcPts val="300"/>
               </a:spcAft>
               <a:buSzPct val="100000"/>
               <a:buChar char="•"/>
             </a:pPr>
             <a:r>
-              <a:rPr lang="en-US" sz="1250" dirty="0">
+              <a:rPr lang="en-US" sz="1100" dirty="0">
                 <a:solidFill>
                   <a:srgbClr val="1B2A22"/>
                 </a:solidFill>
@@ -11256,57 +10534,15 @@
                 <a:ea typeface="Calibri" pitchFamily="34" charset="-122"/>
                 <a:cs typeface="Calibri" pitchFamily="34" charset="-120"/>
               </a:rPr>
-              <a:t>A reserva herda o papel (treino ou teste)</a:t>
-            </a:r>
-            <a:endParaRPr lang="en-US" sz="1250" dirty="0"/>
-          </a:p>
-          <a:p>
-            <a:pPr marL="342900" indent="-342900">
-              <a:spcAft>
-                <a:spcPts val="700"/>
-              </a:spcAft>
-              <a:buSzPct val="100000"/>
-              <a:buChar char="•"/>
-            </a:pPr>
-            <a:r>
-              <a:rPr lang="en-US" sz="1250" dirty="0">
-                <a:solidFill>
-                  <a:srgbClr val="1B2A22"/>
-                </a:solidFill>
-                <a:latin typeface="Calibri" pitchFamily="34" charset="0"/>
-                <a:ea typeface="Calibri" pitchFamily="34" charset="-122"/>
-                <a:cs typeface="Calibri" pitchFamily="34" charset="-120"/>
-              </a:rPr>
-              <a:t>Registro append-only, com data e motivo</a:t>
-            </a:r>
-            <a:endParaRPr lang="en-US" sz="1250" dirty="0"/>
-          </a:p>
-          <a:p>
-            <a:pPr marL="342900" indent="-342900">
-              <a:spcAft>
-                <a:spcPts val="700"/>
-              </a:spcAft>
-              <a:buSzPct val="100000"/>
-              <a:buChar char="•"/>
-            </a:pPr>
-            <a:r>
-              <a:rPr lang="en-US" sz="1250" dirty="0">
-                <a:solidFill>
-                  <a:srgbClr val="1B2A22"/>
-                </a:solidFill>
-                <a:latin typeface="Calibri" pitchFamily="34" charset="0"/>
-                <a:ea typeface="Calibri" pitchFamily="34" charset="-122"/>
-                <a:cs typeface="Calibri" pitchFamily="34" charset="-120"/>
-              </a:rPr>
-              <a:t>Parâmetros em aberto: número de reservas, n mínimo e taxa de recusa</a:t>
-            </a:r>
-            <a:endParaRPr lang="en-US" sz="1250" dirty="0"/>
-          </a:p>
-        </p:txBody>
-      </p:sp>
-      <p:sp>
-        <p:nvSpPr>
-          <p:cNvPr id="11" name="Text 8"/>
+              <a:t>Base: 2 missões medidas (uma terceira foi excluída por ortomosaico degenerado); é uma faixa, não uma estimativa precisa</a:t>
+            </a:r>
+            <a:endParaRPr lang="en-US" sz="1100" dirty="0"/>
+          </a:p>
+        </p:txBody>
+      </p:sp>
+      <p:sp>
+        <p:nvSpPr>
+          <p:cNvPr id="20" name="Text 16"/>
           <p:cNvSpPr txBox="1"/>
           <p:nvPr/>
         </p:nvSpPr>
@@ -11337,7 +10573,7 @@
                 <a:ea typeface="Calibri" pitchFamily="34" charset="-122"/>
                 <a:cs typeface="Calibri" pitchFamily="34" charset="-120"/>
               </a:rPr>
-              <a:t>Refs.: D23; King &amp; Zeng (2001); Olofsson et al. (2014); Cochran (1977). O protocolo de reservas é proposta, em implementação.</a:t>
+              <a:t>Fonte: D16; cobertura_voos.geojson (Missões 000 e 009); agrupamento: planejador de jornadas (teto padrão 6).</a:t>
             </a:r>
             <a:endParaRPr lang="en-US" sz="1000" dirty="0"/>
           </a:p>

</xml_diff>

<commit_message>
docs: apresentação SAREL: slide de logística explica por que 72 polígonos
Co-Authored-By: Claude Sonnet 5.5 <noreply@anthropic.com>
Claude-Session: https://claude.ai/code/session_01QBooVKGGKQGrenTtP2atqx
</commit_message>
<xml_diff>
--- a/docs/Apresentacao_SAREL_Plataforma_Metodo_Desafios.pptx
+++ b/docs/Apresentacao_SAREL_Plataforma_Metodo_Desafios.pptx
@@ -1930,7 +1930,7 @@
           <a:p>
             <a:r>
               <a:rPr lang="en-US" dirty="0"/>
-              <a:t>(1,5 min) Quantidade de voos: são 72 polígonos de 5,02 ha, ou seja, 72 missões de mapeamento, uma por polígono; eram 36 no desenho anterior. Elas não precisam ser 72 saídas: o planejador agrupa polígonos próximos em jornadas de campo, com teto padrão de 6 polígonos por jornada, ajustável, o que dá cerca de 12 jornadas. Esse agrupamento é uma proposta do planejador, ainda não validada em campo. Tempo de voo: a produtividade medida foi de 2,3 ha/min na Missão 009, o que dá cerca de 2,2 min por polígono; mas a única outra missão válida, a 000, teve 0,53 ha/min, o que dá cerca de 9,5 min. Com duas missões medidas, a faixa honesta é de 2 a 10 minutos por polígono, ou de 2,6 a 11 horas de voo no total, sem contar deslocamento. O que domina a campanha é deslocamento, montagem e as 72 autorizações. O número de baterias e de decolagens não está definido: depende da aeronave e do agrupamento, e não tenho esse dado. A tela mostra os três conjuntos da campanha.</a:t>
+              <a:t>(1,5 min) Quantidade de voos: são 72 polígonos de 5,02 ha, ou seja, 72 missões de mapeamento, uma por polígono; eram 36 no desenho anterior. Elas não precisam ser 72 saídas: o planejador agrupa polígonos próximos em jornadas de campo, com teto padrão de 6 polígonos por jornada, ajustável, o que dá cerca de 12 jornadas. Esse agrupamento é uma proposta do planejador, ainda não validada em campo. Tempo de voo: a produtividade medida foi de 2,3 ha/min na Missão 009, o que dá cerca de 2,2 min por polígono; mas a única outra missão válida, a 000, teve 0,53 ha/min, o que dá cerca de 9,5 min. Com duas missões medidas, a faixa honesta é de 2 a 10 minutos por polígono, ou de 2,6 a 11 horas de voo no total, sem contar deslocamento. O que domina a campanha é deslocamento, montagem e as 72 autorizações. O número de baterias e de decolagens não está definido: depende da aeronave e do agrupamento, e não tenho esse dado. Por que 72: é a estrutura de 18 estratos com 4 polígonos cada, e não um excesso. A área total de cerca de 361 ha é o que o custo de voo suporta; ela rende cerca de 1.845 unidades espacialmente independentes (D24), no limite para o bloco espectral e abaixo do recomendado para solo, chuva e terreno. A tela mostra os três conjuntos da campanha.</a:t>
             </a:r>
             <a:endParaRPr lang="en-US" dirty="0"/>
           </a:p>
@@ -10414,8 +10414,8 @@
         </p:nvSpPr>
         <p:spPr>
           <a:xfrm>
-            <a:off x="1158736" y="2313432"/>
-            <a:ext cx="6826528" cy="1453896"/>
+            <a:off x="1815828" y="2267712"/>
+            <a:ext cx="5512343" cy="1179576"/>
           </a:xfrm>
           <a:prstGeom prst="rect">
             <a:avLst/>
@@ -10447,8 +10447,8 @@
         </p:blipFill>
         <p:spPr>
           <a:xfrm>
-            <a:off x="1177024" y="2331720"/>
-            <a:ext cx="6789952" cy="1417320"/>
+            <a:off x="1834116" y="2286000"/>
+            <a:ext cx="5475767" cy="1143000"/>
           </a:xfrm>
           <a:prstGeom prst="rect">
             <a:avLst/>
@@ -10463,8 +10463,8 @@
         </p:nvSpPr>
         <p:spPr>
           <a:xfrm>
-            <a:off x="457200" y="3794760"/>
-            <a:ext cx="8229600" cy="914400"/>
+            <a:off x="457200" y="3474720"/>
+            <a:ext cx="8229600" cy="1280160"/>
           </a:xfrm>
           <a:prstGeom prst="rect">
             <a:avLst/>
@@ -10478,13 +10478,13 @@
           <a:p>
             <a:pPr marL="342900" indent="-342900">
               <a:spcAft>
-                <a:spcPts val="300"/>
+                <a:spcPts val="200"/>
               </a:spcAft>
               <a:buSzPct val="100000"/>
               <a:buChar char="•"/>
             </a:pPr>
             <a:r>
-              <a:rPr lang="en-US" sz="1100" dirty="0">
+              <a:rPr lang="en-US" sz="1050" dirty="0">
                 <a:solidFill>
                   <a:srgbClr val="1B2A22"/>
                 </a:solidFill>
@@ -10492,20 +10492,20 @@
                 <a:ea typeface="Calibri" pitchFamily="34" charset="-122"/>
                 <a:cs typeface="Calibri" pitchFamily="34" charset="-120"/>
               </a:rPr>
-              <a:t>Tempo total de voo: de 2,6 h a 11 h, sem contar o deslocamento, que domina a campanha</a:t>
-            </a:r>
-            <a:endParaRPr lang="en-US" sz="1100" dirty="0"/>
+              <a:t>Por que 72: 18 estratos × 4 polígonos (2 treino + 2 teste); a área total, cerca de 361 ha, é o que o custo de voo suporta e rende cerca de 1.845 unidades independentes (D24): no limite para o bloco espectral e abaixo do recomendado para solo, chuva e terreno</a:t>
+            </a:r>
+            <a:endParaRPr lang="en-US" sz="1050" dirty="0"/>
           </a:p>
           <a:p>
             <a:pPr marL="342900" indent="-342900">
               <a:spcAft>
-                <a:spcPts val="300"/>
+                <a:spcPts val="200"/>
               </a:spcAft>
               <a:buSzPct val="100000"/>
               <a:buChar char="•"/>
             </a:pPr>
             <a:r>
-              <a:rPr lang="en-US" sz="1100" dirty="0">
+              <a:rPr lang="en-US" sz="1050" dirty="0">
                 <a:solidFill>
                   <a:srgbClr val="1B2A22"/>
                 </a:solidFill>
@@ -10513,20 +10513,20 @@
                 <a:ea typeface="Calibri" pitchFamily="34" charset="-122"/>
                 <a:cs typeface="Calibri" pitchFamily="34" charset="-120"/>
               </a:rPr>
-              <a:t>Nº de baterias e de decolagens: ainda não definido; depende da aeronave e do agrupamento</a:t>
-            </a:r>
-            <a:endParaRPr lang="en-US" sz="1100" dirty="0"/>
+              <a:t>Tempo total de voo: de 2,6 h a 11 h, sem contar o deslocamento, que domina a campanha</a:t>
+            </a:r>
+            <a:endParaRPr lang="en-US" sz="1050" dirty="0"/>
           </a:p>
           <a:p>
             <a:pPr marL="342900" indent="-342900">
               <a:spcAft>
-                <a:spcPts val="300"/>
+                <a:spcPts val="200"/>
               </a:spcAft>
               <a:buSzPct val="100000"/>
               <a:buChar char="•"/>
             </a:pPr>
             <a:r>
-              <a:rPr lang="en-US" sz="1100" dirty="0">
+              <a:rPr lang="en-US" sz="1050" dirty="0">
                 <a:solidFill>
                   <a:srgbClr val="1B2A22"/>
                 </a:solidFill>
@@ -10534,9 +10534,30 @@
                 <a:ea typeface="Calibri" pitchFamily="34" charset="-122"/>
                 <a:cs typeface="Calibri" pitchFamily="34" charset="-120"/>
               </a:rPr>
+              <a:t>Nº de baterias e de decolagens: ainda não definido; depende da aeronave e do agrupamento</a:t>
+            </a:r>
+            <a:endParaRPr lang="en-US" sz="1050" dirty="0"/>
+          </a:p>
+          <a:p>
+            <a:pPr marL="342900" indent="-342900">
+              <a:spcAft>
+                <a:spcPts val="200"/>
+              </a:spcAft>
+              <a:buSzPct val="100000"/>
+              <a:buChar char="•"/>
+            </a:pPr>
+            <a:r>
+              <a:rPr lang="en-US" sz="1050" dirty="0">
+                <a:solidFill>
+                  <a:srgbClr val="1B2A22"/>
+                </a:solidFill>
+                <a:latin typeface="Calibri" pitchFamily="34" charset="0"/>
+                <a:ea typeface="Calibri" pitchFamily="34" charset="-122"/>
+                <a:cs typeface="Calibri" pitchFamily="34" charset="-120"/>
+              </a:rPr>
               <a:t>Base: 2 missões medidas (uma terceira foi excluída por ortomosaico degenerado); é uma faixa, não uma estimativa precisa</a:t>
             </a:r>
-            <a:endParaRPr lang="en-US" sz="1100" dirty="0"/>
+            <a:endParaRPr lang="en-US" sz="1050" dirty="0"/>
           </a:p>
         </p:txBody>
       </p:sp>

</xml_diff>

<commit_message>
docs: apresentação SAREL: slide 6 inclui bloco sobre uso da série temporal
Co-Authored-By: Claude Sonnet 5.5 <noreply@anthropic.com>
Claude-Session: https://claude.ai/code/session_01QBooVKGGKQGrenTtP2atqx
</commit_message>
<xml_diff>
--- a/docs/Apresentacao_SAREL_Plataforma_Metodo_Desafios.pptx
+++ b/docs/Apresentacao_SAREL_Plataforma_Metodo_Desafios.pptx
@@ -1666,7 +1666,7 @@
           <a:p>
             <a:r>
               <a:rPr lang="en-US" dirty="0"/>
-              <a:t>(1,5 min) Estratificar é dividir os candidatos em grupos internamente parecidos e amostrar cada grupo separadamente, para que as combinações raras também entrem na amostra. Usamos três dimensões. Declividade, em três faixas (tercis): é a energia do relevo, que governa o escoamento. Frequência de solo nu, em três faixas: é o tempo em que o solo fica descoberto e exposto à chuva. Erodibilidade, em dois níveis: é a suscetibilidade intrínseca do solo, vinda da carta da Embrapa de 2024; nível 2 são as classes alta, muito alta e extremamente alta. Tercil significa dividir os candidatos em três grupos de tamanho aproximado; os dois cortes são calculados sobre os candidatos da própria área, e valores empatados no corte caem no grupo mais baixo, de modo que os grupos podem diferir um pouco em tamanho. 3 x 3 x 2 dá 18 estratos, com quatro polígonos cada: dois para treino e dois para teste. A decisão sobre a classe 6 foi aprovada em 19/10 e está em registro.</a:t>
+              <a:t>(1,5 min) Estratificar é dividir os candidatos em grupos internamente parecidos e amostrar cada grupo separadamente, para que as combinações raras também entrem na amostra. Usamos três dimensões. Declividade, em três faixas (tercis): é a energia do relevo, que governa o escoamento. Frequência de solo nu, em três faixas: é o tempo em que o solo fica descoberto e exposto à chuva. Erodibilidade, em dois níveis: é a suscetibilidade intrínseca do solo, vinda da carta da Embrapa de 2024; nível 2 são as classes alta, muito alta e extremamente alta. Tercil significa dividir os candidatos em três grupos de tamanho aproximado; os dois cortes são calculados sobre os candidatos da própria área, e valores empatados no corte caem no grupo mais baixo, de modo que os grupos podem diferir um pouco em tamanho. 3 x 3 x 2 dá 18 estratos, com quatro polígonos cada: dois para treino e dois para teste. A decisão sobre a classe 6 foi aprovada em 19/10 e está em registro. Onde entra a série temporal: a frequência de solo nu, calculada sobre a fração de cenas Sentinel-2 válidas de 2016 a 2026, é o eixo de solo nu dos estratos; as métricas da série, como persistência e maior sequência de solo nu, também alimentam os preditores do modelo; e há um mínimo de 6 observações válidas por célula e janela, abaixo do qual a métrica é indisponível, não deflacionada. A frequência de solo nu ainda não foi medida, por falta da credencial do Google Earth Engine.</a:t>
             </a:r>
             <a:endParaRPr lang="en-US" dirty="0"/>
           </a:p>
@@ -8405,12 +8405,12 @@
         </p:nvSpPr>
         <p:spPr>
           <a:xfrm>
-            <a:off x="457200" y="1005840"/>
-            <a:ext cx="2468880" cy="1874520"/>
+            <a:off x="457200" y="914400"/>
+            <a:ext cx="2468880" cy="1783080"/>
           </a:xfrm>
           <a:prstGeom prst="roundRect">
             <a:avLst>
-              <a:gd name="adj" fmla="val 3902"/>
+              <a:gd name="adj" fmla="val 4103"/>
             </a:avLst>
           </a:prstGeom>
           <a:solidFill>
@@ -8432,7 +8432,7 @@
         </p:nvSpPr>
         <p:spPr>
           <a:xfrm>
-            <a:off x="594360" y="1097280"/>
+            <a:off x="594360" y="987552"/>
             <a:ext cx="2194560" cy="365760"/>
           </a:xfrm>
           <a:prstGeom prst="rect">
@@ -8471,7 +8471,7 @@
         </p:nvSpPr>
         <p:spPr>
           <a:xfrm>
-            <a:off x="594360" y="1481328"/>
+            <a:off x="594360" y="1325880"/>
             <a:ext cx="2194560" cy="274320"/>
           </a:xfrm>
           <a:prstGeom prst="rect">
@@ -8510,8 +8510,8 @@
         </p:nvSpPr>
         <p:spPr>
           <a:xfrm>
-            <a:off x="594360" y="1810512"/>
-            <a:ext cx="2194560" cy="1280160"/>
+            <a:off x="594360" y="1627632"/>
+            <a:ext cx="2194560" cy="1051560"/>
           </a:xfrm>
           <a:prstGeom prst="rect">
             <a:avLst/>
@@ -8527,7 +8527,7 @@
               <a:buNone/>
             </a:pPr>
             <a:r>
-              <a:rPr lang="en-US" sz="1150" dirty="0">
+              <a:rPr lang="en-US" sz="1050" dirty="0">
                 <a:solidFill>
                   <a:srgbClr val="1B2A22"/>
                 </a:solidFill>
@@ -8537,7 +8537,7 @@
               </a:rPr>
               <a:t>Energia do relevo: quanto mais inclinado, maior a capacidade de transporte do escoamento.</a:t>
             </a:r>
-            <a:endParaRPr lang="en-US" sz="1150" dirty="0"/>
+            <a:endParaRPr lang="en-US" sz="1050" dirty="0"/>
           </a:p>
         </p:txBody>
       </p:sp>
@@ -8549,7 +8549,7 @@
         </p:nvSpPr>
         <p:spPr>
           <a:xfrm>
-            <a:off x="2926080" y="1783080"/>
+            <a:off x="2926080" y="1554480"/>
             <a:ext cx="365760" cy="548640"/>
           </a:xfrm>
           <a:prstGeom prst="rect">
@@ -8588,12 +8588,12 @@
         </p:nvSpPr>
         <p:spPr>
           <a:xfrm>
-            <a:off x="3291840" y="1005840"/>
-            <a:ext cx="2468880" cy="1874520"/>
+            <a:off x="3291840" y="914400"/>
+            <a:ext cx="2468880" cy="1783080"/>
           </a:xfrm>
           <a:prstGeom prst="roundRect">
             <a:avLst>
-              <a:gd name="adj" fmla="val 3902"/>
+              <a:gd name="adj" fmla="val 4103"/>
             </a:avLst>
           </a:prstGeom>
           <a:solidFill>
@@ -8615,7 +8615,7 @@
         </p:nvSpPr>
         <p:spPr>
           <a:xfrm>
-            <a:off x="3429000" y="1097280"/>
+            <a:off x="3429000" y="987552"/>
             <a:ext cx="2194560" cy="365760"/>
           </a:xfrm>
           <a:prstGeom prst="rect">
@@ -8654,7 +8654,7 @@
         </p:nvSpPr>
         <p:spPr>
           <a:xfrm>
-            <a:off x="3429000" y="1481328"/>
+            <a:off x="3429000" y="1325880"/>
             <a:ext cx="2194560" cy="274320"/>
           </a:xfrm>
           <a:prstGeom prst="rect">
@@ -8693,8 +8693,8 @@
         </p:nvSpPr>
         <p:spPr>
           <a:xfrm>
-            <a:off x="3429000" y="1810512"/>
-            <a:ext cx="2194560" cy="1280160"/>
+            <a:off x="3429000" y="1627632"/>
+            <a:ext cx="2194560" cy="1051560"/>
           </a:xfrm>
           <a:prstGeom prst="rect">
             <a:avLst/>
@@ -8710,7 +8710,7 @@
               <a:buNone/>
             </a:pPr>
             <a:r>
-              <a:rPr lang="en-US" sz="1150" dirty="0">
+              <a:rPr lang="en-US" sz="1050" dirty="0">
                 <a:solidFill>
                   <a:srgbClr val="1B2A22"/>
                 </a:solidFill>
@@ -8720,7 +8720,7 @@
               </a:rPr>
               <a:t>Tempo de solo descoberto: fração de cenas de satélite válidas em que a célula aparece exposta à chuva.</a:t>
             </a:r>
-            <a:endParaRPr lang="en-US" sz="1150" dirty="0"/>
+            <a:endParaRPr lang="en-US" sz="1050" dirty="0"/>
           </a:p>
         </p:txBody>
       </p:sp>
@@ -8732,7 +8732,7 @@
         </p:nvSpPr>
         <p:spPr>
           <a:xfrm>
-            <a:off x="5760720" y="1783080"/>
+            <a:off x="5760720" y="1554480"/>
             <a:ext cx="365760" cy="548640"/>
           </a:xfrm>
           <a:prstGeom prst="rect">
@@ -8771,12 +8771,12 @@
         </p:nvSpPr>
         <p:spPr>
           <a:xfrm>
-            <a:off x="6126480" y="1005840"/>
-            <a:ext cx="2468880" cy="1874520"/>
+            <a:off x="6126480" y="914400"/>
+            <a:ext cx="2468880" cy="1783080"/>
           </a:xfrm>
           <a:prstGeom prst="roundRect">
             <a:avLst>
-              <a:gd name="adj" fmla="val 3902"/>
+              <a:gd name="adj" fmla="val 4103"/>
             </a:avLst>
           </a:prstGeom>
           <a:solidFill>
@@ -8798,7 +8798,7 @@
         </p:nvSpPr>
         <p:spPr>
           <a:xfrm>
-            <a:off x="6263640" y="1097280"/>
+            <a:off x="6263640" y="987552"/>
             <a:ext cx="2194560" cy="365760"/>
           </a:xfrm>
           <a:prstGeom prst="rect">
@@ -8837,7 +8837,7 @@
         </p:nvSpPr>
         <p:spPr>
           <a:xfrm>
-            <a:off x="6263640" y="1481328"/>
+            <a:off x="6263640" y="1325880"/>
             <a:ext cx="2194560" cy="274320"/>
           </a:xfrm>
           <a:prstGeom prst="rect">
@@ -8876,8 +8876,8 @@
         </p:nvSpPr>
         <p:spPr>
           <a:xfrm>
-            <a:off x="6263640" y="1810512"/>
-            <a:ext cx="2194560" cy="1280160"/>
+            <a:off x="6263640" y="1627632"/>
+            <a:ext cx="2194560" cy="1051560"/>
           </a:xfrm>
           <a:prstGeom prst="rect">
             <a:avLst/>
@@ -8893,7 +8893,7 @@
               <a:buNone/>
             </a:pPr>
             <a:r>
-              <a:rPr lang="en-US" sz="1150" dirty="0">
+              <a:rPr lang="en-US" sz="1050" dirty="0">
                 <a:solidFill>
                   <a:srgbClr val="1B2A22"/>
                 </a:solidFill>
@@ -8903,7 +8903,7 @@
               </a:rPr>
               <a:t>Carta Embrapa 2024. Nível 1: muito baixa a média (K ≤ 0,0285). Nível 2: alta e muito alta (K ≥ 0,0300); a extremamente alta entra por emenda em registro.</a:t>
             </a:r>
-            <a:endParaRPr lang="en-US" sz="1150" dirty="0"/>
+            <a:endParaRPr lang="en-US" sz="1050" dirty="0"/>
           </a:p>
         </p:txBody>
       </p:sp>
@@ -8915,8 +8915,8 @@
         </p:nvSpPr>
         <p:spPr>
           <a:xfrm>
-            <a:off x="457200" y="3017520"/>
-            <a:ext cx="8229600" cy="365760"/>
+            <a:off x="457200" y="2788920"/>
+            <a:ext cx="8229600" cy="320040"/>
           </a:xfrm>
           <a:prstGeom prst="rect">
             <a:avLst/>
@@ -8932,7 +8932,7 @@
               <a:buNone/>
             </a:pPr>
             <a:r>
-              <a:rPr lang="en-US" sz="1500" b="1" dirty="0">
+              <a:rPr lang="en-US" sz="1400" b="1" dirty="0">
                 <a:solidFill>
                   <a:srgbClr val="1B2A22"/>
                 </a:solidFill>
@@ -8942,7 +8942,7 @@
               </a:rPr>
               <a:t>3 × 3 × 2 = 18 estratos × 4 polígonos (2 treino + 2 held-out) = 72</a:t>
             </a:r>
-            <a:endParaRPr lang="en-US" sz="1500" dirty="0"/>
+            <a:endParaRPr lang="en-US" sz="1400" dirty="0"/>
           </a:p>
         </p:txBody>
       </p:sp>
@@ -8954,8 +8954,8 @@
         </p:nvSpPr>
         <p:spPr>
           <a:xfrm>
-            <a:off x="457200" y="3520440"/>
-            <a:ext cx="8229600" cy="1097280"/>
+            <a:off x="457200" y="3154680"/>
+            <a:ext cx="8229600" cy="731520"/>
           </a:xfrm>
           <a:prstGeom prst="rect">
             <a:avLst/>
@@ -8969,13 +8969,13 @@
           <a:p>
             <a:pPr marL="342900" indent="-342900">
               <a:spcAft>
-                <a:spcPts val="500"/>
+                <a:spcPts val="200"/>
               </a:spcAft>
               <a:buSzPct val="100000"/>
               <a:buChar char="•"/>
             </a:pPr>
             <a:r>
-              <a:rPr lang="en-US" sz="1200" dirty="0">
+              <a:rPr lang="en-US" sz="1050" dirty="0">
                 <a:solidFill>
                   <a:srgbClr val="1B2A22"/>
                 </a:solidFill>
@@ -8983,20 +8983,20 @@
                 <a:ea typeface="Calibri" pitchFamily="34" charset="-122"/>
                 <a:cs typeface="Calibri" pitchFamily="34" charset="-120"/>
               </a:rPr>
-              <a:t>Por que estratificar: sem isso, o acaso concentraria a amostra nas combinações comuns e deixaria vazios os estratos raros (declive alto, muito solo nu, solo erodível), que são justamente os de maior interesse</a:t>
-            </a:r>
-            <a:endParaRPr lang="en-US" sz="1200" dirty="0"/>
+              <a:t>Por que estratificar: sem isso o acaso concentraria a amostra nas combinações comuns e deixaria vazios os estratos raros, de maior interesse</a:t>
+            </a:r>
+            <a:endParaRPr lang="en-US" sz="1050" dirty="0"/>
           </a:p>
           <a:p>
             <a:pPr marL="342900" indent="-342900">
               <a:spcAft>
-                <a:spcPts val="500"/>
+                <a:spcPts val="200"/>
               </a:spcAft>
               <a:buSzPct val="100000"/>
               <a:buChar char="•"/>
             </a:pPr>
             <a:r>
-              <a:rPr lang="en-US" sz="1200" dirty="0">
+              <a:rPr lang="en-US" sz="1050" dirty="0">
                 <a:solidFill>
                   <a:srgbClr val="1B2A22"/>
                 </a:solidFill>
@@ -9004,15 +9004,120 @@
                 <a:ea typeface="Calibri" pitchFamily="34" charset="-122"/>
                 <a:cs typeface="Calibri" pitchFamily="34" charset="-120"/>
               </a:rPr>
-              <a:t>Tercil: divide em três grupos de tamanho aproximado; o corte é calculado sobre os candidatos da própria área e empates caem no grupo mais baixo</a:t>
-            </a:r>
-            <a:endParaRPr lang="en-US" sz="1200" dirty="0"/>
-          </a:p>
-        </p:txBody>
-      </p:sp>
-      <p:sp>
-        <p:nvSpPr>
-          <p:cNvPr id="21" name="Text 18"/>
+              <a:t>Tercil: três grupos de tamanho aproximado; o corte é calculado sobre os candidatos da própria área e empates caem no grupo mais baixo</a:t>
+            </a:r>
+            <a:endParaRPr lang="en-US" sz="1050" dirty="0"/>
+          </a:p>
+        </p:txBody>
+      </p:sp>
+      <p:sp>
+        <p:nvSpPr>
+          <p:cNvPr id="21" name="Shape 18"/>
+          <p:cNvSpPr/>
+          <p:nvPr/>
+        </p:nvSpPr>
+        <p:spPr>
+          <a:xfrm>
+            <a:off x="457200" y="3886200"/>
+            <a:ext cx="8229600" cy="822960"/>
+          </a:xfrm>
+          <a:prstGeom prst="roundRect">
+            <a:avLst>
+              <a:gd name="adj" fmla="val 8889"/>
+            </a:avLst>
+          </a:prstGeom>
+          <a:solidFill>
+            <a:srgbClr val="FBEFE6"/>
+          </a:solidFill>
+          <a:ln w="12700">
+            <a:solidFill>
+              <a:srgbClr val="FBEFE6"/>
+            </a:solidFill>
+            <a:prstDash val="solid"/>
+          </a:ln>
+        </p:spPr>
+      </p:sp>
+      <p:sp>
+        <p:nvSpPr>
+          <p:cNvPr id="22" name="Text 19"/>
+          <p:cNvSpPr txBox="1"/>
+          <p:nvPr/>
+        </p:nvSpPr>
+        <p:spPr>
+          <a:xfrm>
+            <a:off x="594360" y="3922776"/>
+            <a:ext cx="7955280" cy="228600"/>
+          </a:xfrm>
+          <a:prstGeom prst="rect">
+            <a:avLst/>
+          </a:prstGeom>
+          <a:noFill/>
+          <a:ln/>
+        </p:spPr>
+        <p:txBody>
+          <a:bodyPr wrap="square" lIns="0" tIns="0" rIns="0" bIns="0" rtlCol="0" anchor="t"/>
+          <a:lstStyle/>
+          <a:p>
+            <a:pPr indent="0" marL="0">
+              <a:buNone/>
+            </a:pPr>
+            <a:r>
+              <a:rPr lang="en-US" sz="1150" b="1" dirty="0">
+                <a:solidFill>
+                  <a:srgbClr val="C65D3B"/>
+                </a:solidFill>
+                <a:latin typeface="Cambria" pitchFamily="34" charset="0"/>
+                <a:ea typeface="Cambria" pitchFamily="34" charset="-122"/>
+                <a:cs typeface="Cambria" pitchFamily="34" charset="-120"/>
+              </a:rPr>
+              <a:t>Onde entra a série temporal (Sentinel-2, 2016–2026)</a:t>
+            </a:r>
+            <a:endParaRPr lang="en-US" sz="1150" dirty="0"/>
+          </a:p>
+        </p:txBody>
+      </p:sp>
+      <p:sp>
+        <p:nvSpPr>
+          <p:cNvPr id="23" name="Text 20"/>
+          <p:cNvSpPr txBox="1"/>
+          <p:nvPr/>
+        </p:nvSpPr>
+        <p:spPr>
+          <a:xfrm>
+            <a:off x="594360" y="4160520"/>
+            <a:ext cx="7955280" cy="548640"/>
+          </a:xfrm>
+          <a:prstGeom prst="rect">
+            <a:avLst/>
+          </a:prstGeom>
+          <a:noFill/>
+          <a:ln/>
+        </p:spPr>
+        <p:txBody>
+          <a:bodyPr wrap="square" lIns="0" tIns="0" rIns="0" bIns="0" rtlCol="0" anchor="t"/>
+          <a:lstStyle/>
+          <a:p>
+            <a:pPr indent="0" marL="0">
+              <a:buNone/>
+            </a:pPr>
+            <a:r>
+              <a:rPr lang="en-US" sz="1000" dirty="0">
+                <a:solidFill>
+                  <a:srgbClr val="1B2A22"/>
+                </a:solidFill>
+                <a:latin typeface="Calibri" pitchFamily="34" charset="0"/>
+                <a:ea typeface="Calibri" pitchFamily="34" charset="-122"/>
+                <a:cs typeface="Calibri" pitchFamily="34" charset="-120"/>
+              </a:rPr>
+              <a:t>1) Solo nu: fração de cenas válidas em que a célula está exposta = eixo dos estratos.  2) Preditores do modelo: persistência, maior sequência de solo nu e composto espectral.  3) Qualidade: mínimo de 6 observações válidas por célula e janela; abaixo disso a métrica é “indisponível”. A frequência de solo nu ainda não foi medida (falta a credencial do GEE).</a:t>
+            </a:r>
+            <a:endParaRPr lang="en-US" sz="1000" dirty="0"/>
+          </a:p>
+        </p:txBody>
+      </p:sp>
+      <p:sp>
+        <p:nvSpPr>
+          <p:cNvPr id="24" name="Text 21"/>
           <p:cNvSpPr txBox="1"/>
           <p:nvPr/>
         </p:nvSpPr>

</xml_diff>

<commit_message>
docs: apresentação SAREL: remove slide de sorteio selado (13 slides, ~15 min)
Co-Authored-By: Claude Sonnet 5.5 <noreply@anthropic.com>
Claude-Session: https://claude.ai/code/session_01QBooVKGGKQGrenTtP2atqx
</commit_message>
<xml_diff>
--- a/docs/Apresentacao_SAREL_Plataforma_Metodo_Desafios.pptx
+++ b/docs/Apresentacao_SAREL_Plataforma_Metodo_Desafios.pptx
@@ -18,10 +18,9 @@
     <p:sldId id="266" r:id="rId12"/>
     <p:sldId id="267" r:id="rId13"/>
     <p:sldId id="268" r:id="rId14"/>
-    <p:sldId id="269" r:id="rId15"/>
   </p:sldIdLst>
   <p:notesMasterIdLst>
-    <p:notesMasterId r:id="rId16"/>
+    <p:notesMasterId r:id="rId15"/>
   </p:notesMasterIdLst>
   <p:sldSz cx="9144000" cy="5143500"/>
   <p:notesSz cx="5143500" cy="9144000"/>
@@ -874,7 +873,7 @@
           <a:p>
             <a:r>
               <a:rPr lang="en-US" dirty="0"/>
-              <a:t>(1 min) O alvo do modelo não é uma classe, e sim a fração da célula de 10 m delineada como erodida, entre 0 e 1, obtida por rasterização da delineação feita sobre o ortomosaico. O binário, fração maior ou igual a 25%, é derivado e secundário. O intérprete recebe só um código opaco, sem estrato nem papel; o app tem exportação cega por perfil. Isso impede que o modelo aprenda a concordar com o rastreio espectral. Planos de voo só saem com terreno real; os de demonstração são marcados como sintéticos.</a:t>
+              <a:t>(1 min) O campo deixou de ser massa de treino e virou âncora: 60 a 80 pontos dispersos pela bacia, fora dos polígonos, sorteados com probabilidade conhecida, coletados no aplicativo SAREL Coletor, em Android, sob protocolo cego. A função é estimar a prevalência real, por estimador ponderado, e calibrar a acurácia posicional do aparelho. A campanha tem duas ondas; os 30 primeiros pontos são lote piloto. O KoboCollect foi substituído e a fotointerpretação foi aposentada, porque o rótulo centimétrico do voo é melhor e mais fiel ao fenômeno.</a:t>
             </a:r>
             <a:endParaRPr lang="en-US" dirty="0"/>
           </a:p>
@@ -962,7 +961,7 @@
           <a:p>
             <a:r>
               <a:rPr lang="en-US" dirty="0"/>
-              <a:t>(1 min) O campo deixou de ser massa de treino e virou âncora: 60 a 80 pontos dispersos pela bacia, fora dos polígonos, sorteados com probabilidade conhecida, coletados no aplicativo SAREL Coletor, em Android, sob protocolo cego. A função é estimar a prevalência real, por estimador ponderado, e calibrar a acurácia posicional do aparelho. A campanha tem duas ondas; os 30 primeiros pontos são lote piloto. O KoboCollect foi substituído e a fotointerpretação foi aposentada, porque o rótulo centimétrico do voo é melhor e mais fiel ao fenômeno.</a:t>
+              <a:t>(1,5 min) A tela mostra o registro oficial das decisões, com o critério de refutação de D25: três competidores (linha de base RUSLE, regressão penalizada e XGBoost), métrica primária de Spearman no held-out, piso de 0,40 e margem de 0,10 sobre a RUSLE. A inferência usa bootstrap por polígono, porque células do mesmo polígono não são independentes. Os desfechos são corroborada, inconclusiva ou refutada. O estado exibido hoje é 'não avaliado', e isso é intencional: não há resultado. O script grava uma trava e recusa uma segunda avaliação.</a:t>
             </a:r>
             <a:endParaRPr lang="en-US" dirty="0"/>
           </a:p>
@@ -1050,7 +1049,7 @@
           <a:p>
             <a:r>
               <a:rPr lang="en-US" dirty="0"/>
-              <a:t>(1,5 min) A tela mostra o registro oficial das decisões, com o critério de refutação de D25: três competidores (linha de base RUSLE, regressão penalizada e XGBoost), métrica primária de Spearman no held-out, piso de 0,40 e margem de 0,10 sobre a RUSLE. A inferência usa bootstrap por polígono, porque células do mesmo polígono não são independentes. Os desfechos são corroborada, inconclusiva ou refutada. O estado exibido hoje é 'não avaliado', e isso é intencional: não há resultado. O script grava uma trava e recusa uma segunda avaliação.</a:t>
+              <a:t>(1 min) Honestidade sobre o estágio: o que está pronto e o que depende de decisões e de dados. Não há resultado empírico. O sorteio ainda não foi realizado; há decisões do pesquisador pendentes que o sorteio exige e a checagem do pool com candidatos reais. A cifra de acerto de atribuição, antes citada, segue em verificação.</a:t>
             </a:r>
             <a:endParaRPr lang="en-US" dirty="0"/>
           </a:p>
@@ -1138,7 +1137,7 @@
           <a:p>
             <a:r>
               <a:rPr lang="en-US" dirty="0"/>
-              <a:t>(1 min) Honestidade sobre o estágio: o que está pronto e o que depende de decisões e de dados. Não há resultado empírico. O sorteio ainda não foi realizado; há decisões do pesquisador pendentes que o sorteio exige e a checagem do pool com candidatos reais. A cifra de acerto de atribuição, antes citada, segue em verificação.</a:t>
+              <a:t>(Consulta) Lista das referências que sustentam as decisões apresentadas, nos termos em que constam do registro de decisões. As marcadas com † tiveram a leitura e a conferência da fonte feitas no projeto; as demais constam do registro e aguardam conferência bibliográfica completa antes da dissertação.</a:t>
             </a:r>
             <a:endParaRPr lang="en-US" dirty="0"/>
           </a:p>
@@ -1162,94 +1161,6 @@
             <a:fld id="{F7021451-1387-4CA6-816F-3879F97B5CBC}" type="slidenum">
               <a:rPr lang="en-US"/>
               <a:t>13</a:t>
-            </a:fld>
-            <a:endParaRPr lang="en-US"/>
-          </a:p>
-        </p:txBody>
-      </p:sp>
-    </p:spTree>
-    <p:extLst>
-      <p:ext uri="{BB962C8B-B14F-4D97-AF65-F5344CB8AC3E}">
-        <p14:creationId xmlns:p14="http://schemas.microsoft.com/office/powerpoint/2010/main" val="1024086991"/>
-      </p:ext>
-    </p:extLst>
-  </p:cSld>
-  <p:clrMapOvr>
-    <a:masterClrMapping/>
-  </p:clrMapOvr>
-</p:notes>
-</file>
-
-<file path=ppt/notesSlides/notesSlide14.xml><?xml version="1.0" encoding="utf-8"?>
-<p:notes xmlns:a="http://schemas.openxmlformats.org/drawingml/2006/main" xmlns:r="http://schemas.openxmlformats.org/officeDocument/2006/relationships" xmlns:p="http://schemas.openxmlformats.org/presentationml/2006/main">
-  <p:cSld>
-    <p:spTree>
-      <p:nvGrpSpPr>
-        <p:cNvPr id="1" name=""/>
-        <p:cNvGrpSpPr/>
-        <p:nvPr/>
-      </p:nvGrpSpPr>
-      <p:grpSpPr>
-        <a:xfrm>
-          <a:off x="0" y="0"/>
-          <a:ext cx="0" cy="0"/>
-          <a:chOff x="0" y="0"/>
-          <a:chExt cx="0" cy="0"/>
-        </a:xfrm>
-      </p:grpSpPr>
-      <p:sp>
-        <p:nvSpPr>
-          <p:cNvPr id="2" name="Slide Image Placeholder 1"/>
-          <p:cNvSpPr>
-            <a:spLocks noGrp="1" noRot="1" noChangeAspect="1"/>
-          </p:cNvSpPr>
-          <p:nvPr>
-            <p:ph type="sldImg"/>
-          </p:nvPr>
-        </p:nvSpPr>
-        <p:spPr/>
-      </p:sp>
-      <p:sp>
-        <p:nvSpPr>
-          <p:cNvPr id="3" name="Notes Placeholder 2"/>
-          <p:cNvSpPr>
-            <a:spLocks noGrp="1"/>
-          </p:cNvSpPr>
-          <p:nvPr>
-            <p:ph type="body" idx="1"/>
-          </p:nvPr>
-        </p:nvSpPr>
-        <p:spPr/>
-        <p:txBody>
-          <a:bodyPr/>
-          <a:lstStyle/>
-          <a:p>
-            <a:r>
-              <a:rPr lang="en-US" dirty="0"/>
-              <a:t>(Consulta) Lista das referências que sustentam as decisões apresentadas, nos termos em que constam do registro de decisões. As marcadas com † tiveram a leitura e a conferência da fonte feitas no projeto; as demais constam do registro e aguardam conferência bibliográfica completa antes da dissertação.</a:t>
-            </a:r>
-            <a:endParaRPr lang="en-US" dirty="0"/>
-          </a:p>
-        </p:txBody>
-      </p:sp>
-      <p:sp>
-        <p:nvSpPr>
-          <p:cNvPr id="4" name="Slide Number Placeholder 3"/>
-          <p:cNvSpPr>
-            <a:spLocks noGrp="1"/>
-          </p:cNvSpPr>
-          <p:nvPr>
-            <p:ph type="sldNum" sz="quarter" idx="10"/>
-          </p:nvPr>
-        </p:nvSpPr>
-        <p:spPr/>
-        <p:txBody>
-          <a:bodyPr/>
-          <a:lstStyle/>
-          <a:p>
-            <a:fld id="{F7021451-1387-4CA6-816F-3879F97B5CBC}" type="slidenum">
-              <a:rPr lang="en-US"/>
-              <a:t>14</a:t>
             </a:fld>
             <a:endParaRPr lang="en-US"/>
           </a:p>
@@ -1842,7 +1753,7 @@
           <a:p>
             <a:r>
               <a:rPr lang="en-US" dirty="0"/>
-              <a:t>(1,5 min) O sorteio registra semente, commit do código, hash do conjunto de candidatos e uma tabela reversa de códigos opacos, que fica fora do Git. Uma vez gerado, o selo não pode ser refeito, senão se poderia escolher o sorteio que favoreça o resultado. Mas e se o proprietário recusar? A proposta, ainda sem parâmetros decididos, é o mesmo selo trazer, por estrato, uma lista ordenada de reservas: a recusa aciona a próxima do mesmo estrato, que herda o papel de treino ou teste. A ferramenta de pool já existe; a parte das reservas está em implementação.</a:t>
+              <a:t>(1,5 min) Quantidade de voos: são 72 polígonos de 5,02 ha, ou seja, 72 missões de mapeamento, uma por polígono; eram 36 no desenho anterior. Elas não precisam ser 72 saídas: o planejador agrupa polígonos próximos em jornadas de campo, com teto padrão de 6 polígonos por jornada, ajustável, o que dá cerca de 12 jornadas. Esse agrupamento é uma proposta do planejador, ainda não validada em campo. Tempo de voo: a produtividade medida foi de 2,3 ha/min na Missão 009, o que dá cerca de 2,2 min por polígono; mas a única outra missão válida, a 000, teve 0,53 ha/min, o que dá cerca de 9,5 min. Com duas missões medidas, a faixa honesta é de 2 a 10 minutos por polígono, ou de 2,6 a 11 horas de voo no total, sem contar deslocamento. O que domina a campanha é deslocamento, montagem e as 72 autorizações. O número de baterias e de decolagens não está definido: depende da aeronave e do agrupamento, e não tenho esse dado. Por que 72: é a estrutura de 18 estratos com 4 polígonos cada, e não um excesso. A área total de cerca de 361 ha é o que o custo de voo suporta; ela rende cerca de 1.845 unidades espacialmente independentes (D24), no limite para o bloco espectral e abaixo do recomendado para solo, chuva e terreno. A tela mostra os três conjuntos da campanha.</a:t>
             </a:r>
             <a:endParaRPr lang="en-US" dirty="0"/>
           </a:p>
@@ -1930,7 +1841,7 @@
           <a:p>
             <a:r>
               <a:rPr lang="en-US" dirty="0"/>
-              <a:t>(1,5 min) Quantidade de voos: são 72 polígonos de 5,02 ha, ou seja, 72 missões de mapeamento, uma por polígono; eram 36 no desenho anterior. Elas não precisam ser 72 saídas: o planejador agrupa polígonos próximos em jornadas de campo, com teto padrão de 6 polígonos por jornada, ajustável, o que dá cerca de 12 jornadas. Esse agrupamento é uma proposta do planejador, ainda não validada em campo. Tempo de voo: a produtividade medida foi de 2,3 ha/min na Missão 009, o que dá cerca de 2,2 min por polígono; mas a única outra missão válida, a 000, teve 0,53 ha/min, o que dá cerca de 9,5 min. Com duas missões medidas, a faixa honesta é de 2 a 10 minutos por polígono, ou de 2,6 a 11 horas de voo no total, sem contar deslocamento. O que domina a campanha é deslocamento, montagem e as 72 autorizações. O número de baterias e de decolagens não está definido: depende da aeronave e do agrupamento, e não tenho esse dado. Por que 72: é a estrutura de 18 estratos com 4 polígonos cada, e não um excesso. A área total de cerca de 361 ha é o que o custo de voo suporta; ela rende cerca de 1.845 unidades espacialmente independentes (D24), no limite para o bloco espectral e abaixo do recomendado para solo, chuva e terreno. A tela mostra os três conjuntos da campanha.</a:t>
+              <a:t>(1 min) O alvo do modelo não é uma classe, e sim a fração da célula de 10 m delineada como erodida, entre 0 e 1, obtida por rasterização da delineação feita sobre o ortomosaico. O binário, fração maior ou igual a 25%, é derivado e secundário. O intérprete recebe só um código opaco, sem estrato nem papel; o app tem exportação cega por perfil. Isso impede que o modelo aprenda a concordar com o rastreio espectral. Planos de voo só saem com terreno real; os de demonstração são marcados como sintéticos.</a:t>
             </a:r>
             <a:endParaRPr lang="en-US" dirty="0"/>
           </a:p>
@@ -2597,7 +2508,7 @@
                 <a:ea typeface="Cambria" pitchFamily="34" charset="-122"/>
                 <a:cs typeface="Cambria" pitchFamily="34" charset="-120"/>
               </a:rPr>
-              <a:t>Voo cego, delineação e rótulo por fração</a:t>
+              <a:t>Âncora de campo com o SAREL Coletor</a:t>
             </a:r>
             <a:endParaRPr lang="en-US" sz="2200" dirty="0"/>
           </a:p>
@@ -2650,57 +2561,323 @@
         </p:nvSpPr>
         <p:spPr>
           <a:xfrm>
-            <a:off x="472440" y="987552"/>
-            <a:ext cx="8199120" cy="1225296"/>
-          </a:xfrm>
-          <a:prstGeom prst="rect">
-            <a:avLst/>
+            <a:off x="457200" y="1097280"/>
+            <a:ext cx="2606040" cy="1828800"/>
+          </a:xfrm>
+          <a:prstGeom prst="roundRect">
+            <a:avLst>
+              <a:gd name="adj" fmla="val 4000"/>
+            </a:avLst>
           </a:prstGeom>
           <a:solidFill>
-            <a:srgbClr val="FFFFFF"/>
+            <a:srgbClr val="EEF3EF"/>
           </a:solidFill>
-          <a:ln w="9525">
+          <a:ln w="12700">
             <a:solidFill>
-              <a:srgbClr val="B8C4BC"/>
+              <a:srgbClr val="EEF3EF"/>
             </a:solidFill>
             <a:prstDash val="solid"/>
           </a:ln>
         </p:spPr>
       </p:sp>
-      <p:pic>
-        <p:nvPicPr>
-          <p:cNvPr id="6" name="Image 0" descr="img/camp_topo.png">    </p:cNvPr>
-          <p:cNvPicPr>
-            <a:picLocks noChangeAspect="1"/>
-          </p:cNvPicPr>
-          <p:nvPr/>
-        </p:nvPicPr>
-        <p:blipFill>
-          <a:blip r:embed="rId1"/>
-          <a:stretch>
-            <a:fillRect/>
-          </a:stretch>
-        </p:blipFill>
-        <p:spPr>
-          <a:xfrm>
-            <a:off x="490728" y="1005840"/>
-            <a:ext cx="8162544" cy="1188720"/>
+      <p:sp>
+        <p:nvSpPr>
+          <p:cNvPr id="6" name="Text 3"/>
+          <p:cNvSpPr txBox="1"/>
+          <p:nvPr/>
+        </p:nvSpPr>
+        <p:spPr>
+          <a:xfrm>
+            <a:off x="640080" y="1207008"/>
+            <a:ext cx="2240280" cy="457200"/>
           </a:xfrm>
           <a:prstGeom prst="rect">
             <a:avLst/>
           </a:prstGeom>
-        </p:spPr>
-      </p:pic>
-      <p:sp>
-        <p:nvSpPr>
-          <p:cNvPr id="7" name="Text 3"/>
+          <a:noFill/>
+          <a:ln/>
+        </p:spPr>
+        <p:txBody>
+          <a:bodyPr wrap="square" lIns="0" tIns="0" rIns="0" bIns="0" rtlCol="0" anchor="t"/>
+          <a:lstStyle/>
+          <a:p>
+            <a:pPr indent="0" marL="0">
+              <a:buNone/>
+            </a:pPr>
+            <a:r>
+              <a:rPr lang="en-US" sz="1700" b="1" dirty="0">
+                <a:solidFill>
+                  <a:srgbClr val="2F6B4F"/>
+                </a:solidFill>
+                <a:latin typeface="Cambria" pitchFamily="34" charset="0"/>
+                <a:ea typeface="Cambria" pitchFamily="34" charset="-122"/>
+                <a:cs typeface="Cambria" pitchFamily="34" charset="-120"/>
+              </a:rPr>
+              <a:t>60 a 80 pontos</a:t>
+            </a:r>
+            <a:endParaRPr lang="en-US" sz="1700" dirty="0"/>
+          </a:p>
+        </p:txBody>
+      </p:sp>
+      <p:sp>
+        <p:nvSpPr>
+          <p:cNvPr id="7" name="Text 4"/>
           <p:cNvSpPr txBox="1"/>
           <p:nvPr/>
         </p:nvSpPr>
         <p:spPr>
           <a:xfrm>
-            <a:off x="457200" y="2423160"/>
-            <a:ext cx="8229600" cy="2194560"/>
+            <a:off x="640080" y="1737360"/>
+            <a:ext cx="2240280" cy="1143000"/>
+          </a:xfrm>
+          <a:prstGeom prst="rect">
+            <a:avLst/>
+          </a:prstGeom>
+          <a:noFill/>
+          <a:ln/>
+        </p:spPr>
+        <p:txBody>
+          <a:bodyPr wrap="square" lIns="0" tIns="0" rIns="0" bIns="0" rtlCol="0" anchor="t"/>
+          <a:lstStyle/>
+          <a:p>
+            <a:pPr indent="0" marL="0">
+              <a:buNone/>
+            </a:pPr>
+            <a:r>
+              <a:rPr lang="en-US" sz="1300" dirty="0">
+                <a:solidFill>
+                  <a:srgbClr val="1B2A22"/>
+                </a:solidFill>
+                <a:latin typeface="Calibri" pitchFamily="34" charset="0"/>
+                <a:ea typeface="Calibri" pitchFamily="34" charset="-122"/>
+                <a:cs typeface="Calibri" pitchFamily="34" charset="-120"/>
+              </a:rPr>
+              <a:t>dispersos pela bacia, fora dos polígonos, com probabilidade de inclusão conhecida</a:t>
+            </a:r>
+            <a:endParaRPr lang="en-US" sz="1300" dirty="0"/>
+          </a:p>
+        </p:txBody>
+      </p:sp>
+      <p:sp>
+        <p:nvSpPr>
+          <p:cNvPr id="8" name="Shape 5"/>
+          <p:cNvSpPr/>
+          <p:nvPr/>
+        </p:nvSpPr>
+        <p:spPr>
+          <a:xfrm>
+            <a:off x="3246120" y="1097280"/>
+            <a:ext cx="2606040" cy="1828800"/>
+          </a:xfrm>
+          <a:prstGeom prst="roundRect">
+            <a:avLst>
+              <a:gd name="adj" fmla="val 4000"/>
+            </a:avLst>
+          </a:prstGeom>
+          <a:solidFill>
+            <a:srgbClr val="EEF3EF"/>
+          </a:solidFill>
+          <a:ln w="12700">
+            <a:solidFill>
+              <a:srgbClr val="EEF3EF"/>
+            </a:solidFill>
+            <a:prstDash val="solid"/>
+          </a:ln>
+        </p:spPr>
+      </p:sp>
+      <p:sp>
+        <p:nvSpPr>
+          <p:cNvPr id="9" name="Text 6"/>
+          <p:cNvSpPr txBox="1"/>
+          <p:nvPr/>
+        </p:nvSpPr>
+        <p:spPr>
+          <a:xfrm>
+            <a:off x="3429000" y="1207008"/>
+            <a:ext cx="2240280" cy="457200"/>
+          </a:xfrm>
+          <a:prstGeom prst="rect">
+            <a:avLst/>
+          </a:prstGeom>
+          <a:noFill/>
+          <a:ln/>
+        </p:spPr>
+        <p:txBody>
+          <a:bodyPr wrap="square" lIns="0" tIns="0" rIns="0" bIns="0" rtlCol="0" anchor="t"/>
+          <a:lstStyle/>
+          <a:p>
+            <a:pPr indent="0" marL="0">
+              <a:buNone/>
+            </a:pPr>
+            <a:r>
+              <a:rPr lang="en-US" sz="1700" b="1" dirty="0">
+                <a:solidFill>
+                  <a:srgbClr val="2F6B4F"/>
+                </a:solidFill>
+                <a:latin typeface="Cambria" pitchFamily="34" charset="0"/>
+                <a:ea typeface="Cambria" pitchFamily="34" charset="-122"/>
+                <a:cs typeface="Cambria" pitchFamily="34" charset="-120"/>
+              </a:rPr>
+              <a:t>2 ondas</a:t>
+            </a:r>
+            <a:endParaRPr lang="en-US" sz="1700" dirty="0"/>
+          </a:p>
+        </p:txBody>
+      </p:sp>
+      <p:sp>
+        <p:nvSpPr>
+          <p:cNvPr id="10" name="Text 7"/>
+          <p:cNvSpPr txBox="1"/>
+          <p:nvPr/>
+        </p:nvSpPr>
+        <p:spPr>
+          <a:xfrm>
+            <a:off x="3429000" y="1737360"/>
+            <a:ext cx="2240280" cy="1143000"/>
+          </a:xfrm>
+          <a:prstGeom prst="rect">
+            <a:avLst/>
+          </a:prstGeom>
+          <a:noFill/>
+          <a:ln/>
+        </p:spPr>
+        <p:txBody>
+          <a:bodyPr wrap="square" lIns="0" tIns="0" rIns="0" bIns="0" rtlCol="0" anchor="t"/>
+          <a:lstStyle/>
+          <a:p>
+            <a:pPr indent="0" marL="0">
+              <a:buNone/>
+            </a:pPr>
+            <a:r>
+              <a:rPr lang="en-US" sz="1300" dirty="0">
+                <a:solidFill>
+                  <a:srgbClr val="1B2A22"/>
+                </a:solidFill>
+                <a:latin typeface="Calibri" pitchFamily="34" charset="0"/>
+                <a:ea typeface="Calibri" pitchFamily="34" charset="-122"/>
+                <a:cs typeface="Calibri" pitchFamily="34" charset="-120"/>
+              </a:rPr>
+              <a:t>os 30 primeiros pontos são lote piloto: validam o protocolo e medem a acurácia do aparelho</a:t>
+            </a:r>
+            <a:endParaRPr lang="en-US" sz="1300" dirty="0"/>
+          </a:p>
+        </p:txBody>
+      </p:sp>
+      <p:sp>
+        <p:nvSpPr>
+          <p:cNvPr id="11" name="Shape 8"/>
+          <p:cNvSpPr/>
+          <p:nvPr/>
+        </p:nvSpPr>
+        <p:spPr>
+          <a:xfrm>
+            <a:off x="6035040" y="1097280"/>
+            <a:ext cx="2606040" cy="1828800"/>
+          </a:xfrm>
+          <a:prstGeom prst="roundRect">
+            <a:avLst>
+              <a:gd name="adj" fmla="val 4000"/>
+            </a:avLst>
+          </a:prstGeom>
+          <a:solidFill>
+            <a:srgbClr val="EEF3EF"/>
+          </a:solidFill>
+          <a:ln w="12700">
+            <a:solidFill>
+              <a:srgbClr val="EEF3EF"/>
+            </a:solidFill>
+            <a:prstDash val="solid"/>
+          </a:ln>
+        </p:spPr>
+      </p:sp>
+      <p:sp>
+        <p:nvSpPr>
+          <p:cNvPr id="12" name="Text 9"/>
+          <p:cNvSpPr txBox="1"/>
+          <p:nvPr/>
+        </p:nvSpPr>
+        <p:spPr>
+          <a:xfrm>
+            <a:off x="6217920" y="1207008"/>
+            <a:ext cx="2240280" cy="457200"/>
+          </a:xfrm>
+          <a:prstGeom prst="rect">
+            <a:avLst/>
+          </a:prstGeom>
+          <a:noFill/>
+          <a:ln/>
+        </p:spPr>
+        <p:txBody>
+          <a:bodyPr wrap="square" lIns="0" tIns="0" rIns="0" bIns="0" rtlCol="0" anchor="t"/>
+          <a:lstStyle/>
+          <a:p>
+            <a:pPr indent="0" marL="0">
+              <a:buNone/>
+            </a:pPr>
+            <a:r>
+              <a:rPr lang="en-US" sz="1700" b="1" dirty="0">
+                <a:solidFill>
+                  <a:srgbClr val="2F6B4F"/>
+                </a:solidFill>
+                <a:latin typeface="Cambria" pitchFamily="34" charset="0"/>
+                <a:ea typeface="Cambria" pitchFamily="34" charset="-122"/>
+                <a:cs typeface="Cambria" pitchFamily="34" charset="-120"/>
+              </a:rPr>
+              <a:t>Função</a:t>
+            </a:r>
+            <a:endParaRPr lang="en-US" sz="1700" dirty="0"/>
+          </a:p>
+        </p:txBody>
+      </p:sp>
+      <p:sp>
+        <p:nvSpPr>
+          <p:cNvPr id="13" name="Text 10"/>
+          <p:cNvSpPr txBox="1"/>
+          <p:nvPr/>
+        </p:nvSpPr>
+        <p:spPr>
+          <a:xfrm>
+            <a:off x="6217920" y="1737360"/>
+            <a:ext cx="2240280" cy="1143000"/>
+          </a:xfrm>
+          <a:prstGeom prst="rect">
+            <a:avLst/>
+          </a:prstGeom>
+          <a:noFill/>
+          <a:ln/>
+        </p:spPr>
+        <p:txBody>
+          <a:bodyPr wrap="square" lIns="0" tIns="0" rIns="0" bIns="0" rtlCol="0" anchor="t"/>
+          <a:lstStyle/>
+          <a:p>
+            <a:pPr indent="0" marL="0">
+              <a:buNone/>
+            </a:pPr>
+            <a:r>
+              <a:rPr lang="en-US" sz="1300" dirty="0">
+                <a:solidFill>
+                  <a:srgbClr val="1B2A22"/>
+                </a:solidFill>
+                <a:latin typeface="Calibri" pitchFamily="34" charset="0"/>
+                <a:ea typeface="Calibri" pitchFamily="34" charset="-122"/>
+                <a:cs typeface="Calibri" pitchFamily="34" charset="-120"/>
+              </a:rPr>
+              <a:t>estimar a prevalência real e calibrar a posição; não é para treinar o modelo</a:t>
+            </a:r>
+            <a:endParaRPr lang="en-US" sz="1300" dirty="0"/>
+          </a:p>
+        </p:txBody>
+      </p:sp>
+      <p:sp>
+        <p:nvSpPr>
+          <p:cNvPr id="14" name="Text 11"/>
+          <p:cNvSpPr txBox="1"/>
+          <p:nvPr/>
+        </p:nvSpPr>
+        <p:spPr>
+          <a:xfrm>
+            <a:off x="457200" y="3154680"/>
+            <a:ext cx="8229600" cy="1463040"/>
           </a:xfrm>
           <a:prstGeom prst="rect">
             <a:avLst/>
@@ -2728,7 +2905,7 @@
                 <a:ea typeface="Calibri" pitchFamily="34" charset="-122"/>
                 <a:cs typeface="Calibri" pitchFamily="34" charset="-120"/>
               </a:rPr>
-              <a:t>Alvo primário: fração da célula de 10 m delineada como erodida, de 0 a 1 (D26); binário ≥ 0,25 é derivado</a:t>
+              <a:t>Instrumento: SAREL Coletor (Android), em substituição ao KoboCollect</a:t>
             </a:r>
             <a:endParaRPr lang="en-US" sz="1300" dirty="0"/>
           </a:p>
@@ -2749,7 +2926,7 @@
                 <a:ea typeface="Calibri" pitchFamily="34" charset="-122"/>
                 <a:cs typeface="Calibri" pitchFamily="34" charset="-120"/>
               </a:rPr>
-              <a:t>Intérprete cego: recebe só um código opaco, sem estrato nem papel (exportação cega por perfil)</a:t>
+              <a:t>Fotointerpretação (Fase A) aposentada: o rótulo centimétrico do voo é mais fiel à mancha contínua da erosão</a:t>
             </a:r>
             <a:endParaRPr lang="en-US" sz="1300" dirty="0"/>
           </a:p>
@@ -2770,67 +2947,46 @@
                 <a:ea typeface="Calibri" pitchFamily="34" charset="-122"/>
                 <a:cs typeface="Calibri" pitchFamily="34" charset="-120"/>
               </a:rPr>
-              <a:t>Polígonos sorteados pelos estratos biofísicos, nunca pelo rastreio espectral (evita circularidade)</a:t>
+              <a:t>Estimador ponderado pela probabilidade de inclusão (Horvitz-Thompson)</a:t>
             </a:r>
             <a:endParaRPr lang="en-US" sz="1300" dirty="0"/>
           </a:p>
-          <a:p>
-            <a:pPr marL="342900" indent="-342900">
-              <a:spcAft>
-                <a:spcPts val="700"/>
-              </a:spcAft>
-              <a:buSzPct val="100000"/>
-              <a:buChar char="•"/>
-            </a:pPr>
-            <a:r>
-              <a:rPr lang="en-US" sz="1300" dirty="0">
-                <a:solidFill>
-                  <a:srgbClr val="1B2A22"/>
+        </p:txBody>
+      </p:sp>
+      <p:sp>
+        <p:nvSpPr>
+          <p:cNvPr id="15" name="Text 12"/>
+          <p:cNvSpPr txBox="1"/>
+          <p:nvPr/>
+        </p:nvSpPr>
+        <p:spPr>
+          <a:xfrm>
+            <a:off x="457200" y="4754880"/>
+            <a:ext cx="7863840" cy="292608"/>
+          </a:xfrm>
+          <a:prstGeom prst="rect">
+            <a:avLst/>
+          </a:prstGeom>
+          <a:noFill/>
+          <a:ln/>
+        </p:spPr>
+        <p:txBody>
+          <a:bodyPr wrap="square" lIns="0" tIns="0" rIns="0" bIns="0" rtlCol="0" anchor="ctr"/>
+          <a:lstStyle/>
+          <a:p>
+            <a:pPr indent="0" marL="0">
+              <a:buNone/>
+            </a:pPr>
+            <a:r>
+              <a:rPr lang="en-US" sz="1000" i="1" dirty="0">
+                <a:solidFill>
+                  <a:srgbClr val="52605A"/>
                 </a:solidFill>
                 <a:latin typeface="Calibri" pitchFamily="34" charset="0"/>
                 <a:ea typeface="Calibri" pitchFamily="34" charset="-122"/>
                 <a:cs typeface="Calibri" pitchFamily="34" charset="-120"/>
               </a:rPr>
-              <a:t>Planos de voo só com terreno real (Copernicus 30 m); os de demonstração são marcados como sintéticos e não voáveis</a:t>
-            </a:r>
-            <a:endParaRPr lang="en-US" sz="1300" dirty="0"/>
-          </a:p>
-        </p:txBody>
-      </p:sp>
-      <p:sp>
-        <p:nvSpPr>
-          <p:cNvPr id="8" name="Text 4"/>
-          <p:cNvSpPr txBox="1"/>
-          <p:nvPr/>
-        </p:nvSpPr>
-        <p:spPr>
-          <a:xfrm>
-            <a:off x="457200" y="4754880"/>
-            <a:ext cx="7863840" cy="292608"/>
-          </a:xfrm>
-          <a:prstGeom prst="rect">
-            <a:avLst/>
-          </a:prstGeom>
-          <a:noFill/>
-          <a:ln/>
-        </p:spPr>
-        <p:txBody>
-          <a:bodyPr wrap="square" lIns="0" tIns="0" rIns="0" bIns="0" rtlCol="0" anchor="ctr"/>
-          <a:lstStyle/>
-          <a:p>
-            <a:pPr indent="0" marL="0">
-              <a:buNone/>
-            </a:pPr>
-            <a:r>
-              <a:rPr lang="en-US" sz="1000" i="1" dirty="0">
-                <a:solidFill>
-                  <a:srgbClr val="52605A"/>
-                </a:solidFill>
-                <a:latin typeface="Calibri" pitchFamily="34" charset="0"/>
-                <a:ea typeface="Calibri" pitchFamily="34" charset="-122"/>
-                <a:cs typeface="Calibri" pitchFamily="34" charset="-120"/>
-              </a:rPr>
-              <a:t>Refs.: D26, D16, D02; Altman &amp; Royston (2006) sobre dicotomizar variável contínua.</a:t>
+              <a:t>Refs.: D16, D23; Olofsson et al. (2014), amostragem e estimativa de área em sensoriamento remoto.</a:t>
             </a:r>
             <a:endParaRPr lang="en-US" sz="1000" dirty="0"/>
           </a:p>
@@ -2901,7 +3057,7 @@
                 <a:ea typeface="Cambria" pitchFamily="34" charset="-122"/>
                 <a:cs typeface="Cambria" pitchFamily="34" charset="-120"/>
               </a:rPr>
-              <a:t>Âncora de campo com o SAREL Coletor</a:t>
+              <a:t>Avaliação única, com o critério fixado antes</a:t>
             </a:r>
             <a:endParaRPr lang="en-US" sz="2200" dirty="0"/>
           </a:p>
@@ -2954,323 +3110,57 @@
         </p:nvSpPr>
         <p:spPr>
           <a:xfrm>
-            <a:off x="457200" y="1097280"/>
-            <a:ext cx="2606040" cy="1828800"/>
-          </a:xfrm>
-          <a:prstGeom prst="roundRect">
-            <a:avLst>
-              <a:gd name="adj" fmla="val 4000"/>
-            </a:avLst>
+            <a:off x="438912" y="941832"/>
+            <a:ext cx="3831336" cy="3310816"/>
+          </a:xfrm>
+          <a:prstGeom prst="rect">
+            <a:avLst/>
           </a:prstGeom>
           <a:solidFill>
-            <a:srgbClr val="EEF3EF"/>
+            <a:srgbClr val="FFFFFF"/>
           </a:solidFill>
-          <a:ln w="12700">
+          <a:ln w="9525">
             <a:solidFill>
-              <a:srgbClr val="EEF3EF"/>
+              <a:srgbClr val="B8C4BC"/>
             </a:solidFill>
             <a:prstDash val="solid"/>
           </a:ln>
         </p:spPr>
       </p:sp>
-      <p:sp>
-        <p:nvSpPr>
-          <p:cNvPr id="6" name="Text 3"/>
-          <p:cNvSpPr txBox="1"/>
-          <p:nvPr/>
-        </p:nvSpPr>
-        <p:spPr>
-          <a:xfrm>
-            <a:off x="640080" y="1207008"/>
-            <a:ext cx="2240280" cy="457200"/>
+      <p:pic>
+        <p:nvPicPr>
+          <p:cNvPr id="6" name="Image 0" descr="img/decisoes.png">    </p:cNvPr>
+          <p:cNvPicPr>
+            <a:picLocks noChangeAspect="1"/>
+          </p:cNvPicPr>
+          <p:nvPr/>
+        </p:nvPicPr>
+        <p:blipFill>
+          <a:blip r:embed="rId1"/>
+          <a:stretch>
+            <a:fillRect/>
+          </a:stretch>
+        </p:blipFill>
+        <p:spPr>
+          <a:xfrm>
+            <a:off x="457200" y="960120"/>
+            <a:ext cx="3794760" cy="3274240"/>
           </a:xfrm>
           <a:prstGeom prst="rect">
             <a:avLst/>
           </a:prstGeom>
-          <a:noFill/>
-          <a:ln/>
-        </p:spPr>
-        <p:txBody>
-          <a:bodyPr wrap="square" lIns="0" tIns="0" rIns="0" bIns="0" rtlCol="0" anchor="t"/>
-          <a:lstStyle/>
-          <a:p>
-            <a:pPr indent="0" marL="0">
-              <a:buNone/>
-            </a:pPr>
-            <a:r>
-              <a:rPr lang="en-US" sz="1700" b="1" dirty="0">
-                <a:solidFill>
-                  <a:srgbClr val="2F6B4F"/>
-                </a:solidFill>
-                <a:latin typeface="Cambria" pitchFamily="34" charset="0"/>
-                <a:ea typeface="Cambria" pitchFamily="34" charset="-122"/>
-                <a:cs typeface="Cambria" pitchFamily="34" charset="-120"/>
-              </a:rPr>
-              <a:t>60 a 80 pontos</a:t>
-            </a:r>
-            <a:endParaRPr lang="en-US" sz="1700" dirty="0"/>
-          </a:p>
-        </p:txBody>
-      </p:sp>
-      <p:sp>
-        <p:nvSpPr>
-          <p:cNvPr id="7" name="Text 4"/>
+        </p:spPr>
+      </p:pic>
+      <p:sp>
+        <p:nvSpPr>
+          <p:cNvPr id="7" name="Text 3"/>
           <p:cNvSpPr txBox="1"/>
           <p:nvPr/>
         </p:nvSpPr>
         <p:spPr>
           <a:xfrm>
-            <a:off x="640080" y="1737360"/>
-            <a:ext cx="2240280" cy="1143000"/>
-          </a:xfrm>
-          <a:prstGeom prst="rect">
-            <a:avLst/>
-          </a:prstGeom>
-          <a:noFill/>
-          <a:ln/>
-        </p:spPr>
-        <p:txBody>
-          <a:bodyPr wrap="square" lIns="0" tIns="0" rIns="0" bIns="0" rtlCol="0" anchor="t"/>
-          <a:lstStyle/>
-          <a:p>
-            <a:pPr indent="0" marL="0">
-              <a:buNone/>
-            </a:pPr>
-            <a:r>
-              <a:rPr lang="en-US" sz="1300" dirty="0">
-                <a:solidFill>
-                  <a:srgbClr val="1B2A22"/>
-                </a:solidFill>
-                <a:latin typeface="Calibri" pitchFamily="34" charset="0"/>
-                <a:ea typeface="Calibri" pitchFamily="34" charset="-122"/>
-                <a:cs typeface="Calibri" pitchFamily="34" charset="-120"/>
-              </a:rPr>
-              <a:t>dispersos pela bacia, fora dos polígonos, com probabilidade de inclusão conhecida</a:t>
-            </a:r>
-            <a:endParaRPr lang="en-US" sz="1300" dirty="0"/>
-          </a:p>
-        </p:txBody>
-      </p:sp>
-      <p:sp>
-        <p:nvSpPr>
-          <p:cNvPr id="8" name="Shape 5"/>
-          <p:cNvSpPr/>
-          <p:nvPr/>
-        </p:nvSpPr>
-        <p:spPr>
-          <a:xfrm>
-            <a:off x="3246120" y="1097280"/>
-            <a:ext cx="2606040" cy="1828800"/>
-          </a:xfrm>
-          <a:prstGeom prst="roundRect">
-            <a:avLst>
-              <a:gd name="adj" fmla="val 4000"/>
-            </a:avLst>
-          </a:prstGeom>
-          <a:solidFill>
-            <a:srgbClr val="EEF3EF"/>
-          </a:solidFill>
-          <a:ln w="12700">
-            <a:solidFill>
-              <a:srgbClr val="EEF3EF"/>
-            </a:solidFill>
-            <a:prstDash val="solid"/>
-          </a:ln>
-        </p:spPr>
-      </p:sp>
-      <p:sp>
-        <p:nvSpPr>
-          <p:cNvPr id="9" name="Text 6"/>
-          <p:cNvSpPr txBox="1"/>
-          <p:nvPr/>
-        </p:nvSpPr>
-        <p:spPr>
-          <a:xfrm>
-            <a:off x="3429000" y="1207008"/>
-            <a:ext cx="2240280" cy="457200"/>
-          </a:xfrm>
-          <a:prstGeom prst="rect">
-            <a:avLst/>
-          </a:prstGeom>
-          <a:noFill/>
-          <a:ln/>
-        </p:spPr>
-        <p:txBody>
-          <a:bodyPr wrap="square" lIns="0" tIns="0" rIns="0" bIns="0" rtlCol="0" anchor="t"/>
-          <a:lstStyle/>
-          <a:p>
-            <a:pPr indent="0" marL="0">
-              <a:buNone/>
-            </a:pPr>
-            <a:r>
-              <a:rPr lang="en-US" sz="1700" b="1" dirty="0">
-                <a:solidFill>
-                  <a:srgbClr val="2F6B4F"/>
-                </a:solidFill>
-                <a:latin typeface="Cambria" pitchFamily="34" charset="0"/>
-                <a:ea typeface="Cambria" pitchFamily="34" charset="-122"/>
-                <a:cs typeface="Cambria" pitchFamily="34" charset="-120"/>
-              </a:rPr>
-              <a:t>2 ondas</a:t>
-            </a:r>
-            <a:endParaRPr lang="en-US" sz="1700" dirty="0"/>
-          </a:p>
-        </p:txBody>
-      </p:sp>
-      <p:sp>
-        <p:nvSpPr>
-          <p:cNvPr id="10" name="Text 7"/>
-          <p:cNvSpPr txBox="1"/>
-          <p:nvPr/>
-        </p:nvSpPr>
-        <p:spPr>
-          <a:xfrm>
-            <a:off x="3429000" y="1737360"/>
-            <a:ext cx="2240280" cy="1143000"/>
-          </a:xfrm>
-          <a:prstGeom prst="rect">
-            <a:avLst/>
-          </a:prstGeom>
-          <a:noFill/>
-          <a:ln/>
-        </p:spPr>
-        <p:txBody>
-          <a:bodyPr wrap="square" lIns="0" tIns="0" rIns="0" bIns="0" rtlCol="0" anchor="t"/>
-          <a:lstStyle/>
-          <a:p>
-            <a:pPr indent="0" marL="0">
-              <a:buNone/>
-            </a:pPr>
-            <a:r>
-              <a:rPr lang="en-US" sz="1300" dirty="0">
-                <a:solidFill>
-                  <a:srgbClr val="1B2A22"/>
-                </a:solidFill>
-                <a:latin typeface="Calibri" pitchFamily="34" charset="0"/>
-                <a:ea typeface="Calibri" pitchFamily="34" charset="-122"/>
-                <a:cs typeface="Calibri" pitchFamily="34" charset="-120"/>
-              </a:rPr>
-              <a:t>os 30 primeiros pontos são lote piloto: validam o protocolo e medem a acurácia do aparelho</a:t>
-            </a:r>
-            <a:endParaRPr lang="en-US" sz="1300" dirty="0"/>
-          </a:p>
-        </p:txBody>
-      </p:sp>
-      <p:sp>
-        <p:nvSpPr>
-          <p:cNvPr id="11" name="Shape 8"/>
-          <p:cNvSpPr/>
-          <p:nvPr/>
-        </p:nvSpPr>
-        <p:spPr>
-          <a:xfrm>
-            <a:off x="6035040" y="1097280"/>
-            <a:ext cx="2606040" cy="1828800"/>
-          </a:xfrm>
-          <a:prstGeom prst="roundRect">
-            <a:avLst>
-              <a:gd name="adj" fmla="val 4000"/>
-            </a:avLst>
-          </a:prstGeom>
-          <a:solidFill>
-            <a:srgbClr val="EEF3EF"/>
-          </a:solidFill>
-          <a:ln w="12700">
-            <a:solidFill>
-              <a:srgbClr val="EEF3EF"/>
-            </a:solidFill>
-            <a:prstDash val="solid"/>
-          </a:ln>
-        </p:spPr>
-      </p:sp>
-      <p:sp>
-        <p:nvSpPr>
-          <p:cNvPr id="12" name="Text 9"/>
-          <p:cNvSpPr txBox="1"/>
-          <p:nvPr/>
-        </p:nvSpPr>
-        <p:spPr>
-          <a:xfrm>
-            <a:off x="6217920" y="1207008"/>
-            <a:ext cx="2240280" cy="457200"/>
-          </a:xfrm>
-          <a:prstGeom prst="rect">
-            <a:avLst/>
-          </a:prstGeom>
-          <a:noFill/>
-          <a:ln/>
-        </p:spPr>
-        <p:txBody>
-          <a:bodyPr wrap="square" lIns="0" tIns="0" rIns="0" bIns="0" rtlCol="0" anchor="t"/>
-          <a:lstStyle/>
-          <a:p>
-            <a:pPr indent="0" marL="0">
-              <a:buNone/>
-            </a:pPr>
-            <a:r>
-              <a:rPr lang="en-US" sz="1700" b="1" dirty="0">
-                <a:solidFill>
-                  <a:srgbClr val="2F6B4F"/>
-                </a:solidFill>
-                <a:latin typeface="Cambria" pitchFamily="34" charset="0"/>
-                <a:ea typeface="Cambria" pitchFamily="34" charset="-122"/>
-                <a:cs typeface="Cambria" pitchFamily="34" charset="-120"/>
-              </a:rPr>
-              <a:t>Função</a:t>
-            </a:r>
-            <a:endParaRPr lang="en-US" sz="1700" dirty="0"/>
-          </a:p>
-        </p:txBody>
-      </p:sp>
-      <p:sp>
-        <p:nvSpPr>
-          <p:cNvPr id="13" name="Text 10"/>
-          <p:cNvSpPr txBox="1"/>
-          <p:nvPr/>
-        </p:nvSpPr>
-        <p:spPr>
-          <a:xfrm>
-            <a:off x="6217920" y="1737360"/>
-            <a:ext cx="2240280" cy="1143000"/>
-          </a:xfrm>
-          <a:prstGeom prst="rect">
-            <a:avLst/>
-          </a:prstGeom>
-          <a:noFill/>
-          <a:ln/>
-        </p:spPr>
-        <p:txBody>
-          <a:bodyPr wrap="square" lIns="0" tIns="0" rIns="0" bIns="0" rtlCol="0" anchor="t"/>
-          <a:lstStyle/>
-          <a:p>
-            <a:pPr indent="0" marL="0">
-              <a:buNone/>
-            </a:pPr>
-            <a:r>
-              <a:rPr lang="en-US" sz="1300" dirty="0">
-                <a:solidFill>
-                  <a:srgbClr val="1B2A22"/>
-                </a:solidFill>
-                <a:latin typeface="Calibri" pitchFamily="34" charset="0"/>
-                <a:ea typeface="Calibri" pitchFamily="34" charset="-122"/>
-                <a:cs typeface="Calibri" pitchFamily="34" charset="-120"/>
-              </a:rPr>
-              <a:t>estimar a prevalência real e calibrar a posição; não é para treinar o modelo</a:t>
-            </a:r>
-            <a:endParaRPr lang="en-US" sz="1300" dirty="0"/>
-          </a:p>
-        </p:txBody>
-      </p:sp>
-      <p:sp>
-        <p:nvSpPr>
-          <p:cNvPr id="14" name="Text 11"/>
-          <p:cNvSpPr txBox="1"/>
-          <p:nvPr/>
-        </p:nvSpPr>
-        <p:spPr>
-          <a:xfrm>
-            <a:off x="457200" y="3154680"/>
-            <a:ext cx="8229600" cy="1463040"/>
+            <a:off x="4526280" y="1051560"/>
+            <a:ext cx="4251960" cy="3566160"/>
           </a:xfrm>
           <a:prstGeom prst="rect">
             <a:avLst/>
@@ -3290,7 +3180,7 @@
               <a:buChar char="•"/>
             </a:pPr>
             <a:r>
-              <a:rPr lang="en-US" sz="1300" dirty="0">
+              <a:rPr lang="en-US" sz="1250" dirty="0">
                 <a:solidFill>
                   <a:srgbClr val="1B2A22"/>
                 </a:solidFill>
@@ -3298,9 +3188,9 @@
                 <a:ea typeface="Calibri" pitchFamily="34" charset="-122"/>
                 <a:cs typeface="Calibri" pitchFamily="34" charset="-120"/>
               </a:rPr>
-              <a:t>Instrumento: SAREL Coletor (Android), em substituição ao KoboCollect</a:t>
-            </a:r>
-            <a:endParaRPr lang="en-US" sz="1300" dirty="0"/>
+              <a:t>Competidores: linha de base RUSLE, regressão penalizada e XGBoost (perda Tweedie)</a:t>
+            </a:r>
+            <a:endParaRPr lang="en-US" sz="1250" dirty="0"/>
           </a:p>
           <a:p>
             <a:pPr marL="342900" indent="-342900">
@@ -3311,7 +3201,7 @@
               <a:buChar char="•"/>
             </a:pPr>
             <a:r>
-              <a:rPr lang="en-US" sz="1300" dirty="0">
+              <a:rPr lang="en-US" sz="1250" dirty="0">
                 <a:solidFill>
                   <a:srgbClr val="1B2A22"/>
                 </a:solidFill>
@@ -3319,9 +3209,9 @@
                 <a:ea typeface="Calibri" pitchFamily="34" charset="-122"/>
                 <a:cs typeface="Calibri" pitchFamily="34" charset="-120"/>
               </a:rPr>
-              <a:t>Fotointerpretação (Fase A) aposentada: o rótulo centimétrico do voo é mais fiel à mancha contínua da erosão</a:t>
-            </a:r>
-            <a:endParaRPr lang="en-US" sz="1300" dirty="0"/>
+              <a:t>Métrica primária: Spearman no held-out; piso 0,40 e margem 0,10 sobre a RUSLE</a:t>
+            </a:r>
+            <a:endParaRPr lang="en-US" sz="1250" dirty="0"/>
           </a:p>
           <a:p>
             <a:pPr marL="342900" indent="-342900">
@@ -3332,7 +3222,7 @@
               <a:buChar char="•"/>
             </a:pPr>
             <a:r>
-              <a:rPr lang="en-US" sz="1300" dirty="0">
+              <a:rPr lang="en-US" sz="1250" dirty="0">
                 <a:solidFill>
                   <a:srgbClr val="1B2A22"/>
                 </a:solidFill>
@@ -3340,46 +3230,88 @@
                 <a:ea typeface="Calibri" pitchFamily="34" charset="-122"/>
                 <a:cs typeface="Calibri" pitchFamily="34" charset="-120"/>
               </a:rPr>
-              <a:t>Estimador ponderado pela probabilidade de inclusão (Horvitz-Thompson)</a:t>
-            </a:r>
-            <a:endParaRPr lang="en-US" sz="1300" dirty="0"/>
-          </a:p>
-        </p:txBody>
-      </p:sp>
-      <p:sp>
-        <p:nvSpPr>
-          <p:cNvPr id="15" name="Text 12"/>
-          <p:cNvSpPr txBox="1"/>
-          <p:nvPr/>
-        </p:nvSpPr>
-        <p:spPr>
-          <a:xfrm>
-            <a:off x="457200" y="4754880"/>
-            <a:ext cx="7863840" cy="292608"/>
-          </a:xfrm>
-          <a:prstGeom prst="rect">
-            <a:avLst/>
-          </a:prstGeom>
-          <a:noFill/>
-          <a:ln/>
-        </p:spPr>
-        <p:txBody>
-          <a:bodyPr wrap="square" lIns="0" tIns="0" rIns="0" bIns="0" rtlCol="0" anchor="ctr"/>
-          <a:lstStyle/>
-          <a:p>
-            <a:pPr indent="0" marL="0">
-              <a:buNone/>
-            </a:pPr>
-            <a:r>
-              <a:rPr lang="en-US" sz="1000" i="1" dirty="0">
-                <a:solidFill>
-                  <a:srgbClr val="52605A"/>
+              <a:t>Bootstrap por polígono (as células de um polígono não são independentes)</a:t>
+            </a:r>
+            <a:endParaRPr lang="en-US" sz="1250" dirty="0"/>
+          </a:p>
+          <a:p>
+            <a:pPr marL="342900" indent="-342900">
+              <a:spcAft>
+                <a:spcPts val="700"/>
+              </a:spcAft>
+              <a:buSzPct val="100000"/>
+              <a:buChar char="•"/>
+            </a:pPr>
+            <a:r>
+              <a:rPr lang="en-US" sz="1250" dirty="0">
+                <a:solidFill>
+                  <a:srgbClr val="1B2A22"/>
                 </a:solidFill>
                 <a:latin typeface="Calibri" pitchFamily="34" charset="0"/>
                 <a:ea typeface="Calibri" pitchFamily="34" charset="-122"/>
                 <a:cs typeface="Calibri" pitchFamily="34" charset="-120"/>
               </a:rPr>
-              <a:t>Refs.: D16, D23; Olofsson et al. (2014), amostragem e estimativa de área em sensoriamento remoto.</a:t>
+              <a:t>Desfechos: corroborada, inconclusiva ou refutada (e inconclusiva por margem)</a:t>
+            </a:r>
+            <a:endParaRPr lang="en-US" sz="1250" dirty="0"/>
+          </a:p>
+          <a:p>
+            <a:pPr marL="342900" indent="-342900">
+              <a:spcAft>
+                <a:spcPts val="700"/>
+              </a:spcAft>
+              <a:buSzPct val="100000"/>
+              <a:buChar char="•"/>
+            </a:pPr>
+            <a:r>
+              <a:rPr lang="en-US" sz="1250" dirty="0">
+                <a:solidFill>
+                  <a:srgbClr val="1B2A22"/>
+                </a:solidFill>
+                <a:latin typeface="Calibri" pitchFamily="34" charset="0"/>
+                <a:ea typeface="Calibri" pitchFamily="34" charset="-122"/>
+                <a:cs typeface="Calibri" pitchFamily="34" charset="-120"/>
+              </a:rPr>
+              <a:t>Estado hoje: não avaliado. O script grava uma trava e recusa a segunda avaliação</a:t>
+            </a:r>
+            <a:endParaRPr lang="en-US" sz="1250" dirty="0"/>
+          </a:p>
+        </p:txBody>
+      </p:sp>
+      <p:sp>
+        <p:nvSpPr>
+          <p:cNvPr id="8" name="Text 4"/>
+          <p:cNvSpPr txBox="1"/>
+          <p:nvPr/>
+        </p:nvSpPr>
+        <p:spPr>
+          <a:xfrm>
+            <a:off x="457200" y="4754880"/>
+            <a:ext cx="7863840" cy="292608"/>
+          </a:xfrm>
+          <a:prstGeom prst="rect">
+            <a:avLst/>
+          </a:prstGeom>
+          <a:noFill/>
+          <a:ln/>
+        </p:spPr>
+        <p:txBody>
+          <a:bodyPr wrap="square" lIns="0" tIns="0" rIns="0" bIns="0" rtlCol="0" anchor="ctr"/>
+          <a:lstStyle/>
+          <a:p>
+            <a:pPr indent="0" marL="0">
+              <a:buNone/>
+            </a:pPr>
+            <a:r>
+              <a:rPr lang="en-US" sz="1000" i="1" dirty="0">
+                <a:solidFill>
+                  <a:srgbClr val="52605A"/>
+                </a:solidFill>
+                <a:latin typeface="Calibri" pitchFamily="34" charset="0"/>
+                <a:ea typeface="Calibri" pitchFamily="34" charset="-122"/>
+                <a:cs typeface="Calibri" pitchFamily="34" charset="-120"/>
+              </a:rPr>
+              <a:t>Refs.: D25, D24, D26; Nosek et al. (2018); Cameron et al. (2008); van der Ploeg et al. (2014); Hanley &amp; McNeil (1982).</a:t>
             </a:r>
             <a:endParaRPr lang="en-US" sz="1000" dirty="0"/>
           </a:p>
@@ -3450,7 +3382,7 @@
                 <a:ea typeface="Cambria" pitchFamily="34" charset="-122"/>
                 <a:cs typeface="Cambria" pitchFamily="34" charset="-120"/>
               </a:rPr>
-              <a:t>Avaliação única, com o critério fixado antes</a:t>
+              <a:t>Estado atual, limites e próximos passos</a:t>
             </a:r>
             <a:endParaRPr lang="en-US" sz="2200" dirty="0"/>
           </a:p>
@@ -3503,57 +3435,74 @@
         </p:nvSpPr>
         <p:spPr>
           <a:xfrm>
-            <a:off x="438912" y="941832"/>
-            <a:ext cx="3831336" cy="3310816"/>
-          </a:xfrm>
-          <a:prstGeom prst="rect">
-            <a:avLst/>
+            <a:off x="457200" y="1051560"/>
+            <a:ext cx="4023360" cy="3474720"/>
+          </a:xfrm>
+          <a:prstGeom prst="roundRect">
+            <a:avLst>
+              <a:gd name="adj" fmla="val 2105"/>
+            </a:avLst>
           </a:prstGeom>
           <a:solidFill>
-            <a:srgbClr val="FFFFFF"/>
+            <a:srgbClr val="EEF3EF"/>
           </a:solidFill>
-          <a:ln w="9525">
+          <a:ln w="12700">
             <a:solidFill>
-              <a:srgbClr val="B8C4BC"/>
+              <a:srgbClr val="EEF3EF"/>
             </a:solidFill>
             <a:prstDash val="solid"/>
           </a:ln>
         </p:spPr>
       </p:sp>
-      <p:pic>
-        <p:nvPicPr>
-          <p:cNvPr id="6" name="Image 0" descr="img/decisoes.png">    </p:cNvPr>
-          <p:cNvPicPr>
-            <a:picLocks noChangeAspect="1"/>
-          </p:cNvPicPr>
-          <p:nvPr/>
-        </p:nvPicPr>
-        <p:blipFill>
-          <a:blip r:embed="rId1"/>
-          <a:stretch>
-            <a:fillRect/>
-          </a:stretch>
-        </p:blipFill>
-        <p:spPr>
-          <a:xfrm>
-            <a:off x="457200" y="960120"/>
-            <a:ext cx="3794760" cy="3274240"/>
+      <p:sp>
+        <p:nvSpPr>
+          <p:cNvPr id="6" name="Text 3"/>
+          <p:cNvSpPr txBox="1"/>
+          <p:nvPr/>
+        </p:nvSpPr>
+        <p:spPr>
+          <a:xfrm>
+            <a:off x="640080" y="1170432"/>
+            <a:ext cx="3657600" cy="365760"/>
           </a:xfrm>
           <a:prstGeom prst="rect">
             <a:avLst/>
           </a:prstGeom>
-        </p:spPr>
-      </p:pic>
-      <p:sp>
-        <p:nvSpPr>
-          <p:cNvPr id="7" name="Text 3"/>
+          <a:noFill/>
+          <a:ln/>
+        </p:spPr>
+        <p:txBody>
+          <a:bodyPr wrap="square" lIns="0" tIns="0" rIns="0" bIns="0" rtlCol="0" anchor="t"/>
+          <a:lstStyle/>
+          <a:p>
+            <a:pPr indent="0" marL="0">
+              <a:buNone/>
+            </a:pPr>
+            <a:r>
+              <a:rPr lang="en-US" sz="1900" b="1" dirty="0">
+                <a:solidFill>
+                  <a:srgbClr val="2F6B4F"/>
+                </a:solidFill>
+                <a:latin typeface="Cambria" pitchFamily="34" charset="0"/>
+                <a:ea typeface="Cambria" pitchFamily="34" charset="-122"/>
+                <a:cs typeface="Cambria" pitchFamily="34" charset="-120"/>
+              </a:rPr>
+              <a:t>Pronto</a:t>
+            </a:r>
+            <a:endParaRPr lang="en-US" sz="1900" dirty="0"/>
+          </a:p>
+        </p:txBody>
+      </p:sp>
+      <p:sp>
+        <p:nvSpPr>
+          <p:cNvPr id="7" name="Text 4"/>
           <p:cNvSpPr txBox="1"/>
           <p:nvPr/>
         </p:nvSpPr>
         <p:spPr>
           <a:xfrm>
-            <a:off x="4526280" y="1051560"/>
-            <a:ext cx="4251960" cy="3566160"/>
+            <a:off x="640080" y="1600200"/>
+            <a:ext cx="3657600" cy="2834640"/>
           </a:xfrm>
           <a:prstGeom prst="rect">
             <a:avLst/>
@@ -3581,7 +3530,7 @@
                 <a:ea typeface="Calibri" pitchFamily="34" charset="-122"/>
                 <a:cs typeface="Calibri" pitchFamily="34" charset="-120"/>
               </a:rPr>
-              <a:t>Competidores: linha de base RUSLE, regressão penalizada e XGBoost (perda Tweedie)</a:t>
+              <a:t>Plataforma com os módulos do fluxo e recusa de dado sintético</a:t>
             </a:r>
             <a:endParaRPr lang="en-US" sz="1250" dirty="0"/>
           </a:p>
@@ -3602,7 +3551,7 @@
                 <a:ea typeface="Calibri" pitchFamily="34" charset="-122"/>
                 <a:cs typeface="Calibri" pitchFamily="34" charset="-120"/>
               </a:rPr>
-              <a:t>Métrica primária: Spearman no held-out; piso 0,40 e margem 0,10 sobre a RUSLE</a:t>
+              <a:t>Desenho amostral e critério de avaliação pré-registrados</a:t>
             </a:r>
             <a:endParaRPr lang="en-US" sz="1250" dirty="0"/>
           </a:p>
@@ -3623,7 +3572,7 @@
                 <a:ea typeface="Calibri" pitchFamily="34" charset="-122"/>
                 <a:cs typeface="Calibri" pitchFamily="34" charset="-120"/>
               </a:rPr>
-              <a:t>Bootstrap por polígono (as células de um polígono não são independentes)</a:t>
+              <a:t>Ferramenta de checagem do pool por estrato (somente leitura)</a:t>
             </a:r>
             <a:endParaRPr lang="en-US" sz="1250" dirty="0"/>
           </a:p>
@@ -3644,10 +3593,98 @@
                 <a:ea typeface="Calibri" pitchFamily="34" charset="-122"/>
                 <a:cs typeface="Calibri" pitchFamily="34" charset="-120"/>
               </a:rPr>
-              <a:t>Desfechos: corroborada, inconclusiva ou refutada (e inconclusiva por margem)</a:t>
+              <a:t>Pacote de reprodutibilidade com verificador de integridade</a:t>
             </a:r>
             <a:endParaRPr lang="en-US" sz="1250" dirty="0"/>
           </a:p>
+        </p:txBody>
+      </p:sp>
+      <p:sp>
+        <p:nvSpPr>
+          <p:cNvPr id="8" name="Shape 5"/>
+          <p:cNvSpPr/>
+          <p:nvPr/>
+        </p:nvSpPr>
+        <p:spPr>
+          <a:xfrm>
+            <a:off x="4663440" y="1051560"/>
+            <a:ext cx="4023360" cy="3474720"/>
+          </a:xfrm>
+          <a:prstGeom prst="roundRect">
+            <a:avLst>
+              <a:gd name="adj" fmla="val 2105"/>
+            </a:avLst>
+          </a:prstGeom>
+          <a:solidFill>
+            <a:srgbClr val="EEF3EF"/>
+          </a:solidFill>
+          <a:ln w="12700">
+            <a:solidFill>
+              <a:srgbClr val="EEF3EF"/>
+            </a:solidFill>
+            <a:prstDash val="solid"/>
+          </a:ln>
+        </p:spPr>
+      </p:sp>
+      <p:sp>
+        <p:nvSpPr>
+          <p:cNvPr id="9" name="Text 6"/>
+          <p:cNvSpPr txBox="1"/>
+          <p:nvPr/>
+        </p:nvSpPr>
+        <p:spPr>
+          <a:xfrm>
+            <a:off x="4846320" y="1170432"/>
+            <a:ext cx="3657600" cy="365760"/>
+          </a:xfrm>
+          <a:prstGeom prst="rect">
+            <a:avLst/>
+          </a:prstGeom>
+          <a:noFill/>
+          <a:ln/>
+        </p:spPr>
+        <p:txBody>
+          <a:bodyPr wrap="square" lIns="0" tIns="0" rIns="0" bIns="0" rtlCol="0" anchor="t"/>
+          <a:lstStyle/>
+          <a:p>
+            <a:pPr indent="0" marL="0">
+              <a:buNone/>
+            </a:pPr>
+            <a:r>
+              <a:rPr lang="en-US" sz="1900" b="1" dirty="0">
+                <a:solidFill>
+                  <a:srgbClr val="C65D3B"/>
+                </a:solidFill>
+                <a:latin typeface="Cambria" pitchFamily="34" charset="0"/>
+                <a:ea typeface="Cambria" pitchFamily="34" charset="-122"/>
+                <a:cs typeface="Cambria" pitchFamily="34" charset="-120"/>
+              </a:rPr>
+              <a:t>Pendente</a:t>
+            </a:r>
+            <a:endParaRPr lang="en-US" sz="1900" dirty="0"/>
+          </a:p>
+        </p:txBody>
+      </p:sp>
+      <p:sp>
+        <p:nvSpPr>
+          <p:cNvPr id="10" name="Text 7"/>
+          <p:cNvSpPr txBox="1"/>
+          <p:nvPr/>
+        </p:nvSpPr>
+        <p:spPr>
+          <a:xfrm>
+            <a:off x="4846320" y="1600200"/>
+            <a:ext cx="3657600" cy="2834640"/>
+          </a:xfrm>
+          <a:prstGeom prst="rect">
+            <a:avLst/>
+          </a:prstGeom>
+          <a:noFill/>
+          <a:ln/>
+        </p:spPr>
+        <p:txBody>
+          <a:bodyPr wrap="square" lIns="0" tIns="0" rIns="0" bIns="0" rtlCol="0" anchor="t"/>
+          <a:lstStyle/>
           <a:p>
             <a:pPr marL="342900" indent="-342900">
               <a:spcAft>
@@ -3665,48 +3702,93 @@
                 <a:ea typeface="Calibri" pitchFamily="34" charset="-122"/>
                 <a:cs typeface="Calibri" pitchFamily="34" charset="-120"/>
               </a:rPr>
-              <a:t>Estado hoje: não avaliado. O script grava uma trava e recusa a segunda avaliação</a:t>
+              <a:t>Nenhum resultado empírico ainda</a:t>
             </a:r>
             <a:endParaRPr lang="en-US" sz="1250" dirty="0"/>
           </a:p>
-        </p:txBody>
-      </p:sp>
-      <p:sp>
-        <p:nvSpPr>
-          <p:cNvPr id="8" name="Text 4"/>
-          <p:cNvSpPr txBox="1"/>
-          <p:nvPr/>
-        </p:nvSpPr>
-        <p:spPr>
-          <a:xfrm>
-            <a:off x="457200" y="4754880"/>
-            <a:ext cx="7863840" cy="292608"/>
-          </a:xfrm>
-          <a:prstGeom prst="rect">
-            <a:avLst/>
-          </a:prstGeom>
-          <a:noFill/>
-          <a:ln/>
-        </p:spPr>
-        <p:txBody>
-          <a:bodyPr wrap="square" lIns="0" tIns="0" rIns="0" bIns="0" rtlCol="0" anchor="ctr"/>
-          <a:lstStyle/>
-          <a:p>
-            <a:pPr indent="0" marL="0">
-              <a:buNone/>
-            </a:pPr>
-            <a:r>
-              <a:rPr lang="en-US" sz="1000" i="1" dirty="0">
-                <a:solidFill>
-                  <a:srgbClr val="52605A"/>
+          <a:p>
+            <a:pPr marL="342900" indent="-342900">
+              <a:spcAft>
+                <a:spcPts val="700"/>
+              </a:spcAft>
+              <a:buSzPct val="100000"/>
+              <a:buChar char="•"/>
+            </a:pPr>
+            <a:r>
+              <a:rPr lang="en-US" sz="1250" dirty="0">
+                <a:solidFill>
+                  <a:srgbClr val="1B2A22"/>
                 </a:solidFill>
                 <a:latin typeface="Calibri" pitchFamily="34" charset="0"/>
                 <a:ea typeface="Calibri" pitchFamily="34" charset="-122"/>
                 <a:cs typeface="Calibri" pitchFamily="34" charset="-120"/>
               </a:rPr>
-              <a:t>Refs.: D25, D24, D26; Nosek et al. (2018); Cameron et al. (2008); van der Ploeg et al. (2014); Hanley &amp; McNeil (1982).</a:t>
-            </a:r>
-            <a:endParaRPr lang="en-US" sz="1000" dirty="0"/>
+              <a:t>Medir o pool real por estrato e decidir reservas e n mínimo</a:t>
+            </a:r>
+            <a:endParaRPr lang="en-US" sz="1250" dirty="0"/>
+          </a:p>
+          <a:p>
+            <a:pPr marL="342900" indent="-342900">
+              <a:spcAft>
+                <a:spcPts val="700"/>
+              </a:spcAft>
+              <a:buSzPct val="100000"/>
+              <a:buChar char="•"/>
+            </a:pPr>
+            <a:r>
+              <a:rPr lang="en-US" sz="1250" dirty="0">
+                <a:solidFill>
+                  <a:srgbClr val="1B2A22"/>
+                </a:solidFill>
+                <a:latin typeface="Calibri" pitchFamily="34" charset="0"/>
+                <a:ea typeface="Calibri" pitchFamily="34" charset="-122"/>
+                <a:cs typeface="Calibri" pitchFamily="34" charset="-120"/>
+              </a:rPr>
+              <a:t>Decisões antes do sorteio: solo nu, declividade, empates dos tercis</a:t>
+            </a:r>
+            <a:endParaRPr lang="en-US" sz="1250" dirty="0"/>
+          </a:p>
+          <a:p>
+            <a:pPr marL="342900" indent="-342900">
+              <a:spcAft>
+                <a:spcPts val="700"/>
+              </a:spcAft>
+              <a:buSzPct val="100000"/>
+              <a:buChar char="•"/>
+            </a:pPr>
+            <a:r>
+              <a:rPr lang="en-US" sz="1250" dirty="0">
+                <a:solidFill>
+                  <a:srgbClr val="1B2A22"/>
+                </a:solidFill>
+                <a:latin typeface="Calibri" pitchFamily="34" charset="0"/>
+                <a:ea typeface="Calibri" pitchFamily="34" charset="-122"/>
+                <a:cs typeface="Calibri" pitchFamily="34" charset="-120"/>
+              </a:rPr>
+              <a:t>Autorizações, voos e delineação</a:t>
+            </a:r>
+            <a:endParaRPr lang="en-US" sz="1250" dirty="0"/>
+          </a:p>
+          <a:p>
+            <a:pPr marL="342900" indent="-342900">
+              <a:spcAft>
+                <a:spcPts val="700"/>
+              </a:spcAft>
+              <a:buSzPct val="100000"/>
+              <a:buChar char="•"/>
+            </a:pPr>
+            <a:r>
+              <a:rPr lang="en-US" sz="1250" dirty="0">
+                <a:solidFill>
+                  <a:srgbClr val="1B2A22"/>
+                </a:solidFill>
+                <a:latin typeface="Calibri" pitchFamily="34" charset="0"/>
+                <a:ea typeface="Calibri" pitchFamily="34" charset="-122"/>
+                <a:cs typeface="Calibri" pitchFamily="34" charset="-120"/>
+              </a:rPr>
+              <a:t>Acerto de atribuição (antes ≈ 78%): em verificação</a:t>
+            </a:r>
+            <a:endParaRPr lang="en-US" sz="1250" dirty="0"/>
           </a:p>
         </p:txBody>
       </p:sp>
@@ -3775,7 +3857,7 @@
                 <a:ea typeface="Cambria" pitchFamily="34" charset="-122"/>
                 <a:cs typeface="Cambria" pitchFamily="34" charset="-120"/>
               </a:rPr>
-              <a:t>Estado atual, limites e próximos passos</a:t>
+              <a:t>Referências citadas nas decisões do projeto</a:t>
             </a:r>
             <a:endParaRPr lang="en-US" sz="2200" dirty="0"/>
           </a:p>
@@ -3815,481 +3897,6 @@
                 <a:cs typeface="Calibri" pitchFamily="34" charset="-120"/>
               </a:rPr>
               <a:t>13</a:t>
-            </a:r>
-            <a:endParaRPr lang="en-US" sz="1000" dirty="0"/>
-          </a:p>
-        </p:txBody>
-      </p:sp>
-      <p:sp>
-        <p:nvSpPr>
-          <p:cNvPr id="5" name="Shape 2"/>
-          <p:cNvSpPr/>
-          <p:nvPr/>
-        </p:nvSpPr>
-        <p:spPr>
-          <a:xfrm>
-            <a:off x="457200" y="1051560"/>
-            <a:ext cx="4023360" cy="3474720"/>
-          </a:xfrm>
-          <a:prstGeom prst="roundRect">
-            <a:avLst>
-              <a:gd name="adj" fmla="val 2105"/>
-            </a:avLst>
-          </a:prstGeom>
-          <a:solidFill>
-            <a:srgbClr val="EEF3EF"/>
-          </a:solidFill>
-          <a:ln w="12700">
-            <a:solidFill>
-              <a:srgbClr val="EEF3EF"/>
-            </a:solidFill>
-            <a:prstDash val="solid"/>
-          </a:ln>
-        </p:spPr>
-      </p:sp>
-      <p:sp>
-        <p:nvSpPr>
-          <p:cNvPr id="6" name="Text 3"/>
-          <p:cNvSpPr txBox="1"/>
-          <p:nvPr/>
-        </p:nvSpPr>
-        <p:spPr>
-          <a:xfrm>
-            <a:off x="640080" y="1170432"/>
-            <a:ext cx="3657600" cy="365760"/>
-          </a:xfrm>
-          <a:prstGeom prst="rect">
-            <a:avLst/>
-          </a:prstGeom>
-          <a:noFill/>
-          <a:ln/>
-        </p:spPr>
-        <p:txBody>
-          <a:bodyPr wrap="square" lIns="0" tIns="0" rIns="0" bIns="0" rtlCol="0" anchor="t"/>
-          <a:lstStyle/>
-          <a:p>
-            <a:pPr indent="0" marL="0">
-              <a:buNone/>
-            </a:pPr>
-            <a:r>
-              <a:rPr lang="en-US" sz="1900" b="1" dirty="0">
-                <a:solidFill>
-                  <a:srgbClr val="2F6B4F"/>
-                </a:solidFill>
-                <a:latin typeface="Cambria" pitchFamily="34" charset="0"/>
-                <a:ea typeface="Cambria" pitchFamily="34" charset="-122"/>
-                <a:cs typeface="Cambria" pitchFamily="34" charset="-120"/>
-              </a:rPr>
-              <a:t>Pronto</a:t>
-            </a:r>
-            <a:endParaRPr lang="en-US" sz="1900" dirty="0"/>
-          </a:p>
-        </p:txBody>
-      </p:sp>
-      <p:sp>
-        <p:nvSpPr>
-          <p:cNvPr id="7" name="Text 4"/>
-          <p:cNvSpPr txBox="1"/>
-          <p:nvPr/>
-        </p:nvSpPr>
-        <p:spPr>
-          <a:xfrm>
-            <a:off x="640080" y="1600200"/>
-            <a:ext cx="3657600" cy="2834640"/>
-          </a:xfrm>
-          <a:prstGeom prst="rect">
-            <a:avLst/>
-          </a:prstGeom>
-          <a:noFill/>
-          <a:ln/>
-        </p:spPr>
-        <p:txBody>
-          <a:bodyPr wrap="square" lIns="0" tIns="0" rIns="0" bIns="0" rtlCol="0" anchor="t"/>
-          <a:lstStyle/>
-          <a:p>
-            <a:pPr marL="342900" indent="-342900">
-              <a:spcAft>
-                <a:spcPts val="700"/>
-              </a:spcAft>
-              <a:buSzPct val="100000"/>
-              <a:buChar char="•"/>
-            </a:pPr>
-            <a:r>
-              <a:rPr lang="en-US" sz="1250" dirty="0">
-                <a:solidFill>
-                  <a:srgbClr val="1B2A22"/>
-                </a:solidFill>
-                <a:latin typeface="Calibri" pitchFamily="34" charset="0"/>
-                <a:ea typeface="Calibri" pitchFamily="34" charset="-122"/>
-                <a:cs typeface="Calibri" pitchFamily="34" charset="-120"/>
-              </a:rPr>
-              <a:t>Plataforma com os módulos do fluxo e recusa de dado sintético</a:t>
-            </a:r>
-            <a:endParaRPr lang="en-US" sz="1250" dirty="0"/>
-          </a:p>
-          <a:p>
-            <a:pPr marL="342900" indent="-342900">
-              <a:spcAft>
-                <a:spcPts val="700"/>
-              </a:spcAft>
-              <a:buSzPct val="100000"/>
-              <a:buChar char="•"/>
-            </a:pPr>
-            <a:r>
-              <a:rPr lang="en-US" sz="1250" dirty="0">
-                <a:solidFill>
-                  <a:srgbClr val="1B2A22"/>
-                </a:solidFill>
-                <a:latin typeface="Calibri" pitchFamily="34" charset="0"/>
-                <a:ea typeface="Calibri" pitchFamily="34" charset="-122"/>
-                <a:cs typeface="Calibri" pitchFamily="34" charset="-120"/>
-              </a:rPr>
-              <a:t>Desenho amostral e critério de avaliação pré-registrados</a:t>
-            </a:r>
-            <a:endParaRPr lang="en-US" sz="1250" dirty="0"/>
-          </a:p>
-          <a:p>
-            <a:pPr marL="342900" indent="-342900">
-              <a:spcAft>
-                <a:spcPts val="700"/>
-              </a:spcAft>
-              <a:buSzPct val="100000"/>
-              <a:buChar char="•"/>
-            </a:pPr>
-            <a:r>
-              <a:rPr lang="en-US" sz="1250" dirty="0">
-                <a:solidFill>
-                  <a:srgbClr val="1B2A22"/>
-                </a:solidFill>
-                <a:latin typeface="Calibri" pitchFamily="34" charset="0"/>
-                <a:ea typeface="Calibri" pitchFamily="34" charset="-122"/>
-                <a:cs typeface="Calibri" pitchFamily="34" charset="-120"/>
-              </a:rPr>
-              <a:t>Ferramenta de checagem do pool por estrato (somente leitura)</a:t>
-            </a:r>
-            <a:endParaRPr lang="en-US" sz="1250" dirty="0"/>
-          </a:p>
-          <a:p>
-            <a:pPr marL="342900" indent="-342900">
-              <a:spcAft>
-                <a:spcPts val="700"/>
-              </a:spcAft>
-              <a:buSzPct val="100000"/>
-              <a:buChar char="•"/>
-            </a:pPr>
-            <a:r>
-              <a:rPr lang="en-US" sz="1250" dirty="0">
-                <a:solidFill>
-                  <a:srgbClr val="1B2A22"/>
-                </a:solidFill>
-                <a:latin typeface="Calibri" pitchFamily="34" charset="0"/>
-                <a:ea typeface="Calibri" pitchFamily="34" charset="-122"/>
-                <a:cs typeface="Calibri" pitchFamily="34" charset="-120"/>
-              </a:rPr>
-              <a:t>Pacote de reprodutibilidade com verificador de integridade</a:t>
-            </a:r>
-            <a:endParaRPr lang="en-US" sz="1250" dirty="0"/>
-          </a:p>
-        </p:txBody>
-      </p:sp>
-      <p:sp>
-        <p:nvSpPr>
-          <p:cNvPr id="8" name="Shape 5"/>
-          <p:cNvSpPr/>
-          <p:nvPr/>
-        </p:nvSpPr>
-        <p:spPr>
-          <a:xfrm>
-            <a:off x="4663440" y="1051560"/>
-            <a:ext cx="4023360" cy="3474720"/>
-          </a:xfrm>
-          <a:prstGeom prst="roundRect">
-            <a:avLst>
-              <a:gd name="adj" fmla="val 2105"/>
-            </a:avLst>
-          </a:prstGeom>
-          <a:solidFill>
-            <a:srgbClr val="EEF3EF"/>
-          </a:solidFill>
-          <a:ln w="12700">
-            <a:solidFill>
-              <a:srgbClr val="EEF3EF"/>
-            </a:solidFill>
-            <a:prstDash val="solid"/>
-          </a:ln>
-        </p:spPr>
-      </p:sp>
-      <p:sp>
-        <p:nvSpPr>
-          <p:cNvPr id="9" name="Text 6"/>
-          <p:cNvSpPr txBox="1"/>
-          <p:nvPr/>
-        </p:nvSpPr>
-        <p:spPr>
-          <a:xfrm>
-            <a:off x="4846320" y="1170432"/>
-            <a:ext cx="3657600" cy="365760"/>
-          </a:xfrm>
-          <a:prstGeom prst="rect">
-            <a:avLst/>
-          </a:prstGeom>
-          <a:noFill/>
-          <a:ln/>
-        </p:spPr>
-        <p:txBody>
-          <a:bodyPr wrap="square" lIns="0" tIns="0" rIns="0" bIns="0" rtlCol="0" anchor="t"/>
-          <a:lstStyle/>
-          <a:p>
-            <a:pPr indent="0" marL="0">
-              <a:buNone/>
-            </a:pPr>
-            <a:r>
-              <a:rPr lang="en-US" sz="1900" b="1" dirty="0">
-                <a:solidFill>
-                  <a:srgbClr val="C65D3B"/>
-                </a:solidFill>
-                <a:latin typeface="Cambria" pitchFamily="34" charset="0"/>
-                <a:ea typeface="Cambria" pitchFamily="34" charset="-122"/>
-                <a:cs typeface="Cambria" pitchFamily="34" charset="-120"/>
-              </a:rPr>
-              <a:t>Pendente</a:t>
-            </a:r>
-            <a:endParaRPr lang="en-US" sz="1900" dirty="0"/>
-          </a:p>
-        </p:txBody>
-      </p:sp>
-      <p:sp>
-        <p:nvSpPr>
-          <p:cNvPr id="10" name="Text 7"/>
-          <p:cNvSpPr txBox="1"/>
-          <p:nvPr/>
-        </p:nvSpPr>
-        <p:spPr>
-          <a:xfrm>
-            <a:off x="4846320" y="1600200"/>
-            <a:ext cx="3657600" cy="2834640"/>
-          </a:xfrm>
-          <a:prstGeom prst="rect">
-            <a:avLst/>
-          </a:prstGeom>
-          <a:noFill/>
-          <a:ln/>
-        </p:spPr>
-        <p:txBody>
-          <a:bodyPr wrap="square" lIns="0" tIns="0" rIns="0" bIns="0" rtlCol="0" anchor="t"/>
-          <a:lstStyle/>
-          <a:p>
-            <a:pPr marL="342900" indent="-342900">
-              <a:spcAft>
-                <a:spcPts val="700"/>
-              </a:spcAft>
-              <a:buSzPct val="100000"/>
-              <a:buChar char="•"/>
-            </a:pPr>
-            <a:r>
-              <a:rPr lang="en-US" sz="1250" dirty="0">
-                <a:solidFill>
-                  <a:srgbClr val="1B2A22"/>
-                </a:solidFill>
-                <a:latin typeface="Calibri" pitchFamily="34" charset="0"/>
-                <a:ea typeface="Calibri" pitchFamily="34" charset="-122"/>
-                <a:cs typeface="Calibri" pitchFamily="34" charset="-120"/>
-              </a:rPr>
-              <a:t>Nenhum resultado empírico ainda</a:t>
-            </a:r>
-            <a:endParaRPr lang="en-US" sz="1250" dirty="0"/>
-          </a:p>
-          <a:p>
-            <a:pPr marL="342900" indent="-342900">
-              <a:spcAft>
-                <a:spcPts val="700"/>
-              </a:spcAft>
-              <a:buSzPct val="100000"/>
-              <a:buChar char="•"/>
-            </a:pPr>
-            <a:r>
-              <a:rPr lang="en-US" sz="1250" dirty="0">
-                <a:solidFill>
-                  <a:srgbClr val="1B2A22"/>
-                </a:solidFill>
-                <a:latin typeface="Calibri" pitchFamily="34" charset="0"/>
-                <a:ea typeface="Calibri" pitchFamily="34" charset="-122"/>
-                <a:cs typeface="Calibri" pitchFamily="34" charset="-120"/>
-              </a:rPr>
-              <a:t>Medir o pool real por estrato e decidir reservas e n mínimo</a:t>
-            </a:r>
-            <a:endParaRPr lang="en-US" sz="1250" dirty="0"/>
-          </a:p>
-          <a:p>
-            <a:pPr marL="342900" indent="-342900">
-              <a:spcAft>
-                <a:spcPts val="700"/>
-              </a:spcAft>
-              <a:buSzPct val="100000"/>
-              <a:buChar char="•"/>
-            </a:pPr>
-            <a:r>
-              <a:rPr lang="en-US" sz="1250" dirty="0">
-                <a:solidFill>
-                  <a:srgbClr val="1B2A22"/>
-                </a:solidFill>
-                <a:latin typeface="Calibri" pitchFamily="34" charset="0"/>
-                <a:ea typeface="Calibri" pitchFamily="34" charset="-122"/>
-                <a:cs typeface="Calibri" pitchFamily="34" charset="-120"/>
-              </a:rPr>
-              <a:t>Decisões antes do sorteio: solo nu, declividade, empates dos tercis</a:t>
-            </a:r>
-            <a:endParaRPr lang="en-US" sz="1250" dirty="0"/>
-          </a:p>
-          <a:p>
-            <a:pPr marL="342900" indent="-342900">
-              <a:spcAft>
-                <a:spcPts val="700"/>
-              </a:spcAft>
-              <a:buSzPct val="100000"/>
-              <a:buChar char="•"/>
-            </a:pPr>
-            <a:r>
-              <a:rPr lang="en-US" sz="1250" dirty="0">
-                <a:solidFill>
-                  <a:srgbClr val="1B2A22"/>
-                </a:solidFill>
-                <a:latin typeface="Calibri" pitchFamily="34" charset="0"/>
-                <a:ea typeface="Calibri" pitchFamily="34" charset="-122"/>
-                <a:cs typeface="Calibri" pitchFamily="34" charset="-120"/>
-              </a:rPr>
-              <a:t>Autorizações, voos e delineação</a:t>
-            </a:r>
-            <a:endParaRPr lang="en-US" sz="1250" dirty="0"/>
-          </a:p>
-          <a:p>
-            <a:pPr marL="342900" indent="-342900">
-              <a:spcAft>
-                <a:spcPts val="700"/>
-              </a:spcAft>
-              <a:buSzPct val="100000"/>
-              <a:buChar char="•"/>
-            </a:pPr>
-            <a:r>
-              <a:rPr lang="en-US" sz="1250" dirty="0">
-                <a:solidFill>
-                  <a:srgbClr val="1B2A22"/>
-                </a:solidFill>
-                <a:latin typeface="Calibri" pitchFamily="34" charset="0"/>
-                <a:ea typeface="Calibri" pitchFamily="34" charset="-122"/>
-                <a:cs typeface="Calibri" pitchFamily="34" charset="-120"/>
-              </a:rPr>
-              <a:t>Acerto de atribuição (antes ≈ 78%): em verificação</a:t>
-            </a:r>
-            <a:endParaRPr lang="en-US" sz="1250" dirty="0"/>
-          </a:p>
-        </p:txBody>
-      </p:sp>
-    </p:spTree>
-  </p:cSld>
-  <p:clrMapOvr>
-    <a:masterClrMapping/>
-  </p:clrMapOvr>
-</p:sld>
-</file>
-
-<file path=ppt/slides/slide14.xml><?xml version="1.0" encoding="utf-8"?>
-<p:sld xmlns:a="http://schemas.openxmlformats.org/drawingml/2006/main" xmlns:r="http://schemas.openxmlformats.org/officeDocument/2006/relationships" xmlns:p="http://schemas.openxmlformats.org/presentationml/2006/main">
-  <p:cSld name="Slide 14">
-    <p:bg>
-      <p:bgPr>
-        <a:solidFill>
-          <a:srgbClr val="FFFFFF"/>
-        </a:solidFill>
-      </p:bgPr>
-    </p:bg>
-    <p:spTree>
-      <p:nvGrpSpPr>
-        <p:cNvPr id="1" name=""/>
-        <p:cNvGrpSpPr/>
-        <p:nvPr/>
-      </p:nvGrpSpPr>
-      <p:grpSpPr>
-        <a:xfrm>
-          <a:off x="0" y="0"/>
-          <a:ext cx="0" cy="0"/>
-          <a:chOff x="0" y="0"/>
-          <a:chExt cx="0" cy="0"/>
-        </a:xfrm>
-      </p:grpSpPr>
-      <p:sp>
-        <p:nvSpPr>
-          <p:cNvPr id="2" name="Text 0"/>
-          <p:cNvSpPr txBox="1"/>
-          <p:nvPr/>
-        </p:nvSpPr>
-        <p:spPr>
-          <a:xfrm>
-            <a:off x="457200" y="256032"/>
-            <a:ext cx="8229600" cy="685800"/>
-          </a:xfrm>
-          <a:prstGeom prst="rect">
-            <a:avLst/>
-          </a:prstGeom>
-          <a:noFill/>
-          <a:ln/>
-        </p:spPr>
-        <p:txBody>
-          <a:bodyPr wrap="square" lIns="0" tIns="0" rIns="0" bIns="0" rtlCol="0" anchor="t"/>
-          <a:lstStyle/>
-          <a:p>
-            <a:pPr indent="0" marL="0">
-              <a:buNone/>
-            </a:pPr>
-            <a:r>
-              <a:rPr lang="en-US" sz="2200" b="1" dirty="0">
-                <a:solidFill>
-                  <a:srgbClr val="1B2A22"/>
-                </a:solidFill>
-                <a:latin typeface="Cambria" pitchFamily="34" charset="0"/>
-                <a:ea typeface="Cambria" pitchFamily="34" charset="-122"/>
-                <a:cs typeface="Cambria" pitchFamily="34" charset="-120"/>
-              </a:rPr>
-              <a:t>Referências citadas nas decisões do projeto</a:t>
-            </a:r>
-            <a:endParaRPr lang="en-US" sz="2200" dirty="0"/>
-          </a:p>
-        </p:txBody>
-      </p:sp>
-      <p:sp>
-        <p:nvSpPr>
-          <p:cNvPr id="3" name="Text 1"/>
-          <p:cNvSpPr txBox="1"/>
-          <p:nvPr/>
-        </p:nvSpPr>
-        <p:spPr>
-          <a:xfrm>
-            <a:off x="8412480" y="4800600"/>
-            <a:ext cx="457200" cy="228600"/>
-          </a:xfrm>
-          <a:prstGeom prst="rect">
-            <a:avLst/>
-          </a:prstGeom>
-          <a:noFill/>
-          <a:ln/>
-        </p:spPr>
-        <p:txBody>
-          <a:bodyPr wrap="square" lIns="0" tIns="0" rIns="0" bIns="0" rtlCol="0" anchor="t"/>
-          <a:lstStyle/>
-          <a:p>
-            <a:pPr algn="r" indent="0" marL="0">
-              <a:buNone/>
-            </a:pPr>
-            <a:r>
-              <a:rPr lang="en-US" sz="1000" dirty="0">
-                <a:solidFill>
-                  <a:srgbClr val="52605A"/>
-                </a:solidFill>
-                <a:latin typeface="Calibri" pitchFamily="34" charset="0"/>
-                <a:ea typeface="Calibri" pitchFamily="34" charset="-122"/>
-                <a:cs typeface="Calibri" pitchFamily="34" charset="-120"/>
-              </a:rPr>
-              <a:t>14</a:t>
             </a:r>
             <a:endParaRPr lang="en-US" sz="1000" dirty="0"/>
           </a:p>
@@ -9511,7 +9118,7 @@
                 <a:ea typeface="Cambria" pitchFamily="34" charset="-122"/>
                 <a:cs typeface="Cambria" pitchFamily="34" charset="-120"/>
               </a:rPr>
-              <a:t>Sorteio selado e o problema da recusa</a:t>
+              <a:t>Dificuldade: quantos voos e quanto tempo</a:t>
             </a:r>
             <a:endParaRPr lang="en-US" sz="2200" dirty="0"/>
           </a:p>
@@ -9564,12 +9171,12 @@
         </p:nvSpPr>
         <p:spPr>
           <a:xfrm>
-            <a:off x="457200" y="1051560"/>
-            <a:ext cx="4023360" cy="3474720"/>
+            <a:off x="457200" y="1005840"/>
+            <a:ext cx="1920240" cy="1188720"/>
           </a:xfrm>
           <a:prstGeom prst="roundRect">
             <a:avLst>
-              <a:gd name="adj" fmla="val 2105"/>
+              <a:gd name="adj" fmla="val 6154"/>
             </a:avLst>
           </a:prstGeom>
           <a:solidFill>
@@ -9591,8 +9198,8 @@
         </p:nvSpPr>
         <p:spPr>
           <a:xfrm>
-            <a:off x="640080" y="1170432"/>
-            <a:ext cx="3657600" cy="365760"/>
+            <a:off x="457200" y="1115568"/>
+            <a:ext cx="1920240" cy="594360"/>
           </a:xfrm>
           <a:prstGeom prst="rect">
             <a:avLst/>
@@ -9604,21 +9211,21 @@
           <a:bodyPr wrap="square" lIns="0" tIns="0" rIns="0" bIns="0" rtlCol="0" anchor="t"/>
           <a:lstStyle/>
           <a:p>
-            <a:pPr indent="0" marL="0">
+            <a:pPr algn="ctr" indent="0" marL="0">
               <a:buNone/>
             </a:pPr>
             <a:r>
-              <a:rPr lang="en-US" sz="1500" b="1" dirty="0">
-                <a:solidFill>
-                  <a:srgbClr val="2F6B4F"/>
+              <a:rPr lang="en-US" sz="2200" b="1" dirty="0">
+                <a:solidFill>
+                  <a:srgbClr val="C65D3B"/>
                 </a:solidFill>
                 <a:latin typeface="Cambria" pitchFamily="34" charset="0"/>
                 <a:ea typeface="Cambria" pitchFamily="34" charset="-122"/>
                 <a:cs typeface="Cambria" pitchFamily="34" charset="-120"/>
               </a:rPr>
-              <a:t>O que o selo registra</a:t>
-            </a:r>
-            <a:endParaRPr lang="en-US" sz="1500" dirty="0"/>
+              <a:t>72</a:t>
+            </a:r>
+            <a:endParaRPr lang="en-US" sz="2200" dirty="0"/>
           </a:p>
         </p:txBody>
       </p:sp>
@@ -9630,8 +9237,8 @@
         </p:nvSpPr>
         <p:spPr>
           <a:xfrm>
-            <a:off x="640080" y="1600200"/>
-            <a:ext cx="3657600" cy="2834640"/>
+            <a:off x="548640" y="1719072"/>
+            <a:ext cx="1737360" cy="457200"/>
           </a:xfrm>
           <a:prstGeom prst="rect">
             <a:avLst/>
@@ -9643,109 +9250,21 @@
           <a:bodyPr wrap="square" lIns="0" tIns="0" rIns="0" bIns="0" rtlCol="0" anchor="t"/>
           <a:lstStyle/>
           <a:p>
-            <a:pPr marL="342900" indent="-342900">
-              <a:spcAft>
-                <a:spcPts val="700"/>
-              </a:spcAft>
-              <a:buSzPct val="100000"/>
-              <a:buChar char="•"/>
-            </a:pPr>
-            <a:r>
-              <a:rPr lang="en-US" sz="1250" dirty="0">
-                <a:solidFill>
-                  <a:srgbClr val="1B2A22"/>
+            <a:pPr algn="ctr" indent="0" marL="0">
+              <a:buNone/>
+            </a:pPr>
+            <a:r>
+              <a:rPr lang="en-US" sz="1100" dirty="0">
+                <a:solidFill>
+                  <a:srgbClr val="52605A"/>
                 </a:solidFill>
                 <a:latin typeface="Calibri" pitchFamily="34" charset="0"/>
                 <a:ea typeface="Calibri" pitchFamily="34" charset="-122"/>
                 <a:cs typeface="Calibri" pitchFamily="34" charset="-120"/>
               </a:rPr>
-              <a:t>Semente do sorteio e commit do código</a:t>
-            </a:r>
-            <a:endParaRPr lang="en-US" sz="1250" dirty="0"/>
-          </a:p>
-          <a:p>
-            <a:pPr marL="342900" indent="-342900">
-              <a:spcAft>
-                <a:spcPts val="700"/>
-              </a:spcAft>
-              <a:buSzPct val="100000"/>
-              <a:buChar char="•"/>
-            </a:pPr>
-            <a:r>
-              <a:rPr lang="en-US" sz="1250" dirty="0">
-                <a:solidFill>
-                  <a:srgbClr val="1B2A22"/>
-                </a:solidFill>
-                <a:latin typeface="Calibri" pitchFamily="34" charset="0"/>
-                <a:ea typeface="Calibri" pitchFamily="34" charset="-122"/>
-                <a:cs typeface="Calibri" pitchFamily="34" charset="-120"/>
-              </a:rPr>
-              <a:t>SHA-256 do conjunto de candidatos</a:t>
-            </a:r>
-            <a:endParaRPr lang="en-US" sz="1250" dirty="0"/>
-          </a:p>
-          <a:p>
-            <a:pPr marL="342900" indent="-342900">
-              <a:spcAft>
-                <a:spcPts val="700"/>
-              </a:spcAft>
-              <a:buSzPct val="100000"/>
-              <a:buChar char="•"/>
-            </a:pPr>
-            <a:r>
-              <a:rPr lang="en-US" sz="1250" dirty="0">
-                <a:solidFill>
-                  <a:srgbClr val="1B2A22"/>
-                </a:solidFill>
-                <a:latin typeface="Calibri" pitchFamily="34" charset="0"/>
-                <a:ea typeface="Calibri" pitchFamily="34" charset="-122"/>
-                <a:cs typeface="Calibri" pitchFamily="34" charset="-120"/>
-              </a:rPr>
-              <a:t>Hash de integridade do resultado</a:t>
-            </a:r>
-            <a:endParaRPr lang="en-US" sz="1250" dirty="0"/>
-          </a:p>
-          <a:p>
-            <a:pPr marL="342900" indent="-342900">
-              <a:spcAft>
-                <a:spcPts val="700"/>
-              </a:spcAft>
-              <a:buSzPct val="100000"/>
-              <a:buChar char="•"/>
-            </a:pPr>
-            <a:r>
-              <a:rPr lang="en-US" sz="1250" dirty="0">
-                <a:solidFill>
-                  <a:srgbClr val="1B2A22"/>
-                </a:solidFill>
-                <a:latin typeface="Calibri" pitchFamily="34" charset="0"/>
-                <a:ea typeface="Calibri" pitchFamily="34" charset="-122"/>
-                <a:cs typeface="Calibri" pitchFamily="34" charset="-120"/>
-              </a:rPr>
-              <a:t>Tabela reversa de códigos opacos, fora do Git</a:t>
-            </a:r>
-            <a:endParaRPr lang="en-US" sz="1250" dirty="0"/>
-          </a:p>
-          <a:p>
-            <a:pPr marL="342900" indent="-342900">
-              <a:spcAft>
-                <a:spcPts val="700"/>
-              </a:spcAft>
-              <a:buSzPct val="100000"/>
-              <a:buChar char="•"/>
-            </a:pPr>
-            <a:r>
-              <a:rPr lang="en-US" sz="1250" dirty="0">
-                <a:solidFill>
-                  <a:srgbClr val="1B2A22"/>
-                </a:solidFill>
-                <a:latin typeface="Calibri" pitchFamily="34" charset="0"/>
-                <a:ea typeface="Calibri" pitchFamily="34" charset="-122"/>
-                <a:cs typeface="Calibri" pitchFamily="34" charset="-120"/>
-              </a:rPr>
-              <a:t>Recusa de candidato sintético e de segunda execução</a:t>
-            </a:r>
-            <a:endParaRPr lang="en-US" sz="1250" dirty="0"/>
+              <a:t>missões de mapeamento, uma por polígono (eram 36)</a:t>
+            </a:r>
+            <a:endParaRPr lang="en-US" sz="1100" dirty="0"/>
           </a:p>
         </p:txBody>
       </p:sp>
@@ -9757,12 +9276,12 @@
         </p:nvSpPr>
         <p:spPr>
           <a:xfrm>
-            <a:off x="4663440" y="1051560"/>
-            <a:ext cx="4023360" cy="3474720"/>
+            <a:off x="2514600" y="1005840"/>
+            <a:ext cx="1920240" cy="1188720"/>
           </a:xfrm>
           <a:prstGeom prst="roundRect">
             <a:avLst>
-              <a:gd name="adj" fmla="val 2105"/>
+              <a:gd name="adj" fmla="val 6154"/>
             </a:avLst>
           </a:prstGeom>
           <a:solidFill>
@@ -9784,8 +9303,8 @@
         </p:nvSpPr>
         <p:spPr>
           <a:xfrm>
-            <a:off x="4846320" y="1170432"/>
-            <a:ext cx="3657600" cy="365760"/>
+            <a:off x="2514600" y="1115568"/>
+            <a:ext cx="1920240" cy="594360"/>
           </a:xfrm>
           <a:prstGeom prst="rect">
             <a:avLst/>
@@ -9797,21 +9316,21 @@
           <a:bodyPr wrap="square" lIns="0" tIns="0" rIns="0" bIns="0" rtlCol="0" anchor="t"/>
           <a:lstStyle/>
           <a:p>
-            <a:pPr indent="0" marL="0">
+            <a:pPr algn="ctr" indent="0" marL="0">
               <a:buNone/>
             </a:pPr>
             <a:r>
-              <a:rPr lang="en-US" sz="1500" b="1" dirty="0">
-                <a:solidFill>
-                  <a:srgbClr val="C65D3B"/>
+              <a:rPr lang="en-US" sz="2200" b="1" dirty="0">
+                <a:solidFill>
+                  <a:srgbClr val="2F6B4F"/>
                 </a:solidFill>
                 <a:latin typeface="Cambria" pitchFamily="34" charset="0"/>
                 <a:ea typeface="Cambria" pitchFamily="34" charset="-122"/>
                 <a:cs typeface="Cambria" pitchFamily="34" charset="-120"/>
               </a:rPr>
-              <a:t>Se recusar (proposta)</a:t>
-            </a:r>
-            <a:endParaRPr lang="en-US" sz="1500" dirty="0"/>
+              <a:t>≈ 12</a:t>
+            </a:r>
+            <a:endParaRPr lang="en-US" sz="2200" dirty="0"/>
           </a:p>
         </p:txBody>
       </p:sp>
@@ -9823,8 +9342,8 @@
         </p:nvSpPr>
         <p:spPr>
           <a:xfrm>
-            <a:off x="4846320" y="1600200"/>
-            <a:ext cx="3657600" cy="2834640"/>
+            <a:off x="2606040" y="1719072"/>
+            <a:ext cx="1737360" cy="457200"/>
           </a:xfrm>
           <a:prstGeom prst="rect">
             <a:avLst/>
@@ -9836,15 +9355,313 @@
           <a:bodyPr wrap="square" lIns="0" tIns="0" rIns="0" bIns="0" rtlCol="0" anchor="t"/>
           <a:lstStyle/>
           <a:p>
+            <a:pPr algn="ctr" indent="0" marL="0">
+              <a:buNone/>
+            </a:pPr>
+            <a:r>
+              <a:rPr lang="en-US" sz="1100" dirty="0">
+                <a:solidFill>
+                  <a:srgbClr val="52605A"/>
+                </a:solidFill>
+                <a:latin typeface="Calibri" pitchFamily="34" charset="0"/>
+                <a:ea typeface="Calibri" pitchFamily="34" charset="-122"/>
+                <a:cs typeface="Calibri" pitchFamily="34" charset="-120"/>
+              </a:rPr>
+              <a:t>jornadas de campo, com até 6 polígonos cada (proposta)</a:t>
+            </a:r>
+            <a:endParaRPr lang="en-US" sz="1100" dirty="0"/>
+          </a:p>
+        </p:txBody>
+      </p:sp>
+      <p:sp>
+        <p:nvSpPr>
+          <p:cNvPr id="11" name="Shape 8"/>
+          <p:cNvSpPr/>
+          <p:nvPr/>
+        </p:nvSpPr>
+        <p:spPr>
+          <a:xfrm>
+            <a:off x="4572000" y="1005840"/>
+            <a:ext cx="1920240" cy="1188720"/>
+          </a:xfrm>
+          <a:prstGeom prst="roundRect">
+            <a:avLst>
+              <a:gd name="adj" fmla="val 6154"/>
+            </a:avLst>
+          </a:prstGeom>
+          <a:solidFill>
+            <a:srgbClr val="EEF3EF"/>
+          </a:solidFill>
+          <a:ln w="12700">
+            <a:solidFill>
+              <a:srgbClr val="EEF3EF"/>
+            </a:solidFill>
+            <a:prstDash val="solid"/>
+          </a:ln>
+        </p:spPr>
+      </p:sp>
+      <p:sp>
+        <p:nvSpPr>
+          <p:cNvPr id="12" name="Text 9"/>
+          <p:cNvSpPr txBox="1"/>
+          <p:nvPr/>
+        </p:nvSpPr>
+        <p:spPr>
+          <a:xfrm>
+            <a:off x="4572000" y="1115568"/>
+            <a:ext cx="1920240" cy="594360"/>
+          </a:xfrm>
+          <a:prstGeom prst="rect">
+            <a:avLst/>
+          </a:prstGeom>
+          <a:noFill/>
+          <a:ln/>
+        </p:spPr>
+        <p:txBody>
+          <a:bodyPr wrap="square" lIns="0" tIns="0" rIns="0" bIns="0" rtlCol="0" anchor="t"/>
+          <a:lstStyle/>
+          <a:p>
+            <a:pPr algn="ctr" indent="0" marL="0">
+              <a:buNone/>
+            </a:pPr>
+            <a:r>
+              <a:rPr lang="en-US" sz="2200" b="1" dirty="0">
+                <a:solidFill>
+                  <a:srgbClr val="2F6B4F"/>
+                </a:solidFill>
+                <a:latin typeface="Cambria" pitchFamily="34" charset="0"/>
+                <a:ea typeface="Cambria" pitchFamily="34" charset="-122"/>
+                <a:cs typeface="Cambria" pitchFamily="34" charset="-120"/>
+              </a:rPr>
+              <a:t>2 a 10 min</a:t>
+            </a:r>
+            <a:endParaRPr lang="en-US" sz="2200" dirty="0"/>
+          </a:p>
+        </p:txBody>
+      </p:sp>
+      <p:sp>
+        <p:nvSpPr>
+          <p:cNvPr id="13" name="Text 10"/>
+          <p:cNvSpPr txBox="1"/>
+          <p:nvPr/>
+        </p:nvSpPr>
+        <p:spPr>
+          <a:xfrm>
+            <a:off x="4663440" y="1719072"/>
+            <a:ext cx="1737360" cy="457200"/>
+          </a:xfrm>
+          <a:prstGeom prst="rect">
+            <a:avLst/>
+          </a:prstGeom>
+          <a:noFill/>
+          <a:ln/>
+        </p:spPr>
+        <p:txBody>
+          <a:bodyPr wrap="square" lIns="0" tIns="0" rIns="0" bIns="0" rtlCol="0" anchor="t"/>
+          <a:lstStyle/>
+          <a:p>
+            <a:pPr algn="ctr" indent="0" marL="0">
+              <a:buNone/>
+            </a:pPr>
+            <a:r>
+              <a:rPr lang="en-US" sz="1100" dirty="0">
+                <a:solidFill>
+                  <a:srgbClr val="52605A"/>
+                </a:solidFill>
+                <a:latin typeface="Calibri" pitchFamily="34" charset="0"/>
+                <a:ea typeface="Calibri" pitchFamily="34" charset="-122"/>
+                <a:cs typeface="Calibri" pitchFamily="34" charset="-120"/>
+              </a:rPr>
+              <a:t>de voo por polígono (2,3 ha/min na Missão 009; 0,53 na 000)</a:t>
+            </a:r>
+            <a:endParaRPr lang="en-US" sz="1100" dirty="0"/>
+          </a:p>
+        </p:txBody>
+      </p:sp>
+      <p:sp>
+        <p:nvSpPr>
+          <p:cNvPr id="14" name="Shape 11"/>
+          <p:cNvSpPr/>
+          <p:nvPr/>
+        </p:nvSpPr>
+        <p:spPr>
+          <a:xfrm>
+            <a:off x="6629400" y="1005840"/>
+            <a:ext cx="2057400" cy="1188720"/>
+          </a:xfrm>
+          <a:prstGeom prst="roundRect">
+            <a:avLst>
+              <a:gd name="adj" fmla="val 6154"/>
+            </a:avLst>
+          </a:prstGeom>
+          <a:solidFill>
+            <a:srgbClr val="EEF3EF"/>
+          </a:solidFill>
+          <a:ln w="12700">
+            <a:solidFill>
+              <a:srgbClr val="EEF3EF"/>
+            </a:solidFill>
+            <a:prstDash val="solid"/>
+          </a:ln>
+        </p:spPr>
+      </p:sp>
+      <p:sp>
+        <p:nvSpPr>
+          <p:cNvPr id="15" name="Text 12"/>
+          <p:cNvSpPr txBox="1"/>
+          <p:nvPr/>
+        </p:nvSpPr>
+        <p:spPr>
+          <a:xfrm>
+            <a:off x="6629400" y="1115568"/>
+            <a:ext cx="2057400" cy="594360"/>
+          </a:xfrm>
+          <a:prstGeom prst="rect">
+            <a:avLst/>
+          </a:prstGeom>
+          <a:noFill/>
+          <a:ln/>
+        </p:spPr>
+        <p:txBody>
+          <a:bodyPr wrap="square" lIns="0" tIns="0" rIns="0" bIns="0" rtlCol="0" anchor="t"/>
+          <a:lstStyle/>
+          <a:p>
+            <a:pPr algn="ctr" indent="0" marL="0">
+              <a:buNone/>
+            </a:pPr>
+            <a:r>
+              <a:rPr lang="en-US" sz="2200" b="1" dirty="0">
+                <a:solidFill>
+                  <a:srgbClr val="C65D3B"/>
+                </a:solidFill>
+                <a:latin typeface="Cambria" pitchFamily="34" charset="0"/>
+                <a:ea typeface="Cambria" pitchFamily="34" charset="-122"/>
+                <a:cs typeface="Cambria" pitchFamily="34" charset="-120"/>
+              </a:rPr>
+              <a:t>72</a:t>
+            </a:r>
+            <a:endParaRPr lang="en-US" sz="2200" dirty="0"/>
+          </a:p>
+        </p:txBody>
+      </p:sp>
+      <p:sp>
+        <p:nvSpPr>
+          <p:cNvPr id="16" name="Text 13"/>
+          <p:cNvSpPr txBox="1"/>
+          <p:nvPr/>
+        </p:nvSpPr>
+        <p:spPr>
+          <a:xfrm>
+            <a:off x="6720840" y="1719072"/>
+            <a:ext cx="1874520" cy="457200"/>
+          </a:xfrm>
+          <a:prstGeom prst="rect">
+            <a:avLst/>
+          </a:prstGeom>
+          <a:noFill/>
+          <a:ln/>
+        </p:spPr>
+        <p:txBody>
+          <a:bodyPr wrap="square" lIns="0" tIns="0" rIns="0" bIns="0" rtlCol="0" anchor="t"/>
+          <a:lstStyle/>
+          <a:p>
+            <a:pPr algn="ctr" indent="0" marL="0">
+              <a:buNone/>
+            </a:pPr>
+            <a:r>
+              <a:rPr lang="en-US" sz="1100" dirty="0">
+                <a:solidFill>
+                  <a:srgbClr val="52605A"/>
+                </a:solidFill>
+                <a:latin typeface="Calibri" pitchFamily="34" charset="0"/>
+                <a:ea typeface="Calibri" pitchFamily="34" charset="-122"/>
+                <a:cs typeface="Calibri" pitchFamily="34" charset="-120"/>
+              </a:rPr>
+              <a:t>autorizações de proprietário</a:t>
+            </a:r>
+            <a:endParaRPr lang="en-US" sz="1100" dirty="0"/>
+          </a:p>
+        </p:txBody>
+      </p:sp>
+      <p:sp>
+        <p:nvSpPr>
+          <p:cNvPr id="17" name="Shape 14"/>
+          <p:cNvSpPr/>
+          <p:nvPr/>
+        </p:nvSpPr>
+        <p:spPr>
+          <a:xfrm>
+            <a:off x="1815828" y="2267712"/>
+            <a:ext cx="5512343" cy="1179576"/>
+          </a:xfrm>
+          <a:prstGeom prst="rect">
+            <a:avLst/>
+          </a:prstGeom>
+          <a:solidFill>
+            <a:srgbClr val="FFFFFF"/>
+          </a:solidFill>
+          <a:ln w="9525">
+            <a:solidFill>
+              <a:srgbClr val="B8C4BC"/>
+            </a:solidFill>
+            <a:prstDash val="solid"/>
+          </a:ln>
+        </p:spPr>
+      </p:sp>
+      <p:pic>
+        <p:nvPicPr>
+          <p:cNvPr id="18" name="Image 0" descr="img/camp_cards.png">    </p:cNvPr>
+          <p:cNvPicPr>
+            <a:picLocks noChangeAspect="1"/>
+          </p:cNvPicPr>
+          <p:nvPr/>
+        </p:nvPicPr>
+        <p:blipFill>
+          <a:blip r:embed="rId1"/>
+          <a:stretch>
+            <a:fillRect/>
+          </a:stretch>
+        </p:blipFill>
+        <p:spPr>
+          <a:xfrm>
+            <a:off x="1834116" y="2286000"/>
+            <a:ext cx="5475767" cy="1143000"/>
+          </a:xfrm>
+          <a:prstGeom prst="rect">
+            <a:avLst/>
+          </a:prstGeom>
+        </p:spPr>
+      </p:pic>
+      <p:sp>
+        <p:nvSpPr>
+          <p:cNvPr id="19" name="Text 15"/>
+          <p:cNvSpPr txBox="1"/>
+          <p:nvPr/>
+        </p:nvSpPr>
+        <p:spPr>
+          <a:xfrm>
+            <a:off x="457200" y="3474720"/>
+            <a:ext cx="8229600" cy="1280160"/>
+          </a:xfrm>
+          <a:prstGeom prst="rect">
+            <a:avLst/>
+          </a:prstGeom>
+          <a:noFill/>
+          <a:ln/>
+        </p:spPr>
+        <p:txBody>
+          <a:bodyPr wrap="square" lIns="0" tIns="0" rIns="0" bIns="0" rtlCol="0" anchor="t"/>
+          <a:lstStyle/>
+          <a:p>
             <a:pPr marL="342900" indent="-342900">
               <a:spcAft>
-                <a:spcPts val="700"/>
+                <a:spcPts val="200"/>
               </a:spcAft>
               <a:buSzPct val="100000"/>
               <a:buChar char="•"/>
             </a:pPr>
             <a:r>
-              <a:rPr lang="en-US" sz="1250" dirty="0">
+              <a:rPr lang="en-US" sz="1050" dirty="0">
                 <a:solidFill>
                   <a:srgbClr val="1B2A22"/>
                 </a:solidFill>
@@ -9852,20 +9669,20 @@
                 <a:ea typeface="Calibri" pitchFamily="34" charset="-122"/>
                 <a:cs typeface="Calibri" pitchFamily="34" charset="-120"/>
               </a:rPr>
-              <a:t>No mesmo selo: 4 titulares e reservas ordenadas por estrato</a:t>
-            </a:r>
-            <a:endParaRPr lang="en-US" sz="1250" dirty="0"/>
+              <a:t>Por que 72: 18 estratos × 4 polígonos (2 treino + 2 teste); a área total, cerca de 361 ha, é o que o custo de voo suporta e rende cerca de 1.845 unidades independentes (D24): no limite para o bloco espectral e abaixo do recomendado para solo, chuva e terreno</a:t>
+            </a:r>
+            <a:endParaRPr lang="en-US" sz="1050" dirty="0"/>
           </a:p>
           <a:p>
             <a:pPr marL="342900" indent="-342900">
               <a:spcAft>
-                <a:spcPts val="700"/>
+                <a:spcPts val="200"/>
               </a:spcAft>
               <a:buSzPct val="100000"/>
               <a:buChar char="•"/>
             </a:pPr>
             <a:r>
-              <a:rPr lang="en-US" sz="1250" dirty="0">
+              <a:rPr lang="en-US" sz="1050" dirty="0">
                 <a:solidFill>
                   <a:srgbClr val="1B2A22"/>
                 </a:solidFill>
@@ -9873,20 +9690,20 @@
                 <a:ea typeface="Calibri" pitchFamily="34" charset="-122"/>
                 <a:cs typeface="Calibri" pitchFamily="34" charset="-120"/>
               </a:rPr>
-              <a:t>Recusa aciona a próxima reserva do mesmo estrato</a:t>
-            </a:r>
-            <a:endParaRPr lang="en-US" sz="1250" dirty="0"/>
+              <a:t>Tempo total de voo: de 2,6 h a 11 h, sem contar o deslocamento, que domina a campanha</a:t>
+            </a:r>
+            <a:endParaRPr lang="en-US" sz="1050" dirty="0"/>
           </a:p>
           <a:p>
             <a:pPr marL="342900" indent="-342900">
               <a:spcAft>
-                <a:spcPts val="700"/>
+                <a:spcPts val="200"/>
               </a:spcAft>
               <a:buSzPct val="100000"/>
               <a:buChar char="•"/>
             </a:pPr>
             <a:r>
-              <a:rPr lang="en-US" sz="1250" dirty="0">
+              <a:rPr lang="en-US" sz="1050" dirty="0">
                 <a:solidFill>
                   <a:srgbClr val="1B2A22"/>
                 </a:solidFill>
@@ -9894,20 +9711,20 @@
                 <a:ea typeface="Calibri" pitchFamily="34" charset="-122"/>
                 <a:cs typeface="Calibri" pitchFamily="34" charset="-120"/>
               </a:rPr>
-              <a:t>A reserva herda o papel (treino ou teste)</a:t>
-            </a:r>
-            <a:endParaRPr lang="en-US" sz="1250" dirty="0"/>
+              <a:t>Nº de baterias e de decolagens: ainda não definido; depende da aeronave e do agrupamento</a:t>
+            </a:r>
+            <a:endParaRPr lang="en-US" sz="1050" dirty="0"/>
           </a:p>
           <a:p>
             <a:pPr marL="342900" indent="-342900">
               <a:spcAft>
-                <a:spcPts val="700"/>
+                <a:spcPts val="200"/>
               </a:spcAft>
               <a:buSzPct val="100000"/>
               <a:buChar char="•"/>
             </a:pPr>
             <a:r>
-              <a:rPr lang="en-US" sz="1250" dirty="0">
+              <a:rPr lang="en-US" sz="1050" dirty="0">
                 <a:solidFill>
                   <a:srgbClr val="1B2A22"/>
                 </a:solidFill>
@@ -9915,67 +9732,46 @@
                 <a:ea typeface="Calibri" pitchFamily="34" charset="-122"/>
                 <a:cs typeface="Calibri" pitchFamily="34" charset="-120"/>
               </a:rPr>
-              <a:t>Registro append-only, com data e motivo</a:t>
-            </a:r>
-            <a:endParaRPr lang="en-US" sz="1250" dirty="0"/>
-          </a:p>
-          <a:p>
-            <a:pPr marL="342900" indent="-342900">
-              <a:spcAft>
-                <a:spcPts val="700"/>
-              </a:spcAft>
-              <a:buSzPct val="100000"/>
-              <a:buChar char="•"/>
-            </a:pPr>
-            <a:r>
-              <a:rPr lang="en-US" sz="1250" dirty="0">
-                <a:solidFill>
-                  <a:srgbClr val="1B2A22"/>
+              <a:t>Base: 2 missões medidas (uma terceira foi excluída por ortomosaico degenerado); é uma faixa, não uma estimativa precisa</a:t>
+            </a:r>
+            <a:endParaRPr lang="en-US" sz="1050" dirty="0"/>
+          </a:p>
+        </p:txBody>
+      </p:sp>
+      <p:sp>
+        <p:nvSpPr>
+          <p:cNvPr id="20" name="Text 16"/>
+          <p:cNvSpPr txBox="1"/>
+          <p:nvPr/>
+        </p:nvSpPr>
+        <p:spPr>
+          <a:xfrm>
+            <a:off x="457200" y="4754880"/>
+            <a:ext cx="7863840" cy="292608"/>
+          </a:xfrm>
+          <a:prstGeom prst="rect">
+            <a:avLst/>
+          </a:prstGeom>
+          <a:noFill/>
+          <a:ln/>
+        </p:spPr>
+        <p:txBody>
+          <a:bodyPr wrap="square" lIns="0" tIns="0" rIns="0" bIns="0" rtlCol="0" anchor="ctr"/>
+          <a:lstStyle/>
+          <a:p>
+            <a:pPr indent="0" marL="0">
+              <a:buNone/>
+            </a:pPr>
+            <a:r>
+              <a:rPr lang="en-US" sz="1000" i="1" dirty="0">
+                <a:solidFill>
+                  <a:srgbClr val="52605A"/>
                 </a:solidFill>
                 <a:latin typeface="Calibri" pitchFamily="34" charset="0"/>
                 <a:ea typeface="Calibri" pitchFamily="34" charset="-122"/>
                 <a:cs typeface="Calibri" pitchFamily="34" charset="-120"/>
               </a:rPr>
-              <a:t>Parâmetros em aberto: número de reservas, n mínimo e taxa de recusa</a:t>
-            </a:r>
-            <a:endParaRPr lang="en-US" sz="1250" dirty="0"/>
-          </a:p>
-        </p:txBody>
-      </p:sp>
-      <p:sp>
-        <p:nvSpPr>
-          <p:cNvPr id="11" name="Text 8"/>
-          <p:cNvSpPr txBox="1"/>
-          <p:nvPr/>
-        </p:nvSpPr>
-        <p:spPr>
-          <a:xfrm>
-            <a:off x="457200" y="4754880"/>
-            <a:ext cx="7863840" cy="292608"/>
-          </a:xfrm>
-          <a:prstGeom prst="rect">
-            <a:avLst/>
-          </a:prstGeom>
-          <a:noFill/>
-          <a:ln/>
-        </p:spPr>
-        <p:txBody>
-          <a:bodyPr wrap="square" lIns="0" tIns="0" rIns="0" bIns="0" rtlCol="0" anchor="ctr"/>
-          <a:lstStyle/>
-          <a:p>
-            <a:pPr indent="0" marL="0">
-              <a:buNone/>
-            </a:pPr>
-            <a:r>
-              <a:rPr lang="en-US" sz="1000" i="1" dirty="0">
-                <a:solidFill>
-                  <a:srgbClr val="52605A"/>
-                </a:solidFill>
-                <a:latin typeface="Calibri" pitchFamily="34" charset="0"/>
-                <a:ea typeface="Calibri" pitchFamily="34" charset="-122"/>
-                <a:cs typeface="Calibri" pitchFamily="34" charset="-120"/>
-              </a:rPr>
-              <a:t>Refs.: D23; King &amp; Zeng (2001); Olofsson et al. (2014); Cochran (1977). O protocolo de reservas é proposta, em implementação.</a:t>
+              <a:t>Fonte: D16; cobertura_voos.geojson (Missões 000 e 009); agrupamento: planejador de jornadas (teto padrão 6).</a:t>
             </a:r>
             <a:endParaRPr lang="en-US" sz="1000" dirty="0"/>
           </a:p>
@@ -10046,7 +9842,7 @@
                 <a:ea typeface="Cambria" pitchFamily="34" charset="-122"/>
                 <a:cs typeface="Cambria" pitchFamily="34" charset="-120"/>
               </a:rPr>
-              <a:t>Dificuldade: quantos voos e quanto tempo</a:t>
+              <a:t>Voo cego, delineação e rótulo por fração</a:t>
             </a:r>
             <a:endParaRPr lang="en-US" sz="2200" dirty="0"/>
           </a:p>
@@ -10099,428 +9895,8 @@
         </p:nvSpPr>
         <p:spPr>
           <a:xfrm>
-            <a:off x="457200" y="1005840"/>
-            <a:ext cx="1920240" cy="1188720"/>
-          </a:xfrm>
-          <a:prstGeom prst="roundRect">
-            <a:avLst>
-              <a:gd name="adj" fmla="val 6154"/>
-            </a:avLst>
-          </a:prstGeom>
-          <a:solidFill>
-            <a:srgbClr val="EEF3EF"/>
-          </a:solidFill>
-          <a:ln w="12700">
-            <a:solidFill>
-              <a:srgbClr val="EEF3EF"/>
-            </a:solidFill>
-            <a:prstDash val="solid"/>
-          </a:ln>
-        </p:spPr>
-      </p:sp>
-      <p:sp>
-        <p:nvSpPr>
-          <p:cNvPr id="6" name="Text 3"/>
-          <p:cNvSpPr txBox="1"/>
-          <p:nvPr/>
-        </p:nvSpPr>
-        <p:spPr>
-          <a:xfrm>
-            <a:off x="457200" y="1115568"/>
-            <a:ext cx="1920240" cy="594360"/>
-          </a:xfrm>
-          <a:prstGeom prst="rect">
-            <a:avLst/>
-          </a:prstGeom>
-          <a:noFill/>
-          <a:ln/>
-        </p:spPr>
-        <p:txBody>
-          <a:bodyPr wrap="square" lIns="0" tIns="0" rIns="0" bIns="0" rtlCol="0" anchor="t"/>
-          <a:lstStyle/>
-          <a:p>
-            <a:pPr algn="ctr" indent="0" marL="0">
-              <a:buNone/>
-            </a:pPr>
-            <a:r>
-              <a:rPr lang="en-US" sz="2200" b="1" dirty="0">
-                <a:solidFill>
-                  <a:srgbClr val="C65D3B"/>
-                </a:solidFill>
-                <a:latin typeface="Cambria" pitchFamily="34" charset="0"/>
-                <a:ea typeface="Cambria" pitchFamily="34" charset="-122"/>
-                <a:cs typeface="Cambria" pitchFamily="34" charset="-120"/>
-              </a:rPr>
-              <a:t>72</a:t>
-            </a:r>
-            <a:endParaRPr lang="en-US" sz="2200" dirty="0"/>
-          </a:p>
-        </p:txBody>
-      </p:sp>
-      <p:sp>
-        <p:nvSpPr>
-          <p:cNvPr id="7" name="Text 4"/>
-          <p:cNvSpPr txBox="1"/>
-          <p:nvPr/>
-        </p:nvSpPr>
-        <p:spPr>
-          <a:xfrm>
-            <a:off x="548640" y="1719072"/>
-            <a:ext cx="1737360" cy="457200"/>
-          </a:xfrm>
-          <a:prstGeom prst="rect">
-            <a:avLst/>
-          </a:prstGeom>
-          <a:noFill/>
-          <a:ln/>
-        </p:spPr>
-        <p:txBody>
-          <a:bodyPr wrap="square" lIns="0" tIns="0" rIns="0" bIns="0" rtlCol="0" anchor="t"/>
-          <a:lstStyle/>
-          <a:p>
-            <a:pPr algn="ctr" indent="0" marL="0">
-              <a:buNone/>
-            </a:pPr>
-            <a:r>
-              <a:rPr lang="en-US" sz="1100" dirty="0">
-                <a:solidFill>
-                  <a:srgbClr val="52605A"/>
-                </a:solidFill>
-                <a:latin typeface="Calibri" pitchFamily="34" charset="0"/>
-                <a:ea typeface="Calibri" pitchFamily="34" charset="-122"/>
-                <a:cs typeface="Calibri" pitchFamily="34" charset="-120"/>
-              </a:rPr>
-              <a:t>missões de mapeamento, uma por polígono (eram 36)</a:t>
-            </a:r>
-            <a:endParaRPr lang="en-US" sz="1100" dirty="0"/>
-          </a:p>
-        </p:txBody>
-      </p:sp>
-      <p:sp>
-        <p:nvSpPr>
-          <p:cNvPr id="8" name="Shape 5"/>
-          <p:cNvSpPr/>
-          <p:nvPr/>
-        </p:nvSpPr>
-        <p:spPr>
-          <a:xfrm>
-            <a:off x="2514600" y="1005840"/>
-            <a:ext cx="1920240" cy="1188720"/>
-          </a:xfrm>
-          <a:prstGeom prst="roundRect">
-            <a:avLst>
-              <a:gd name="adj" fmla="val 6154"/>
-            </a:avLst>
-          </a:prstGeom>
-          <a:solidFill>
-            <a:srgbClr val="EEF3EF"/>
-          </a:solidFill>
-          <a:ln w="12700">
-            <a:solidFill>
-              <a:srgbClr val="EEF3EF"/>
-            </a:solidFill>
-            <a:prstDash val="solid"/>
-          </a:ln>
-        </p:spPr>
-      </p:sp>
-      <p:sp>
-        <p:nvSpPr>
-          <p:cNvPr id="9" name="Text 6"/>
-          <p:cNvSpPr txBox="1"/>
-          <p:nvPr/>
-        </p:nvSpPr>
-        <p:spPr>
-          <a:xfrm>
-            <a:off x="2514600" y="1115568"/>
-            <a:ext cx="1920240" cy="594360"/>
-          </a:xfrm>
-          <a:prstGeom prst="rect">
-            <a:avLst/>
-          </a:prstGeom>
-          <a:noFill/>
-          <a:ln/>
-        </p:spPr>
-        <p:txBody>
-          <a:bodyPr wrap="square" lIns="0" tIns="0" rIns="0" bIns="0" rtlCol="0" anchor="t"/>
-          <a:lstStyle/>
-          <a:p>
-            <a:pPr algn="ctr" indent="0" marL="0">
-              <a:buNone/>
-            </a:pPr>
-            <a:r>
-              <a:rPr lang="en-US" sz="2200" b="1" dirty="0">
-                <a:solidFill>
-                  <a:srgbClr val="2F6B4F"/>
-                </a:solidFill>
-                <a:latin typeface="Cambria" pitchFamily="34" charset="0"/>
-                <a:ea typeface="Cambria" pitchFamily="34" charset="-122"/>
-                <a:cs typeface="Cambria" pitchFamily="34" charset="-120"/>
-              </a:rPr>
-              <a:t>≈ 12</a:t>
-            </a:r>
-            <a:endParaRPr lang="en-US" sz="2200" dirty="0"/>
-          </a:p>
-        </p:txBody>
-      </p:sp>
-      <p:sp>
-        <p:nvSpPr>
-          <p:cNvPr id="10" name="Text 7"/>
-          <p:cNvSpPr txBox="1"/>
-          <p:nvPr/>
-        </p:nvSpPr>
-        <p:spPr>
-          <a:xfrm>
-            <a:off x="2606040" y="1719072"/>
-            <a:ext cx="1737360" cy="457200"/>
-          </a:xfrm>
-          <a:prstGeom prst="rect">
-            <a:avLst/>
-          </a:prstGeom>
-          <a:noFill/>
-          <a:ln/>
-        </p:spPr>
-        <p:txBody>
-          <a:bodyPr wrap="square" lIns="0" tIns="0" rIns="0" bIns="0" rtlCol="0" anchor="t"/>
-          <a:lstStyle/>
-          <a:p>
-            <a:pPr algn="ctr" indent="0" marL="0">
-              <a:buNone/>
-            </a:pPr>
-            <a:r>
-              <a:rPr lang="en-US" sz="1100" dirty="0">
-                <a:solidFill>
-                  <a:srgbClr val="52605A"/>
-                </a:solidFill>
-                <a:latin typeface="Calibri" pitchFamily="34" charset="0"/>
-                <a:ea typeface="Calibri" pitchFamily="34" charset="-122"/>
-                <a:cs typeface="Calibri" pitchFamily="34" charset="-120"/>
-              </a:rPr>
-              <a:t>jornadas de campo, com até 6 polígonos cada (proposta)</a:t>
-            </a:r>
-            <a:endParaRPr lang="en-US" sz="1100" dirty="0"/>
-          </a:p>
-        </p:txBody>
-      </p:sp>
-      <p:sp>
-        <p:nvSpPr>
-          <p:cNvPr id="11" name="Shape 8"/>
-          <p:cNvSpPr/>
-          <p:nvPr/>
-        </p:nvSpPr>
-        <p:spPr>
-          <a:xfrm>
-            <a:off x="4572000" y="1005840"/>
-            <a:ext cx="1920240" cy="1188720"/>
-          </a:xfrm>
-          <a:prstGeom prst="roundRect">
-            <a:avLst>
-              <a:gd name="adj" fmla="val 6154"/>
-            </a:avLst>
-          </a:prstGeom>
-          <a:solidFill>
-            <a:srgbClr val="EEF3EF"/>
-          </a:solidFill>
-          <a:ln w="12700">
-            <a:solidFill>
-              <a:srgbClr val="EEF3EF"/>
-            </a:solidFill>
-            <a:prstDash val="solid"/>
-          </a:ln>
-        </p:spPr>
-      </p:sp>
-      <p:sp>
-        <p:nvSpPr>
-          <p:cNvPr id="12" name="Text 9"/>
-          <p:cNvSpPr txBox="1"/>
-          <p:nvPr/>
-        </p:nvSpPr>
-        <p:spPr>
-          <a:xfrm>
-            <a:off x="4572000" y="1115568"/>
-            <a:ext cx="1920240" cy="594360"/>
-          </a:xfrm>
-          <a:prstGeom prst="rect">
-            <a:avLst/>
-          </a:prstGeom>
-          <a:noFill/>
-          <a:ln/>
-        </p:spPr>
-        <p:txBody>
-          <a:bodyPr wrap="square" lIns="0" tIns="0" rIns="0" bIns="0" rtlCol="0" anchor="t"/>
-          <a:lstStyle/>
-          <a:p>
-            <a:pPr algn="ctr" indent="0" marL="0">
-              <a:buNone/>
-            </a:pPr>
-            <a:r>
-              <a:rPr lang="en-US" sz="2200" b="1" dirty="0">
-                <a:solidFill>
-                  <a:srgbClr val="2F6B4F"/>
-                </a:solidFill>
-                <a:latin typeface="Cambria" pitchFamily="34" charset="0"/>
-                <a:ea typeface="Cambria" pitchFamily="34" charset="-122"/>
-                <a:cs typeface="Cambria" pitchFamily="34" charset="-120"/>
-              </a:rPr>
-              <a:t>2 a 10 min</a:t>
-            </a:r>
-            <a:endParaRPr lang="en-US" sz="2200" dirty="0"/>
-          </a:p>
-        </p:txBody>
-      </p:sp>
-      <p:sp>
-        <p:nvSpPr>
-          <p:cNvPr id="13" name="Text 10"/>
-          <p:cNvSpPr txBox="1"/>
-          <p:nvPr/>
-        </p:nvSpPr>
-        <p:spPr>
-          <a:xfrm>
-            <a:off x="4663440" y="1719072"/>
-            <a:ext cx="1737360" cy="457200"/>
-          </a:xfrm>
-          <a:prstGeom prst="rect">
-            <a:avLst/>
-          </a:prstGeom>
-          <a:noFill/>
-          <a:ln/>
-        </p:spPr>
-        <p:txBody>
-          <a:bodyPr wrap="square" lIns="0" tIns="0" rIns="0" bIns="0" rtlCol="0" anchor="t"/>
-          <a:lstStyle/>
-          <a:p>
-            <a:pPr algn="ctr" indent="0" marL="0">
-              <a:buNone/>
-            </a:pPr>
-            <a:r>
-              <a:rPr lang="en-US" sz="1100" dirty="0">
-                <a:solidFill>
-                  <a:srgbClr val="52605A"/>
-                </a:solidFill>
-                <a:latin typeface="Calibri" pitchFamily="34" charset="0"/>
-                <a:ea typeface="Calibri" pitchFamily="34" charset="-122"/>
-                <a:cs typeface="Calibri" pitchFamily="34" charset="-120"/>
-              </a:rPr>
-              <a:t>de voo por polígono (2,3 ha/min na Missão 009; 0,53 na 000)</a:t>
-            </a:r>
-            <a:endParaRPr lang="en-US" sz="1100" dirty="0"/>
-          </a:p>
-        </p:txBody>
-      </p:sp>
-      <p:sp>
-        <p:nvSpPr>
-          <p:cNvPr id="14" name="Shape 11"/>
-          <p:cNvSpPr/>
-          <p:nvPr/>
-        </p:nvSpPr>
-        <p:spPr>
-          <a:xfrm>
-            <a:off x="6629400" y="1005840"/>
-            <a:ext cx="2057400" cy="1188720"/>
-          </a:xfrm>
-          <a:prstGeom prst="roundRect">
-            <a:avLst>
-              <a:gd name="adj" fmla="val 6154"/>
-            </a:avLst>
-          </a:prstGeom>
-          <a:solidFill>
-            <a:srgbClr val="EEF3EF"/>
-          </a:solidFill>
-          <a:ln w="12700">
-            <a:solidFill>
-              <a:srgbClr val="EEF3EF"/>
-            </a:solidFill>
-            <a:prstDash val="solid"/>
-          </a:ln>
-        </p:spPr>
-      </p:sp>
-      <p:sp>
-        <p:nvSpPr>
-          <p:cNvPr id="15" name="Text 12"/>
-          <p:cNvSpPr txBox="1"/>
-          <p:nvPr/>
-        </p:nvSpPr>
-        <p:spPr>
-          <a:xfrm>
-            <a:off x="6629400" y="1115568"/>
-            <a:ext cx="2057400" cy="594360"/>
-          </a:xfrm>
-          <a:prstGeom prst="rect">
-            <a:avLst/>
-          </a:prstGeom>
-          <a:noFill/>
-          <a:ln/>
-        </p:spPr>
-        <p:txBody>
-          <a:bodyPr wrap="square" lIns="0" tIns="0" rIns="0" bIns="0" rtlCol="0" anchor="t"/>
-          <a:lstStyle/>
-          <a:p>
-            <a:pPr algn="ctr" indent="0" marL="0">
-              <a:buNone/>
-            </a:pPr>
-            <a:r>
-              <a:rPr lang="en-US" sz="2200" b="1" dirty="0">
-                <a:solidFill>
-                  <a:srgbClr val="C65D3B"/>
-                </a:solidFill>
-                <a:latin typeface="Cambria" pitchFamily="34" charset="0"/>
-                <a:ea typeface="Cambria" pitchFamily="34" charset="-122"/>
-                <a:cs typeface="Cambria" pitchFamily="34" charset="-120"/>
-              </a:rPr>
-              <a:t>72</a:t>
-            </a:r>
-            <a:endParaRPr lang="en-US" sz="2200" dirty="0"/>
-          </a:p>
-        </p:txBody>
-      </p:sp>
-      <p:sp>
-        <p:nvSpPr>
-          <p:cNvPr id="16" name="Text 13"/>
-          <p:cNvSpPr txBox="1"/>
-          <p:nvPr/>
-        </p:nvSpPr>
-        <p:spPr>
-          <a:xfrm>
-            <a:off x="6720840" y="1719072"/>
-            <a:ext cx="1874520" cy="457200"/>
-          </a:xfrm>
-          <a:prstGeom prst="rect">
-            <a:avLst/>
-          </a:prstGeom>
-          <a:noFill/>
-          <a:ln/>
-        </p:spPr>
-        <p:txBody>
-          <a:bodyPr wrap="square" lIns="0" tIns="0" rIns="0" bIns="0" rtlCol="0" anchor="t"/>
-          <a:lstStyle/>
-          <a:p>
-            <a:pPr algn="ctr" indent="0" marL="0">
-              <a:buNone/>
-            </a:pPr>
-            <a:r>
-              <a:rPr lang="en-US" sz="1100" dirty="0">
-                <a:solidFill>
-                  <a:srgbClr val="52605A"/>
-                </a:solidFill>
-                <a:latin typeface="Calibri" pitchFamily="34" charset="0"/>
-                <a:ea typeface="Calibri" pitchFamily="34" charset="-122"/>
-                <a:cs typeface="Calibri" pitchFamily="34" charset="-120"/>
-              </a:rPr>
-              <a:t>autorizações de proprietário</a:t>
-            </a:r>
-            <a:endParaRPr lang="en-US" sz="1100" dirty="0"/>
-          </a:p>
-        </p:txBody>
-      </p:sp>
-      <p:sp>
-        <p:nvSpPr>
-          <p:cNvPr id="17" name="Shape 14"/>
-          <p:cNvSpPr/>
-          <p:nvPr/>
-        </p:nvSpPr>
-        <p:spPr>
-          <a:xfrm>
-            <a:off x="1815828" y="2267712"/>
-            <a:ext cx="5512343" cy="1179576"/>
+            <a:off x="472440" y="987552"/>
+            <a:ext cx="8199120" cy="1225296"/>
           </a:xfrm>
           <a:prstGeom prst="rect">
             <a:avLst/>
@@ -10538,7 +9914,7 @@
       </p:sp>
       <p:pic>
         <p:nvPicPr>
-          <p:cNvPr id="18" name="Image 0" descr="img/camp_cards.png">    </p:cNvPr>
+          <p:cNvPr id="6" name="Image 0" descr="img/camp_topo.png">    </p:cNvPr>
           <p:cNvPicPr>
             <a:picLocks noChangeAspect="1"/>
           </p:cNvPicPr>
@@ -10552,8 +9928,8 @@
         </p:blipFill>
         <p:spPr>
           <a:xfrm>
-            <a:off x="1834116" y="2286000"/>
-            <a:ext cx="5475767" cy="1143000"/>
+            <a:off x="490728" y="1005840"/>
+            <a:ext cx="8162544" cy="1188720"/>
           </a:xfrm>
           <a:prstGeom prst="rect">
             <a:avLst/>
@@ -10562,14 +9938,14 @@
       </p:pic>
       <p:sp>
         <p:nvSpPr>
-          <p:cNvPr id="19" name="Text 15"/>
+          <p:cNvPr id="7" name="Text 3"/>
           <p:cNvSpPr txBox="1"/>
           <p:nvPr/>
         </p:nvSpPr>
         <p:spPr>
           <a:xfrm>
-            <a:off x="457200" y="3474720"/>
-            <a:ext cx="8229600" cy="1280160"/>
+            <a:off x="457200" y="2423160"/>
+            <a:ext cx="8229600" cy="2194560"/>
           </a:xfrm>
           <a:prstGeom prst="rect">
             <a:avLst/>
@@ -10583,13 +9959,13 @@
           <a:p>
             <a:pPr marL="342900" indent="-342900">
               <a:spcAft>
-                <a:spcPts val="200"/>
+                <a:spcPts val="700"/>
               </a:spcAft>
               <a:buSzPct val="100000"/>
               <a:buChar char="•"/>
             </a:pPr>
             <a:r>
-              <a:rPr lang="en-US" sz="1050" dirty="0">
+              <a:rPr lang="en-US" sz="1300" dirty="0">
                 <a:solidFill>
                   <a:srgbClr val="1B2A22"/>
                 </a:solidFill>
@@ -10597,20 +9973,20 @@
                 <a:ea typeface="Calibri" pitchFamily="34" charset="-122"/>
                 <a:cs typeface="Calibri" pitchFamily="34" charset="-120"/>
               </a:rPr>
-              <a:t>Por que 72: 18 estratos × 4 polígonos (2 treino + 2 teste); a área total, cerca de 361 ha, é o que o custo de voo suporta e rende cerca de 1.845 unidades independentes (D24): no limite para o bloco espectral e abaixo do recomendado para solo, chuva e terreno</a:t>
-            </a:r>
-            <a:endParaRPr lang="en-US" sz="1050" dirty="0"/>
+              <a:t>Alvo primário: fração da célula de 10 m delineada como erodida, de 0 a 1 (D26); binário ≥ 0,25 é derivado</a:t>
+            </a:r>
+            <a:endParaRPr lang="en-US" sz="1300" dirty="0"/>
           </a:p>
           <a:p>
             <a:pPr marL="342900" indent="-342900">
               <a:spcAft>
-                <a:spcPts val="200"/>
+                <a:spcPts val="700"/>
               </a:spcAft>
               <a:buSzPct val="100000"/>
               <a:buChar char="•"/>
             </a:pPr>
             <a:r>
-              <a:rPr lang="en-US" sz="1050" dirty="0">
+              <a:rPr lang="en-US" sz="1300" dirty="0">
                 <a:solidFill>
                   <a:srgbClr val="1B2A22"/>
                 </a:solidFill>
@@ -10618,20 +9994,20 @@
                 <a:ea typeface="Calibri" pitchFamily="34" charset="-122"/>
                 <a:cs typeface="Calibri" pitchFamily="34" charset="-120"/>
               </a:rPr>
-              <a:t>Tempo total de voo: de 2,6 h a 11 h, sem contar o deslocamento, que domina a campanha</a:t>
-            </a:r>
-            <a:endParaRPr lang="en-US" sz="1050" dirty="0"/>
+              <a:t>Intérprete cego: recebe só um código opaco, sem estrato nem papel (exportação cega por perfil)</a:t>
+            </a:r>
+            <a:endParaRPr lang="en-US" sz="1300" dirty="0"/>
           </a:p>
           <a:p>
             <a:pPr marL="342900" indent="-342900">
               <a:spcAft>
-                <a:spcPts val="200"/>
+                <a:spcPts val="700"/>
               </a:spcAft>
               <a:buSzPct val="100000"/>
               <a:buChar char="•"/>
             </a:pPr>
             <a:r>
-              <a:rPr lang="en-US" sz="1050" dirty="0">
+              <a:rPr lang="en-US" sz="1300" dirty="0">
                 <a:solidFill>
                   <a:srgbClr val="1B2A22"/>
                 </a:solidFill>
@@ -10639,20 +10015,20 @@
                 <a:ea typeface="Calibri" pitchFamily="34" charset="-122"/>
                 <a:cs typeface="Calibri" pitchFamily="34" charset="-120"/>
               </a:rPr>
-              <a:t>Nº de baterias e de decolagens: ainda não definido; depende da aeronave e do agrupamento</a:t>
-            </a:r>
-            <a:endParaRPr lang="en-US" sz="1050" dirty="0"/>
+              <a:t>Polígonos sorteados pelos estratos biofísicos, nunca pelo rastreio espectral (evita circularidade)</a:t>
+            </a:r>
+            <a:endParaRPr lang="en-US" sz="1300" dirty="0"/>
           </a:p>
           <a:p>
             <a:pPr marL="342900" indent="-342900">
               <a:spcAft>
-                <a:spcPts val="200"/>
+                <a:spcPts val="700"/>
               </a:spcAft>
               <a:buSzPct val="100000"/>
               <a:buChar char="•"/>
             </a:pPr>
             <a:r>
-              <a:rPr lang="en-US" sz="1050" dirty="0">
+              <a:rPr lang="en-US" sz="1300" dirty="0">
                 <a:solidFill>
                   <a:srgbClr val="1B2A22"/>
                 </a:solidFill>
@@ -10660,15 +10036,15 @@
                 <a:ea typeface="Calibri" pitchFamily="34" charset="-122"/>
                 <a:cs typeface="Calibri" pitchFamily="34" charset="-120"/>
               </a:rPr>
-              <a:t>Base: 2 missões medidas (uma terceira foi excluída por ortomosaico degenerado); é uma faixa, não uma estimativa precisa</a:t>
-            </a:r>
-            <a:endParaRPr lang="en-US" sz="1050" dirty="0"/>
-          </a:p>
-        </p:txBody>
-      </p:sp>
-      <p:sp>
-        <p:nvSpPr>
-          <p:cNvPr id="20" name="Text 16"/>
+              <a:t>Planos de voo só com terreno real (Copernicus 30 m); os de demonstração são marcados como sintéticos e não voáveis</a:t>
+            </a:r>
+            <a:endParaRPr lang="en-US" sz="1300" dirty="0"/>
+          </a:p>
+        </p:txBody>
+      </p:sp>
+      <p:sp>
+        <p:nvSpPr>
+          <p:cNvPr id="8" name="Text 4"/>
           <p:cNvSpPr txBox="1"/>
           <p:nvPr/>
         </p:nvSpPr>
@@ -10699,7 +10075,7 @@
                 <a:ea typeface="Calibri" pitchFamily="34" charset="-122"/>
                 <a:cs typeface="Calibri" pitchFamily="34" charset="-120"/>
               </a:rPr>
-              <a:t>Fonte: D16; cobertura_voos.geojson (Missões 000 e 009); agrupamento: planejador de jornadas (teto padrão 6).</a:t>
+              <a:t>Refs.: D26, D16, D02; Altman &amp; Royston (2006) sobre dicotomizar variável contínua.</a:t>
             </a:r>
             <a:endParaRPr lang="en-US" sz="1000" dirty="0"/>
           </a:p>

</xml_diff>

<commit_message>
docs: apresentação SAREL: slide de voos informa aeronave, 3 baterias e tempo do plano de voo
Co-Authored-By: Claude Sonnet 5.5 <noreply@anthropic.com>
Claude-Session: https://claude.ai/code/session_01QBooVKGGKQGrenTtP2atqx
</commit_message>
<xml_diff>
--- a/docs/Apresentacao_SAREL_Plataforma_Metodo_Desafios.pptx
+++ b/docs/Apresentacao_SAREL_Plataforma_Metodo_Desafios.pptx
@@ -1753,7 +1753,7 @@
           <a:p>
             <a:r>
               <a:rPr lang="en-US" dirty="0"/>
-              <a:t>(1,5 min) Quantidade de voos: são 72 polígonos de 5,02 ha, ou seja, 72 missões de mapeamento, uma por polígono; eram 36 no desenho anterior. Elas não precisam ser 72 saídas: o planejador agrupa polígonos próximos em jornadas de campo, com teto padrão de 6 polígonos por jornada, ajustável, o que dá cerca de 12 jornadas. Esse agrupamento é uma proposta do planejador, ainda não validada em campo. Tempo de voo: a produtividade medida foi de 2,3 ha/min na Missão 009, o que dá cerca de 2,2 min por polígono; mas a única outra missão válida, a 000, teve 0,53 ha/min, o que dá cerca de 9,5 min. Com duas missões medidas, a faixa honesta é de 2 a 10 minutos por polígono, ou de 2,6 a 11 horas de voo no total, sem contar deslocamento. O que domina a campanha é deslocamento, montagem e as 72 autorizações. O número de baterias e de decolagens não está definido: depende da aeronave e do agrupamento, e não tenho esse dado. Por que 72: é a estrutura de 18 estratos com 4 polígonos cada, e não um excesso. A área total de cerca de 361 ha é o que o custo de voo suporta; ela rende cerca de 1.845 unidades espacialmente independentes (D24), no limite para o bloco espectral e abaixo do recomendado para solo, chuva e terreno. A tela mostra os três conjuntos da campanha.</a:t>
+              <a:t>(1,5 min) Aeronave: Spectral 2, da Nuvem UAV, com a câmera multiespectral MicaSense Altum; há 3 baterias disponíveis. Quantidade de voos: são 72 polígonos de 5,02 ha, ou seja, 72 missões de mapeamento, uma por polígono; eram 36 no desenho anterior. Por que 72: é a estrutura de 18 estratos com 4 polígonos cada. A área total, de cerca de 361 ha, é o que o custo de voo suporta e rende cerca de 1.845 unidades espacialmente independentes (D24), no limite para o bloco espectral e abaixo do recomendado para solo, chuva e terreno. Tempo: o plano de voo para 4 cm de resolução usa altitude de 92,8 m, cerca de 7 linhas e 123 disparos por polígono, com velocidade medida de 8,7 a 9,2 m/s nos logs reais; isso dá cerca de 3 minutos de mapeamento por polígono, mais as curvas. Em horas, são pelo menos 3,6 h de mapeamento nos 72 polígonos, sem contar decolagem, pouso, troca de bateria e deslocamento, que dominam a campanha. Com teto padrão de 6 polígonos por jornada, são cerca de 12 jornadas e dois polígonos por bateria; isso é compatível com as duas missões já voadas, de 9 a 13 minutos, mas a autonomia útil de cada bateria ainda precisa ser confirmada. Nas duas missões medidas a produtividade foi de 2,3 ha/min na Missão 009 e 0,53 ha/min na 000, de modo que o tempo real pode ser maior que o planejado. Há ainda 72 autorizações de proprietário a obter.</a:t>
             </a:r>
             <a:endParaRPr lang="en-US" dirty="0"/>
           </a:p>
@@ -9367,7 +9367,7 @@
                 <a:ea typeface="Calibri" pitchFamily="34" charset="-122"/>
                 <a:cs typeface="Calibri" pitchFamily="34" charset="-120"/>
               </a:rPr>
-              <a:t>jornadas de campo, com até 6 polígonos cada (proposta)</a:t>
+              <a:t>jornadas, com até 6 polígonos e 3 baterias cada (proposta)</a:t>
             </a:r>
             <a:endParaRPr lang="en-US" sz="1100" dirty="0"/>
           </a:p>
@@ -9433,7 +9433,7 @@
                 <a:ea typeface="Cambria" pitchFamily="34" charset="-122"/>
                 <a:cs typeface="Cambria" pitchFamily="34" charset="-120"/>
               </a:rPr>
-              <a:t>2 a 10 min</a:t>
+              <a:t>≈ 3 min</a:t>
             </a:r>
             <a:endParaRPr lang="en-US" sz="2200" dirty="0"/>
           </a:p>
@@ -9472,7 +9472,7 @@
                 <a:ea typeface="Calibri" pitchFamily="34" charset="-122"/>
                 <a:cs typeface="Calibri" pitchFamily="34" charset="-120"/>
               </a:rPr>
-              <a:t>de voo por polígono (2,3 ha/min na Missão 009; 0,53 na 000)</a:t>
+              <a:t>de mapeamento por polígono, mais curvas (plano de voo)</a:t>
             </a:r>
             <a:endParaRPr lang="en-US" sz="1100" dirty="0"/>
           </a:p>
@@ -9591,8 +9591,8 @@
         </p:nvSpPr>
         <p:spPr>
           <a:xfrm>
-            <a:off x="1815828" y="2267712"/>
-            <a:ext cx="5512343" cy="1179576"/>
+            <a:off x="2144374" y="2267712"/>
+            <a:ext cx="4855251" cy="1042416"/>
           </a:xfrm>
           <a:prstGeom prst="rect">
             <a:avLst/>
@@ -9624,8 +9624,8 @@
         </p:blipFill>
         <p:spPr>
           <a:xfrm>
-            <a:off x="1834116" y="2286000"/>
-            <a:ext cx="5475767" cy="1143000"/>
+            <a:off x="2162662" y="2286000"/>
+            <a:ext cx="4818675" cy="1005840"/>
           </a:xfrm>
           <a:prstGeom prst="rect">
             <a:avLst/>
@@ -9640,8 +9640,8 @@
         </p:nvSpPr>
         <p:spPr>
           <a:xfrm>
-            <a:off x="457200" y="3474720"/>
-            <a:ext cx="8229600" cy="1280160"/>
+            <a:off x="457200" y="3337560"/>
+            <a:ext cx="8229600" cy="1371600"/>
           </a:xfrm>
           <a:prstGeom prst="rect">
             <a:avLst/>
@@ -9661,7 +9661,7 @@
               <a:buChar char="•"/>
             </a:pPr>
             <a:r>
-              <a:rPr lang="en-US" sz="1050" dirty="0">
+              <a:rPr lang="en-US" sz="1000" dirty="0">
                 <a:solidFill>
                   <a:srgbClr val="1B2A22"/>
                 </a:solidFill>
@@ -9669,9 +9669,9 @@
                 <a:ea typeface="Calibri" pitchFamily="34" charset="-122"/>
                 <a:cs typeface="Calibri" pitchFamily="34" charset="-120"/>
               </a:rPr>
-              <a:t>Por que 72: 18 estratos × 4 polígonos (2 treino + 2 teste); a área total, cerca de 361 ha, é o que o custo de voo suporta e rende cerca de 1.845 unidades independentes (D24): no limite para o bloco espectral e abaixo do recomendado para solo, chuva e terreno</a:t>
-            </a:r>
-            <a:endParaRPr lang="en-US" sz="1050" dirty="0"/>
+              <a:t>Aeronave: Spectral 2 (Nuvem UAV), câmera MicaSense Altum; 3 baterias. Plano: 4 cm de GSD, 92,8 m de altitude, 8,7 a 9,2 m/s (medido), cerca de 7 linhas e 123 disparos por polígono</a:t>
+            </a:r>
+            <a:endParaRPr lang="en-US" sz="1000" dirty="0"/>
           </a:p>
           <a:p>
             <a:pPr marL="342900" indent="-342900">
@@ -9682,7 +9682,7 @@
               <a:buChar char="•"/>
             </a:pPr>
             <a:r>
-              <a:rPr lang="en-US" sz="1050" dirty="0">
+              <a:rPr lang="en-US" sz="1000" dirty="0">
                 <a:solidFill>
                   <a:srgbClr val="1B2A22"/>
                 </a:solidFill>
@@ -9690,9 +9690,9 @@
                 <a:ea typeface="Calibri" pitchFamily="34" charset="-122"/>
                 <a:cs typeface="Calibri" pitchFamily="34" charset="-120"/>
               </a:rPr>
-              <a:t>Tempo total de voo: de 2,6 h a 11 h, sem contar o deslocamento, que domina a campanha</a:t>
-            </a:r>
-            <a:endParaRPr lang="en-US" sz="1050" dirty="0"/>
+              <a:t>Por que 72: 18 estratos × 4 polígonos (2 treino + 2 teste); a área total, cerca de 361 ha, é o que o custo de voo suporta e rende cerca de 1.845 unidades independentes (D24)</a:t>
+            </a:r>
+            <a:endParaRPr lang="en-US" sz="1000" dirty="0"/>
           </a:p>
           <a:p>
             <a:pPr marL="342900" indent="-342900">
@@ -9703,7 +9703,7 @@
               <a:buChar char="•"/>
             </a:pPr>
             <a:r>
-              <a:rPr lang="en-US" sz="1050" dirty="0">
+              <a:rPr lang="en-US" sz="1000" dirty="0">
                 <a:solidFill>
                   <a:srgbClr val="1B2A22"/>
                 </a:solidFill>
@@ -9711,67 +9711,46 @@
                 <a:ea typeface="Calibri" pitchFamily="34" charset="-122"/>
                 <a:cs typeface="Calibri" pitchFamily="34" charset="-120"/>
               </a:rPr>
-              <a:t>Nº de baterias e de decolagens: ainda não definido; depende da aeronave e do agrupamento</a:t>
-            </a:r>
-            <a:endParaRPr lang="en-US" sz="1050" dirty="0"/>
-          </a:p>
-          <a:p>
-            <a:pPr marL="342900" indent="-342900">
-              <a:spcAft>
-                <a:spcPts val="200"/>
-              </a:spcAft>
-              <a:buSzPct val="100000"/>
-              <a:buChar char="•"/>
-            </a:pPr>
-            <a:r>
-              <a:rPr lang="en-US" sz="1050" dirty="0">
-                <a:solidFill>
-                  <a:srgbClr val="1B2A22"/>
+              <a:t>Tempo: pelo menos 3,6 h de mapeamento nos 72; 6 polígonos por jornada = 2 por bateria, compatível com as missões já voadas (9 a 13 min); autonomia útil a confirmar. Produtividade medida: 2,3 ha/min (Missão 009) e 0,53 (000)</a:t>
+            </a:r>
+            <a:endParaRPr lang="en-US" sz="1000" dirty="0"/>
+          </a:p>
+        </p:txBody>
+      </p:sp>
+      <p:sp>
+        <p:nvSpPr>
+          <p:cNvPr id="20" name="Text 16"/>
+          <p:cNvSpPr txBox="1"/>
+          <p:nvPr/>
+        </p:nvSpPr>
+        <p:spPr>
+          <a:xfrm>
+            <a:off x="457200" y="4754880"/>
+            <a:ext cx="7863840" cy="292608"/>
+          </a:xfrm>
+          <a:prstGeom prst="rect">
+            <a:avLst/>
+          </a:prstGeom>
+          <a:noFill/>
+          <a:ln/>
+        </p:spPr>
+        <p:txBody>
+          <a:bodyPr wrap="square" lIns="0" tIns="0" rIns="0" bIns="0" rtlCol="0" anchor="ctr"/>
+          <a:lstStyle/>
+          <a:p>
+            <a:pPr indent="0" marL="0">
+              <a:buNone/>
+            </a:pPr>
+            <a:r>
+              <a:rPr lang="en-US" sz="1000" i="1" dirty="0">
+                <a:solidFill>
+                  <a:srgbClr val="52605A"/>
                 </a:solidFill>
                 <a:latin typeface="Calibri" pitchFamily="34" charset="0"/>
                 <a:ea typeface="Calibri" pitchFamily="34" charset="-122"/>
                 <a:cs typeface="Calibri" pitchFamily="34" charset="-120"/>
               </a:rPr>
-              <a:t>Base: 2 missões medidas (uma terceira foi excluída por ortomosaico degenerado); é uma faixa, não uma estimativa precisa</a:t>
-            </a:r>
-            <a:endParaRPr lang="en-US" sz="1050" dirty="0"/>
-          </a:p>
-        </p:txBody>
-      </p:sp>
-      <p:sp>
-        <p:nvSpPr>
-          <p:cNvPr id="20" name="Text 16"/>
-          <p:cNvSpPr txBox="1"/>
-          <p:nvPr/>
-        </p:nvSpPr>
-        <p:spPr>
-          <a:xfrm>
-            <a:off x="457200" y="4754880"/>
-            <a:ext cx="7863840" cy="292608"/>
-          </a:xfrm>
-          <a:prstGeom prst="rect">
-            <a:avLst/>
-          </a:prstGeom>
-          <a:noFill/>
-          <a:ln/>
-        </p:spPr>
-        <p:txBody>
-          <a:bodyPr wrap="square" lIns="0" tIns="0" rIns="0" bIns="0" rtlCol="0" anchor="ctr"/>
-          <a:lstStyle/>
-          <a:p>
-            <a:pPr indent="0" marL="0">
-              <a:buNone/>
-            </a:pPr>
-            <a:r>
-              <a:rPr lang="en-US" sz="1000" i="1" dirty="0">
-                <a:solidFill>
-                  <a:srgbClr val="52605A"/>
-                </a:solidFill>
-                <a:latin typeface="Calibri" pitchFamily="34" charset="0"/>
-                <a:ea typeface="Calibri" pitchFamily="34" charset="-122"/>
-                <a:cs typeface="Calibri" pitchFamily="34" charset="-120"/>
-              </a:rPr>
-              <a:t>Fonte: D16; cobertura_voos.geojson (Missões 000 e 009); agrupamento: planejador de jornadas (teto padrão 6).</a:t>
+              <a:t>Fonte: D16; plano de voo (exportação NControl); cobertura_voos.geojson (Missões 000 e 009). Jornadas: planejador (teto padrão 6).</a:t>
             </a:r>
             <a:endParaRPr lang="en-US" sz="1000" dirty="0"/>
           </a:p>

</xml_diff>

<commit_message>
docs: apresentação SAREL em duas versões (seminário sem o quarto desfecho; completa com ele)
Co-Authored-By: Claude Sonnet 5.5 <noreply@anthropic.com>
Claude-Session: https://claude.ai/code/session_01QBooVKGGKQGrenTtP2atqx
</commit_message>
<xml_diff>
--- a/docs/Apresentacao_SAREL_Plataforma_Metodo_Desafios.pptx
+++ b/docs/Apresentacao_SAREL_Plataforma_Metodo_Desafios.pptx
@@ -3159,8 +3159,8 @@
         </p:nvSpPr>
         <p:spPr>
           <a:xfrm>
-            <a:off x="4526280" y="1051560"/>
-            <a:ext cx="4251960" cy="3566160"/>
+            <a:off x="4526280" y="1005840"/>
+            <a:ext cx="4251960" cy="3703320"/>
           </a:xfrm>
           <a:prstGeom prst="rect">
             <a:avLst/>

</xml_diff>

<commit_message>
docs: apresentação SAREL com o quarto desfecho e versão de seminário sem ele
Co-Authored-By: Claude Sonnet 5.5 <noreply@anthropic.com>
Claude-Session: https://claude.ai/code/session_01QBooVKGGKQGrenTtP2atqx
</commit_message>
<xml_diff>
--- a/docs/Apresentacao_SAREL_Plataforma_Metodo_Desafios.pptx
+++ b/docs/Apresentacao_SAREL_Plataforma_Metodo_Desafios.pptx
@@ -961,7 +961,7 @@
           <a:p>
             <a:r>
               <a:rPr lang="en-US" dirty="0"/>
-              <a:t>(1,5 min) A tela mostra o registro oficial das decisões, com o critério de refutação de D25: três competidores (linha de base RUSLE, regressão penalizada e XGBoost), métrica primária de Spearman no held-out, piso de 0,40 e margem de 0,10 sobre a RUSLE. A inferência usa bootstrap por polígono, porque células do mesmo polígono não são independentes. Os desfechos são corroborada, inconclusiva ou refutada. O estado exibido hoje é 'não avaliado', e isso é intencional: não há resultado. O script grava uma trava e recusa uma segunda avaliação.</a:t>
+              <a:t>(1,5 min) A tela mostra o registro oficial das decisões, com o critério de refutação de D25: três competidores (linha de base RUSLE, regressão penalizada e XGBoost), métrica primária de Spearman no held-out, piso de 0,40 e margem de 0,10 sobre a RUSLE. A inferência usa bootstrap por polígono, porque células do mesmo polígono não são independentes. Os desfechos são corroborada, inconclusiva ou refutada. O estado exibido hoje é 'não avaliado', e isso é intencional: não há resultado. O script grava uma trava e recusa uma segunda avaliação. Há ainda um quarto desfecho, independente dos três: se a regressão penalizada empatar com o XGBoost ou vencê-lo dentro do intervalo, a hipótese de que é preciso um ensemble de árvores fica refutada, mesmo que o sensoriamento remoto vença o RUSLE. São resultados distintos e ambos publicáveis; o segundo indicaria que o ganho está nos preditores e não na flexibilidade do algoritmo.</a:t>
             </a:r>
             <a:endParaRPr lang="en-US" dirty="0"/>
           </a:p>
@@ -3180,7 +3180,7 @@
               <a:buChar char="•"/>
             </a:pPr>
             <a:r>
-              <a:rPr lang="en-US" sz="1250" dirty="0">
+              <a:rPr lang="en-US" sz="1100" dirty="0">
                 <a:solidFill>
                   <a:srgbClr val="1B2A22"/>
                 </a:solidFill>
@@ -3190,7 +3190,7 @@
               </a:rPr>
               <a:t>Competidores: linha de base RUSLE, regressão penalizada e XGBoost (perda Tweedie)</a:t>
             </a:r>
-            <a:endParaRPr lang="en-US" sz="1250" dirty="0"/>
+            <a:endParaRPr lang="en-US" sz="1100" dirty="0"/>
           </a:p>
           <a:p>
             <a:pPr marL="342900" indent="-342900">
@@ -3201,7 +3201,7 @@
               <a:buChar char="•"/>
             </a:pPr>
             <a:r>
-              <a:rPr lang="en-US" sz="1250" dirty="0">
+              <a:rPr lang="en-US" sz="1100" dirty="0">
                 <a:solidFill>
                   <a:srgbClr val="1B2A22"/>
                 </a:solidFill>
@@ -3211,7 +3211,7 @@
               </a:rPr>
               <a:t>Métrica primária: Spearman no held-out; piso 0,40 e margem 0,10 sobre a RUSLE</a:t>
             </a:r>
-            <a:endParaRPr lang="en-US" sz="1250" dirty="0"/>
+            <a:endParaRPr lang="en-US" sz="1100" dirty="0"/>
           </a:p>
           <a:p>
             <a:pPr marL="342900" indent="-342900">
@@ -3222,7 +3222,7 @@
               <a:buChar char="•"/>
             </a:pPr>
             <a:r>
-              <a:rPr lang="en-US" sz="1250" dirty="0">
+              <a:rPr lang="en-US" sz="1100" dirty="0">
                 <a:solidFill>
                   <a:srgbClr val="1B2A22"/>
                 </a:solidFill>
@@ -3232,7 +3232,7 @@
               </a:rPr>
               <a:t>Bootstrap por polígono (as células de um polígono não são independentes)</a:t>
             </a:r>
-            <a:endParaRPr lang="en-US" sz="1250" dirty="0"/>
+            <a:endParaRPr lang="en-US" sz="1100" dirty="0"/>
           </a:p>
           <a:p>
             <a:pPr marL="342900" indent="-342900">
@@ -3243,7 +3243,7 @@
               <a:buChar char="•"/>
             </a:pPr>
             <a:r>
-              <a:rPr lang="en-US" sz="1250" dirty="0">
+              <a:rPr lang="en-US" sz="1100" dirty="0">
                 <a:solidFill>
                   <a:srgbClr val="1B2A22"/>
                 </a:solidFill>
@@ -3253,7 +3253,7 @@
               </a:rPr>
               <a:t>Desfechos: corroborada, inconclusiva ou refutada (e inconclusiva por margem)</a:t>
             </a:r>
-            <a:endParaRPr lang="en-US" sz="1250" dirty="0"/>
+            <a:endParaRPr lang="en-US" sz="1100" dirty="0"/>
           </a:p>
           <a:p>
             <a:pPr marL="342900" indent="-342900">
@@ -3264,7 +3264,7 @@
               <a:buChar char="•"/>
             </a:pPr>
             <a:r>
-              <a:rPr lang="en-US" sz="1250" dirty="0">
+              <a:rPr lang="en-US" sz="1100" dirty="0">
                 <a:solidFill>
                   <a:srgbClr val="1B2A22"/>
                 </a:solidFill>
@@ -3274,7 +3274,28 @@
               </a:rPr>
               <a:t>Estado hoje: não avaliado. O script grava uma trava e recusa a segunda avaliação</a:t>
             </a:r>
-            <a:endParaRPr lang="en-US" sz="1250" dirty="0"/>
+            <a:endParaRPr lang="en-US" sz="1100" dirty="0"/>
+          </a:p>
+          <a:p>
+            <a:pPr marL="342900" indent="-342900">
+              <a:spcAft>
+                <a:spcPts val="700"/>
+              </a:spcAft>
+              <a:buSzPct val="100000"/>
+              <a:buChar char="•"/>
+            </a:pPr>
+            <a:r>
+              <a:rPr lang="en-US" sz="1100" dirty="0">
+                <a:solidFill>
+                  <a:srgbClr val="1B2A22"/>
+                </a:solidFill>
+                <a:latin typeface="Calibri" pitchFamily="34" charset="0"/>
+                <a:ea typeface="Calibri" pitchFamily="34" charset="-122"/>
+                <a:cs typeface="Calibri" pitchFamily="34" charset="-120"/>
+              </a:rPr>
+              <a:t>Quarto desfecho, independente: se a regressão penalizada empatar com o XGBoost ou o vencer (IC 95% da diferença com limite inferior ≤ 0), a hipótese de que é preciso ensemble de árvores fica refutada, mesmo que o sensoriamento remoto vença o RUSLE</a:t>
+            </a:r>
+            <a:endParaRPr lang="en-US" sz="1100" dirty="0"/>
           </a:p>
         </p:txBody>
       </p:sp>

</xml_diff>